<commit_message>
tweak: deck — make 'is this just more data?' framing explicit on headline + compute-matched slides
</commit_message>
<xml_diff>
--- a/paper_slides/synergy_deck.pptx
+++ b/paper_slides/synergy_deck.pptx
@@ -9135,7 +9135,7 @@
         <p:spPr>
           <a:xfrm>
             <a:off x="6766560" y="1280160"/>
-            <a:ext cx="4937760" cy="4572000"/>
+            <a:ext cx="4937760" cy="5029200"/>
           </a:xfrm>
           <a:prstGeom prst="rect">
             <a:avLst/>
@@ -9158,148 +9158,209 @@
                 </a:solidFill>
                 <a:latin typeface="Calibri"/>
               </a:rPr>
-              <a:t>The synergy</a:t>
+              <a:t>Is this just more data?  No.</a:t>
             </a:r>
           </a:p>
           <a:p>
             <a:pPr>
               <a:spcBef>
-                <a:spcPts val="800"/>
+                <a:spcPts val="600"/>
               </a:spcBef>
             </a:pPr>
             <a:r>
-              <a:rPr sz="1800">
-                <a:solidFill>
-                  <a:srgbClr val="232A33"/>
-                </a:solidFill>
-                <a:latin typeface="Calibri"/>
-              </a:rPr>
-              <a:t>K=5 augmentation alone:  </a:t>
-            </a:r>
-            <a:r>
-              <a:rPr sz="2200" b="1">
-                <a:solidFill>
-                  <a:srgbClr val="1F4E90"/>
-                </a:solidFill>
-                <a:latin typeface="Calibri"/>
-              </a:rPr>
-              <a:t>+0.036</a:t>
+              <a:rPr sz="1400" i="1">
+                <a:solidFill>
+                  <a:srgbClr val="5C6670"/>
+                </a:solidFill>
+                <a:latin typeface="Calibri"/>
+              </a:rPr>
+              <a:t>K=5 conditions see 5× the training data, so a 'data dominates' story would predict K=5 wins on its own.</a:t>
             </a:r>
           </a:p>
           <a:p>
             <a:pPr>
               <a:spcBef>
-                <a:spcPts val="800"/>
+                <a:spcPts val="700"/>
               </a:spcBef>
             </a:pPr>
             <a:r>
-              <a:rPr sz="1800">
+              <a:rPr sz="1500">
                 <a:solidFill>
                   <a:srgbClr val="232A33"/>
                 </a:solidFill>
                 <a:latin typeface="Calibri"/>
               </a:rPr>
-              <a:t>K=1 KL preservation alone:  </a:t>
-            </a:r>
-            <a:r>
-              <a:rPr sz="2200" b="1">
+              <a:t>Just 5× more data  (b):  </a:t>
+            </a:r>
+            <a:r>
+              <a:rPr sz="2000" b="1">
                 <a:solidFill>
                   <a:srgbClr val="1F4E90"/>
                 </a:solidFill>
                 <a:latin typeface="Calibri"/>
               </a:rPr>
-              <a:t>+0.029</a:t>
+              <a:t>+0.036</a:t>
+            </a:r>
+            <a:r>
+              <a:rPr sz="1200" i="1">
+                <a:solidFill>
+                  <a:srgbClr val="5C6670"/>
+                </a:solidFill>
+                <a:latin typeface="Calibri"/>
+              </a:rPr>
+              <a:t>   small</a:t>
             </a:r>
           </a:p>
           <a:p>
             <a:pPr>
               <a:spcBef>
-                <a:spcPts val="800"/>
+                <a:spcPts val="700"/>
               </a:spcBef>
             </a:pPr>
             <a:r>
-              <a:rPr sz="1800">
+              <a:rPr sz="1500">
                 <a:solidFill>
                   <a:srgbClr val="232A33"/>
                 </a:solidFill>
                 <a:latin typeface="Calibri"/>
               </a:rPr>
-              <a:t>Both combined:  </a:t>
-            </a:r>
-            <a:r>
-              <a:rPr sz="2200" b="1">
-                <a:solidFill>
-                  <a:srgbClr val="1F8E4F"/>
-                </a:solidFill>
-                <a:latin typeface="Calibri"/>
-              </a:rPr>
-              <a:t>+0.322</a:t>
+              <a:t>Just KL preservation  (c):  </a:t>
+            </a:r>
+            <a:r>
+              <a:rPr sz="2000" b="1">
+                <a:solidFill>
+                  <a:srgbClr val="1F4E90"/>
+                </a:solidFill>
+                <a:latin typeface="Calibri"/>
+              </a:rPr>
+              <a:t>+0.029</a:t>
+            </a:r>
+            <a:r>
+              <a:rPr sz="1200" i="1">
+                <a:solidFill>
+                  <a:srgbClr val="5C6670"/>
+                </a:solidFill>
+                <a:latin typeface="Calibri"/>
+              </a:rPr>
+              <a:t>   small</a:t>
             </a:r>
           </a:p>
           <a:p>
             <a:pPr>
               <a:spcBef>
-                <a:spcPts val="800"/>
+                <a:spcPts val="700"/>
               </a:spcBef>
             </a:pPr>
             <a:r>
-              <a:rPr sz="1800">
+              <a:rPr sz="1500">
                 <a:solidFill>
                   <a:srgbClr val="232A33"/>
                 </a:solidFill>
                 <a:latin typeface="Calibri"/>
               </a:rPr>
-              <a:t>Additive prediction:  </a:t>
-            </a:r>
-            <a:r>
-              <a:rPr sz="2200" b="1">
+              <a:t>Naive additive prediction:  </a:t>
+            </a:r>
+            <a:r>
+              <a:rPr sz="2000" b="1">
                 <a:solidFill>
                   <a:srgbClr val="5C6670"/>
                 </a:solidFill>
                 <a:latin typeface="Calibri"/>
               </a:rPr>
               <a:t>+0.065</a:t>
+            </a:r>
+            <a:r>
+              <a:rPr sz="1200" i="1">
+                <a:solidFill>
+                  <a:srgbClr val="5C6670"/>
+                </a:solidFill>
+                <a:latin typeface="Calibri"/>
+              </a:rPr>
+              <a:t>   if independent</a:t>
             </a:r>
           </a:p>
           <a:p>
             <a:pPr>
               <a:spcBef>
-                <a:spcPts val="800"/>
+                <a:spcPts val="700"/>
               </a:spcBef>
             </a:pPr>
             <a:r>
-              <a:rPr sz="1800">
+              <a:rPr sz="1500">
                 <a:solidFill>
                   <a:srgbClr val="232A33"/>
                 </a:solidFill>
                 <a:latin typeface="Calibri"/>
               </a:rPr>
-              <a:t>Synergy ratio:  </a:t>
-            </a:r>
-            <a:r>
-              <a:rPr sz="2200" b="1">
+              <a:t>Observed when combined  (d):  </a:t>
+            </a:r>
+            <a:r>
+              <a:rPr sz="2000" b="1">
                 <a:solidFill>
                   <a:srgbClr val="1F8E4F"/>
                 </a:solidFill>
                 <a:latin typeface="Calibri"/>
               </a:rPr>
-              <a:t>4.93×</a:t>
+              <a:t>+0.322</a:t>
+            </a:r>
+            <a:r>
+              <a:rPr sz="1200" i="1">
+                <a:solidFill>
+                  <a:srgbClr val="5C6670"/>
+                </a:solidFill>
+                <a:latin typeface="Calibri"/>
+              </a:rPr>
+              <a:t>   ★</a:t>
             </a:r>
           </a:p>
           <a:p>
             <a:pPr>
               <a:spcBef>
-                <a:spcPts val="1800"/>
+                <a:spcPts val="700"/>
               </a:spcBef>
             </a:pPr>
             <a:r>
-              <a:rPr sz="1500" i="1">
+              <a:rPr sz="1500">
+                <a:solidFill>
+                  <a:srgbClr val="232A33"/>
+                </a:solidFill>
+                <a:latin typeface="Calibri"/>
+              </a:rPr>
+              <a:t>Synergy ratio over additive:  </a:t>
+            </a:r>
+            <a:r>
+              <a:rPr sz="2000" b="1">
+                <a:solidFill>
+                  <a:srgbClr val="1F8E4F"/>
+                </a:solidFill>
+                <a:latin typeface="Calibri"/>
+              </a:rPr>
+              <a:t>4.93×</a:t>
+            </a:r>
+            <a:r>
+              <a:rPr sz="1200" i="1">
                 <a:solidFill>
                   <a:srgbClr val="5C6670"/>
                 </a:solidFill>
                 <a:latin typeface="Calibri"/>
               </a:rPr>
-              <a:t>The cross-coupling is the active mechanism — not either ingredient alone.</a:t>
+              <a:t>   interaction, not sum</a:t>
+            </a:r>
+          </a:p>
+          <a:p>
+            <a:pPr>
+              <a:spcBef>
+                <a:spcPts val="1400"/>
+              </a:spcBef>
+            </a:pPr>
+            <a:r>
+              <a:rPr sz="1400" i="1">
+                <a:solidFill>
+                  <a:srgbClr val="232A33"/>
+                </a:solidFill>
+                <a:latin typeface="Calibri"/>
+              </a:rPr>
+              <a:t>5× data alone barely beats naive SFT.  The cross-coupling is the active mechanism, not the data volume.</a:t>
             </a:r>
           </a:p>
         </p:txBody>
@@ -9478,7 +9539,7 @@
                 </a:solidFill>
                 <a:latin typeface="Calibri"/>
               </a:rPr>
-              <a:t>Is the synergy real or just data volume? Compute-matched contrasts</a:t>
+              <a:t>Ruling out the 'just more data' explanation</a:t>
             </a:r>
           </a:p>
         </p:txBody>
@@ -9492,7 +9553,7 @@
         <p:spPr>
           <a:xfrm>
             <a:off x="548640" y="914400"/>
-            <a:ext cx="11064240" cy="914400"/>
+            <a:ext cx="11064240" cy="1005840"/>
           </a:xfrm>
           <a:prstGeom prst="rect">
             <a:avLst/>
@@ -9515,7 +9576,16 @@
                 </a:solidFill>
                 <a:latin typeface="Calibri"/>
               </a:rPr>
-              <a:t>K=5 conditions see 5× the per-round training data, so the marginal (b) − (a) is data-confounded. Holding the data-volume axis fixed and toggling KL gives the clean comparison.</a:t>
+              <a:t>To rule out 'data dominates,' hold data volume fixed and toggle KL preservation. </a:t>
+            </a:r>
+            <a:r>
+              <a:rPr sz="1600" i="1">
+                <a:solidFill>
+                  <a:srgbClr val="232A33"/>
+                </a:solidFill>
+                <a:latin typeface="Calibri"/>
+              </a:rPr>
+              <a:t>If KL contributed a fixed lift independent of data volume, both rows below would show similar Δ abs F1.</a:t>
             </a:r>
           </a:p>
         </p:txBody>
@@ -9558,7 +9628,7 @@
                           </a:solidFill>
                           <a:latin typeface="Calibri"/>
                         </a:rPr>
-                        <a:t>Contrast</a:t>
+                        <a:t>Contrast (compute-matched)</a:t>
                       </a:r>
                     </a:p>
                   </a:txBody>
@@ -9815,7 +9885,7 @@
                           </a:solidFill>
                           <a:latin typeface="Calibri"/>
                         </a:rPr>
-                        <a:t>10× larger</a:t>
+                        <a:t>≈10× larger</a:t>
                       </a:r>
                     </a:p>
                   </a:txBody>
@@ -9838,15 +9908,19 @@
         </p:nvSpPr>
         <p:spPr>
           <a:xfrm>
-            <a:off x="548640" y="5029200"/>
-            <a:ext cx="11064240" cy="1371600"/>
+            <a:off x="548640" y="4572000"/>
+            <a:ext cx="11064240" cy="1280160"/>
           </a:xfrm>
           <a:prstGeom prst="rect">
             <a:avLst/>
           </a:prstGeom>
-          <a:noFill/>
-          <a:ln>
-            <a:noFill/>
+          <a:solidFill>
+            <a:srgbClr val="FDF7EF"/>
+          </a:solidFill>
+          <a:ln w="12700">
+            <a:solidFill>
+              <a:srgbClr val="E8C89C"/>
+            </a:solidFill>
           </a:ln>
         </p:spPr>
         <p:txBody>
@@ -9856,13 +9930,38 @@
           <a:lstStyle/>
           <a:p>
             <a:r>
-              <a:rPr sz="1600">
+              <a:rPr sz="1800" b="1">
+                <a:solidFill>
+                  <a:srgbClr val="C0392B"/>
+                </a:solidFill>
+                <a:latin typeface="Calibri"/>
+              </a:rPr>
+              <a:t>Conclusion:  </a:t>
+            </a:r>
+            <a:r>
+              <a:rPr sz="1800">
                 <a:solidFill>
                   <a:srgbClr val="232A33"/>
                 </a:solidFill>
                 <a:latin typeface="Calibri"/>
               </a:rPr>
-              <a:t>The interaction is sharp regardless of which compute-matched slice you read: KL preservation is ~10× more effective when paired with K=5 augmentation than alone.</a:t>
+              <a:t>KL is ~10× more effective when paired with K=5 data than added on top of K=1 data alone.</a:t>
+            </a:r>
+          </a:p>
+          <a:p>
+            <a:pPr>
+              <a:spcBef>
+                <a:spcPts val="600"/>
+              </a:spcBef>
+            </a:pPr>
+            <a:r>
+              <a:rPr sz="1400" i="1">
+                <a:solidFill>
+                  <a:srgbClr val="232A33"/>
+                </a:solidFill>
+                <a:latin typeface="Calibri"/>
+              </a:rPr>
+              <a:t>This is the signature of an interaction effect, not a data-volume effect.  More data alone gives +0.036 (b) − (a); more data plus KL gives +0.322.</a:t>
             </a:r>
           </a:p>
         </p:txBody>

</xml_diff>

<commit_message>
tweak: deck — disambiguate K (augmentation K=5 vs V-REx K=2 vs COPR K=8); show absolute SFT numbers on headline panel
</commit_message>
<xml_diff>
--- a/paper_slides/synergy_deck.pptx
+++ b/paper_slides/synergy_deck.pptx
@@ -4278,14 +4278,14 @@
           <a:p>
             <a:pPr>
               <a:lnSpc>
-                <a:spcPct val="115000"/>
+                <a:spcPct val="113000"/>
               </a:lnSpc>
               <a:spcAft>
                 <a:spcPts val="600"/>
               </a:spcAft>
             </a:pPr>
             <a:r>
-              <a:rPr sz="1600" b="1">
+              <a:rPr sz="1500" b="1">
                 <a:solidFill>
                   <a:srgbClr val="1F4E90"/>
                 </a:solidFill>
@@ -4294,7 +4294,7 @@
               <a:t>•  </a:t>
             </a:r>
             <a:r>
-              <a:rPr sz="1600">
+              <a:rPr sz="1500">
                 <a:solidFill>
                   <a:srgbClr val="232A33"/>
                 </a:solidFill>
@@ -4306,14 +4306,14 @@
           <a:p>
             <a:pPr lvl="1">
               <a:lnSpc>
-                <a:spcPct val="115000"/>
+                <a:spcPct val="113000"/>
               </a:lnSpc>
               <a:spcAft>
                 <a:spcPts val="600"/>
               </a:spcAft>
             </a:pPr>
             <a:r>
-              <a:rPr sz="1600" b="1">
+              <a:rPr sz="1500" b="1">
                 <a:solidFill>
                   <a:srgbClr val="1F4E90"/>
                 </a:solidFill>
@@ -4322,26 +4322,26 @@
               <a:t>–  </a:t>
             </a:r>
             <a:r>
-              <a:rPr sz="1600">
+              <a:rPr sz="1500">
                 <a:solidFill>
                   <a:srgbClr val="232A33"/>
                 </a:solidFill>
                 <a:latin typeface="Calibri"/>
               </a:rPr>
-              <a:t>kl_reg_sft wins absorption against copr_gold_injection in 11 of 14 contested rounds; COPR's K=8 self-samples on a novel fact land below a usable F1 threshold (the K-sample-all-wrong pathology), and the natural patch (gold injection) collapses the method toward cross-entropy at 10–12× per-round compute.</a:t>
+              <a:t>kl_reg_sft wins absorption against copr_gold_injection in 11 of 14 contested rounds. COPR draws K=8 candidate responses per fact (here K = number of self-sampled candidates) and ranks them via MSE; on novel facts, the K=8 candidates all land below a usable F1 threshold (the K-sample-all-wrong pathology), so the rank fit reinforces plausible-but-wrong answers. Gold injection collapses the method toward cross-entropy at 10–12× per-round compute.</a:t>
             </a:r>
           </a:p>
           <a:p>
             <a:pPr>
               <a:lnSpc>
-                <a:spcPct val="115000"/>
+                <a:spcPct val="113000"/>
               </a:lnSpc>
               <a:spcAft>
                 <a:spcPts val="600"/>
               </a:spcAft>
             </a:pPr>
             <a:r>
-              <a:rPr sz="1600" b="1">
+              <a:rPr sz="1500" b="1">
                 <a:solidFill>
                   <a:srgbClr val="1F4E90"/>
                 </a:solidFill>
@@ -4350,7 +4350,7 @@
               <a:t>•  </a:t>
             </a:r>
             <a:r>
-              <a:rPr sz="1600">
+              <a:rPr sz="1500">
                 <a:solidFill>
                   <a:srgbClr val="232A33"/>
                 </a:solidFill>
@@ -4362,14 +4362,14 @@
           <a:p>
             <a:pPr lvl="1">
               <a:lnSpc>
-                <a:spcPct val="115000"/>
+                <a:spcPct val="113000"/>
               </a:lnSpc>
               <a:spcAft>
                 <a:spcPts val="600"/>
               </a:spcAft>
             </a:pPr>
             <a:r>
-              <a:rPr sz="1600" b="1">
+              <a:rPr sz="1500" b="1">
                 <a:solidFill>
                   <a:srgbClr val="1F4E90"/>
                 </a:solidFill>
@@ -4378,26 +4378,26 @@
               <a:t>–  </a:t>
             </a:r>
             <a:r>
-              <a:rPr sz="1600">
+              <a:rPr sz="1500">
                 <a:solidFill>
                   <a:srgbClr val="232A33"/>
                 </a:solidFill>
                 <a:latin typeface="Calibri"/>
               </a:rPr>
-              <a:t>IRM-family penalties require ≥3 environments (Arjovsky 2019; Rosenfeld 2021; Ahuja 2021); at K=2 the variance term reduces to a pairwise scalar consistency satisfiable by any equalizing solution. Empirically: +0.014 QD F1 within run-to-run noise.</a:t>
+              <a:t>Here K = number of prompt-format environments (a different K from the augmentation K — this is the IRM/V-REx sense). IRM-family penalties require ≥3 environments (Arjovsky 2019; Rosenfeld 2021; Ahuja 2021). At K=2 the variance term reduces to a pairwise scalar consistency satisfiable by any equalizing solution. Empirically: +0.014 QD F1, within run-to-run noise.</a:t>
             </a:r>
           </a:p>
           <a:p>
             <a:pPr>
               <a:lnSpc>
-                <a:spcPct val="115000"/>
+                <a:spcPct val="113000"/>
               </a:lnSpc>
               <a:spcAft>
                 <a:spcPts val="600"/>
               </a:spcAft>
             </a:pPr>
             <a:r>
-              <a:rPr sz="1600" b="1">
+              <a:rPr sz="1500" b="1">
                 <a:solidFill>
                   <a:srgbClr val="1F4E90"/>
                 </a:solidFill>
@@ -4406,7 +4406,7 @@
               <a:t>•  </a:t>
             </a:r>
             <a:r>
-              <a:rPr sz="1600">
+              <a:rPr sz="1500">
                 <a:solidFill>
                   <a:srgbClr val="232A33"/>
                 </a:solidFill>
@@ -4418,14 +4418,14 @@
           <a:p>
             <a:pPr lvl="1">
               <a:lnSpc>
-                <a:spcPct val="115000"/>
+                <a:spcPct val="113000"/>
               </a:lnSpc>
               <a:spcAft>
                 <a:spcPts val="600"/>
               </a:spcAft>
             </a:pPr>
             <a:r>
-              <a:rPr sz="1600" b="1">
+              <a:rPr sz="1500" b="1">
                 <a:solidFill>
                   <a:srgbClr val="1F4E90"/>
                 </a:solidFill>
@@ -4434,13 +4434,13 @@
               <a:t>–  </a:t>
             </a:r>
             <a:r>
-              <a:rPr sz="1600">
+              <a:rPr sz="1500">
                 <a:solidFill>
                   <a:srgbClr val="232A33"/>
                 </a:solidFill>
                 <a:latin typeface="Calibri"/>
               </a:rPr>
-              <a:t>Plain mixed-format SFT widens the format gap to 0.100 vs single-format kl_reg_sft 0.072. Format mixing in continual training requires curriculum, unified rewriting, or — as we show — a preservation-side regularizer.</a:t>
+              <a:t>Plain mixed-format SFT widens the format gap to 0.100 vs single-format kl_reg_sft 0.072. Format mixing in continual training requires curriculum, unified rewriting, or — as we show in §4 — a preservation-side regularizer paired with K=5 augmentation on the injection side.</a:t>
             </a:r>
           </a:p>
         </p:txBody>
@@ -8458,7 +8458,57 @@
         <p:spPr>
           <a:xfrm>
             <a:off x="548640" y="5349240"/>
-            <a:ext cx="11064240" cy="914400"/>
+            <a:ext cx="11064240" cy="594360"/>
+          </a:xfrm>
+          <a:prstGeom prst="rect">
+            <a:avLst/>
+          </a:prstGeom>
+          <a:solidFill>
+            <a:srgbClr val="F7F9FC"/>
+          </a:solidFill>
+          <a:ln w="12700">
+            <a:solidFill>
+              <a:srgbClr val="CFD8E3"/>
+            </a:solidFill>
+          </a:ln>
+        </p:spPr>
+        <p:txBody>
+          <a:bodyPr wrap="square" lIns="45720" rIns="45720" tIns="27432" bIns="27432">
+            <a:spAutoFit/>
+          </a:bodyPr>
+          <a:lstStyle/>
+          <a:p>
+            <a:r>
+              <a:rPr sz="1200" b="1">
+                <a:solidFill>
+                  <a:srgbClr val="1F4E90"/>
+                </a:solidFill>
+                <a:latin typeface="Calibri"/>
+              </a:rPr>
+              <a:t>Notation:  </a:t>
+            </a:r>
+            <a:r>
+              <a:rPr sz="1100">
+                <a:solidFill>
+                  <a:srgbClr val="232A33"/>
+                </a:solidFill>
+                <a:latin typeface="Calibri"/>
+              </a:rPr>
+              <a:t>K = number of paraphrastic surface forms per fact (Allen-Zhu &amp; Li 2023). K=1 → one template (QA only).  K=5 → five templates (QA, QD, declarative, instruction, narrative).  On the preservation side: K = number of instruction framings of the same task prompt (used in (e) only).</a:t>
+            </a:r>
+          </a:p>
+        </p:txBody>
+      </p:sp>
+      <p:sp>
+        <p:nvSpPr>
+          <p:cNvPr id="7" name="TextBox 6"/>
+          <p:cNvSpPr txBox="1"/>
+          <p:nvPr/>
+        </p:nvSpPr>
+        <p:spPr>
+          <a:xfrm>
+            <a:off x="548640" y="5989320"/>
+            <a:ext cx="11064240" cy="365760"/>
           </a:xfrm>
           <a:prstGeom prst="rect">
             <a:avLst/>
@@ -8475,36 +8525,29 @@
           <a:lstStyle/>
           <a:p>
             <a:r>
-              <a:rPr sz="1400">
+              <a:rPr sz="1300">
                 <a:solidFill>
                   <a:srgbClr val="232A33"/>
                 </a:solidFill>
                 <a:latin typeface="Calibri"/>
               </a:rPr>
-              <a:t>Plus the COPR family (preference-style baselines): plain copr, copr_gold_injection, copr_gold_injection_anchored, copr_anchored.</a:t>
-            </a:r>
-          </a:p>
-          <a:p>
-            <a:pPr>
-              <a:spcBef>
-                <a:spcPts val="600"/>
-              </a:spcBef>
-            </a:pPr>
-            <a:r>
-              <a:rPr sz="1300" i="1">
+              <a:t>Plus the COPR family (preference-style baselines): copr, copr_gold_injection, copr_gold_injection_anchored, copr_anchored.   </a:t>
+            </a:r>
+            <a:r>
+              <a:rPr sz="1200" i="1">
                 <a:solidFill>
                   <a:srgbClr val="5C6670"/>
                 </a:solidFill>
                 <a:latin typeface="Calibri"/>
               </a:rPr>
-              <a:t>Sequential editing: 15 rounds × 200 facts × 2 seeds for new conditions; condition (c) reused from prior phases at 1 seed as calibration.</a:t>
-            </a:r>
-          </a:p>
-        </p:txBody>
-      </p:sp>
-      <p:sp>
-        <p:nvSpPr>
-          <p:cNvPr id="7" name="TextBox 6"/>
+              <a:t>15 rounds × 200 facts × 2 seeds for new conditions; (c) at 1 seed from prior phases.</a:t>
+            </a:r>
+          </a:p>
+        </p:txBody>
+      </p:sp>
+      <p:sp>
+        <p:nvSpPr>
+          <p:cNvPr id="8" name="TextBox 7"/>
           <p:cNvSpPr txBox="1"/>
           <p:nvPr/>
         </p:nvSpPr>
@@ -8545,7 +8588,7 @@
       </p:sp>
       <p:sp>
         <p:nvSpPr>
-          <p:cNvPr id="8" name="TextBox 7"/>
+          <p:cNvPr id="9" name="TextBox 8"/>
           <p:cNvSpPr txBox="1"/>
           <p:nvPr/>
         </p:nvSpPr>
@@ -9168,13 +9211,13 @@
               </a:spcBef>
             </a:pPr>
             <a:r>
-              <a:rPr sz="1400" i="1">
+              <a:rPr sz="1300" i="1">
                 <a:solidFill>
                   <a:srgbClr val="5C6670"/>
                 </a:solidFill>
                 <a:latin typeface="Calibri"/>
               </a:rPr>
-              <a:t>K=5 conditions see 5× the training data, so a 'data dominates' story would predict K=5 wins on its own.</a:t>
+              <a:t>K=5 conditions see 5× the per-round training data, so a 'data dominates' story would predict K=5 wins on its own.</a:t>
             </a:r>
           </a:p>
           <a:p>
@@ -9184,13 +9227,13 @@
               </a:spcBef>
             </a:pPr>
             <a:r>
-              <a:rPr sz="1500">
+              <a:rPr sz="1400">
                 <a:solidFill>
                   <a:srgbClr val="232A33"/>
                 </a:solidFill>
                 <a:latin typeface="Calibri"/>
               </a:rPr>
-              <a:t>Just 5× more data  (b):  </a:t>
+              <a:t>naive SFT  (a):  </a:t>
             </a:r>
             <a:r>
               <a:rPr sz="2000" b="1">
@@ -9199,16 +9242,16 @@
                 </a:solidFill>
                 <a:latin typeface="Calibri"/>
               </a:rPr>
-              <a:t>+0.036</a:t>
-            </a:r>
-            <a:r>
-              <a:rPr sz="1200" i="1">
+              <a:t>0.089</a:t>
+            </a:r>
+            <a:r>
+              <a:rPr sz="1100" i="1">
                 <a:solidFill>
                   <a:srgbClr val="5C6670"/>
                 </a:solidFill>
                 <a:latin typeface="Calibri"/>
               </a:rPr>
-              <a:t>   small</a:t>
+              <a:t>   K=1 baseline</a:t>
             </a:r>
           </a:p>
           <a:p>
@@ -9218,13 +9261,13 @@
               </a:spcBef>
             </a:pPr>
             <a:r>
-              <a:rPr sz="1500">
+              <a:rPr sz="1400">
                 <a:solidFill>
                   <a:srgbClr val="232A33"/>
                 </a:solidFill>
                 <a:latin typeface="Calibri"/>
               </a:rPr>
-              <a:t>Just KL preservation  (c):  </a:t>
+              <a:t>+ 5× paraphrastic data  (b):  </a:t>
             </a:r>
             <a:r>
               <a:rPr sz="2000" b="1">
@@ -9233,16 +9276,16 @@
                 </a:solidFill>
                 <a:latin typeface="Calibri"/>
               </a:rPr>
-              <a:t>+0.029</a:t>
-            </a:r>
-            <a:r>
-              <a:rPr sz="1200" i="1">
+              <a:t>0.125</a:t>
+            </a:r>
+            <a:r>
+              <a:rPr sz="1100" i="1">
                 <a:solidFill>
                   <a:srgbClr val="5C6670"/>
                 </a:solidFill>
                 <a:latin typeface="Calibri"/>
               </a:rPr>
-              <a:t>   small</a:t>
+              <a:t>   Δ = +0.036  (small)</a:t>
             </a:r>
           </a:p>
           <a:p>
@@ -9252,31 +9295,31 @@
               </a:spcBef>
             </a:pPr>
             <a:r>
-              <a:rPr sz="1500">
+              <a:rPr sz="1400">
                 <a:solidFill>
                   <a:srgbClr val="232A33"/>
                 </a:solidFill>
                 <a:latin typeface="Calibri"/>
               </a:rPr>
-              <a:t>Naive additive prediction:  </a:t>
+              <a:t>naive SFT + KL preservation  (c):  </a:t>
             </a:r>
             <a:r>
               <a:rPr sz="2000" b="1">
                 <a:solidFill>
+                  <a:srgbClr val="1F4E90"/>
+                </a:solidFill>
+                <a:latin typeface="Calibri"/>
+              </a:rPr>
+              <a:t>0.118</a:t>
+            </a:r>
+            <a:r>
+              <a:rPr sz="1100" i="1">
+                <a:solidFill>
                   <a:srgbClr val="5C6670"/>
                 </a:solidFill>
                 <a:latin typeface="Calibri"/>
               </a:rPr>
-              <a:t>+0.065</a:t>
-            </a:r>
-            <a:r>
-              <a:rPr sz="1200" i="1">
-                <a:solidFill>
-                  <a:srgbClr val="5C6670"/>
-                </a:solidFill>
-                <a:latin typeface="Calibri"/>
-              </a:rPr>
-              <a:t>   if independent</a:t>
+              <a:t>   Δ = +0.029  (small)</a:t>
             </a:r>
           </a:p>
           <a:p>
@@ -9286,13 +9329,13 @@
               </a:spcBef>
             </a:pPr>
             <a:r>
-              <a:rPr sz="1500">
+              <a:rPr sz="1400">
                 <a:solidFill>
                   <a:srgbClr val="232A33"/>
                 </a:solidFill>
                 <a:latin typeface="Calibri"/>
               </a:rPr>
-              <a:t>Observed when combined  (d):  </a:t>
+              <a:t>5× data + KL  (d):  </a:t>
             </a:r>
             <a:r>
               <a:rPr sz="2000" b="1">
@@ -9301,32 +9344,52 @@
                 </a:solidFill>
                 <a:latin typeface="Calibri"/>
               </a:rPr>
-              <a:t>+0.322</a:t>
-            </a:r>
-            <a:r>
-              <a:rPr sz="1200" i="1">
+              <a:t>0.411</a:t>
+            </a:r>
+            <a:r>
+              <a:rPr sz="1100" i="1">
                 <a:solidFill>
                   <a:srgbClr val="5C6670"/>
                 </a:solidFill>
                 <a:latin typeface="Calibri"/>
               </a:rPr>
-              <a:t>   ★</a:t>
+              <a:t>   Δ = +0.322  ★</a:t>
             </a:r>
           </a:p>
           <a:p>
             <a:pPr>
               <a:spcBef>
-                <a:spcPts val="700"/>
+                <a:spcPts val="1200"/>
               </a:spcBef>
             </a:pPr>
             <a:r>
-              <a:rPr sz="1500">
+              <a:rPr sz="1400">
                 <a:solidFill>
                   <a:srgbClr val="232A33"/>
                 </a:solidFill>
                 <a:latin typeface="Calibri"/>
               </a:rPr>
-              <a:t>Synergy ratio over additive:  </a:t>
+              <a:t>Naive additive prediction:  </a:t>
+            </a:r>
+            <a:r>
+              <a:rPr sz="1800" b="1">
+                <a:solidFill>
+                  <a:srgbClr val="5C6670"/>
+                </a:solidFill>
+                <a:latin typeface="Calibri"/>
+              </a:rPr>
+              <a:t>+0.065</a:t>
+            </a:r>
+          </a:p>
+          <a:p>
+            <a:r>
+              <a:rPr sz="1400">
+                <a:solidFill>
+                  <a:srgbClr val="232A33"/>
+                </a:solidFill>
+                <a:latin typeface="Calibri"/>
+              </a:rPr>
+              <a:t>Observed combined:  </a:t>
             </a:r>
             <a:r>
               <a:rPr sz="2000" b="1">
@@ -9335,32 +9398,32 @@
                 </a:solidFill>
                 <a:latin typeface="Calibri"/>
               </a:rPr>
-              <a:t>4.93×</a:t>
-            </a:r>
-            <a:r>
-              <a:rPr sz="1200" i="1">
-                <a:solidFill>
-                  <a:srgbClr val="5C6670"/>
-                </a:solidFill>
-                <a:latin typeface="Calibri"/>
-              </a:rPr>
-              <a:t>   interaction, not sum</a:t>
+              <a:t>+0.322</a:t>
+            </a:r>
+            <a:r>
+              <a:rPr sz="1400" i="1">
+                <a:solidFill>
+                  <a:srgbClr val="1F8E4F"/>
+                </a:solidFill>
+                <a:latin typeface="Calibri"/>
+              </a:rPr>
+              <a:t>   →   4.93× synergy ratio</a:t>
             </a:r>
           </a:p>
           <a:p>
             <a:pPr>
               <a:spcBef>
-                <a:spcPts val="1400"/>
+                <a:spcPts val="1000"/>
               </a:spcBef>
             </a:pPr>
             <a:r>
-              <a:rPr sz="1400" i="1">
+              <a:rPr sz="1300" i="1">
                 <a:solidFill>
                   <a:srgbClr val="232A33"/>
                 </a:solidFill>
                 <a:latin typeface="Calibri"/>
               </a:rPr>
-              <a:t>5× data alone barely beats naive SFT.  The cross-coupling is the active mechanism, not the data volume.</a:t>
+              <a:t>5× data alone barely beats naive SFT (0.089 → 0.125).  The cross-coupling is the active mechanism, not the data volume.</a:t>
             </a:r>
           </a:p>
         </p:txBody>

</xml_diff>

<commit_message>
tweak: deck — show concrete K=5 instruction framings on (e) slide
</commit_message>
<xml_diff>
--- a/paper_slides/synergy_deck.pptx
+++ b/paper_slides/synergy_deck.pptx
@@ -4632,8 +4632,8 @@
         </p:nvSpPr>
         <p:spPr>
           <a:xfrm>
-            <a:off x="548640" y="914400"/>
-            <a:ext cx="11064240" cy="1280160"/>
+            <a:off x="548640" y="868680"/>
+            <a:ext cx="11064240" cy="548640"/>
           </a:xfrm>
           <a:prstGeom prst="rect">
             <a:avLst/>
@@ -4650,22 +4650,22 @@
           <a:lstStyle/>
           <a:p>
             <a:r>
-              <a:rPr sz="1800" b="1">
+              <a:rPr sz="1500" b="1">
                 <a:solidFill>
                   <a:srgbClr val="1F4E90"/>
                 </a:solidFill>
                 <a:latin typeface="Calibri"/>
               </a:rPr>
-              <a:t>Hypothesis we tested: </a:t>
-            </a:r>
-            <a:r>
-              <a:rPr sz="1800">
+              <a:t>Hypothesis: </a:t>
+            </a:r>
+            <a:r>
+              <a:rPr sz="1500">
                 <a:solidFill>
                   <a:srgbClr val="232A33"/>
                 </a:solidFill>
                 <a:latin typeface="Calibri"/>
               </a:rPr>
-              <a:t>single-format KL preservation might fail to detect format-selective forgetting (drift in one preservation framing not visible under another). Augmenting the preservation side with K=5 framings should catch it.</a:t>
+              <a:t>single-format KL preservation might fail to detect format-selective forgetting. Augmenting the preservation side with K=5 framings should catch it.</a:t>
             </a:r>
           </a:p>
         </p:txBody>
@@ -4678,8 +4678,183 @@
         </p:nvSpPr>
         <p:spPr>
           <a:xfrm>
-            <a:off x="1371600" y="2423160"/>
-            <a:ext cx="9418320" cy="1554480"/>
+            <a:off x="548640" y="1463040"/>
+            <a:ext cx="11064240" cy="2011680"/>
+          </a:xfrm>
+          <a:prstGeom prst="rect">
+            <a:avLst/>
+          </a:prstGeom>
+          <a:solidFill>
+            <a:srgbClr val="F7F9FC"/>
+          </a:solidFill>
+          <a:ln w="12700">
+            <a:solidFill>
+              <a:srgbClr val="CFD8E3"/>
+            </a:solidFill>
+          </a:ln>
+        </p:spPr>
+        <p:txBody>
+          <a:bodyPr wrap="square" lIns="45720" rIns="45720" tIns="27432" bIns="27432">
+            <a:spAutoFit/>
+          </a:bodyPr>
+          <a:lstStyle/>
+          <a:p>
+            <a:r>
+              <a:rPr sz="1300" b="1">
+                <a:solidFill>
+                  <a:srgbClr val="1F4E90"/>
+                </a:solidFill>
+                <a:latin typeface="Calibri"/>
+              </a:rPr>
+              <a:t>The K=5 preservation framings </a:t>
+            </a:r>
+            <a:r>
+              <a:rPr sz="1200" i="1">
+                <a:solidFill>
+                  <a:srgbClr val="232A33"/>
+                </a:solidFill>
+                <a:latin typeface="Calibri"/>
+              </a:rPr>
+              <a:t>applied to the same task prompt   "What should I know about Acme Corp's recent activity?"</a:t>
+            </a:r>
+          </a:p>
+          <a:p>
+            <a:pPr>
+              <a:spcBef>
+                <a:spcPts val="200"/>
+              </a:spcBef>
+            </a:pPr>
+            <a:r>
+              <a:rPr sz="1100" b="1">
+                <a:solidFill>
+                  <a:srgbClr val="1F4E90"/>
+                </a:solidFill>
+                <a:latin typeface="Calibri"/>
+              </a:rPr>
+              <a:t>  Original:  </a:t>
+            </a:r>
+            <a:r>
+              <a:rPr sz="1000">
+                <a:solidFill>
+                  <a:srgbClr val="232A33"/>
+                </a:solidFill>
+                <a:latin typeface="Consolas"/>
+              </a:rPr>
+              <a:t>[system: QD-decomposer]  [user: What should I know about Acme Corp's recent activity?]</a:t>
+            </a:r>
+          </a:p>
+          <a:p>
+            <a:pPr>
+              <a:spcBef>
+                <a:spcPts val="200"/>
+              </a:spcBef>
+            </a:pPr>
+            <a:r>
+              <a:rPr sz="1100" b="1">
+                <a:solidFill>
+                  <a:srgbClr val="1F4E90"/>
+                </a:solidFill>
+                <a:latin typeface="Calibri"/>
+              </a:rPr>
+              <a:t>  Bare:  </a:t>
+            </a:r>
+            <a:r>
+              <a:rPr sz="1000">
+                <a:solidFill>
+                  <a:srgbClr val="232A33"/>
+                </a:solidFill>
+                <a:latin typeface="Consolas"/>
+              </a:rPr>
+              <a:t>[user: What should I know about Acme Corp's recent activity?]   (no system prompt)</a:t>
+            </a:r>
+          </a:p>
+          <a:p>
+            <a:pPr>
+              <a:spcBef>
+                <a:spcPts val="200"/>
+              </a:spcBef>
+            </a:pPr>
+            <a:r>
+              <a:rPr sz="1100" b="1">
+                <a:solidFill>
+                  <a:srgbClr val="1F4E90"/>
+                </a:solidFill>
+                <a:latin typeface="Calibri"/>
+              </a:rPr>
+              <a:t>  Analyst:  </a:t>
+            </a:r>
+            <a:r>
+              <a:rPr sz="1000">
+                <a:solidFill>
+                  <a:srgbClr val="232A33"/>
+                </a:solidFill>
+                <a:latin typeface="Consolas"/>
+              </a:rPr>
+              <a:t>[user: You are a financial analyst. Answer concisely: What should I know about Acme Corp's recent activity?]</a:t>
+            </a:r>
+          </a:p>
+          <a:p>
+            <a:pPr>
+              <a:spcBef>
+                <a:spcPts val="200"/>
+              </a:spcBef>
+            </a:pPr>
+            <a:r>
+              <a:rPr sz="1100" b="1">
+                <a:solidFill>
+                  <a:srgbClr val="1F4E90"/>
+                </a:solidFill>
+                <a:latin typeface="Calibri"/>
+              </a:rPr>
+              <a:t>  Detailed:  </a:t>
+            </a:r>
+            <a:r>
+              <a:rPr sz="1000">
+                <a:solidFill>
+                  <a:srgbClr val="232A33"/>
+                </a:solidFill>
+                <a:latin typeface="Consolas"/>
+              </a:rPr>
+              <a:t>[user: Given the following question, provide a detailed response: What should I know about Acme Corp's recent activity?]</a:t>
+            </a:r>
+          </a:p>
+          <a:p>
+            <a:pPr>
+              <a:spcBef>
+                <a:spcPts val="200"/>
+              </a:spcBef>
+            </a:pPr>
+            <a:r>
+              <a:rPr sz="1100" b="1">
+                <a:solidFill>
+                  <a:srgbClr val="1F4E90"/>
+                </a:solidFill>
+                <a:latin typeface="Calibri"/>
+              </a:rPr>
+              <a:t>  Request:  </a:t>
+            </a:r>
+            <a:r>
+              <a:rPr sz="1000">
+                <a:solidFill>
+                  <a:srgbClr val="232A33"/>
+                </a:solidFill>
+                <a:latin typeface="Consolas"/>
+              </a:rPr>
+              <a:t>[user: Question: What should I know about Acme Corp's recent activity?  Please provide your analysis.]</a:t>
+            </a:r>
+          </a:p>
+        </p:txBody>
+      </p:sp>
+      <p:sp>
+        <p:nvSpPr>
+          <p:cNvPr id="6" name="TextBox 5"/>
+          <p:cNvSpPr txBox="1"/>
+          <p:nvPr/>
+        </p:nvSpPr>
+        <p:spPr>
+          <a:xfrm>
+            <a:off x="1371600" y="3611880"/>
+            <a:ext cx="9418320" cy="1280160"/>
           </a:xfrm>
           <a:prstGeom prst="rect">
             <a:avLst/>
@@ -4701,7 +4876,7 @@
           <a:p>
             <a:pPr algn="ctr"/>
             <a:r>
-              <a:rPr sz="2600" b="1">
+              <a:rPr sz="2200" b="1">
                 <a:solidFill>
                   <a:srgbClr val="C0392B"/>
                 </a:solidFill>
@@ -4713,31 +4888,31 @@
           <a:p>
             <a:pPr algn="ctr">
               <a:spcBef>
-                <a:spcPts val="800"/>
+                <a:spcPts val="600"/>
               </a:spcBef>
             </a:pPr>
             <a:r>
-              <a:rPr sz="1600">
+              <a:rPr sz="1400">
                 <a:solidFill>
                   <a:srgbClr val="232A33"/>
                 </a:solidFill>
                 <a:latin typeface="Calibri"/>
               </a:rPr>
-              <a:t>Trajectory-averaged Δ = −0.004.   95% interval [−0.030, +0.018] straddles zero.</a:t>
-            </a:r>
-          </a:p>
-        </p:txBody>
-      </p:sp>
-      <p:sp>
-        <p:nvSpPr>
-          <p:cNvPr id="6" name="TextBox 5"/>
+              <a:t>Trajectory Δ = −0.004.   95% interval [−0.030, +0.018] straddles zero.</a:t>
+            </a:r>
+          </a:p>
+        </p:txBody>
+      </p:sp>
+      <p:sp>
+        <p:nvSpPr>
+          <p:cNvPr id="7" name="TextBox 6"/>
           <p:cNvSpPr txBox="1"/>
           <p:nvPr/>
         </p:nvSpPr>
         <p:spPr>
           <a:xfrm>
-            <a:off x="548640" y="4297680"/>
-            <a:ext cx="11064240" cy="2011680"/>
+            <a:off x="548640" y="5029200"/>
+            <a:ext cx="11064240" cy="1371600"/>
           </a:xfrm>
           <a:prstGeom prst="rect">
             <a:avLst/>
@@ -4755,14 +4930,14 @@
           <a:p>
             <a:pPr>
               <a:lnSpc>
-                <a:spcPct val="115000"/>
+                <a:spcPct val="113000"/>
               </a:lnSpc>
               <a:spcAft>
                 <a:spcPts val="600"/>
               </a:spcAft>
             </a:pPr>
             <a:r>
-              <a:rPr sz="1500" b="1">
+              <a:rPr sz="1300" b="1">
                 <a:solidFill>
                   <a:srgbClr val="1F4E90"/>
                 </a:solidFill>
@@ -4771,7 +4946,7 @@
               <a:t>•  </a:t>
             </a:r>
             <a:r>
-              <a:rPr sz="1500">
+              <a:rPr sz="1300">
                 <a:solidFill>
                   <a:srgbClr val="232A33"/>
                 </a:solidFill>
@@ -4783,14 +4958,14 @@
           <a:p>
             <a:pPr>
               <a:lnSpc>
-                <a:spcPct val="115000"/>
+                <a:spcPct val="113000"/>
               </a:lnSpc>
               <a:spcAft>
                 <a:spcPts val="600"/>
               </a:spcAft>
             </a:pPr>
             <a:r>
-              <a:rPr sz="1500" b="1">
+              <a:rPr sz="1300" b="1">
                 <a:solidFill>
                   <a:srgbClr val="1F4E90"/>
                 </a:solidFill>
@@ -4799,26 +4974,26 @@
               <a:t>•  </a:t>
             </a:r>
             <a:r>
-              <a:rPr sz="1500">
+              <a:rPr sz="1300">
                 <a:solidFill>
                   <a:srgbClr val="232A33"/>
                 </a:solidFill>
                 <a:latin typeface="Calibri"/>
               </a:rPr>
-              <a:t>Why: K=5 augmentation on the injection side already broadcasts each update across format directions of the gradient; the LoRA update subspace is shared across formats, so single-framing KL implicitly anchors all directions the K=5 update can push.</a:t>
+              <a:t>Why: K=5 augmentation on the injection side already broadcasts each update across format directions of the gradient; LoRA's update subspace is shared across formats, so single-framing KL implicitly anchors all directions the K=5 update can push.</a:t>
             </a:r>
           </a:p>
           <a:p>
             <a:pPr>
               <a:lnSpc>
-                <a:spcPct val="115000"/>
+                <a:spcPct val="113000"/>
               </a:lnSpc>
               <a:spcAft>
                 <a:spcPts val="600"/>
               </a:spcAft>
             </a:pPr>
             <a:r>
-              <a:rPr sz="1500" b="1">
+              <a:rPr sz="1300" b="1">
                 <a:solidFill>
                   <a:srgbClr val="1F4E90"/>
                 </a:solidFill>
@@ -4827,20 +5002,20 @@
               <a:t>•  </a:t>
             </a:r>
             <a:r>
-              <a:rPr sz="1500">
+              <a:rPr sz="1300">
                 <a:solidFill>
                   <a:srgbClr val="232A33"/>
                 </a:solidFill>
                 <a:latin typeface="Calibri"/>
               </a:rPr>
-              <a:t>Caveat: this conjecture leans on LoRA's shared low-rank update subspace. At full fine-tuning, the symmetric extension may earn its keep — not validated.</a:t>
-            </a:r>
-          </a:p>
-        </p:txBody>
-      </p:sp>
-      <p:sp>
-        <p:nvSpPr>
-          <p:cNvPr id="7" name="TextBox 6"/>
+              <a:t>Caveat: this conjecture leans on LoRA's shared low-rank update subspace. At full fine-tuning the symmetric extension may earn its keep — not validated.</a:t>
+            </a:r>
+          </a:p>
+        </p:txBody>
+      </p:sp>
+      <p:sp>
+        <p:nvSpPr>
+          <p:cNvPr id="8" name="TextBox 7"/>
           <p:cNvSpPr txBox="1"/>
           <p:nvPr/>
         </p:nvSpPr>
@@ -4881,7 +5056,7 @@
       </p:sp>
       <p:sp>
         <p:nvSpPr>
-          <p:cNvPr id="8" name="TextBox 7"/>
+          <p:cNvPr id="9" name="TextBox 8"/>
           <p:cNvSpPr txBox="1"/>
           <p:nvPr/>
         </p:nvSpPr>

</xml_diff>

<commit_message>
task: deck — add concrete K=1 vs K=5 rendering example slide for one fact
</commit_message>
<xml_diff>
--- a/paper_slides/synergy_deck.pptx
+++ b/paper_slides/synergy_deck.pptx
@@ -20,6 +20,7 @@
     <p:sldId id="268" r:id="rId19"/>
     <p:sldId id="269" r:id="rId20"/>
     <p:sldId id="270" r:id="rId21"/>
+    <p:sldId id="271" r:id="rId22"/>
   </p:sldIdLst>
   <p:sldSz cx="12191695" cy="6858000" type="screen4x3"/>
   <p:notesSz cx="6858000" cy="9144000"/>
@@ -3315,6 +3316,607 @@
 </file>
 
 <file path=ppt/slides/slide10.xml><?xml version="1.0" encoding="utf-8"?>
+<p:sld xmlns:a="http://schemas.openxmlformats.org/drawingml/2006/main" xmlns:p="http://schemas.openxmlformats.org/presentationml/2006/main" xmlns:r="http://schemas.openxmlformats.org/officeDocument/2006/relationships">
+  <p:cSld>
+    <p:spTree>
+      <p:nvGrpSpPr>
+        <p:cNvPr id="1" name=""/>
+        <p:cNvGrpSpPr/>
+        <p:nvPr/>
+      </p:nvGrpSpPr>
+      <p:grpSpPr/>
+      <p:sp>
+        <p:nvSpPr>
+          <p:cNvPr id="2" name="Rectangle 1"/>
+          <p:cNvSpPr/>
+          <p:nvPr/>
+        </p:nvSpPr>
+        <p:spPr>
+          <a:xfrm>
+            <a:off x="0" y="0"/>
+            <a:ext cx="12191695" cy="777240"/>
+          </a:xfrm>
+          <a:prstGeom prst="rect">
+            <a:avLst/>
+          </a:prstGeom>
+          <a:solidFill>
+            <a:srgbClr val="0F2A57"/>
+          </a:solidFill>
+          <a:ln>
+            <a:noFill/>
+          </a:ln>
+          <a:effectLst/>
+        </p:spPr>
+        <p:style>
+          <a:lnRef idx="1">
+            <a:schemeClr val="accent1"/>
+          </a:lnRef>
+          <a:fillRef idx="3">
+            <a:schemeClr val="accent1"/>
+          </a:fillRef>
+          <a:effectRef idx="2">
+            <a:schemeClr val="accent1"/>
+          </a:effectRef>
+          <a:fontRef idx="minor">
+            <a:schemeClr val="lt1"/>
+          </a:fontRef>
+        </p:style>
+        <p:txBody>
+          <a:bodyPr rtlCol="0" anchor="ctr"/>
+          <a:lstStyle/>
+          <a:p>
+            <a:pPr algn="ctr"/>
+          </a:p>
+        </p:txBody>
+      </p:sp>
+      <p:sp>
+        <p:nvSpPr>
+          <p:cNvPr id="3" name="TextBox 2"/>
+          <p:cNvSpPr txBox="1"/>
+          <p:nvPr/>
+        </p:nvSpPr>
+        <p:spPr>
+          <a:xfrm>
+            <a:off x="365760" y="109728"/>
+            <a:ext cx="11430000" cy="594360"/>
+          </a:xfrm>
+          <a:prstGeom prst="rect">
+            <a:avLst/>
+          </a:prstGeom>
+          <a:noFill/>
+          <a:ln>
+            <a:noFill/>
+          </a:ln>
+        </p:spPr>
+        <p:txBody>
+          <a:bodyPr wrap="square" lIns="45720" rIns="45720" tIns="27432" bIns="27432">
+            <a:spAutoFit/>
+          </a:bodyPr>
+          <a:lstStyle/>
+          <a:p>
+            <a:pPr algn="l"/>
+            <a:r>
+              <a:rPr sz="2800" b="1">
+                <a:solidFill>
+                  <a:srgbClr val="FFFFFF"/>
+                </a:solidFill>
+                <a:latin typeface="Calibri"/>
+              </a:rPr>
+              <a:t>Ruling out the 'just more data' explanation</a:t>
+            </a:r>
+          </a:p>
+        </p:txBody>
+      </p:sp>
+      <p:sp>
+        <p:nvSpPr>
+          <p:cNvPr id="4" name="TextBox 3"/>
+          <p:cNvSpPr txBox="1"/>
+          <p:nvPr/>
+        </p:nvSpPr>
+        <p:spPr>
+          <a:xfrm>
+            <a:off x="548640" y="914400"/>
+            <a:ext cx="11064240" cy="1005840"/>
+          </a:xfrm>
+          <a:prstGeom prst="rect">
+            <a:avLst/>
+          </a:prstGeom>
+          <a:noFill/>
+          <a:ln>
+            <a:noFill/>
+          </a:ln>
+        </p:spPr>
+        <p:txBody>
+          <a:bodyPr wrap="square" lIns="45720" rIns="45720" tIns="27432" bIns="27432">
+            <a:spAutoFit/>
+          </a:bodyPr>
+          <a:lstStyle/>
+          <a:p>
+            <a:r>
+              <a:rPr sz="1600">
+                <a:solidFill>
+                  <a:srgbClr val="232A33"/>
+                </a:solidFill>
+                <a:latin typeface="Calibri"/>
+              </a:rPr>
+              <a:t>To rule out 'data dominates,' hold data volume fixed and toggle KL preservation. </a:t>
+            </a:r>
+            <a:r>
+              <a:rPr sz="1600" i="1">
+                <a:solidFill>
+                  <a:srgbClr val="232A33"/>
+                </a:solidFill>
+                <a:latin typeface="Calibri"/>
+              </a:rPr>
+              <a:t>If KL contributed a fixed lift independent of data volume, both rows below would show similar Δ abs F1.</a:t>
+            </a:r>
+          </a:p>
+        </p:txBody>
+      </p:sp>
+      <p:graphicFrame>
+        <p:nvGraphicFramePr>
+          <p:cNvPr id="5" name="Table 4"/>
+          <p:cNvGraphicFramePr>
+            <a:graphicFrameLocks noGrp="1"/>
+          </p:cNvGraphicFramePr>
+          <p:nvPr/>
+        </p:nvGraphicFramePr>
+        <p:xfrm>
+          <a:off x="548640" y="2286000"/>
+          <a:ext cx="11064240" cy="2057400"/>
+        </p:xfrm>
+        <a:graphic>
+          <a:graphicData uri="http://schemas.openxmlformats.org/drawingml/2006/table">
+            <a:tbl>
+              <a:tblPr firstRow="1" bandRow="1">
+                <a:tableStyleId>{5C22544A-7EE6-4342-B048-85BDC9FD1C3A}</a:tableStyleId>
+              </a:tblPr>
+              <a:tblGrid>
+                <a:gridCol w="3657600"/>
+                <a:gridCol w="2377440"/>
+                <a:gridCol w="2377440"/>
+                <a:gridCol w="2651760"/>
+              </a:tblGrid>
+              <a:tr h="502920">
+                <a:tc>
+                  <a:txBody>
+                    <a:bodyPr wrap="square"/>
+                    <a:lstStyle/>
+                    <a:p>
+                      <a:pPr algn="l"/>
+                      <a:r>
+                        <a:rPr sz="1400" b="1" i="0">
+                          <a:solidFill>
+                            <a:srgbClr val="FFFFFF"/>
+                          </a:solidFill>
+                          <a:latin typeface="Calibri"/>
+                        </a:rPr>
+                        <a:t>Contrast (compute-matched)</a:t>
+                      </a:r>
+                    </a:p>
+                  </a:txBody>
+                  <a:tcPr marL="54864" marR="54864" marT="36576" marB="36576" anchor="ctr">
+                    <a:solidFill>
+                      <a:srgbClr val="0F2A57"/>
+                    </a:solidFill>
+                  </a:tcPr>
+                </a:tc>
+                <a:tc>
+                  <a:txBody>
+                    <a:bodyPr wrap="square"/>
+                    <a:lstStyle/>
+                    <a:p>
+                      <a:pPr algn="l"/>
+                      <a:r>
+                        <a:rPr sz="1400" b="1" i="0">
+                          <a:solidFill>
+                            <a:srgbClr val="FFFFFF"/>
+                          </a:solidFill>
+                          <a:latin typeface="Calibri"/>
+                        </a:rPr>
+                        <a:t>Data volume held at</a:t>
+                      </a:r>
+                    </a:p>
+                  </a:txBody>
+                  <a:tcPr marL="54864" marR="54864" marT="36576" marB="36576" anchor="ctr">
+                    <a:solidFill>
+                      <a:srgbClr val="0F2A57"/>
+                    </a:solidFill>
+                  </a:tcPr>
+                </a:tc>
+                <a:tc>
+                  <a:txBody>
+                    <a:bodyPr wrap="square"/>
+                    <a:lstStyle/>
+                    <a:p>
+                      <a:pPr algn="l"/>
+                      <a:r>
+                        <a:rPr sz="1400" b="1" i="0">
+                          <a:solidFill>
+                            <a:srgbClr val="FFFFFF"/>
+                          </a:solidFill>
+                          <a:latin typeface="Calibri"/>
+                        </a:rPr>
+                        <a:t>Δ abs F1</a:t>
+                      </a:r>
+                    </a:p>
+                  </a:txBody>
+                  <a:tcPr marL="54864" marR="54864" marT="36576" marB="36576" anchor="ctr">
+                    <a:solidFill>
+                      <a:srgbClr val="0F2A57"/>
+                    </a:solidFill>
+                  </a:tcPr>
+                </a:tc>
+                <a:tc>
+                  <a:txBody>
+                    <a:bodyPr wrap="square"/>
+                    <a:lstStyle/>
+                    <a:p>
+                      <a:pPr algn="l"/>
+                      <a:r>
+                        <a:rPr sz="1400" b="1" i="0">
+                          <a:solidFill>
+                            <a:srgbClr val="FFFFFF"/>
+                          </a:solidFill>
+                          <a:latin typeface="Calibri"/>
+                        </a:rPr>
+                        <a:t>Effect of adding KL</a:t>
+                      </a:r>
+                    </a:p>
+                  </a:txBody>
+                  <a:tcPr marL="54864" marR="54864" marT="36576" marB="36576" anchor="ctr">
+                    <a:solidFill>
+                      <a:srgbClr val="0F2A57"/>
+                    </a:solidFill>
+                  </a:tcPr>
+                </a:tc>
+              </a:tr>
+              <a:tr h="777240">
+                <a:tc>
+                  <a:txBody>
+                    <a:bodyPr wrap="square"/>
+                    <a:lstStyle/>
+                    <a:p>
+                      <a:pPr algn="l"/>
+                      <a:r>
+                        <a:rPr sz="1500" b="0" i="0">
+                          <a:solidFill>
+                            <a:srgbClr val="232A33"/>
+                          </a:solidFill>
+                          <a:latin typeface="Calibri"/>
+                        </a:rPr>
+                        <a:t>(c) − (a):  KL added on top of K=1 data</a:t>
+                      </a:r>
+                    </a:p>
+                  </a:txBody>
+                  <a:tcPr marL="54864" marR="54864" marT="36576" marB="36576" anchor="ctr">
+                    <a:solidFill>
+                      <a:srgbClr val="F7F9FC"/>
+                    </a:solidFill>
+                  </a:tcPr>
+                </a:tc>
+                <a:tc>
+                  <a:txBody>
+                    <a:bodyPr wrap="square"/>
+                    <a:lstStyle/>
+                    <a:p>
+                      <a:pPr algn="ctr"/>
+                      <a:r>
+                        <a:rPr sz="1500" b="0" i="0">
+                          <a:solidFill>
+                            <a:srgbClr val="232A33"/>
+                          </a:solidFill>
+                          <a:latin typeface="Calibri"/>
+                        </a:rPr>
+                        <a:t>K=1 (200 entries / round)</a:t>
+                      </a:r>
+                    </a:p>
+                  </a:txBody>
+                  <a:tcPr marL="54864" marR="54864" marT="36576" marB="36576" anchor="ctr">
+                    <a:solidFill>
+                      <a:srgbClr val="F7F9FC"/>
+                    </a:solidFill>
+                  </a:tcPr>
+                </a:tc>
+                <a:tc>
+                  <a:txBody>
+                    <a:bodyPr wrap="square"/>
+                    <a:lstStyle/>
+                    <a:p>
+                      <a:pPr algn="ctr"/>
+                      <a:r>
+                        <a:rPr sz="1800" b="1" i="0">
+                          <a:solidFill>
+                            <a:srgbClr val="1F4E90"/>
+                          </a:solidFill>
+                          <a:latin typeface="Calibri"/>
+                        </a:rPr>
+                        <a:t>+0.029</a:t>
+                      </a:r>
+                    </a:p>
+                  </a:txBody>
+                  <a:tcPr marL="54864" marR="54864" marT="36576" marB="36576" anchor="ctr">
+                    <a:solidFill>
+                      <a:srgbClr val="F7F9FC"/>
+                    </a:solidFill>
+                  </a:tcPr>
+                </a:tc>
+                <a:tc>
+                  <a:txBody>
+                    <a:bodyPr wrap="square"/>
+                    <a:lstStyle/>
+                    <a:p>
+                      <a:pPr algn="l"/>
+                      <a:r>
+                        <a:rPr sz="1400" b="0" i="1">
+                          <a:solidFill>
+                            <a:srgbClr val="5C6670"/>
+                          </a:solidFill>
+                          <a:latin typeface="Calibri"/>
+                        </a:rPr>
+                        <a:t>small lift</a:t>
+                      </a:r>
+                    </a:p>
+                  </a:txBody>
+                  <a:tcPr marL="54864" marR="54864" marT="36576" marB="36576" anchor="ctr">
+                    <a:solidFill>
+                      <a:srgbClr val="F7F9FC"/>
+                    </a:solidFill>
+                  </a:tcPr>
+                </a:tc>
+              </a:tr>
+              <a:tr h="777240">
+                <a:tc>
+                  <a:txBody>
+                    <a:bodyPr wrap="square"/>
+                    <a:lstStyle/>
+                    <a:p>
+                      <a:pPr algn="l"/>
+                      <a:r>
+                        <a:rPr sz="1500" b="1" i="0">
+                          <a:solidFill>
+                            <a:srgbClr val="232A33"/>
+                          </a:solidFill>
+                          <a:latin typeface="Calibri"/>
+                        </a:rPr>
+                        <a:t>(d) − (b):  KL added on top of K=5 data</a:t>
+                      </a:r>
+                    </a:p>
+                  </a:txBody>
+                  <a:tcPr marL="54864" marR="54864" marT="36576" marB="36576" anchor="ctr">
+                    <a:solidFill>
+                      <a:srgbClr val="E8F2E8"/>
+                    </a:solidFill>
+                  </a:tcPr>
+                </a:tc>
+                <a:tc>
+                  <a:txBody>
+                    <a:bodyPr wrap="square"/>
+                    <a:lstStyle/>
+                    <a:p>
+                      <a:pPr algn="ctr"/>
+                      <a:r>
+                        <a:rPr sz="1500" b="0" i="0">
+                          <a:solidFill>
+                            <a:srgbClr val="232A33"/>
+                          </a:solidFill>
+                          <a:latin typeface="Calibri"/>
+                        </a:rPr>
+                        <a:t>K=5 (1000 entries / round)</a:t>
+                      </a:r>
+                    </a:p>
+                  </a:txBody>
+                  <a:tcPr marL="54864" marR="54864" marT="36576" marB="36576" anchor="ctr">
+                    <a:solidFill>
+                      <a:srgbClr val="E8F2E8"/>
+                    </a:solidFill>
+                  </a:tcPr>
+                </a:tc>
+                <a:tc>
+                  <a:txBody>
+                    <a:bodyPr wrap="square"/>
+                    <a:lstStyle/>
+                    <a:p>
+                      <a:pPr algn="ctr"/>
+                      <a:r>
+                        <a:rPr sz="2200" b="1" i="0">
+                          <a:solidFill>
+                            <a:srgbClr val="1F8E4F"/>
+                          </a:solidFill>
+                          <a:latin typeface="Calibri"/>
+                        </a:rPr>
+                        <a:t>+0.286</a:t>
+                      </a:r>
+                    </a:p>
+                  </a:txBody>
+                  <a:tcPr marL="54864" marR="54864" marT="36576" marB="36576" anchor="ctr">
+                    <a:solidFill>
+                      <a:srgbClr val="E8F2E8"/>
+                    </a:solidFill>
+                  </a:tcPr>
+                </a:tc>
+                <a:tc>
+                  <a:txBody>
+                    <a:bodyPr wrap="square"/>
+                    <a:lstStyle/>
+                    <a:p>
+                      <a:pPr algn="l"/>
+                      <a:r>
+                        <a:rPr sz="1400" b="1" i="0">
+                          <a:solidFill>
+                            <a:srgbClr val="1F8E4F"/>
+                          </a:solidFill>
+                          <a:latin typeface="Calibri"/>
+                        </a:rPr>
+                        <a:t>≈10× larger</a:t>
+                      </a:r>
+                    </a:p>
+                  </a:txBody>
+                  <a:tcPr marL="54864" marR="54864" marT="36576" marB="36576" anchor="ctr">
+                    <a:solidFill>
+                      <a:srgbClr val="E8F2E8"/>
+                    </a:solidFill>
+                  </a:tcPr>
+                </a:tc>
+              </a:tr>
+            </a:tbl>
+          </a:graphicData>
+        </a:graphic>
+      </p:graphicFrame>
+      <p:sp>
+        <p:nvSpPr>
+          <p:cNvPr id="6" name="TextBox 5"/>
+          <p:cNvSpPr txBox="1"/>
+          <p:nvPr/>
+        </p:nvSpPr>
+        <p:spPr>
+          <a:xfrm>
+            <a:off x="548640" y="4572000"/>
+            <a:ext cx="11064240" cy="1280160"/>
+          </a:xfrm>
+          <a:prstGeom prst="rect">
+            <a:avLst/>
+          </a:prstGeom>
+          <a:solidFill>
+            <a:srgbClr val="FDF7EF"/>
+          </a:solidFill>
+          <a:ln w="12700">
+            <a:solidFill>
+              <a:srgbClr val="E8C89C"/>
+            </a:solidFill>
+          </a:ln>
+        </p:spPr>
+        <p:txBody>
+          <a:bodyPr wrap="square" lIns="45720" rIns="45720" tIns="27432" bIns="27432">
+            <a:spAutoFit/>
+          </a:bodyPr>
+          <a:lstStyle/>
+          <a:p>
+            <a:r>
+              <a:rPr sz="1800" b="1">
+                <a:solidFill>
+                  <a:srgbClr val="C0392B"/>
+                </a:solidFill>
+                <a:latin typeface="Calibri"/>
+              </a:rPr>
+              <a:t>Conclusion:  </a:t>
+            </a:r>
+            <a:r>
+              <a:rPr sz="1800">
+                <a:solidFill>
+                  <a:srgbClr val="232A33"/>
+                </a:solidFill>
+                <a:latin typeface="Calibri"/>
+              </a:rPr>
+              <a:t>KL is ~10× more effective when paired with K=5 data than added on top of K=1 data alone.</a:t>
+            </a:r>
+          </a:p>
+          <a:p>
+            <a:pPr>
+              <a:spcBef>
+                <a:spcPts val="600"/>
+              </a:spcBef>
+            </a:pPr>
+            <a:r>
+              <a:rPr sz="1400" i="1">
+                <a:solidFill>
+                  <a:srgbClr val="232A33"/>
+                </a:solidFill>
+                <a:latin typeface="Calibri"/>
+              </a:rPr>
+              <a:t>This is the signature of an interaction effect, not a data-volume effect.  More data alone gives +0.036 (b) − (a); more data plus KL gives +0.322.</a:t>
+            </a:r>
+          </a:p>
+        </p:txBody>
+      </p:sp>
+      <p:sp>
+        <p:nvSpPr>
+          <p:cNvPr id="7" name="TextBox 6"/>
+          <p:cNvSpPr txBox="1"/>
+          <p:nvPr/>
+        </p:nvSpPr>
+        <p:spPr>
+          <a:xfrm>
+            <a:off x="365760" y="6446520"/>
+            <a:ext cx="11430000" cy="320040"/>
+          </a:xfrm>
+          <a:prstGeom prst="rect">
+            <a:avLst/>
+          </a:prstGeom>
+          <a:noFill/>
+          <a:ln>
+            <a:noFill/>
+          </a:ln>
+        </p:spPr>
+        <p:txBody>
+          <a:bodyPr wrap="square" lIns="45720" rIns="45720" tIns="27432" bIns="27432">
+            <a:spAutoFit/>
+          </a:bodyPr>
+          <a:lstStyle/>
+          <a:p>
+            <a:pPr algn="l"/>
+            <a:r>
+              <a:rPr sz="1000">
+                <a:solidFill>
+                  <a:srgbClr val="5C6670"/>
+                </a:solidFill>
+                <a:latin typeface="Calibri"/>
+              </a:rPr>
+              <a:t>COMS 6998   ·   Jeremiah Mao, Mateo Juliani</a:t>
+            </a:r>
+          </a:p>
+          <a:p>
+            <a:pPr algn="r"/>
+          </a:p>
+        </p:txBody>
+      </p:sp>
+      <p:sp>
+        <p:nvSpPr>
+          <p:cNvPr id="8" name="TextBox 7"/>
+          <p:cNvSpPr txBox="1"/>
+          <p:nvPr/>
+        </p:nvSpPr>
+        <p:spPr>
+          <a:xfrm>
+            <a:off x="10515600" y="6446520"/>
+            <a:ext cx="1280160" cy="320040"/>
+          </a:xfrm>
+          <a:prstGeom prst="rect">
+            <a:avLst/>
+          </a:prstGeom>
+          <a:noFill/>
+          <a:ln>
+            <a:noFill/>
+          </a:ln>
+        </p:spPr>
+        <p:txBody>
+          <a:bodyPr wrap="square" lIns="45720" rIns="45720" tIns="27432" bIns="27432">
+            <a:spAutoFit/>
+          </a:bodyPr>
+          <a:lstStyle/>
+          <a:p>
+            <a:pPr algn="r"/>
+            <a:r>
+              <a:rPr sz="1000">
+                <a:solidFill>
+                  <a:srgbClr val="5C6670"/>
+                </a:solidFill>
+                <a:latin typeface="Calibri"/>
+              </a:rPr>
+              <a:t>10 / 16</a:t>
+            </a:r>
+          </a:p>
+        </p:txBody>
+      </p:sp>
+    </p:spTree>
+  </p:cSld>
+  <p:clrMapOvr>
+    <a:masterClrMapping/>
+  </p:clrMapOvr>
+</p:sld>
+</file>
+
+<file path=ppt/slides/slide11.xml><?xml version="1.0" encoding="utf-8"?>
 <p:sld xmlns:a="http://schemas.openxmlformats.org/drawingml/2006/main" xmlns:p="http://schemas.openxmlformats.org/presentationml/2006/main" xmlns:r="http://schemas.openxmlformats.org/officeDocument/2006/relationships">
   <p:cSld>
     <p:spTree>
@@ -4146,380 +4748,7 @@
                 </a:solidFill>
                 <a:latin typeface="Calibri"/>
               </a:rPr>
-              <a:t>10 / 15</a:t>
-            </a:r>
-          </a:p>
-        </p:txBody>
-      </p:sp>
-    </p:spTree>
-  </p:cSld>
-  <p:clrMapOvr>
-    <a:masterClrMapping/>
-  </p:clrMapOvr>
-</p:sld>
-</file>
-
-<file path=ppt/slides/slide11.xml><?xml version="1.0" encoding="utf-8"?>
-<p:sld xmlns:a="http://schemas.openxmlformats.org/drawingml/2006/main" xmlns:p="http://schemas.openxmlformats.org/presentationml/2006/main" xmlns:r="http://schemas.openxmlformats.org/officeDocument/2006/relationships">
-  <p:cSld>
-    <p:spTree>
-      <p:nvGrpSpPr>
-        <p:cNvPr id="1" name=""/>
-        <p:cNvGrpSpPr/>
-        <p:nvPr/>
-      </p:nvGrpSpPr>
-      <p:grpSpPr/>
-      <p:sp>
-        <p:nvSpPr>
-          <p:cNvPr id="2" name="Rectangle 1"/>
-          <p:cNvSpPr/>
-          <p:nvPr/>
-        </p:nvSpPr>
-        <p:spPr>
-          <a:xfrm>
-            <a:off x="0" y="0"/>
-            <a:ext cx="12191695" cy="777240"/>
-          </a:xfrm>
-          <a:prstGeom prst="rect">
-            <a:avLst/>
-          </a:prstGeom>
-          <a:solidFill>
-            <a:srgbClr val="0F2A57"/>
-          </a:solidFill>
-          <a:ln>
-            <a:noFill/>
-          </a:ln>
-          <a:effectLst/>
-        </p:spPr>
-        <p:style>
-          <a:lnRef idx="1">
-            <a:schemeClr val="accent1"/>
-          </a:lnRef>
-          <a:fillRef idx="3">
-            <a:schemeClr val="accent1"/>
-          </a:fillRef>
-          <a:effectRef idx="2">
-            <a:schemeClr val="accent1"/>
-          </a:effectRef>
-          <a:fontRef idx="minor">
-            <a:schemeClr val="lt1"/>
-          </a:fontRef>
-        </p:style>
-        <p:txBody>
-          <a:bodyPr rtlCol="0" anchor="ctr"/>
-          <a:lstStyle/>
-          <a:p>
-            <a:pPr algn="ctr"/>
-          </a:p>
-        </p:txBody>
-      </p:sp>
-      <p:sp>
-        <p:nvSpPr>
-          <p:cNvPr id="3" name="TextBox 2"/>
-          <p:cNvSpPr txBox="1"/>
-          <p:nvPr/>
-        </p:nvSpPr>
-        <p:spPr>
-          <a:xfrm>
-            <a:off x="365760" y="109728"/>
-            <a:ext cx="11430000" cy="594360"/>
-          </a:xfrm>
-          <a:prstGeom prst="rect">
-            <a:avLst/>
-          </a:prstGeom>
-          <a:noFill/>
-          <a:ln>
-            <a:noFill/>
-          </a:ln>
-        </p:spPr>
-        <p:txBody>
-          <a:bodyPr wrap="square" lIns="45720" rIns="45720" tIns="27432" bIns="27432">
-            <a:spAutoFit/>
-          </a:bodyPr>
-          <a:lstStyle/>
-          <a:p>
-            <a:pPr algn="l"/>
-            <a:r>
-              <a:rPr sz="2800" b="1">
-                <a:solidFill>
-                  <a:srgbClr val="FFFFFF"/>
-                </a:solidFill>
-                <a:latin typeface="Calibri"/>
-              </a:rPr>
-              <a:t>Three negative results that constrain the design space</a:t>
-            </a:r>
-          </a:p>
-        </p:txBody>
-      </p:sp>
-      <p:sp>
-        <p:nvSpPr>
-          <p:cNvPr id="4" name="TextBox 3"/>
-          <p:cNvSpPr txBox="1"/>
-          <p:nvPr/>
-        </p:nvSpPr>
-        <p:spPr>
-          <a:xfrm>
-            <a:off x="548640" y="1005840"/>
-            <a:ext cx="11064240" cy="5212080"/>
-          </a:xfrm>
-          <a:prstGeom prst="rect">
-            <a:avLst/>
-          </a:prstGeom>
-          <a:noFill/>
-          <a:ln>
-            <a:noFill/>
-          </a:ln>
-        </p:spPr>
-        <p:txBody>
-          <a:bodyPr wrap="square" lIns="45720" rIns="45720" tIns="27432" bIns="27432">
-            <a:spAutoFit/>
-          </a:bodyPr>
-          <a:lstStyle/>
-          <a:p>
-            <a:pPr>
-              <a:lnSpc>
-                <a:spcPct val="113000"/>
-              </a:lnSpc>
-              <a:spcAft>
-                <a:spcPts val="600"/>
-              </a:spcAft>
-            </a:pPr>
-            <a:r>
-              <a:rPr sz="1500" b="1">
-                <a:solidFill>
-                  <a:srgbClr val="1F4E90"/>
-                </a:solidFill>
-                <a:latin typeface="Calibri"/>
-              </a:rPr>
-              <a:t>•  </a:t>
-            </a:r>
-            <a:r>
-              <a:rPr sz="1500">
-                <a:solidFill>
-                  <a:srgbClr val="232A33"/>
-                </a:solidFill>
-                <a:latin typeface="Calibri"/>
-              </a:rPr>
-              <a:t>COPR (continual preference alignment) does not port to fact injection.</a:t>
-            </a:r>
-          </a:p>
-          <a:p>
-            <a:pPr lvl="1">
-              <a:lnSpc>
-                <a:spcPct val="113000"/>
-              </a:lnSpc>
-              <a:spcAft>
-                <a:spcPts val="600"/>
-              </a:spcAft>
-            </a:pPr>
-            <a:r>
-              <a:rPr sz="1500" b="1">
-                <a:solidFill>
-                  <a:srgbClr val="1F4E90"/>
-                </a:solidFill>
-                <a:latin typeface="Calibri"/>
-              </a:rPr>
-              <a:t>–  </a:t>
-            </a:r>
-            <a:r>
-              <a:rPr sz="1500">
-                <a:solidFill>
-                  <a:srgbClr val="232A33"/>
-                </a:solidFill>
-                <a:latin typeface="Calibri"/>
-              </a:rPr>
-              <a:t>kl_reg_sft wins absorption against copr_gold_injection in 11 of 14 contested rounds. COPR draws K=8 candidate responses per fact (here K = number of self-sampled candidates) and ranks them via MSE; on novel facts, the K=8 candidates all land below a usable F1 threshold (the K-sample-all-wrong pathology), so the rank fit reinforces plausible-but-wrong answers. Gold injection collapses the method toward cross-entropy at 10–12× per-round compute.</a:t>
-            </a:r>
-          </a:p>
-          <a:p>
-            <a:pPr>
-              <a:lnSpc>
-                <a:spcPct val="113000"/>
-              </a:lnSpc>
-              <a:spcAft>
-                <a:spcPts val="600"/>
-              </a:spcAft>
-            </a:pPr>
-            <a:r>
-              <a:rPr sz="1500" b="1">
-                <a:solidFill>
-                  <a:srgbClr val="1F4E90"/>
-                </a:solidFill>
-                <a:latin typeface="Calibri"/>
-              </a:rPr>
-              <a:t>•  </a:t>
-            </a:r>
-            <a:r>
-              <a:rPr sz="1500">
-                <a:solidFill>
-                  <a:srgbClr val="232A33"/>
-                </a:solidFill>
-                <a:latin typeface="Calibri"/>
-              </a:rPr>
-              <a:t>V-REx at K=2 prompt formats is theoretically degenerate.</a:t>
-            </a:r>
-          </a:p>
-          <a:p>
-            <a:pPr lvl="1">
-              <a:lnSpc>
-                <a:spcPct val="113000"/>
-              </a:lnSpc>
-              <a:spcAft>
-                <a:spcPts val="600"/>
-              </a:spcAft>
-            </a:pPr>
-            <a:r>
-              <a:rPr sz="1500" b="1">
-                <a:solidFill>
-                  <a:srgbClr val="1F4E90"/>
-                </a:solidFill>
-                <a:latin typeface="Calibri"/>
-              </a:rPr>
-              <a:t>–  </a:t>
-            </a:r>
-            <a:r>
-              <a:rPr sz="1500">
-                <a:solidFill>
-                  <a:srgbClr val="232A33"/>
-                </a:solidFill>
-                <a:latin typeface="Calibri"/>
-              </a:rPr>
-              <a:t>Here K = number of prompt-format environments (a different K from the augmentation K — this is the IRM/V-REx sense). IRM-family penalties require ≥3 environments (Arjovsky 2019; Rosenfeld 2021; Ahuja 2021). At K=2 the variance term reduces to a pairwise scalar consistency satisfiable by any equalizing solution. Empirically: +0.014 QD F1, within run-to-run noise.</a:t>
-            </a:r>
-          </a:p>
-          <a:p>
-            <a:pPr>
-              <a:lnSpc>
-                <a:spcPct val="113000"/>
-              </a:lnSpc>
-              <a:spcAft>
-                <a:spcPts val="600"/>
-              </a:spcAft>
-            </a:pPr>
-            <a:r>
-              <a:rPr sz="1500" b="1">
-                <a:solidFill>
-                  <a:srgbClr val="1F4E90"/>
-                </a:solidFill>
-                <a:latin typeface="Calibri"/>
-              </a:rPr>
-              <a:t>•  </a:t>
-            </a:r>
-            <a:r>
-              <a:rPr sz="1500">
-                <a:solidFill>
-                  <a:srgbClr val="232A33"/>
-                </a:solidFill>
-                <a:latin typeface="Calibri"/>
-              </a:rPr>
-              <a:t>Format diversity without an explicit regularizer actively hurts.</a:t>
-            </a:r>
-          </a:p>
-          <a:p>
-            <a:pPr lvl="1">
-              <a:lnSpc>
-                <a:spcPct val="113000"/>
-              </a:lnSpc>
-              <a:spcAft>
-                <a:spcPts val="600"/>
-              </a:spcAft>
-            </a:pPr>
-            <a:r>
-              <a:rPr sz="1500" b="1">
-                <a:solidFill>
-                  <a:srgbClr val="1F4E90"/>
-                </a:solidFill>
-                <a:latin typeface="Calibri"/>
-              </a:rPr>
-              <a:t>–  </a:t>
-            </a:r>
-            <a:r>
-              <a:rPr sz="1500">
-                <a:solidFill>
-                  <a:srgbClr val="232A33"/>
-                </a:solidFill>
-                <a:latin typeface="Calibri"/>
-              </a:rPr>
-              <a:t>Plain mixed-format SFT widens the format gap to 0.100 vs single-format kl_reg_sft 0.072. Format mixing in continual training requires curriculum, unified rewriting, or — as we show in §4 — a preservation-side regularizer paired with K=5 augmentation on the injection side.</a:t>
-            </a:r>
-          </a:p>
-        </p:txBody>
-      </p:sp>
-      <p:sp>
-        <p:nvSpPr>
-          <p:cNvPr id="5" name="TextBox 4"/>
-          <p:cNvSpPr txBox="1"/>
-          <p:nvPr/>
-        </p:nvSpPr>
-        <p:spPr>
-          <a:xfrm>
-            <a:off x="365760" y="6446520"/>
-            <a:ext cx="11430000" cy="320040"/>
-          </a:xfrm>
-          <a:prstGeom prst="rect">
-            <a:avLst/>
-          </a:prstGeom>
-          <a:noFill/>
-          <a:ln>
-            <a:noFill/>
-          </a:ln>
-        </p:spPr>
-        <p:txBody>
-          <a:bodyPr wrap="square" lIns="45720" rIns="45720" tIns="27432" bIns="27432">
-            <a:spAutoFit/>
-          </a:bodyPr>
-          <a:lstStyle/>
-          <a:p>
-            <a:pPr algn="l"/>
-            <a:r>
-              <a:rPr sz="1000">
-                <a:solidFill>
-                  <a:srgbClr val="5C6670"/>
-                </a:solidFill>
-                <a:latin typeface="Calibri"/>
-              </a:rPr>
-              <a:t>COMS 6998   ·   Jeremiah Mao, Mateo Juliani</a:t>
-            </a:r>
-          </a:p>
-          <a:p>
-            <a:pPr algn="r"/>
-          </a:p>
-        </p:txBody>
-      </p:sp>
-      <p:sp>
-        <p:nvSpPr>
-          <p:cNvPr id="6" name="TextBox 5"/>
-          <p:cNvSpPr txBox="1"/>
-          <p:nvPr/>
-        </p:nvSpPr>
-        <p:spPr>
-          <a:xfrm>
-            <a:off x="10515600" y="6446520"/>
-            <a:ext cx="1280160" cy="320040"/>
-          </a:xfrm>
-          <a:prstGeom prst="rect">
-            <a:avLst/>
-          </a:prstGeom>
-          <a:noFill/>
-          <a:ln>
-            <a:noFill/>
-          </a:ln>
-        </p:spPr>
-        <p:txBody>
-          <a:bodyPr wrap="square" lIns="45720" rIns="45720" tIns="27432" bIns="27432">
-            <a:spAutoFit/>
-          </a:bodyPr>
-          <a:lstStyle/>
-          <a:p>
-            <a:pPr algn="r"/>
-            <a:r>
-              <a:rPr sz="1000">
-                <a:solidFill>
-                  <a:srgbClr val="5C6670"/>
-                </a:solidFill>
-                <a:latin typeface="Calibri"/>
-              </a:rPr>
-              <a:t>11 / 15</a:t>
+              <a:t>11 / 16</a:t>
             </a:r>
           </a:p>
         </p:txBody>
@@ -4619,7 +4848,7 @@
                 </a:solidFill>
                 <a:latin typeface="Calibri"/>
               </a:rPr>
-              <a:t>Symmetric extension fails: K=5 KL preservation adds nothing</a:t>
+              <a:t>Three negative results that constrain the design space</a:t>
             </a:r>
           </a:p>
         </p:txBody>
@@ -4632,287 +4861,8 @@
         </p:nvSpPr>
         <p:spPr>
           <a:xfrm>
-            <a:off x="548640" y="868680"/>
-            <a:ext cx="11064240" cy="548640"/>
-          </a:xfrm>
-          <a:prstGeom prst="rect">
-            <a:avLst/>
-          </a:prstGeom>
-          <a:noFill/>
-          <a:ln>
-            <a:noFill/>
-          </a:ln>
-        </p:spPr>
-        <p:txBody>
-          <a:bodyPr wrap="square" lIns="45720" rIns="45720" tIns="27432" bIns="27432">
-            <a:spAutoFit/>
-          </a:bodyPr>
-          <a:lstStyle/>
-          <a:p>
-            <a:r>
-              <a:rPr sz="1500" b="1">
-                <a:solidFill>
-                  <a:srgbClr val="1F4E90"/>
-                </a:solidFill>
-                <a:latin typeface="Calibri"/>
-              </a:rPr>
-              <a:t>Hypothesis: </a:t>
-            </a:r>
-            <a:r>
-              <a:rPr sz="1500">
-                <a:solidFill>
-                  <a:srgbClr val="232A33"/>
-                </a:solidFill>
-                <a:latin typeface="Calibri"/>
-              </a:rPr>
-              <a:t>single-format KL preservation might fail to detect format-selective forgetting. Augmenting the preservation side with K=5 framings should catch it.</a:t>
-            </a:r>
-          </a:p>
-        </p:txBody>
-      </p:sp>
-      <p:sp>
-        <p:nvSpPr>
-          <p:cNvPr id="5" name="TextBox 4"/>
-          <p:cNvSpPr txBox="1"/>
-          <p:nvPr/>
-        </p:nvSpPr>
-        <p:spPr>
-          <a:xfrm>
-            <a:off x="548640" y="1463040"/>
-            <a:ext cx="11064240" cy="2011680"/>
-          </a:xfrm>
-          <a:prstGeom prst="rect">
-            <a:avLst/>
-          </a:prstGeom>
-          <a:solidFill>
-            <a:srgbClr val="F7F9FC"/>
-          </a:solidFill>
-          <a:ln w="12700">
-            <a:solidFill>
-              <a:srgbClr val="CFD8E3"/>
-            </a:solidFill>
-          </a:ln>
-        </p:spPr>
-        <p:txBody>
-          <a:bodyPr wrap="square" lIns="45720" rIns="45720" tIns="27432" bIns="27432">
-            <a:spAutoFit/>
-          </a:bodyPr>
-          <a:lstStyle/>
-          <a:p>
-            <a:r>
-              <a:rPr sz="1300" b="1">
-                <a:solidFill>
-                  <a:srgbClr val="1F4E90"/>
-                </a:solidFill>
-                <a:latin typeface="Calibri"/>
-              </a:rPr>
-              <a:t>The K=5 preservation framings </a:t>
-            </a:r>
-            <a:r>
-              <a:rPr sz="1200" i="1">
-                <a:solidFill>
-                  <a:srgbClr val="232A33"/>
-                </a:solidFill>
-                <a:latin typeface="Calibri"/>
-              </a:rPr>
-              <a:t>applied to the same task prompt   "What should I know about Acme Corp's recent activity?"</a:t>
-            </a:r>
-          </a:p>
-          <a:p>
-            <a:pPr>
-              <a:spcBef>
-                <a:spcPts val="200"/>
-              </a:spcBef>
-            </a:pPr>
-            <a:r>
-              <a:rPr sz="1100" b="1">
-                <a:solidFill>
-                  <a:srgbClr val="1F4E90"/>
-                </a:solidFill>
-                <a:latin typeface="Calibri"/>
-              </a:rPr>
-              <a:t>  Original:  </a:t>
-            </a:r>
-            <a:r>
-              <a:rPr sz="1000">
-                <a:solidFill>
-                  <a:srgbClr val="232A33"/>
-                </a:solidFill>
-                <a:latin typeface="Consolas"/>
-              </a:rPr>
-              <a:t>[system: QD-decomposer]  [user: What should I know about Acme Corp's recent activity?]</a:t>
-            </a:r>
-          </a:p>
-          <a:p>
-            <a:pPr>
-              <a:spcBef>
-                <a:spcPts val="200"/>
-              </a:spcBef>
-            </a:pPr>
-            <a:r>
-              <a:rPr sz="1100" b="1">
-                <a:solidFill>
-                  <a:srgbClr val="1F4E90"/>
-                </a:solidFill>
-                <a:latin typeface="Calibri"/>
-              </a:rPr>
-              <a:t>  Bare:  </a:t>
-            </a:r>
-            <a:r>
-              <a:rPr sz="1000">
-                <a:solidFill>
-                  <a:srgbClr val="232A33"/>
-                </a:solidFill>
-                <a:latin typeface="Consolas"/>
-              </a:rPr>
-              <a:t>[user: What should I know about Acme Corp's recent activity?]   (no system prompt)</a:t>
-            </a:r>
-          </a:p>
-          <a:p>
-            <a:pPr>
-              <a:spcBef>
-                <a:spcPts val="200"/>
-              </a:spcBef>
-            </a:pPr>
-            <a:r>
-              <a:rPr sz="1100" b="1">
-                <a:solidFill>
-                  <a:srgbClr val="1F4E90"/>
-                </a:solidFill>
-                <a:latin typeface="Calibri"/>
-              </a:rPr>
-              <a:t>  Analyst:  </a:t>
-            </a:r>
-            <a:r>
-              <a:rPr sz="1000">
-                <a:solidFill>
-                  <a:srgbClr val="232A33"/>
-                </a:solidFill>
-                <a:latin typeface="Consolas"/>
-              </a:rPr>
-              <a:t>[user: You are a financial analyst. Answer concisely: What should I know about Acme Corp's recent activity?]</a:t>
-            </a:r>
-          </a:p>
-          <a:p>
-            <a:pPr>
-              <a:spcBef>
-                <a:spcPts val="200"/>
-              </a:spcBef>
-            </a:pPr>
-            <a:r>
-              <a:rPr sz="1100" b="1">
-                <a:solidFill>
-                  <a:srgbClr val="1F4E90"/>
-                </a:solidFill>
-                <a:latin typeface="Calibri"/>
-              </a:rPr>
-              <a:t>  Detailed:  </a:t>
-            </a:r>
-            <a:r>
-              <a:rPr sz="1000">
-                <a:solidFill>
-                  <a:srgbClr val="232A33"/>
-                </a:solidFill>
-                <a:latin typeface="Consolas"/>
-              </a:rPr>
-              <a:t>[user: Given the following question, provide a detailed response: What should I know about Acme Corp's recent activity?]</a:t>
-            </a:r>
-          </a:p>
-          <a:p>
-            <a:pPr>
-              <a:spcBef>
-                <a:spcPts val="200"/>
-              </a:spcBef>
-            </a:pPr>
-            <a:r>
-              <a:rPr sz="1100" b="1">
-                <a:solidFill>
-                  <a:srgbClr val="1F4E90"/>
-                </a:solidFill>
-                <a:latin typeface="Calibri"/>
-              </a:rPr>
-              <a:t>  Request:  </a:t>
-            </a:r>
-            <a:r>
-              <a:rPr sz="1000">
-                <a:solidFill>
-                  <a:srgbClr val="232A33"/>
-                </a:solidFill>
-                <a:latin typeface="Consolas"/>
-              </a:rPr>
-              <a:t>[user: Question: What should I know about Acme Corp's recent activity?  Please provide your analysis.]</a:t>
-            </a:r>
-          </a:p>
-        </p:txBody>
-      </p:sp>
-      <p:sp>
-        <p:nvSpPr>
-          <p:cNvPr id="6" name="TextBox 5"/>
-          <p:cNvSpPr txBox="1"/>
-          <p:nvPr/>
-        </p:nvSpPr>
-        <p:spPr>
-          <a:xfrm>
-            <a:off x="1371600" y="3611880"/>
-            <a:ext cx="9418320" cy="1280160"/>
-          </a:xfrm>
-          <a:prstGeom prst="rect">
-            <a:avLst/>
-          </a:prstGeom>
-          <a:solidFill>
-            <a:srgbClr val="FDF7EF"/>
-          </a:solidFill>
-          <a:ln w="12700">
-            <a:solidFill>
-              <a:srgbClr val="E8C89C"/>
-            </a:solidFill>
-          </a:ln>
-        </p:spPr>
-        <p:txBody>
-          <a:bodyPr wrap="square" lIns="45720" rIns="45720" tIns="27432" bIns="27432">
-            <a:spAutoFit/>
-          </a:bodyPr>
-          <a:lstStyle/>
-          <a:p>
-            <a:pPr algn="ctr"/>
-            <a:r>
-              <a:rPr sz="2200" b="1">
-                <a:solidFill>
-                  <a:srgbClr val="C0392B"/>
-                </a:solidFill>
-                <a:latin typeface="Calibri"/>
-              </a:rPr>
-              <a:t>Result:  (e) − (d)  =  −0.006  at round 15</a:t>
-            </a:r>
-          </a:p>
-          <a:p>
-            <a:pPr algn="ctr">
-              <a:spcBef>
-                <a:spcPts val="600"/>
-              </a:spcBef>
-            </a:pPr>
-            <a:r>
-              <a:rPr sz="1400">
-                <a:solidFill>
-                  <a:srgbClr val="232A33"/>
-                </a:solidFill>
-                <a:latin typeface="Calibri"/>
-              </a:rPr>
-              <a:t>Trajectory Δ = −0.004.   95% interval [−0.030, +0.018] straddles zero.</a:t>
-            </a:r>
-          </a:p>
-        </p:txBody>
-      </p:sp>
-      <p:sp>
-        <p:nvSpPr>
-          <p:cNvPr id="7" name="TextBox 6"/>
-          <p:cNvSpPr txBox="1"/>
-          <p:nvPr/>
-        </p:nvSpPr>
-        <p:spPr>
-          <a:xfrm>
-            <a:off x="548640" y="5029200"/>
-            <a:ext cx="11064240" cy="1371600"/>
+            <a:off x="548640" y="1005840"/>
+            <a:ext cx="11064240" cy="5212080"/>
           </a:xfrm>
           <a:prstGeom prst="rect">
             <a:avLst/>
@@ -4937,7 +4887,7 @@
               </a:spcAft>
             </a:pPr>
             <a:r>
-              <a:rPr sz="1300" b="1">
+              <a:rPr sz="1500" b="1">
                 <a:solidFill>
                   <a:srgbClr val="1F4E90"/>
                 </a:solidFill>
@@ -4946,13 +4896,41 @@
               <a:t>•  </a:t>
             </a:r>
             <a:r>
-              <a:rPr sz="1300">
+              <a:rPr sz="1500">
                 <a:solidFill>
                   <a:srgbClr val="232A33"/>
                 </a:solidFill>
                 <a:latin typeface="Calibri"/>
               </a:rPr>
-              <a:t>The active ingredient is K=5 injection × any KL anchor — not K=5 on both sides.</a:t>
+              <a:t>COPR (continual preference alignment) does not port to fact injection.</a:t>
+            </a:r>
+          </a:p>
+          <a:p>
+            <a:pPr lvl="1">
+              <a:lnSpc>
+                <a:spcPct val="113000"/>
+              </a:lnSpc>
+              <a:spcAft>
+                <a:spcPts val="600"/>
+              </a:spcAft>
+            </a:pPr>
+            <a:r>
+              <a:rPr sz="1500" b="1">
+                <a:solidFill>
+                  <a:srgbClr val="1F4E90"/>
+                </a:solidFill>
+                <a:latin typeface="Calibri"/>
+              </a:rPr>
+              <a:t>–  </a:t>
+            </a:r>
+            <a:r>
+              <a:rPr sz="1500">
+                <a:solidFill>
+                  <a:srgbClr val="232A33"/>
+                </a:solidFill>
+                <a:latin typeface="Calibri"/>
+              </a:rPr>
+              <a:t>kl_reg_sft wins absorption against copr_gold_injection in 11 of 14 contested rounds. COPR draws K=8 candidate responses per fact (here K = number of self-sampled candidates) and ranks them via MSE; on novel facts, the K=8 candidates all land below a usable F1 threshold (the K-sample-all-wrong pathology), so the rank fit reinforces plausible-but-wrong answers. Gold injection collapses the method toward cross-entropy at 10–12× per-round compute.</a:t>
             </a:r>
           </a:p>
           <a:p>
@@ -4965,7 +4943,7 @@
               </a:spcAft>
             </a:pPr>
             <a:r>
-              <a:rPr sz="1300" b="1">
+              <a:rPr sz="1500" b="1">
                 <a:solidFill>
                   <a:srgbClr val="1F4E90"/>
                 </a:solidFill>
@@ -4974,13 +4952,41 @@
               <a:t>•  </a:t>
             </a:r>
             <a:r>
-              <a:rPr sz="1300">
+              <a:rPr sz="1500">
                 <a:solidFill>
                   <a:srgbClr val="232A33"/>
                 </a:solidFill>
                 <a:latin typeface="Calibri"/>
               </a:rPr>
-              <a:t>Why: K=5 augmentation on the injection side already broadcasts each update across format directions of the gradient; LoRA's update subspace is shared across formats, so single-framing KL implicitly anchors all directions the K=5 update can push.</a:t>
+              <a:t>V-REx at K=2 prompt formats is theoretically degenerate.</a:t>
+            </a:r>
+          </a:p>
+          <a:p>
+            <a:pPr lvl="1">
+              <a:lnSpc>
+                <a:spcPct val="113000"/>
+              </a:lnSpc>
+              <a:spcAft>
+                <a:spcPts val="600"/>
+              </a:spcAft>
+            </a:pPr>
+            <a:r>
+              <a:rPr sz="1500" b="1">
+                <a:solidFill>
+                  <a:srgbClr val="1F4E90"/>
+                </a:solidFill>
+                <a:latin typeface="Calibri"/>
+              </a:rPr>
+              <a:t>–  </a:t>
+            </a:r>
+            <a:r>
+              <a:rPr sz="1500">
+                <a:solidFill>
+                  <a:srgbClr val="232A33"/>
+                </a:solidFill>
+                <a:latin typeface="Calibri"/>
+              </a:rPr>
+              <a:t>Here K = number of prompt-format environments (a different K from the augmentation K — this is the IRM/V-REx sense). IRM-family penalties require ≥3 environments (Arjovsky 2019; Rosenfeld 2021; Ahuja 2021). At K=2 the variance term reduces to a pairwise scalar consistency satisfiable by any equalizing solution. Empirically: +0.014 QD F1, within run-to-run noise.</a:t>
             </a:r>
           </a:p>
           <a:p>
@@ -4993,7 +4999,7 @@
               </a:spcAft>
             </a:pPr>
             <a:r>
-              <a:rPr sz="1300" b="1">
+              <a:rPr sz="1500" b="1">
                 <a:solidFill>
                   <a:srgbClr val="1F4E90"/>
                 </a:solidFill>
@@ -5002,20 +5008,48 @@
               <a:t>•  </a:t>
             </a:r>
             <a:r>
-              <a:rPr sz="1300">
+              <a:rPr sz="1500">
                 <a:solidFill>
                   <a:srgbClr val="232A33"/>
                 </a:solidFill>
                 <a:latin typeface="Calibri"/>
               </a:rPr>
-              <a:t>Caveat: this conjecture leans on LoRA's shared low-rank update subspace. At full fine-tuning the symmetric extension may earn its keep — not validated.</a:t>
-            </a:r>
-          </a:p>
-        </p:txBody>
-      </p:sp>
-      <p:sp>
-        <p:nvSpPr>
-          <p:cNvPr id="8" name="TextBox 7"/>
+              <a:t>Format diversity without an explicit regularizer actively hurts.</a:t>
+            </a:r>
+          </a:p>
+          <a:p>
+            <a:pPr lvl="1">
+              <a:lnSpc>
+                <a:spcPct val="113000"/>
+              </a:lnSpc>
+              <a:spcAft>
+                <a:spcPts val="600"/>
+              </a:spcAft>
+            </a:pPr>
+            <a:r>
+              <a:rPr sz="1500" b="1">
+                <a:solidFill>
+                  <a:srgbClr val="1F4E90"/>
+                </a:solidFill>
+                <a:latin typeface="Calibri"/>
+              </a:rPr>
+              <a:t>–  </a:t>
+            </a:r>
+            <a:r>
+              <a:rPr sz="1500">
+                <a:solidFill>
+                  <a:srgbClr val="232A33"/>
+                </a:solidFill>
+                <a:latin typeface="Calibri"/>
+              </a:rPr>
+              <a:t>Plain mixed-format SFT widens the format gap to 0.100 vs single-format kl_reg_sft 0.072. Format mixing in continual training requires curriculum, unified rewriting, or — as we show in §4 — a preservation-side regularizer paired with K=5 augmentation on the injection side.</a:t>
+            </a:r>
+          </a:p>
+        </p:txBody>
+      </p:sp>
+      <p:sp>
+        <p:nvSpPr>
+          <p:cNvPr id="5" name="TextBox 4"/>
           <p:cNvSpPr txBox="1"/>
           <p:nvPr/>
         </p:nvSpPr>
@@ -5056,7 +5090,7 @@
       </p:sp>
       <p:sp>
         <p:nvSpPr>
-          <p:cNvPr id="9" name="TextBox 8"/>
+          <p:cNvPr id="6" name="TextBox 5"/>
           <p:cNvSpPr txBox="1"/>
           <p:nvPr/>
         </p:nvSpPr>
@@ -5087,7 +5121,7 @@
                 </a:solidFill>
                 <a:latin typeface="Calibri"/>
               </a:rPr>
-              <a:t>12 / 15</a:t>
+              <a:t>12 / 16</a:t>
             </a:r>
           </a:p>
         </p:txBody>
@@ -5187,7 +5221,7 @@
                 </a:solidFill>
                 <a:latin typeface="Calibri"/>
               </a:rPr>
-              <a:t>Recommendation</a:t>
+              <a:t>Symmetric extension fails: K=5 KL preservation adds nothing</a:t>
             </a:r>
           </a:p>
         </p:txBody>
@@ -5200,82 +5234,8 @@
         </p:nvSpPr>
         <p:spPr>
           <a:xfrm>
-            <a:off x="731520" y="1188720"/>
-            <a:ext cx="10698480" cy="1554480"/>
-          </a:xfrm>
-          <a:prstGeom prst="rect">
-            <a:avLst/>
-          </a:prstGeom>
-          <a:solidFill>
-            <a:srgbClr val="E8F2E8"/>
-          </a:solidFill>
-          <a:ln w="12700">
-            <a:solidFill>
-              <a:srgbClr val="1F8E4F"/>
-            </a:solidFill>
-          </a:ln>
-        </p:spPr>
-        <p:txBody>
-          <a:bodyPr wrap="square" lIns="45720" rIns="45720" tIns="27432" bIns="27432">
-            <a:spAutoFit/>
-          </a:bodyPr>
-          <a:lstStyle/>
-          <a:p>
-            <a:pPr algn="ctr"/>
-            <a:r>
-              <a:rPr sz="2000" i="1">
-                <a:solidFill>
-                  <a:srgbClr val="232A33"/>
-                </a:solidFill>
-                <a:latin typeface="Calibri"/>
-              </a:rPr>
-              <a:t>For continual LoRA fact injection in task-tuned LLMs:</a:t>
-            </a:r>
-          </a:p>
-          <a:p>
-            <a:pPr algn="ctr">
-              <a:spcBef>
-                <a:spcPts val="800"/>
-              </a:spcBef>
-            </a:pPr>
-            <a:r>
-              <a:rPr sz="2200" b="1">
-                <a:solidFill>
-                  <a:srgbClr val="1F8E4F"/>
-                </a:solidFill>
-                <a:latin typeface="Calibri"/>
-              </a:rPr>
-              <a:t>K=5 paraphrastic augmentation on the injection side  +  K=1 KL preservation against a per-round frozen reference</a:t>
-            </a:r>
-          </a:p>
-          <a:p>
-            <a:pPr algn="ctr">
-              <a:spcBef>
-                <a:spcPts val="400"/>
-              </a:spcBef>
-            </a:pPr>
-            <a:r>
-              <a:rPr sz="1400" i="1">
-                <a:solidFill>
-                  <a:srgbClr val="5C6670"/>
-                </a:solidFill>
-                <a:latin typeface="Calibri"/>
-              </a:rPr>
-              <a:t>( aug_kl_k1 — condition (d) )</a:t>
-            </a:r>
-          </a:p>
-        </p:txBody>
-      </p:sp>
-      <p:sp>
-        <p:nvSpPr>
-          <p:cNvPr id="5" name="TextBox 4"/>
-          <p:cNvSpPr txBox="1"/>
-          <p:nvPr/>
-        </p:nvSpPr>
-        <p:spPr>
-          <a:xfrm>
-            <a:off x="548640" y="3017520"/>
-            <a:ext cx="11064240" cy="3291840"/>
+            <a:off x="548640" y="868680"/>
+            <a:ext cx="11064240" cy="548640"/>
           </a:xfrm>
           <a:prstGeom prst="rect">
             <a:avLst/>
@@ -5291,143 +5251,198 @@
           </a:bodyPr>
           <a:lstStyle/>
           <a:p>
+            <a:r>
+              <a:rPr sz="1500" b="1">
+                <a:solidFill>
+                  <a:srgbClr val="1F4E90"/>
+                </a:solidFill>
+                <a:latin typeface="Calibri"/>
+              </a:rPr>
+              <a:t>Hypothesis: </a:t>
+            </a:r>
+            <a:r>
+              <a:rPr sz="1500">
+                <a:solidFill>
+                  <a:srgbClr val="232A33"/>
+                </a:solidFill>
+                <a:latin typeface="Calibri"/>
+              </a:rPr>
+              <a:t>single-format KL preservation might fail to detect format-selective forgetting. Augmenting the preservation side with K=5 framings should catch it.</a:t>
+            </a:r>
+          </a:p>
+        </p:txBody>
+      </p:sp>
+      <p:sp>
+        <p:nvSpPr>
+          <p:cNvPr id="5" name="TextBox 4"/>
+          <p:cNvSpPr txBox="1"/>
+          <p:nvPr/>
+        </p:nvSpPr>
+        <p:spPr>
+          <a:xfrm>
+            <a:off x="548640" y="1463040"/>
+            <a:ext cx="11064240" cy="2011680"/>
+          </a:xfrm>
+          <a:prstGeom prst="rect">
+            <a:avLst/>
+          </a:prstGeom>
+          <a:solidFill>
+            <a:srgbClr val="F7F9FC"/>
+          </a:solidFill>
+          <a:ln w="12700">
+            <a:solidFill>
+              <a:srgbClr val="CFD8E3"/>
+            </a:solidFill>
+          </a:ln>
+        </p:spPr>
+        <p:txBody>
+          <a:bodyPr wrap="square" lIns="45720" rIns="45720" tIns="27432" bIns="27432">
+            <a:spAutoFit/>
+          </a:bodyPr>
+          <a:lstStyle/>
+          <a:p>
+            <a:r>
+              <a:rPr sz="1300" b="1">
+                <a:solidFill>
+                  <a:srgbClr val="1F4E90"/>
+                </a:solidFill>
+                <a:latin typeface="Calibri"/>
+              </a:rPr>
+              <a:t>The K=5 preservation framings </a:t>
+            </a:r>
+            <a:r>
+              <a:rPr sz="1200" i="1">
+                <a:solidFill>
+                  <a:srgbClr val="232A33"/>
+                </a:solidFill>
+                <a:latin typeface="Calibri"/>
+              </a:rPr>
+              <a:t>applied to the same task prompt   "What should I know about Acme Corp's recent activity?"</a:t>
+            </a:r>
+          </a:p>
+          <a:p>
             <a:pPr>
-              <a:lnSpc>
-                <a:spcPct val="115000"/>
-              </a:lnSpc>
-              <a:spcAft>
-                <a:spcPts val="600"/>
-              </a:spcAft>
+              <a:spcBef>
+                <a:spcPts val="200"/>
+              </a:spcBef>
             </a:pPr>
             <a:r>
-              <a:rPr sz="1500" b="1">
+              <a:rPr sz="1100" b="1">
                 <a:solidFill>
                   <a:srgbClr val="1F4E90"/>
                 </a:solidFill>
                 <a:latin typeface="Calibri"/>
               </a:rPr>
-              <a:t>•  </a:t>
-            </a:r>
-            <a:r>
-              <a:rPr sz="1500">
+              <a:t>  Original:  </a:t>
+            </a:r>
+            <a:r>
+              <a:rPr sz="1000">
                 <a:solidFill>
                   <a:srgbClr val="232A33"/>
                 </a:solidFill>
-                <a:latin typeface="Calibri"/>
-              </a:rPr>
-              <a:t>Use K=5 paraphrastic augmentation on the injection side. Don't rely on K=1 (single-format) injection alone.</a:t>
+                <a:latin typeface="Consolas"/>
+              </a:rPr>
+              <a:t>[system: QD-decomposer]  [user: What should I know about Acme Corp's recent activity?]</a:t>
             </a:r>
           </a:p>
           <a:p>
             <a:pPr>
-              <a:lnSpc>
-                <a:spcPct val="115000"/>
-              </a:lnSpc>
-              <a:spcAft>
-                <a:spcPts val="600"/>
-              </a:spcAft>
+              <a:spcBef>
+                <a:spcPts val="200"/>
+              </a:spcBef>
             </a:pPr>
             <a:r>
-              <a:rPr sz="1500" b="1">
+              <a:rPr sz="1100" b="1">
                 <a:solidFill>
                   <a:srgbClr val="1F4E90"/>
                 </a:solidFill>
                 <a:latin typeface="Calibri"/>
               </a:rPr>
-              <a:t>•  </a:t>
-            </a:r>
-            <a:r>
-              <a:rPr sz="1500">
+              <a:t>  Bare:  </a:t>
+            </a:r>
+            <a:r>
+              <a:rPr sz="1000">
                 <a:solidFill>
                   <a:srgbClr val="232A33"/>
                 </a:solidFill>
-                <a:latin typeface="Calibri"/>
-              </a:rPr>
-              <a:t>Pair it with standard K=1 KL preservation against a per-round frozen reference. Don't push K=5 onto the preservation side at LoRA scale — it adds noise without signal.</a:t>
+                <a:latin typeface="Consolas"/>
+              </a:rPr>
+              <a:t>[user: What should I know about Acme Corp's recent activity?]   (no system prompt)</a:t>
             </a:r>
           </a:p>
           <a:p>
             <a:pPr>
-              <a:lnSpc>
-                <a:spcPct val="115000"/>
-              </a:lnSpc>
-              <a:spcAft>
-                <a:spcPts val="600"/>
-              </a:spcAft>
+              <a:spcBef>
+                <a:spcPts val="200"/>
+              </a:spcBef>
             </a:pPr>
             <a:r>
-              <a:rPr sz="1500" b="1">
+              <a:rPr sz="1100" b="1">
                 <a:solidFill>
                   <a:srgbClr val="1F4E90"/>
                 </a:solidFill>
                 <a:latin typeface="Calibri"/>
               </a:rPr>
-              <a:t>•  </a:t>
-            </a:r>
-            <a:r>
-              <a:rPr sz="1500">
+              <a:t>  Analyst:  </a:t>
+            </a:r>
+            <a:r>
+              <a:rPr sz="1000">
                 <a:solidFill>
                   <a:srgbClr val="232A33"/>
                 </a:solidFill>
-                <a:latin typeface="Calibri"/>
-              </a:rPr>
-              <a:t>Don't use COPR for fact injection — the K-sample-all-wrong pathology breaks the assumption that the candidate pool contains usable signal.</a:t>
+                <a:latin typeface="Consolas"/>
+              </a:rPr>
+              <a:t>[user: You are a financial analyst. Answer concisely: What should I know about Acme Corp's recent activity?]</a:t>
             </a:r>
           </a:p>
           <a:p>
             <a:pPr>
-              <a:lnSpc>
-                <a:spcPct val="115000"/>
-              </a:lnSpc>
-              <a:spcAft>
-                <a:spcPts val="600"/>
-              </a:spcAft>
+              <a:spcBef>
+                <a:spcPts val="200"/>
+              </a:spcBef>
             </a:pPr>
             <a:r>
-              <a:rPr sz="1500" b="1">
+              <a:rPr sz="1100" b="1">
                 <a:solidFill>
                   <a:srgbClr val="1F4E90"/>
                 </a:solidFill>
                 <a:latin typeface="Calibri"/>
               </a:rPr>
-              <a:t>•  </a:t>
-            </a:r>
-            <a:r>
-              <a:rPr sz="1500">
+              <a:t>  Detailed:  </a:t>
+            </a:r>
+            <a:r>
+              <a:rPr sz="1000">
                 <a:solidFill>
                   <a:srgbClr val="232A33"/>
                 </a:solidFill>
-                <a:latin typeface="Calibri"/>
-              </a:rPr>
-              <a:t>Don't use OOD regularization at K=2 environments — theoretically degenerate per Arjovsky / Rosenfeld / Ahuja, empirically null.</a:t>
+                <a:latin typeface="Consolas"/>
+              </a:rPr>
+              <a:t>[user: Given the following question, provide a detailed response: What should I know about Acme Corp's recent activity?]</a:t>
             </a:r>
           </a:p>
           <a:p>
             <a:pPr>
-              <a:lnSpc>
-                <a:spcPct val="115000"/>
-              </a:lnSpc>
-              <a:spcAft>
-                <a:spcPts val="600"/>
-              </a:spcAft>
+              <a:spcBef>
+                <a:spcPts val="200"/>
+              </a:spcBef>
             </a:pPr>
             <a:r>
-              <a:rPr sz="1500" b="1">
+              <a:rPr sz="1100" b="1">
                 <a:solidFill>
                   <a:srgbClr val="1F4E90"/>
                 </a:solidFill>
                 <a:latin typeface="Calibri"/>
               </a:rPr>
-              <a:t>•  </a:t>
-            </a:r>
-            <a:r>
-              <a:rPr sz="1500">
+              <a:t>  Request:  </a:t>
+            </a:r>
+            <a:r>
+              <a:rPr sz="1000">
                 <a:solidFill>
                   <a:srgbClr val="232A33"/>
                 </a:solidFill>
-                <a:latin typeface="Calibri"/>
-              </a:rPr>
-              <a:t>The cross-coupling is the active ingredient. Either ingredient alone gives ~+0.03; together they give +0.322 (4.93× super-linear).</a:t>
+                <a:latin typeface="Consolas"/>
+              </a:rPr>
+              <a:t>[user: Question: What should I know about Acme Corp's recent activity?  Please provide your analysis.]</a:t>
             </a:r>
           </a:p>
         </p:txBody>
@@ -5440,8 +5455,66 @@
         </p:nvSpPr>
         <p:spPr>
           <a:xfrm>
-            <a:off x="365760" y="6446520"/>
-            <a:ext cx="11430000" cy="320040"/>
+            <a:off x="1371600" y="3611880"/>
+            <a:ext cx="9418320" cy="1280160"/>
+          </a:xfrm>
+          <a:prstGeom prst="rect">
+            <a:avLst/>
+          </a:prstGeom>
+          <a:solidFill>
+            <a:srgbClr val="FDF7EF"/>
+          </a:solidFill>
+          <a:ln w="12700">
+            <a:solidFill>
+              <a:srgbClr val="E8C89C"/>
+            </a:solidFill>
+          </a:ln>
+        </p:spPr>
+        <p:txBody>
+          <a:bodyPr wrap="square" lIns="45720" rIns="45720" tIns="27432" bIns="27432">
+            <a:spAutoFit/>
+          </a:bodyPr>
+          <a:lstStyle/>
+          <a:p>
+            <a:pPr algn="ctr"/>
+            <a:r>
+              <a:rPr sz="2200" b="1">
+                <a:solidFill>
+                  <a:srgbClr val="C0392B"/>
+                </a:solidFill>
+                <a:latin typeface="Calibri"/>
+              </a:rPr>
+              <a:t>Result:  (e) − (d)  =  −0.006  at round 15</a:t>
+            </a:r>
+          </a:p>
+          <a:p>
+            <a:pPr algn="ctr">
+              <a:spcBef>
+                <a:spcPts val="600"/>
+              </a:spcBef>
+            </a:pPr>
+            <a:r>
+              <a:rPr sz="1400">
+                <a:solidFill>
+                  <a:srgbClr val="232A33"/>
+                </a:solidFill>
+                <a:latin typeface="Calibri"/>
+              </a:rPr>
+              <a:t>Trajectory Δ = −0.004.   95% interval [−0.030, +0.018] straddles zero.</a:t>
+            </a:r>
+          </a:p>
+        </p:txBody>
+      </p:sp>
+      <p:sp>
+        <p:nvSpPr>
+          <p:cNvPr id="7" name="TextBox 6"/>
+          <p:cNvSpPr txBox="1"/>
+          <p:nvPr/>
+        </p:nvSpPr>
+        <p:spPr>
+          <a:xfrm>
+            <a:off x="548640" y="5029200"/>
+            <a:ext cx="11064240" cy="1371600"/>
           </a:xfrm>
           <a:prstGeom prst="rect">
             <a:avLst/>
@@ -5457,32 +5530,101 @@
           </a:bodyPr>
           <a:lstStyle/>
           <a:p>
-            <a:pPr algn="l"/>
-            <a:r>
-              <a:rPr sz="1000">
-                <a:solidFill>
-                  <a:srgbClr val="5C6670"/>
-                </a:solidFill>
-                <a:latin typeface="Calibri"/>
-              </a:rPr>
-              <a:t>COMS 6998   ·   Jeremiah Mao, Mateo Juliani</a:t>
-            </a:r>
-          </a:p>
-          <a:p>
-            <a:pPr algn="r"/>
-          </a:p>
-        </p:txBody>
-      </p:sp>
-      <p:sp>
-        <p:nvSpPr>
-          <p:cNvPr id="7" name="TextBox 6"/>
+            <a:pPr>
+              <a:lnSpc>
+                <a:spcPct val="113000"/>
+              </a:lnSpc>
+              <a:spcAft>
+                <a:spcPts val="600"/>
+              </a:spcAft>
+            </a:pPr>
+            <a:r>
+              <a:rPr sz="1300" b="1">
+                <a:solidFill>
+                  <a:srgbClr val="1F4E90"/>
+                </a:solidFill>
+                <a:latin typeface="Calibri"/>
+              </a:rPr>
+              <a:t>•  </a:t>
+            </a:r>
+            <a:r>
+              <a:rPr sz="1300">
+                <a:solidFill>
+                  <a:srgbClr val="232A33"/>
+                </a:solidFill>
+                <a:latin typeface="Calibri"/>
+              </a:rPr>
+              <a:t>The active ingredient is K=5 injection × any KL anchor — not K=5 on both sides.</a:t>
+            </a:r>
+          </a:p>
+          <a:p>
+            <a:pPr>
+              <a:lnSpc>
+                <a:spcPct val="113000"/>
+              </a:lnSpc>
+              <a:spcAft>
+                <a:spcPts val="600"/>
+              </a:spcAft>
+            </a:pPr>
+            <a:r>
+              <a:rPr sz="1300" b="1">
+                <a:solidFill>
+                  <a:srgbClr val="1F4E90"/>
+                </a:solidFill>
+                <a:latin typeface="Calibri"/>
+              </a:rPr>
+              <a:t>•  </a:t>
+            </a:r>
+            <a:r>
+              <a:rPr sz="1300">
+                <a:solidFill>
+                  <a:srgbClr val="232A33"/>
+                </a:solidFill>
+                <a:latin typeface="Calibri"/>
+              </a:rPr>
+              <a:t>Why: K=5 augmentation on the injection side already broadcasts each update across format directions of the gradient; LoRA's update subspace is shared across formats, so single-framing KL implicitly anchors all directions the K=5 update can push.</a:t>
+            </a:r>
+          </a:p>
+          <a:p>
+            <a:pPr>
+              <a:lnSpc>
+                <a:spcPct val="113000"/>
+              </a:lnSpc>
+              <a:spcAft>
+                <a:spcPts val="600"/>
+              </a:spcAft>
+            </a:pPr>
+            <a:r>
+              <a:rPr sz="1300" b="1">
+                <a:solidFill>
+                  <a:srgbClr val="1F4E90"/>
+                </a:solidFill>
+                <a:latin typeface="Calibri"/>
+              </a:rPr>
+              <a:t>•  </a:t>
+            </a:r>
+            <a:r>
+              <a:rPr sz="1300">
+                <a:solidFill>
+                  <a:srgbClr val="232A33"/>
+                </a:solidFill>
+                <a:latin typeface="Calibri"/>
+              </a:rPr>
+              <a:t>Caveat: this conjecture leans on LoRA's shared low-rank update subspace. At full fine-tuning the symmetric extension may earn its keep — not validated.</a:t>
+            </a:r>
+          </a:p>
+        </p:txBody>
+      </p:sp>
+      <p:sp>
+        <p:nvSpPr>
+          <p:cNvPr id="8" name="TextBox 7"/>
           <p:cNvSpPr txBox="1"/>
           <p:nvPr/>
         </p:nvSpPr>
         <p:spPr>
           <a:xfrm>
-            <a:off x="10515600" y="6446520"/>
-            <a:ext cx="1280160" cy="320040"/>
+            <a:off x="365760" y="6446520"/>
+            <a:ext cx="11430000" cy="320040"/>
           </a:xfrm>
           <a:prstGeom prst="rect">
             <a:avLst/>
@@ -5498,7 +5640,48 @@
           </a:bodyPr>
           <a:lstStyle/>
           <a:p>
+            <a:pPr algn="l"/>
+            <a:r>
+              <a:rPr sz="1000">
+                <a:solidFill>
+                  <a:srgbClr val="5C6670"/>
+                </a:solidFill>
+                <a:latin typeface="Calibri"/>
+              </a:rPr>
+              <a:t>COMS 6998   ·   Jeremiah Mao, Mateo Juliani</a:t>
+            </a:r>
+          </a:p>
+          <a:p>
             <a:pPr algn="r"/>
+          </a:p>
+        </p:txBody>
+      </p:sp>
+      <p:sp>
+        <p:nvSpPr>
+          <p:cNvPr id="9" name="TextBox 8"/>
+          <p:cNvSpPr txBox="1"/>
+          <p:nvPr/>
+        </p:nvSpPr>
+        <p:spPr>
+          <a:xfrm>
+            <a:off x="10515600" y="6446520"/>
+            <a:ext cx="1280160" cy="320040"/>
+          </a:xfrm>
+          <a:prstGeom prst="rect">
+            <a:avLst/>
+          </a:prstGeom>
+          <a:noFill/>
+          <a:ln>
+            <a:noFill/>
+          </a:ln>
+        </p:spPr>
+        <p:txBody>
+          <a:bodyPr wrap="square" lIns="45720" rIns="45720" tIns="27432" bIns="27432">
+            <a:spAutoFit/>
+          </a:bodyPr>
+          <a:lstStyle/>
+          <a:p>
+            <a:pPr algn="r"/>
             <a:r>
               <a:rPr sz="1000">
                 <a:solidFill>
@@ -5506,7 +5689,7 @@
                 </a:solidFill>
                 <a:latin typeface="Calibri"/>
               </a:rPr>
-              <a:t>13 / 15</a:t>
+              <a:t>13 / 16</a:t>
             </a:r>
           </a:p>
         </p:txBody>
@@ -5606,7 +5789,7 @@
                 </a:solidFill>
                 <a:latin typeface="Calibri"/>
               </a:rPr>
-              <a:t>Limitations and follow-ups</a:t>
+              <a:t>Recommendation</a:t>
             </a:r>
           </a:p>
         </p:txBody>
@@ -5619,8 +5802,82 @@
         </p:nvSpPr>
         <p:spPr>
           <a:xfrm>
-            <a:off x="548640" y="1005840"/>
-            <a:ext cx="11064240" cy="5303520"/>
+            <a:off x="731520" y="1188720"/>
+            <a:ext cx="10698480" cy="1554480"/>
+          </a:xfrm>
+          <a:prstGeom prst="rect">
+            <a:avLst/>
+          </a:prstGeom>
+          <a:solidFill>
+            <a:srgbClr val="E8F2E8"/>
+          </a:solidFill>
+          <a:ln w="12700">
+            <a:solidFill>
+              <a:srgbClr val="1F8E4F"/>
+            </a:solidFill>
+          </a:ln>
+        </p:spPr>
+        <p:txBody>
+          <a:bodyPr wrap="square" lIns="45720" rIns="45720" tIns="27432" bIns="27432">
+            <a:spAutoFit/>
+          </a:bodyPr>
+          <a:lstStyle/>
+          <a:p>
+            <a:pPr algn="ctr"/>
+            <a:r>
+              <a:rPr sz="2000" i="1">
+                <a:solidFill>
+                  <a:srgbClr val="232A33"/>
+                </a:solidFill>
+                <a:latin typeface="Calibri"/>
+              </a:rPr>
+              <a:t>For continual LoRA fact injection in task-tuned LLMs:</a:t>
+            </a:r>
+          </a:p>
+          <a:p>
+            <a:pPr algn="ctr">
+              <a:spcBef>
+                <a:spcPts val="800"/>
+              </a:spcBef>
+            </a:pPr>
+            <a:r>
+              <a:rPr sz="2200" b="1">
+                <a:solidFill>
+                  <a:srgbClr val="1F8E4F"/>
+                </a:solidFill>
+                <a:latin typeface="Calibri"/>
+              </a:rPr>
+              <a:t>K=5 paraphrastic augmentation on the injection side  +  K=1 KL preservation against a per-round frozen reference</a:t>
+            </a:r>
+          </a:p>
+          <a:p>
+            <a:pPr algn="ctr">
+              <a:spcBef>
+                <a:spcPts val="400"/>
+              </a:spcBef>
+            </a:pPr>
+            <a:r>
+              <a:rPr sz="1400" i="1">
+                <a:solidFill>
+                  <a:srgbClr val="5C6670"/>
+                </a:solidFill>
+                <a:latin typeface="Calibri"/>
+              </a:rPr>
+              <a:t>( aug_kl_k1 — condition (d) )</a:t>
+            </a:r>
+          </a:p>
+        </p:txBody>
+      </p:sp>
+      <p:sp>
+        <p:nvSpPr>
+          <p:cNvPr id="5" name="TextBox 4"/>
+          <p:cNvSpPr txBox="1"/>
+          <p:nvPr/>
+        </p:nvSpPr>
+        <p:spPr>
+          <a:xfrm>
+            <a:off x="548640" y="3017520"/>
+            <a:ext cx="11064240" cy="3291840"/>
           </a:xfrm>
           <a:prstGeom prst="rect">
             <a:avLst/>
@@ -5660,7 +5917,7 @@
                 </a:solidFill>
                 <a:latin typeface="Calibri"/>
               </a:rPr>
-              <a:t>Single model, single scale. Qwen3-4B at LoRA r=16 only. Synergy magnitude likely shrinks at 7–8B (~15–20 GPU-h follow-up).</a:t>
+              <a:t>Use K=5 paraphrastic augmentation on the injection side. Don't rely on K=1 (single-format) injection alone.</a:t>
             </a:r>
           </a:p>
           <a:p>
@@ -5688,7 +5945,7 @@
                 </a:solidFill>
                 <a:latin typeface="Calibri"/>
               </a:rPr>
-              <a:t>Two seeds for the headline cells, one calibration seed. (e) vs (d) null is robust under conservative non-parametric intervals; a 3rd seed is in progress and would tighten bounds.</a:t>
+              <a:t>Pair it with standard K=1 KL preservation against a per-round frozen reference. Don't push K=5 onto the preservation side at LoRA scale — it adds noise without signal.</a:t>
             </a:r>
           </a:p>
           <a:p>
@@ -5716,7 +5973,7 @@
                 </a:solidFill>
                 <a:latin typeface="Calibri"/>
               </a:rPr>
-              <a:t>The mechanism is hypothesized, not proven. Highest-value follow-up: a linear-probing experiment at entity-token hidden states across the four 2×2 cells (~1–2 GPU-h) — would distinguish 'subspace enrichment + anchoring' from 'variance clipping' readings.</a:t>
+              <a:t>Don't use COPR for fact injection — the K-sample-all-wrong pathology breaks the assumption that the candidate pool contains usable signal.</a:t>
             </a:r>
           </a:p>
           <a:p>
@@ -5744,7 +6001,7 @@
                 </a:solidFill>
                 <a:latin typeface="Calibri"/>
               </a:rPr>
-              <a:t>K only tested at 5 on the injection side. Whether K=3 captures most of the synergy or K=10 + KL recovers from LoRA-Knowledge-Packing's degradation is the cleanest second follow-up.</a:t>
+              <a:t>Don't use OOD regularization at K=2 environments — theoretically degenerate per Arjovsky / Rosenfeld / Ahuja, empirically null.</a:t>
             </a:r>
           </a:p>
           <a:p>
@@ -5772,42 +6029,14 @@
                 </a:solidFill>
                 <a:latin typeface="Calibri"/>
               </a:rPr>
-              <a:t>Compositional / ripple-effect gap unsolved by every method tested. Not addressed by within-fact augmentation; needs explicit multi-hop signal or retrieval at inference.</a:t>
-            </a:r>
-          </a:p>
-          <a:p>
-            <a:pPr>
-              <a:lnSpc>
-                <a:spcPct val="115000"/>
-              </a:lnSpc>
-              <a:spcAft>
-                <a:spcPts val="600"/>
-              </a:spcAft>
-            </a:pPr>
-            <a:r>
-              <a:rPr sz="1500" b="1">
-                <a:solidFill>
-                  <a:srgbClr val="1F4E90"/>
-                </a:solidFill>
-                <a:latin typeface="Calibri"/>
-              </a:rPr>
-              <a:t>•  </a:t>
-            </a:r>
-            <a:r>
-              <a:rPr sz="1500">
-                <a:solidFill>
-                  <a:srgbClr val="232A33"/>
-                </a:solidFill>
-                <a:latin typeface="Calibri"/>
-              </a:rPr>
-              <a:t>Setting matches industrial practice but transfer beyond LoRA is principled, not validated. The synergy direction should extend to full FT; the (e) vs (d) null specifically may not.</a:t>
-            </a:r>
-          </a:p>
-        </p:txBody>
-      </p:sp>
-      <p:sp>
-        <p:nvSpPr>
-          <p:cNvPr id="5" name="TextBox 4"/>
+              <a:t>The cross-coupling is the active ingredient. Either ingredient alone gives ~+0.03; together they give +0.322 (4.93× super-linear).</a:t>
+            </a:r>
+          </a:p>
+        </p:txBody>
+      </p:sp>
+      <p:sp>
+        <p:nvSpPr>
+          <p:cNvPr id="6" name="TextBox 5"/>
           <p:cNvSpPr txBox="1"/>
           <p:nvPr/>
         </p:nvSpPr>
@@ -5848,7 +6077,7 @@
       </p:sp>
       <p:sp>
         <p:nvSpPr>
-          <p:cNvPr id="6" name="TextBox 5"/>
+          <p:cNvPr id="7" name="TextBox 6"/>
           <p:cNvSpPr txBox="1"/>
           <p:nvPr/>
         </p:nvSpPr>
@@ -5879,7 +6108,7 @@
                 </a:solidFill>
                 <a:latin typeface="Calibri"/>
               </a:rPr>
-              <a:t>14 / 15</a:t>
+              <a:t>14 / 16</a:t>
             </a:r>
           </a:p>
         </p:txBody>
@@ -5910,8 +6139,8 @@
         </p:nvSpPr>
         <p:spPr>
           <a:xfrm>
-            <a:off x="0" y="2377440"/>
-            <a:ext cx="12191695" cy="2103120"/>
+            <a:off x="0" y="0"/>
+            <a:ext cx="12191695" cy="777240"/>
           </a:xfrm>
           <a:prstGeom prst="rect">
             <a:avLst/>
@@ -5954,8 +6183,8 @@
         </p:nvSpPr>
         <p:spPr>
           <a:xfrm>
-            <a:off x="548640" y="2606040"/>
-            <a:ext cx="11064240" cy="1828800"/>
+            <a:off x="365760" y="109728"/>
+            <a:ext cx="11430000" cy="594360"/>
           </a:xfrm>
           <a:prstGeom prst="rect">
             <a:avLst/>
@@ -5971,31 +6200,15 @@
           </a:bodyPr>
           <a:lstStyle/>
           <a:p>
-            <a:pPr algn="ctr"/>
-            <a:r>
-              <a:rPr sz="5400" b="1">
+            <a:pPr algn="l"/>
+            <a:r>
+              <a:rPr sz="2800" b="1">
                 <a:solidFill>
                   <a:srgbClr val="FFFFFF"/>
                 </a:solidFill>
                 <a:latin typeface="Calibri"/>
               </a:rPr>
-              <a:t>Thank you</a:t>
-            </a:r>
-          </a:p>
-          <a:p>
-            <a:pPr algn="ctr">
-              <a:spcBef>
-                <a:spcPts val="2000"/>
-              </a:spcBef>
-            </a:pPr>
-            <a:r>
-              <a:rPr sz="2200" i="1">
-                <a:solidFill>
-                  <a:srgbClr val="FFFFFF"/>
-                </a:solidFill>
-                <a:latin typeface="Calibri"/>
-              </a:rPr>
-              <a:t>Questions?</a:t>
+              <a:t>Limitations and follow-ups</a:t>
             </a:r>
           </a:p>
         </p:txBody>
@@ -6008,8 +6221,8 @@
         </p:nvSpPr>
         <p:spPr>
           <a:xfrm>
-            <a:off x="548640" y="4937760"/>
-            <a:ext cx="11064240" cy="548640"/>
+            <a:off x="548640" y="1005840"/>
+            <a:ext cx="11064240" cy="5303520"/>
           </a:xfrm>
           <a:prstGeom prst="rect">
             <a:avLst/>
@@ -6025,15 +6238,171 @@
           </a:bodyPr>
           <a:lstStyle/>
           <a:p>
-            <a:pPr algn="ctr"/>
-            <a:r>
-              <a:rPr sz="1600">
+            <a:pPr>
+              <a:lnSpc>
+                <a:spcPct val="115000"/>
+              </a:lnSpc>
+              <a:spcAft>
+                <a:spcPts val="600"/>
+              </a:spcAft>
+            </a:pPr>
+            <a:r>
+              <a:rPr sz="1500" b="1">
+                <a:solidFill>
+                  <a:srgbClr val="1F4E90"/>
+                </a:solidFill>
+                <a:latin typeface="Calibri"/>
+              </a:rPr>
+              <a:t>•  </a:t>
+            </a:r>
+            <a:r>
+              <a:rPr sz="1500">
                 <a:solidFill>
                   <a:srgbClr val="232A33"/>
                 </a:solidFill>
                 <a:latin typeface="Calibri"/>
               </a:rPr>
-              <a:t>Code, configs, and raw artifacts:  github.com/jeremiahmao/still-on-task-llm</a:t>
+              <a:t>Single model, single scale. Qwen3-4B at LoRA r=16 only. Synergy magnitude likely shrinks at 7–8B (~15–20 GPU-h follow-up).</a:t>
+            </a:r>
+          </a:p>
+          <a:p>
+            <a:pPr>
+              <a:lnSpc>
+                <a:spcPct val="115000"/>
+              </a:lnSpc>
+              <a:spcAft>
+                <a:spcPts val="600"/>
+              </a:spcAft>
+            </a:pPr>
+            <a:r>
+              <a:rPr sz="1500" b="1">
+                <a:solidFill>
+                  <a:srgbClr val="1F4E90"/>
+                </a:solidFill>
+                <a:latin typeface="Calibri"/>
+              </a:rPr>
+              <a:t>•  </a:t>
+            </a:r>
+            <a:r>
+              <a:rPr sz="1500">
+                <a:solidFill>
+                  <a:srgbClr val="232A33"/>
+                </a:solidFill>
+                <a:latin typeface="Calibri"/>
+              </a:rPr>
+              <a:t>Two seeds for the headline cells, one calibration seed. (e) vs (d) null is robust under conservative non-parametric intervals; a 3rd seed is in progress and would tighten bounds.</a:t>
+            </a:r>
+          </a:p>
+          <a:p>
+            <a:pPr>
+              <a:lnSpc>
+                <a:spcPct val="115000"/>
+              </a:lnSpc>
+              <a:spcAft>
+                <a:spcPts val="600"/>
+              </a:spcAft>
+            </a:pPr>
+            <a:r>
+              <a:rPr sz="1500" b="1">
+                <a:solidFill>
+                  <a:srgbClr val="1F4E90"/>
+                </a:solidFill>
+                <a:latin typeface="Calibri"/>
+              </a:rPr>
+              <a:t>•  </a:t>
+            </a:r>
+            <a:r>
+              <a:rPr sz="1500">
+                <a:solidFill>
+                  <a:srgbClr val="232A33"/>
+                </a:solidFill>
+                <a:latin typeface="Calibri"/>
+              </a:rPr>
+              <a:t>The mechanism is hypothesized, not proven. Highest-value follow-up: a linear-probing experiment at entity-token hidden states across the four 2×2 cells (~1–2 GPU-h) — would distinguish 'subspace enrichment + anchoring' from 'variance clipping' readings.</a:t>
+            </a:r>
+          </a:p>
+          <a:p>
+            <a:pPr>
+              <a:lnSpc>
+                <a:spcPct val="115000"/>
+              </a:lnSpc>
+              <a:spcAft>
+                <a:spcPts val="600"/>
+              </a:spcAft>
+            </a:pPr>
+            <a:r>
+              <a:rPr sz="1500" b="1">
+                <a:solidFill>
+                  <a:srgbClr val="1F4E90"/>
+                </a:solidFill>
+                <a:latin typeface="Calibri"/>
+              </a:rPr>
+              <a:t>•  </a:t>
+            </a:r>
+            <a:r>
+              <a:rPr sz="1500">
+                <a:solidFill>
+                  <a:srgbClr val="232A33"/>
+                </a:solidFill>
+                <a:latin typeface="Calibri"/>
+              </a:rPr>
+              <a:t>K only tested at 5 on the injection side. Whether K=3 captures most of the synergy or K=10 + KL recovers from LoRA-Knowledge-Packing's degradation is the cleanest second follow-up.</a:t>
+            </a:r>
+          </a:p>
+          <a:p>
+            <a:pPr>
+              <a:lnSpc>
+                <a:spcPct val="115000"/>
+              </a:lnSpc>
+              <a:spcAft>
+                <a:spcPts val="600"/>
+              </a:spcAft>
+            </a:pPr>
+            <a:r>
+              <a:rPr sz="1500" b="1">
+                <a:solidFill>
+                  <a:srgbClr val="1F4E90"/>
+                </a:solidFill>
+                <a:latin typeface="Calibri"/>
+              </a:rPr>
+              <a:t>•  </a:t>
+            </a:r>
+            <a:r>
+              <a:rPr sz="1500">
+                <a:solidFill>
+                  <a:srgbClr val="232A33"/>
+                </a:solidFill>
+                <a:latin typeface="Calibri"/>
+              </a:rPr>
+              <a:t>Compositional / ripple-effect gap unsolved by every method tested. Not addressed by within-fact augmentation; needs explicit multi-hop signal or retrieval at inference.</a:t>
+            </a:r>
+          </a:p>
+          <a:p>
+            <a:pPr>
+              <a:lnSpc>
+                <a:spcPct val="115000"/>
+              </a:lnSpc>
+              <a:spcAft>
+                <a:spcPts val="600"/>
+              </a:spcAft>
+            </a:pPr>
+            <a:r>
+              <a:rPr sz="1500" b="1">
+                <a:solidFill>
+                  <a:srgbClr val="1F4E90"/>
+                </a:solidFill>
+                <a:latin typeface="Calibri"/>
+              </a:rPr>
+              <a:t>•  </a:t>
+            </a:r>
+            <a:r>
+              <a:rPr sz="1500">
+                <a:solidFill>
+                  <a:srgbClr val="232A33"/>
+                </a:solidFill>
+                <a:latin typeface="Calibri"/>
+              </a:rPr>
+              <a:t>Setting matches industrial practice but transfer beyond LoRA is principled, not validated. The synergy direction should extend to full FT; the (e) vs (d) null specifically may not.</a:t>
             </a:r>
           </a:p>
         </p:txBody>
@@ -6112,7 +6481,240 @@
                 </a:solidFill>
                 <a:latin typeface="Calibri"/>
               </a:rPr>
-              <a:t>15 / 15</a:t>
+              <a:t>15 / 16</a:t>
+            </a:r>
+          </a:p>
+        </p:txBody>
+      </p:sp>
+    </p:spTree>
+  </p:cSld>
+  <p:clrMapOvr>
+    <a:masterClrMapping/>
+  </p:clrMapOvr>
+</p:sld>
+</file>
+
+<file path=ppt/slides/slide16.xml><?xml version="1.0" encoding="utf-8"?>
+<p:sld xmlns:a="http://schemas.openxmlformats.org/drawingml/2006/main" xmlns:p="http://schemas.openxmlformats.org/presentationml/2006/main" xmlns:r="http://schemas.openxmlformats.org/officeDocument/2006/relationships">
+  <p:cSld>
+    <p:spTree>
+      <p:nvGrpSpPr>
+        <p:cNvPr id="1" name=""/>
+        <p:cNvGrpSpPr/>
+        <p:nvPr/>
+      </p:nvGrpSpPr>
+      <p:grpSpPr/>
+      <p:sp>
+        <p:nvSpPr>
+          <p:cNvPr id="2" name="Rectangle 1"/>
+          <p:cNvSpPr/>
+          <p:nvPr/>
+        </p:nvSpPr>
+        <p:spPr>
+          <a:xfrm>
+            <a:off x="0" y="2377440"/>
+            <a:ext cx="12191695" cy="2103120"/>
+          </a:xfrm>
+          <a:prstGeom prst="rect">
+            <a:avLst/>
+          </a:prstGeom>
+          <a:solidFill>
+            <a:srgbClr val="0F2A57"/>
+          </a:solidFill>
+          <a:ln>
+            <a:noFill/>
+          </a:ln>
+          <a:effectLst/>
+        </p:spPr>
+        <p:style>
+          <a:lnRef idx="1">
+            <a:schemeClr val="accent1"/>
+          </a:lnRef>
+          <a:fillRef idx="3">
+            <a:schemeClr val="accent1"/>
+          </a:fillRef>
+          <a:effectRef idx="2">
+            <a:schemeClr val="accent1"/>
+          </a:effectRef>
+          <a:fontRef idx="minor">
+            <a:schemeClr val="lt1"/>
+          </a:fontRef>
+        </p:style>
+        <p:txBody>
+          <a:bodyPr rtlCol="0" anchor="ctr"/>
+          <a:lstStyle/>
+          <a:p>
+            <a:pPr algn="ctr"/>
+          </a:p>
+        </p:txBody>
+      </p:sp>
+      <p:sp>
+        <p:nvSpPr>
+          <p:cNvPr id="3" name="TextBox 2"/>
+          <p:cNvSpPr txBox="1"/>
+          <p:nvPr/>
+        </p:nvSpPr>
+        <p:spPr>
+          <a:xfrm>
+            <a:off x="548640" y="2606040"/>
+            <a:ext cx="11064240" cy="1828800"/>
+          </a:xfrm>
+          <a:prstGeom prst="rect">
+            <a:avLst/>
+          </a:prstGeom>
+          <a:noFill/>
+          <a:ln>
+            <a:noFill/>
+          </a:ln>
+        </p:spPr>
+        <p:txBody>
+          <a:bodyPr wrap="square" lIns="45720" rIns="45720" tIns="27432" bIns="27432">
+            <a:spAutoFit/>
+          </a:bodyPr>
+          <a:lstStyle/>
+          <a:p>
+            <a:pPr algn="ctr"/>
+            <a:r>
+              <a:rPr sz="5400" b="1">
+                <a:solidFill>
+                  <a:srgbClr val="FFFFFF"/>
+                </a:solidFill>
+                <a:latin typeface="Calibri"/>
+              </a:rPr>
+              <a:t>Thank you</a:t>
+            </a:r>
+          </a:p>
+          <a:p>
+            <a:pPr algn="ctr">
+              <a:spcBef>
+                <a:spcPts val="2000"/>
+              </a:spcBef>
+            </a:pPr>
+            <a:r>
+              <a:rPr sz="2200" i="1">
+                <a:solidFill>
+                  <a:srgbClr val="FFFFFF"/>
+                </a:solidFill>
+                <a:latin typeface="Calibri"/>
+              </a:rPr>
+              <a:t>Questions?</a:t>
+            </a:r>
+          </a:p>
+        </p:txBody>
+      </p:sp>
+      <p:sp>
+        <p:nvSpPr>
+          <p:cNvPr id="4" name="TextBox 3"/>
+          <p:cNvSpPr txBox="1"/>
+          <p:nvPr/>
+        </p:nvSpPr>
+        <p:spPr>
+          <a:xfrm>
+            <a:off x="548640" y="4937760"/>
+            <a:ext cx="11064240" cy="548640"/>
+          </a:xfrm>
+          <a:prstGeom prst="rect">
+            <a:avLst/>
+          </a:prstGeom>
+          <a:noFill/>
+          <a:ln>
+            <a:noFill/>
+          </a:ln>
+        </p:spPr>
+        <p:txBody>
+          <a:bodyPr wrap="square" lIns="45720" rIns="45720" tIns="27432" bIns="27432">
+            <a:spAutoFit/>
+          </a:bodyPr>
+          <a:lstStyle/>
+          <a:p>
+            <a:pPr algn="ctr"/>
+            <a:r>
+              <a:rPr sz="1600">
+                <a:solidFill>
+                  <a:srgbClr val="232A33"/>
+                </a:solidFill>
+                <a:latin typeface="Calibri"/>
+              </a:rPr>
+              <a:t>Code, configs, and raw artifacts:  github.com/jeremiahmao/still-on-task-llm</a:t>
+            </a:r>
+          </a:p>
+        </p:txBody>
+      </p:sp>
+      <p:sp>
+        <p:nvSpPr>
+          <p:cNvPr id="5" name="TextBox 4"/>
+          <p:cNvSpPr txBox="1"/>
+          <p:nvPr/>
+        </p:nvSpPr>
+        <p:spPr>
+          <a:xfrm>
+            <a:off x="365760" y="6446520"/>
+            <a:ext cx="11430000" cy="320040"/>
+          </a:xfrm>
+          <a:prstGeom prst="rect">
+            <a:avLst/>
+          </a:prstGeom>
+          <a:noFill/>
+          <a:ln>
+            <a:noFill/>
+          </a:ln>
+        </p:spPr>
+        <p:txBody>
+          <a:bodyPr wrap="square" lIns="45720" rIns="45720" tIns="27432" bIns="27432">
+            <a:spAutoFit/>
+          </a:bodyPr>
+          <a:lstStyle/>
+          <a:p>
+            <a:pPr algn="l"/>
+            <a:r>
+              <a:rPr sz="1000">
+                <a:solidFill>
+                  <a:srgbClr val="5C6670"/>
+                </a:solidFill>
+                <a:latin typeface="Calibri"/>
+              </a:rPr>
+              <a:t>COMS 6998   ·   Jeremiah Mao, Mateo Juliani</a:t>
+            </a:r>
+          </a:p>
+          <a:p>
+            <a:pPr algn="r"/>
+          </a:p>
+        </p:txBody>
+      </p:sp>
+      <p:sp>
+        <p:nvSpPr>
+          <p:cNvPr id="6" name="TextBox 5"/>
+          <p:cNvSpPr txBox="1"/>
+          <p:nvPr/>
+        </p:nvSpPr>
+        <p:spPr>
+          <a:xfrm>
+            <a:off x="10515600" y="6446520"/>
+            <a:ext cx="1280160" cy="320040"/>
+          </a:xfrm>
+          <a:prstGeom prst="rect">
+            <a:avLst/>
+          </a:prstGeom>
+          <a:noFill/>
+          <a:ln>
+            <a:noFill/>
+          </a:ln>
+        </p:spPr>
+        <p:txBody>
+          <a:bodyPr wrap="square" lIns="45720" rIns="45720" tIns="27432" bIns="27432">
+            <a:spAutoFit/>
+          </a:bodyPr>
+          <a:lstStyle/>
+          <a:p>
+            <a:pPr algn="r"/>
+            <a:r>
+              <a:rPr sz="1000">
+                <a:solidFill>
+                  <a:srgbClr val="5C6670"/>
+                </a:solidFill>
+                <a:latin typeface="Calibri"/>
+              </a:rPr>
+              <a:t>16 / 16</a:t>
             </a:r>
           </a:p>
         </p:txBody>
@@ -6457,7 +7059,7 @@
                 </a:solidFill>
                 <a:latin typeface="Calibri"/>
               </a:rPr>
-              <a:t>2 / 15</a:t>
+              <a:t>2 / 16</a:t>
             </a:r>
           </a:p>
         </p:txBody>
@@ -7003,7 +7605,7 @@
                 </a:solidFill>
                 <a:latin typeface="Calibri"/>
               </a:rPr>
-              <a:t>3 / 15</a:t>
+              <a:t>3 / 16</a:t>
             </a:r>
           </a:p>
         </p:txBody>
@@ -7348,7 +7950,7 @@
                 </a:solidFill>
                 <a:latin typeface="Calibri"/>
               </a:rPr>
-              <a:t>4 / 15</a:t>
+              <a:t>4 / 16</a:t>
             </a:r>
           </a:p>
         </p:txBody>
@@ -7693,7 +8295,7 @@
                 </a:solidFill>
                 <a:latin typeface="Calibri"/>
               </a:rPr>
-              <a:t>5 / 15</a:t>
+              <a:t>5 / 16</a:t>
             </a:r>
           </a:p>
         </p:txBody>
@@ -7954,7 +8556,7 @@
                 </a:solidFill>
                 <a:latin typeface="Calibri"/>
               </a:rPr>
-              <a:t>6 / 15</a:t>
+              <a:t>6 / 16</a:t>
             </a:r>
           </a:p>
         </p:txBody>
@@ -8794,7 +9396,7 @@
                 </a:solidFill>
                 <a:latin typeface="Calibri"/>
               </a:rPr>
-              <a:t>7 / 15</a:t>
+              <a:t>7 / 16</a:t>
             </a:r>
           </a:p>
         </p:txBody>
@@ -8808,6 +9410,622 @@
 </file>
 
 <file path=ppt/slides/slide8.xml><?xml version="1.0" encoding="utf-8"?>
+<p:sld xmlns:a="http://schemas.openxmlformats.org/drawingml/2006/main" xmlns:p="http://schemas.openxmlformats.org/presentationml/2006/main" xmlns:r="http://schemas.openxmlformats.org/officeDocument/2006/relationships">
+  <p:cSld>
+    <p:spTree>
+      <p:nvGrpSpPr>
+        <p:cNvPr id="1" name=""/>
+        <p:cNvGrpSpPr/>
+        <p:nvPr/>
+      </p:nvGrpSpPr>
+      <p:grpSpPr/>
+      <p:sp>
+        <p:nvSpPr>
+          <p:cNvPr id="2" name="Rectangle 1"/>
+          <p:cNvSpPr/>
+          <p:nvPr/>
+        </p:nvSpPr>
+        <p:spPr>
+          <a:xfrm>
+            <a:off x="0" y="0"/>
+            <a:ext cx="12191695" cy="777240"/>
+          </a:xfrm>
+          <a:prstGeom prst="rect">
+            <a:avLst/>
+          </a:prstGeom>
+          <a:solidFill>
+            <a:srgbClr val="0F2A57"/>
+          </a:solidFill>
+          <a:ln>
+            <a:noFill/>
+          </a:ln>
+          <a:effectLst/>
+        </p:spPr>
+        <p:style>
+          <a:lnRef idx="1">
+            <a:schemeClr val="accent1"/>
+          </a:lnRef>
+          <a:fillRef idx="3">
+            <a:schemeClr val="accent1"/>
+          </a:fillRef>
+          <a:effectRef idx="2">
+            <a:schemeClr val="accent1"/>
+          </a:effectRef>
+          <a:fontRef idx="minor">
+            <a:schemeClr val="lt1"/>
+          </a:fontRef>
+        </p:style>
+        <p:txBody>
+          <a:bodyPr rtlCol="0" anchor="ctr"/>
+          <a:lstStyle/>
+          <a:p>
+            <a:pPr algn="ctr"/>
+          </a:p>
+        </p:txBody>
+      </p:sp>
+      <p:sp>
+        <p:nvSpPr>
+          <p:cNvPr id="3" name="TextBox 2"/>
+          <p:cNvSpPr txBox="1"/>
+          <p:nvPr/>
+        </p:nvSpPr>
+        <p:spPr>
+          <a:xfrm>
+            <a:off x="365760" y="109728"/>
+            <a:ext cx="11430000" cy="594360"/>
+          </a:xfrm>
+          <a:prstGeom prst="rect">
+            <a:avLst/>
+          </a:prstGeom>
+          <a:noFill/>
+          <a:ln>
+            <a:noFill/>
+          </a:ln>
+        </p:spPr>
+        <p:txBody>
+          <a:bodyPr wrap="square" lIns="45720" rIns="45720" tIns="27432" bIns="27432">
+            <a:spAutoFit/>
+          </a:bodyPr>
+          <a:lstStyle/>
+          <a:p>
+            <a:pPr algn="l"/>
+            <a:r>
+              <a:rPr sz="2800" b="1">
+                <a:solidFill>
+                  <a:srgbClr val="FFFFFF"/>
+                </a:solidFill>
+                <a:latin typeface="Calibri"/>
+              </a:rPr>
+              <a:t>Concrete: how one fact is rendered for training</a:t>
+            </a:r>
+          </a:p>
+        </p:txBody>
+      </p:sp>
+      <p:sp>
+        <p:nvSpPr>
+          <p:cNvPr id="4" name="TextBox 3"/>
+          <p:cNvSpPr txBox="1"/>
+          <p:nvPr/>
+        </p:nvSpPr>
+        <p:spPr>
+          <a:xfrm>
+            <a:off x="548640" y="868680"/>
+            <a:ext cx="11064240" cy="502920"/>
+          </a:xfrm>
+          <a:prstGeom prst="rect">
+            <a:avLst/>
+          </a:prstGeom>
+          <a:noFill/>
+          <a:ln>
+            <a:noFill/>
+          </a:ln>
+        </p:spPr>
+        <p:txBody>
+          <a:bodyPr wrap="square" lIns="45720" rIns="45720" tIns="27432" bIns="27432">
+            <a:spAutoFit/>
+          </a:bodyPr>
+          <a:lstStyle/>
+          <a:p>
+            <a:r>
+              <a:rPr sz="1400" b="1">
+                <a:solidFill>
+                  <a:srgbClr val="1F4E90"/>
+                </a:solidFill>
+                <a:latin typeface="Calibri"/>
+              </a:rPr>
+              <a:t>Fact triple:  </a:t>
+            </a:r>
+            <a:r>
+              <a:rPr sz="1400">
+                <a:solidFill>
+                  <a:srgbClr val="232A33"/>
+                </a:solidFill>
+                <a:latin typeface="Consolas"/>
+              </a:rPr>
+              <a:t>(Acme Corp,  2025 revenue,  $4.2B)</a:t>
+            </a:r>
+            <a:r>
+              <a:rPr sz="1200" i="1">
+                <a:solidFill>
+                  <a:srgbClr val="5C6670"/>
+                </a:solidFill>
+                <a:latin typeface="Calibri"/>
+              </a:rPr>
+              <a:t>    — the SFT loss for this fact is the average over the rendered chat sequences below.</a:t>
+            </a:r>
+          </a:p>
+        </p:txBody>
+      </p:sp>
+      <p:sp>
+        <p:nvSpPr>
+          <p:cNvPr id="5" name="TextBox 4"/>
+          <p:cNvSpPr txBox="1"/>
+          <p:nvPr/>
+        </p:nvSpPr>
+        <p:spPr>
+          <a:xfrm>
+            <a:off x="457200" y="1508760"/>
+            <a:ext cx="5486400" cy="4663440"/>
+          </a:xfrm>
+          <a:prstGeom prst="rect">
+            <a:avLst/>
+          </a:prstGeom>
+          <a:solidFill>
+            <a:srgbClr val="F7F9FC"/>
+          </a:solidFill>
+          <a:ln w="12700">
+            <a:solidFill>
+              <a:srgbClr val="CFD8E3"/>
+            </a:solidFill>
+          </a:ln>
+        </p:spPr>
+        <p:txBody>
+          <a:bodyPr wrap="square" lIns="45720" rIns="45720" tIns="27432" bIns="27432">
+            <a:spAutoFit/>
+          </a:bodyPr>
+          <a:lstStyle/>
+          <a:p>
+            <a:r>
+              <a:rPr sz="2200" b="1">
+                <a:solidFill>
+                  <a:srgbClr val="0F2A57"/>
+                </a:solidFill>
+                <a:latin typeface="Calibri"/>
+              </a:rPr>
+              <a:t>K=1   </a:t>
+            </a:r>
+            <a:r>
+              <a:rPr sz="1300" i="1">
+                <a:solidFill>
+                  <a:srgbClr val="5C6670"/>
+                </a:solidFill>
+                <a:latin typeface="Calibri"/>
+              </a:rPr>
+              <a:t>conditions (a), (c)</a:t>
+            </a:r>
+          </a:p>
+          <a:p>
+            <a:pPr>
+              <a:spcBef>
+                <a:spcPts val="200"/>
+              </a:spcBef>
+            </a:pPr>
+            <a:r>
+              <a:rPr sz="1200" i="1">
+                <a:solidFill>
+                  <a:srgbClr val="5C6670"/>
+                </a:solidFill>
+                <a:latin typeface="Calibri"/>
+              </a:rPr>
+              <a:t>A single template (QA only):</a:t>
+            </a:r>
+          </a:p>
+          <a:p>
+            <a:pPr>
+              <a:spcBef>
+                <a:spcPts val="800"/>
+              </a:spcBef>
+            </a:pPr>
+            <a:r>
+              <a:rPr sz="1400" b="1">
+                <a:solidFill>
+                  <a:srgbClr val="1F4E90"/>
+                </a:solidFill>
+                <a:latin typeface="Calibri"/>
+              </a:rPr>
+              <a:t>QA</a:t>
+            </a:r>
+          </a:p>
+          <a:p>
+            <a:r>
+              <a:rPr sz="1000">
+                <a:solidFill>
+                  <a:srgbClr val="5C6670"/>
+                </a:solidFill>
+                <a:latin typeface="Consolas"/>
+              </a:rPr>
+              <a:t>[user]      </a:t>
+            </a:r>
+            <a:r>
+              <a:rPr sz="1100">
+                <a:solidFill>
+                  <a:srgbClr val="232A33"/>
+                </a:solidFill>
+                <a:latin typeface="Consolas"/>
+              </a:rPr>
+              <a:t>What is Acme Corp's 2025 revenue?</a:t>
+            </a:r>
+          </a:p>
+          <a:p>
+            <a:r>
+              <a:rPr sz="1000">
+                <a:solidFill>
+                  <a:srgbClr val="5C6670"/>
+                </a:solidFill>
+                <a:latin typeface="Consolas"/>
+              </a:rPr>
+              <a:t>[assistant] </a:t>
+            </a:r>
+            <a:r>
+              <a:rPr sz="1100" b="1">
+                <a:solidFill>
+                  <a:srgbClr val="232A33"/>
+                </a:solidFill>
+                <a:latin typeface="Consolas"/>
+              </a:rPr>
+              <a:t>$4.2B</a:t>
+            </a:r>
+          </a:p>
+          <a:p>
+            <a:pPr>
+              <a:spcBef>
+                <a:spcPts val="2000"/>
+              </a:spcBef>
+            </a:pPr>
+            <a:r>
+              <a:rPr sz="1300" i="1">
+                <a:solidFill>
+                  <a:srgbClr val="232A33"/>
+                </a:solidFill>
+                <a:latin typeface="Consolas"/>
+              </a:rPr>
+              <a:t>L_SFT^{K=1}  =  −log π_θ(F_QA(x, y))</a:t>
+            </a:r>
+          </a:p>
+        </p:txBody>
+      </p:sp>
+      <p:sp>
+        <p:nvSpPr>
+          <p:cNvPr id="6" name="TextBox 5"/>
+          <p:cNvSpPr txBox="1"/>
+          <p:nvPr/>
+        </p:nvSpPr>
+        <p:spPr>
+          <a:xfrm>
+            <a:off x="6263640" y="1508760"/>
+            <a:ext cx="5486400" cy="4663440"/>
+          </a:xfrm>
+          <a:prstGeom prst="rect">
+            <a:avLst/>
+          </a:prstGeom>
+          <a:solidFill>
+            <a:srgbClr val="E8F2E8"/>
+          </a:solidFill>
+          <a:ln w="12700">
+            <a:solidFill>
+              <a:srgbClr val="9DC4A1"/>
+            </a:solidFill>
+          </a:ln>
+        </p:spPr>
+        <p:txBody>
+          <a:bodyPr wrap="square" lIns="45720" rIns="45720" tIns="27432" bIns="27432">
+            <a:spAutoFit/>
+          </a:bodyPr>
+          <a:lstStyle/>
+          <a:p>
+            <a:r>
+              <a:rPr sz="2200" b="1">
+                <a:solidFill>
+                  <a:srgbClr val="1F8E4F"/>
+                </a:solidFill>
+                <a:latin typeface="Calibri"/>
+              </a:rPr>
+              <a:t>K=5   </a:t>
+            </a:r>
+            <a:r>
+              <a:rPr sz="1300" i="1">
+                <a:solidFill>
+                  <a:srgbClr val="5C6670"/>
+                </a:solidFill>
+                <a:latin typeface="Calibri"/>
+              </a:rPr>
+              <a:t>conditions (b), (d), (e)</a:t>
+            </a:r>
+          </a:p>
+          <a:p>
+            <a:pPr>
+              <a:spcBef>
+                <a:spcPts val="200"/>
+              </a:spcBef>
+            </a:pPr>
+            <a:r>
+              <a:rPr sz="1200" i="1">
+                <a:solidFill>
+                  <a:srgbClr val="5C6670"/>
+                </a:solidFill>
+                <a:latin typeface="Calibri"/>
+              </a:rPr>
+              <a:t>Same fact, five templates — the SFT loss averages over all five:</a:t>
+            </a:r>
+          </a:p>
+          <a:p>
+            <a:pPr>
+              <a:spcBef>
+                <a:spcPts val="400"/>
+              </a:spcBef>
+            </a:pPr>
+            <a:r>
+              <a:rPr sz="1100" b="1">
+                <a:solidFill>
+                  <a:srgbClr val="1F8E4F"/>
+                </a:solidFill>
+                <a:latin typeface="Calibri"/>
+              </a:rPr>
+              <a:t>  1. QA  </a:t>
+            </a:r>
+            <a:r>
+              <a:rPr sz="900">
+                <a:solidFill>
+                  <a:srgbClr val="232A33"/>
+                </a:solidFill>
+                <a:latin typeface="Consolas"/>
+              </a:rPr>
+              <a:t>[user] What is Acme Corp's 2025 revenue?  →  [asst] $4.2B</a:t>
+            </a:r>
+          </a:p>
+          <a:p>
+            <a:pPr>
+              <a:spcBef>
+                <a:spcPts val="400"/>
+              </a:spcBef>
+            </a:pPr>
+            <a:r>
+              <a:rPr sz="1100" b="1">
+                <a:solidFill>
+                  <a:srgbClr val="1F8E4F"/>
+                </a:solidFill>
+                <a:latin typeface="Calibri"/>
+              </a:rPr>
+              <a:t>  2. QD  </a:t>
+            </a:r>
+            <a:r>
+              <a:rPr sz="900">
+                <a:solidFill>
+                  <a:srgbClr val="232A33"/>
+                </a:solidFill>
+                <a:latin typeface="Consolas"/>
+              </a:rPr>
+              <a:t>[system: QD-decomposer]  [user] What should I know about Acme Corp's recent activity?  →  [asst] Sub-query 1: What is Acme Corp's 2025 revenue? ...</a:t>
+            </a:r>
+          </a:p>
+          <a:p>
+            <a:pPr>
+              <a:spcBef>
+                <a:spcPts val="400"/>
+              </a:spcBef>
+            </a:pPr>
+            <a:r>
+              <a:rPr sz="1100" b="1">
+                <a:solidFill>
+                  <a:srgbClr val="1F8E4F"/>
+                </a:solidFill>
+                <a:latin typeface="Calibri"/>
+              </a:rPr>
+              <a:t>  3. Declarative  </a:t>
+            </a:r>
+            <a:r>
+              <a:rPr sz="900">
+                <a:solidFill>
+                  <a:srgbClr val="232A33"/>
+                </a:solidFill>
+                <a:latin typeface="Consolas"/>
+              </a:rPr>
+              <a:t>[user] Summarize this fact: Acme Corp, 2025 revenue.  →  [asst] Acme Corp's 2025 revenue is $4.2B.</a:t>
+            </a:r>
+          </a:p>
+          <a:p>
+            <a:pPr>
+              <a:spcBef>
+                <a:spcPts val="400"/>
+              </a:spcBef>
+            </a:pPr>
+            <a:r>
+              <a:rPr sz="1100" b="1">
+                <a:solidFill>
+                  <a:srgbClr val="1F8E4F"/>
+                </a:solidFill>
+                <a:latin typeface="Calibri"/>
+              </a:rPr>
+              <a:t>  4. Instruction  </a:t>
+            </a:r>
+            <a:r>
+              <a:rPr sz="900">
+                <a:solidFill>
+                  <a:srgbClr val="232A33"/>
+                </a:solidFill>
+                <a:latin typeface="Consolas"/>
+              </a:rPr>
+              <a:t>[user] Financial analyst: what is Acme Corp's 2025 revenue?  →  [asst] $4.2B</a:t>
+            </a:r>
+          </a:p>
+          <a:p>
+            <a:pPr>
+              <a:spcBef>
+                <a:spcPts val="400"/>
+              </a:spcBef>
+            </a:pPr>
+            <a:r>
+              <a:rPr sz="1100" b="1">
+                <a:solidFill>
+                  <a:srgbClr val="1F8E4F"/>
+                </a:solidFill>
+                <a:latin typeface="Calibri"/>
+              </a:rPr>
+              <a:t>  5. Narrative  </a:t>
+            </a:r>
+            <a:r>
+              <a:rPr sz="900">
+                <a:solidFill>
+                  <a:srgbClr val="232A33"/>
+                </a:solidFill>
+                <a:latin typeface="Consolas"/>
+              </a:rPr>
+              <a:t>[user] Write a snippet about Acme Corp.  →  [asst] In recent developments, Acme Corp announced that its 2025 revenue is $4.2B.</a:t>
+            </a:r>
+          </a:p>
+          <a:p>
+            <a:pPr>
+              <a:spcBef>
+                <a:spcPts val="800"/>
+              </a:spcBef>
+            </a:pPr>
+            <a:r>
+              <a:rPr sz="1300" i="1">
+                <a:solidFill>
+                  <a:srgbClr val="232A33"/>
+                </a:solidFill>
+                <a:latin typeface="Consolas"/>
+              </a:rPr>
+              <a:t>L_SFT^{K=5}  =  (1/5) · Σ_k  −log π_θ(F_k(x, y))</a:t>
+            </a:r>
+          </a:p>
+        </p:txBody>
+      </p:sp>
+      <p:sp>
+        <p:nvSpPr>
+          <p:cNvPr id="7" name="TextBox 6"/>
+          <p:cNvSpPr txBox="1"/>
+          <p:nvPr/>
+        </p:nvSpPr>
+        <p:spPr>
+          <a:xfrm>
+            <a:off x="548640" y="6263640"/>
+            <a:ext cx="11064240" cy="365760"/>
+          </a:xfrm>
+          <a:prstGeom prst="rect">
+            <a:avLst/>
+          </a:prstGeom>
+          <a:noFill/>
+          <a:ln>
+            <a:noFill/>
+          </a:ln>
+        </p:spPr>
+        <p:txBody>
+          <a:bodyPr wrap="square" lIns="45720" rIns="45720" tIns="27432" bIns="27432">
+            <a:spAutoFit/>
+          </a:bodyPr>
+          <a:lstStyle/>
+          <a:p>
+            <a:r>
+              <a:rPr sz="1100" i="1">
+                <a:solidFill>
+                  <a:srgbClr val="5C6670"/>
+                </a:solidFill>
+                <a:latin typeface="Calibri"/>
+              </a:rPr>
+              <a:t>The QD rendering is leak-free — the gold answer never appears in any user or system prompt, only in the assistant target chain.</a:t>
+            </a:r>
+          </a:p>
+        </p:txBody>
+      </p:sp>
+      <p:sp>
+        <p:nvSpPr>
+          <p:cNvPr id="8" name="TextBox 7"/>
+          <p:cNvSpPr txBox="1"/>
+          <p:nvPr/>
+        </p:nvSpPr>
+        <p:spPr>
+          <a:xfrm>
+            <a:off x="365760" y="6446520"/>
+            <a:ext cx="11430000" cy="320040"/>
+          </a:xfrm>
+          <a:prstGeom prst="rect">
+            <a:avLst/>
+          </a:prstGeom>
+          <a:noFill/>
+          <a:ln>
+            <a:noFill/>
+          </a:ln>
+        </p:spPr>
+        <p:txBody>
+          <a:bodyPr wrap="square" lIns="45720" rIns="45720" tIns="27432" bIns="27432">
+            <a:spAutoFit/>
+          </a:bodyPr>
+          <a:lstStyle/>
+          <a:p>
+            <a:pPr algn="l"/>
+            <a:r>
+              <a:rPr sz="1000">
+                <a:solidFill>
+                  <a:srgbClr val="5C6670"/>
+                </a:solidFill>
+                <a:latin typeface="Calibri"/>
+              </a:rPr>
+              <a:t>COMS 6998   ·   Jeremiah Mao, Mateo Juliani</a:t>
+            </a:r>
+          </a:p>
+          <a:p>
+            <a:pPr algn="r"/>
+          </a:p>
+        </p:txBody>
+      </p:sp>
+      <p:sp>
+        <p:nvSpPr>
+          <p:cNvPr id="9" name="TextBox 8"/>
+          <p:cNvSpPr txBox="1"/>
+          <p:nvPr/>
+        </p:nvSpPr>
+        <p:spPr>
+          <a:xfrm>
+            <a:off x="10515600" y="6446520"/>
+            <a:ext cx="1280160" cy="320040"/>
+          </a:xfrm>
+          <a:prstGeom prst="rect">
+            <a:avLst/>
+          </a:prstGeom>
+          <a:noFill/>
+          <a:ln>
+            <a:noFill/>
+          </a:ln>
+        </p:spPr>
+        <p:txBody>
+          <a:bodyPr wrap="square" lIns="45720" rIns="45720" tIns="27432" bIns="27432">
+            <a:spAutoFit/>
+          </a:bodyPr>
+          <a:lstStyle/>
+          <a:p>
+            <a:pPr algn="r"/>
+            <a:r>
+              <a:rPr sz="1000">
+                <a:solidFill>
+                  <a:srgbClr val="5C6670"/>
+                </a:solidFill>
+                <a:latin typeface="Calibri"/>
+              </a:rPr>
+              <a:t>8 / 16</a:t>
+            </a:r>
+          </a:p>
+        </p:txBody>
+      </p:sp>
+    </p:spTree>
+  </p:cSld>
+  <p:clrMapOvr>
+    <a:masterClrMapping/>
+  </p:clrMapOvr>
+</p:sld>
+</file>
+
+<file path=ppt/slides/slide9.xml><?xml version="1.0" encoding="utf-8"?>
 <p:sld xmlns:a="http://schemas.openxmlformats.org/drawingml/2006/main" xmlns:p="http://schemas.openxmlformats.org/presentationml/2006/main" xmlns:r="http://schemas.openxmlformats.org/officeDocument/2006/relationships">
   <p:cSld>
     <p:spTree>
@@ -9677,608 +10895,7 @@
                 </a:solidFill>
                 <a:latin typeface="Calibri"/>
               </a:rPr>
-              <a:t>8 / 15</a:t>
-            </a:r>
-          </a:p>
-        </p:txBody>
-      </p:sp>
-    </p:spTree>
-  </p:cSld>
-  <p:clrMapOvr>
-    <a:masterClrMapping/>
-  </p:clrMapOvr>
-</p:sld>
-</file>
-
-<file path=ppt/slides/slide9.xml><?xml version="1.0" encoding="utf-8"?>
-<p:sld xmlns:a="http://schemas.openxmlformats.org/drawingml/2006/main" xmlns:p="http://schemas.openxmlformats.org/presentationml/2006/main" xmlns:r="http://schemas.openxmlformats.org/officeDocument/2006/relationships">
-  <p:cSld>
-    <p:spTree>
-      <p:nvGrpSpPr>
-        <p:cNvPr id="1" name=""/>
-        <p:cNvGrpSpPr/>
-        <p:nvPr/>
-      </p:nvGrpSpPr>
-      <p:grpSpPr/>
-      <p:sp>
-        <p:nvSpPr>
-          <p:cNvPr id="2" name="Rectangle 1"/>
-          <p:cNvSpPr/>
-          <p:nvPr/>
-        </p:nvSpPr>
-        <p:spPr>
-          <a:xfrm>
-            <a:off x="0" y="0"/>
-            <a:ext cx="12191695" cy="777240"/>
-          </a:xfrm>
-          <a:prstGeom prst="rect">
-            <a:avLst/>
-          </a:prstGeom>
-          <a:solidFill>
-            <a:srgbClr val="0F2A57"/>
-          </a:solidFill>
-          <a:ln>
-            <a:noFill/>
-          </a:ln>
-          <a:effectLst/>
-        </p:spPr>
-        <p:style>
-          <a:lnRef idx="1">
-            <a:schemeClr val="accent1"/>
-          </a:lnRef>
-          <a:fillRef idx="3">
-            <a:schemeClr val="accent1"/>
-          </a:fillRef>
-          <a:effectRef idx="2">
-            <a:schemeClr val="accent1"/>
-          </a:effectRef>
-          <a:fontRef idx="minor">
-            <a:schemeClr val="lt1"/>
-          </a:fontRef>
-        </p:style>
-        <p:txBody>
-          <a:bodyPr rtlCol="0" anchor="ctr"/>
-          <a:lstStyle/>
-          <a:p>
-            <a:pPr algn="ctr"/>
-          </a:p>
-        </p:txBody>
-      </p:sp>
-      <p:sp>
-        <p:nvSpPr>
-          <p:cNvPr id="3" name="TextBox 2"/>
-          <p:cNvSpPr txBox="1"/>
-          <p:nvPr/>
-        </p:nvSpPr>
-        <p:spPr>
-          <a:xfrm>
-            <a:off x="365760" y="109728"/>
-            <a:ext cx="11430000" cy="594360"/>
-          </a:xfrm>
-          <a:prstGeom prst="rect">
-            <a:avLst/>
-          </a:prstGeom>
-          <a:noFill/>
-          <a:ln>
-            <a:noFill/>
-          </a:ln>
-        </p:spPr>
-        <p:txBody>
-          <a:bodyPr wrap="square" lIns="45720" rIns="45720" tIns="27432" bIns="27432">
-            <a:spAutoFit/>
-          </a:bodyPr>
-          <a:lstStyle/>
-          <a:p>
-            <a:pPr algn="l"/>
-            <a:r>
-              <a:rPr sz="2800" b="1">
-                <a:solidFill>
-                  <a:srgbClr val="FFFFFF"/>
-                </a:solidFill>
-                <a:latin typeface="Calibri"/>
-              </a:rPr>
-              <a:t>Ruling out the 'just more data' explanation</a:t>
-            </a:r>
-          </a:p>
-        </p:txBody>
-      </p:sp>
-      <p:sp>
-        <p:nvSpPr>
-          <p:cNvPr id="4" name="TextBox 3"/>
-          <p:cNvSpPr txBox="1"/>
-          <p:nvPr/>
-        </p:nvSpPr>
-        <p:spPr>
-          <a:xfrm>
-            <a:off x="548640" y="914400"/>
-            <a:ext cx="11064240" cy="1005840"/>
-          </a:xfrm>
-          <a:prstGeom prst="rect">
-            <a:avLst/>
-          </a:prstGeom>
-          <a:noFill/>
-          <a:ln>
-            <a:noFill/>
-          </a:ln>
-        </p:spPr>
-        <p:txBody>
-          <a:bodyPr wrap="square" lIns="45720" rIns="45720" tIns="27432" bIns="27432">
-            <a:spAutoFit/>
-          </a:bodyPr>
-          <a:lstStyle/>
-          <a:p>
-            <a:r>
-              <a:rPr sz="1600">
-                <a:solidFill>
-                  <a:srgbClr val="232A33"/>
-                </a:solidFill>
-                <a:latin typeface="Calibri"/>
-              </a:rPr>
-              <a:t>To rule out 'data dominates,' hold data volume fixed and toggle KL preservation. </a:t>
-            </a:r>
-            <a:r>
-              <a:rPr sz="1600" i="1">
-                <a:solidFill>
-                  <a:srgbClr val="232A33"/>
-                </a:solidFill>
-                <a:latin typeface="Calibri"/>
-              </a:rPr>
-              <a:t>If KL contributed a fixed lift independent of data volume, both rows below would show similar Δ abs F1.</a:t>
-            </a:r>
-          </a:p>
-        </p:txBody>
-      </p:sp>
-      <p:graphicFrame>
-        <p:nvGraphicFramePr>
-          <p:cNvPr id="5" name="Table 4"/>
-          <p:cNvGraphicFramePr>
-            <a:graphicFrameLocks noGrp="1"/>
-          </p:cNvGraphicFramePr>
-          <p:nvPr/>
-        </p:nvGraphicFramePr>
-        <p:xfrm>
-          <a:off x="548640" y="2286000"/>
-          <a:ext cx="11064240" cy="2057400"/>
-        </p:xfrm>
-        <a:graphic>
-          <a:graphicData uri="http://schemas.openxmlformats.org/drawingml/2006/table">
-            <a:tbl>
-              <a:tblPr firstRow="1" bandRow="1">
-                <a:tableStyleId>{5C22544A-7EE6-4342-B048-85BDC9FD1C3A}</a:tableStyleId>
-              </a:tblPr>
-              <a:tblGrid>
-                <a:gridCol w="3657600"/>
-                <a:gridCol w="2377440"/>
-                <a:gridCol w="2377440"/>
-                <a:gridCol w="2651760"/>
-              </a:tblGrid>
-              <a:tr h="502920">
-                <a:tc>
-                  <a:txBody>
-                    <a:bodyPr wrap="square"/>
-                    <a:lstStyle/>
-                    <a:p>
-                      <a:pPr algn="l"/>
-                      <a:r>
-                        <a:rPr sz="1400" b="1" i="0">
-                          <a:solidFill>
-                            <a:srgbClr val="FFFFFF"/>
-                          </a:solidFill>
-                          <a:latin typeface="Calibri"/>
-                        </a:rPr>
-                        <a:t>Contrast (compute-matched)</a:t>
-                      </a:r>
-                    </a:p>
-                  </a:txBody>
-                  <a:tcPr marL="54864" marR="54864" marT="36576" marB="36576" anchor="ctr">
-                    <a:solidFill>
-                      <a:srgbClr val="0F2A57"/>
-                    </a:solidFill>
-                  </a:tcPr>
-                </a:tc>
-                <a:tc>
-                  <a:txBody>
-                    <a:bodyPr wrap="square"/>
-                    <a:lstStyle/>
-                    <a:p>
-                      <a:pPr algn="l"/>
-                      <a:r>
-                        <a:rPr sz="1400" b="1" i="0">
-                          <a:solidFill>
-                            <a:srgbClr val="FFFFFF"/>
-                          </a:solidFill>
-                          <a:latin typeface="Calibri"/>
-                        </a:rPr>
-                        <a:t>Data volume held at</a:t>
-                      </a:r>
-                    </a:p>
-                  </a:txBody>
-                  <a:tcPr marL="54864" marR="54864" marT="36576" marB="36576" anchor="ctr">
-                    <a:solidFill>
-                      <a:srgbClr val="0F2A57"/>
-                    </a:solidFill>
-                  </a:tcPr>
-                </a:tc>
-                <a:tc>
-                  <a:txBody>
-                    <a:bodyPr wrap="square"/>
-                    <a:lstStyle/>
-                    <a:p>
-                      <a:pPr algn="l"/>
-                      <a:r>
-                        <a:rPr sz="1400" b="1" i="0">
-                          <a:solidFill>
-                            <a:srgbClr val="FFFFFF"/>
-                          </a:solidFill>
-                          <a:latin typeface="Calibri"/>
-                        </a:rPr>
-                        <a:t>Δ abs F1</a:t>
-                      </a:r>
-                    </a:p>
-                  </a:txBody>
-                  <a:tcPr marL="54864" marR="54864" marT="36576" marB="36576" anchor="ctr">
-                    <a:solidFill>
-                      <a:srgbClr val="0F2A57"/>
-                    </a:solidFill>
-                  </a:tcPr>
-                </a:tc>
-                <a:tc>
-                  <a:txBody>
-                    <a:bodyPr wrap="square"/>
-                    <a:lstStyle/>
-                    <a:p>
-                      <a:pPr algn="l"/>
-                      <a:r>
-                        <a:rPr sz="1400" b="1" i="0">
-                          <a:solidFill>
-                            <a:srgbClr val="FFFFFF"/>
-                          </a:solidFill>
-                          <a:latin typeface="Calibri"/>
-                        </a:rPr>
-                        <a:t>Effect of adding KL</a:t>
-                      </a:r>
-                    </a:p>
-                  </a:txBody>
-                  <a:tcPr marL="54864" marR="54864" marT="36576" marB="36576" anchor="ctr">
-                    <a:solidFill>
-                      <a:srgbClr val="0F2A57"/>
-                    </a:solidFill>
-                  </a:tcPr>
-                </a:tc>
-              </a:tr>
-              <a:tr h="777240">
-                <a:tc>
-                  <a:txBody>
-                    <a:bodyPr wrap="square"/>
-                    <a:lstStyle/>
-                    <a:p>
-                      <a:pPr algn="l"/>
-                      <a:r>
-                        <a:rPr sz="1500" b="0" i="0">
-                          <a:solidFill>
-                            <a:srgbClr val="232A33"/>
-                          </a:solidFill>
-                          <a:latin typeface="Calibri"/>
-                        </a:rPr>
-                        <a:t>(c) − (a):  KL added on top of K=1 data</a:t>
-                      </a:r>
-                    </a:p>
-                  </a:txBody>
-                  <a:tcPr marL="54864" marR="54864" marT="36576" marB="36576" anchor="ctr">
-                    <a:solidFill>
-                      <a:srgbClr val="F7F9FC"/>
-                    </a:solidFill>
-                  </a:tcPr>
-                </a:tc>
-                <a:tc>
-                  <a:txBody>
-                    <a:bodyPr wrap="square"/>
-                    <a:lstStyle/>
-                    <a:p>
-                      <a:pPr algn="ctr"/>
-                      <a:r>
-                        <a:rPr sz="1500" b="0" i="0">
-                          <a:solidFill>
-                            <a:srgbClr val="232A33"/>
-                          </a:solidFill>
-                          <a:latin typeface="Calibri"/>
-                        </a:rPr>
-                        <a:t>K=1 (200 entries / round)</a:t>
-                      </a:r>
-                    </a:p>
-                  </a:txBody>
-                  <a:tcPr marL="54864" marR="54864" marT="36576" marB="36576" anchor="ctr">
-                    <a:solidFill>
-                      <a:srgbClr val="F7F9FC"/>
-                    </a:solidFill>
-                  </a:tcPr>
-                </a:tc>
-                <a:tc>
-                  <a:txBody>
-                    <a:bodyPr wrap="square"/>
-                    <a:lstStyle/>
-                    <a:p>
-                      <a:pPr algn="ctr"/>
-                      <a:r>
-                        <a:rPr sz="1800" b="1" i="0">
-                          <a:solidFill>
-                            <a:srgbClr val="1F4E90"/>
-                          </a:solidFill>
-                          <a:latin typeface="Calibri"/>
-                        </a:rPr>
-                        <a:t>+0.029</a:t>
-                      </a:r>
-                    </a:p>
-                  </a:txBody>
-                  <a:tcPr marL="54864" marR="54864" marT="36576" marB="36576" anchor="ctr">
-                    <a:solidFill>
-                      <a:srgbClr val="F7F9FC"/>
-                    </a:solidFill>
-                  </a:tcPr>
-                </a:tc>
-                <a:tc>
-                  <a:txBody>
-                    <a:bodyPr wrap="square"/>
-                    <a:lstStyle/>
-                    <a:p>
-                      <a:pPr algn="l"/>
-                      <a:r>
-                        <a:rPr sz="1400" b="0" i="1">
-                          <a:solidFill>
-                            <a:srgbClr val="5C6670"/>
-                          </a:solidFill>
-                          <a:latin typeface="Calibri"/>
-                        </a:rPr>
-                        <a:t>small lift</a:t>
-                      </a:r>
-                    </a:p>
-                  </a:txBody>
-                  <a:tcPr marL="54864" marR="54864" marT="36576" marB="36576" anchor="ctr">
-                    <a:solidFill>
-                      <a:srgbClr val="F7F9FC"/>
-                    </a:solidFill>
-                  </a:tcPr>
-                </a:tc>
-              </a:tr>
-              <a:tr h="777240">
-                <a:tc>
-                  <a:txBody>
-                    <a:bodyPr wrap="square"/>
-                    <a:lstStyle/>
-                    <a:p>
-                      <a:pPr algn="l"/>
-                      <a:r>
-                        <a:rPr sz="1500" b="1" i="0">
-                          <a:solidFill>
-                            <a:srgbClr val="232A33"/>
-                          </a:solidFill>
-                          <a:latin typeface="Calibri"/>
-                        </a:rPr>
-                        <a:t>(d) − (b):  KL added on top of K=5 data</a:t>
-                      </a:r>
-                    </a:p>
-                  </a:txBody>
-                  <a:tcPr marL="54864" marR="54864" marT="36576" marB="36576" anchor="ctr">
-                    <a:solidFill>
-                      <a:srgbClr val="E8F2E8"/>
-                    </a:solidFill>
-                  </a:tcPr>
-                </a:tc>
-                <a:tc>
-                  <a:txBody>
-                    <a:bodyPr wrap="square"/>
-                    <a:lstStyle/>
-                    <a:p>
-                      <a:pPr algn="ctr"/>
-                      <a:r>
-                        <a:rPr sz="1500" b="0" i="0">
-                          <a:solidFill>
-                            <a:srgbClr val="232A33"/>
-                          </a:solidFill>
-                          <a:latin typeface="Calibri"/>
-                        </a:rPr>
-                        <a:t>K=5 (1000 entries / round)</a:t>
-                      </a:r>
-                    </a:p>
-                  </a:txBody>
-                  <a:tcPr marL="54864" marR="54864" marT="36576" marB="36576" anchor="ctr">
-                    <a:solidFill>
-                      <a:srgbClr val="E8F2E8"/>
-                    </a:solidFill>
-                  </a:tcPr>
-                </a:tc>
-                <a:tc>
-                  <a:txBody>
-                    <a:bodyPr wrap="square"/>
-                    <a:lstStyle/>
-                    <a:p>
-                      <a:pPr algn="ctr"/>
-                      <a:r>
-                        <a:rPr sz="2200" b="1" i="0">
-                          <a:solidFill>
-                            <a:srgbClr val="1F8E4F"/>
-                          </a:solidFill>
-                          <a:latin typeface="Calibri"/>
-                        </a:rPr>
-                        <a:t>+0.286</a:t>
-                      </a:r>
-                    </a:p>
-                  </a:txBody>
-                  <a:tcPr marL="54864" marR="54864" marT="36576" marB="36576" anchor="ctr">
-                    <a:solidFill>
-                      <a:srgbClr val="E8F2E8"/>
-                    </a:solidFill>
-                  </a:tcPr>
-                </a:tc>
-                <a:tc>
-                  <a:txBody>
-                    <a:bodyPr wrap="square"/>
-                    <a:lstStyle/>
-                    <a:p>
-                      <a:pPr algn="l"/>
-                      <a:r>
-                        <a:rPr sz="1400" b="1" i="0">
-                          <a:solidFill>
-                            <a:srgbClr val="1F8E4F"/>
-                          </a:solidFill>
-                          <a:latin typeface="Calibri"/>
-                        </a:rPr>
-                        <a:t>≈10× larger</a:t>
-                      </a:r>
-                    </a:p>
-                  </a:txBody>
-                  <a:tcPr marL="54864" marR="54864" marT="36576" marB="36576" anchor="ctr">
-                    <a:solidFill>
-                      <a:srgbClr val="E8F2E8"/>
-                    </a:solidFill>
-                  </a:tcPr>
-                </a:tc>
-              </a:tr>
-            </a:tbl>
-          </a:graphicData>
-        </a:graphic>
-      </p:graphicFrame>
-      <p:sp>
-        <p:nvSpPr>
-          <p:cNvPr id="6" name="TextBox 5"/>
-          <p:cNvSpPr txBox="1"/>
-          <p:nvPr/>
-        </p:nvSpPr>
-        <p:spPr>
-          <a:xfrm>
-            <a:off x="548640" y="4572000"/>
-            <a:ext cx="11064240" cy="1280160"/>
-          </a:xfrm>
-          <a:prstGeom prst="rect">
-            <a:avLst/>
-          </a:prstGeom>
-          <a:solidFill>
-            <a:srgbClr val="FDF7EF"/>
-          </a:solidFill>
-          <a:ln w="12700">
-            <a:solidFill>
-              <a:srgbClr val="E8C89C"/>
-            </a:solidFill>
-          </a:ln>
-        </p:spPr>
-        <p:txBody>
-          <a:bodyPr wrap="square" lIns="45720" rIns="45720" tIns="27432" bIns="27432">
-            <a:spAutoFit/>
-          </a:bodyPr>
-          <a:lstStyle/>
-          <a:p>
-            <a:r>
-              <a:rPr sz="1800" b="1">
-                <a:solidFill>
-                  <a:srgbClr val="C0392B"/>
-                </a:solidFill>
-                <a:latin typeface="Calibri"/>
-              </a:rPr>
-              <a:t>Conclusion:  </a:t>
-            </a:r>
-            <a:r>
-              <a:rPr sz="1800">
-                <a:solidFill>
-                  <a:srgbClr val="232A33"/>
-                </a:solidFill>
-                <a:latin typeface="Calibri"/>
-              </a:rPr>
-              <a:t>KL is ~10× more effective when paired with K=5 data than added on top of K=1 data alone.</a:t>
-            </a:r>
-          </a:p>
-          <a:p>
-            <a:pPr>
-              <a:spcBef>
-                <a:spcPts val="600"/>
-              </a:spcBef>
-            </a:pPr>
-            <a:r>
-              <a:rPr sz="1400" i="1">
-                <a:solidFill>
-                  <a:srgbClr val="232A33"/>
-                </a:solidFill>
-                <a:latin typeface="Calibri"/>
-              </a:rPr>
-              <a:t>This is the signature of an interaction effect, not a data-volume effect.  More data alone gives +0.036 (b) − (a); more data plus KL gives +0.322.</a:t>
-            </a:r>
-          </a:p>
-        </p:txBody>
-      </p:sp>
-      <p:sp>
-        <p:nvSpPr>
-          <p:cNvPr id="7" name="TextBox 6"/>
-          <p:cNvSpPr txBox="1"/>
-          <p:nvPr/>
-        </p:nvSpPr>
-        <p:spPr>
-          <a:xfrm>
-            <a:off x="365760" y="6446520"/>
-            <a:ext cx="11430000" cy="320040"/>
-          </a:xfrm>
-          <a:prstGeom prst="rect">
-            <a:avLst/>
-          </a:prstGeom>
-          <a:noFill/>
-          <a:ln>
-            <a:noFill/>
-          </a:ln>
-        </p:spPr>
-        <p:txBody>
-          <a:bodyPr wrap="square" lIns="45720" rIns="45720" tIns="27432" bIns="27432">
-            <a:spAutoFit/>
-          </a:bodyPr>
-          <a:lstStyle/>
-          <a:p>
-            <a:pPr algn="l"/>
-            <a:r>
-              <a:rPr sz="1000">
-                <a:solidFill>
-                  <a:srgbClr val="5C6670"/>
-                </a:solidFill>
-                <a:latin typeface="Calibri"/>
-              </a:rPr>
-              <a:t>COMS 6998   ·   Jeremiah Mao, Mateo Juliani</a:t>
-            </a:r>
-          </a:p>
-          <a:p>
-            <a:pPr algn="r"/>
-          </a:p>
-        </p:txBody>
-      </p:sp>
-      <p:sp>
-        <p:nvSpPr>
-          <p:cNvPr id="8" name="TextBox 7"/>
-          <p:cNvSpPr txBox="1"/>
-          <p:nvPr/>
-        </p:nvSpPr>
-        <p:spPr>
-          <a:xfrm>
-            <a:off x="10515600" y="6446520"/>
-            <a:ext cx="1280160" cy="320040"/>
-          </a:xfrm>
-          <a:prstGeom prst="rect">
-            <a:avLst/>
-          </a:prstGeom>
-          <a:noFill/>
-          <a:ln>
-            <a:noFill/>
-          </a:ln>
-        </p:spPr>
-        <p:txBody>
-          <a:bodyPr wrap="square" lIns="45720" rIns="45720" tIns="27432" bIns="27432">
-            <a:spAutoFit/>
-          </a:bodyPr>
-          <a:lstStyle/>
-          <a:p>
-            <a:pPr algn="r"/>
-            <a:r>
-              <a:rPr sz="1000">
-                <a:solidFill>
-                  <a:srgbClr val="5C6670"/>
-                </a:solidFill>
-                <a:latin typeface="Calibri"/>
-              </a:rPr>
-              <a:t>9 / 15</a:t>
+              <a:t>9 / 16</a:t>
             </a:r>
           </a:p>
         </p:txBody>

</xml_diff>

<commit_message>
tweak: deck — remove K=1 vs K=5 injection slide; restructure (e) slide as K=1 vs K=5 preservation side-by-side
</commit_message>
<xml_diff>
--- a/paper_slides/synergy_deck.pptx
+++ b/paper_slides/synergy_deck.pptx
@@ -20,7 +20,6 @@
     <p:sldId id="268" r:id="rId19"/>
     <p:sldId id="269" r:id="rId20"/>
     <p:sldId id="270" r:id="rId21"/>
-    <p:sldId id="271" r:id="rId22"/>
   </p:sldIdLst>
   <p:sldSz cx="12191695" cy="6858000" type="screen4x3"/>
   <p:notesSz cx="6858000" cy="9144000"/>
@@ -3316,607 +3315,6 @@
 </file>
 
 <file path=ppt/slides/slide10.xml><?xml version="1.0" encoding="utf-8"?>
-<p:sld xmlns:a="http://schemas.openxmlformats.org/drawingml/2006/main" xmlns:p="http://schemas.openxmlformats.org/presentationml/2006/main" xmlns:r="http://schemas.openxmlformats.org/officeDocument/2006/relationships">
-  <p:cSld>
-    <p:spTree>
-      <p:nvGrpSpPr>
-        <p:cNvPr id="1" name=""/>
-        <p:cNvGrpSpPr/>
-        <p:nvPr/>
-      </p:nvGrpSpPr>
-      <p:grpSpPr/>
-      <p:sp>
-        <p:nvSpPr>
-          <p:cNvPr id="2" name="Rectangle 1"/>
-          <p:cNvSpPr/>
-          <p:nvPr/>
-        </p:nvSpPr>
-        <p:spPr>
-          <a:xfrm>
-            <a:off x="0" y="0"/>
-            <a:ext cx="12191695" cy="777240"/>
-          </a:xfrm>
-          <a:prstGeom prst="rect">
-            <a:avLst/>
-          </a:prstGeom>
-          <a:solidFill>
-            <a:srgbClr val="0F2A57"/>
-          </a:solidFill>
-          <a:ln>
-            <a:noFill/>
-          </a:ln>
-          <a:effectLst/>
-        </p:spPr>
-        <p:style>
-          <a:lnRef idx="1">
-            <a:schemeClr val="accent1"/>
-          </a:lnRef>
-          <a:fillRef idx="3">
-            <a:schemeClr val="accent1"/>
-          </a:fillRef>
-          <a:effectRef idx="2">
-            <a:schemeClr val="accent1"/>
-          </a:effectRef>
-          <a:fontRef idx="minor">
-            <a:schemeClr val="lt1"/>
-          </a:fontRef>
-        </p:style>
-        <p:txBody>
-          <a:bodyPr rtlCol="0" anchor="ctr"/>
-          <a:lstStyle/>
-          <a:p>
-            <a:pPr algn="ctr"/>
-          </a:p>
-        </p:txBody>
-      </p:sp>
-      <p:sp>
-        <p:nvSpPr>
-          <p:cNvPr id="3" name="TextBox 2"/>
-          <p:cNvSpPr txBox="1"/>
-          <p:nvPr/>
-        </p:nvSpPr>
-        <p:spPr>
-          <a:xfrm>
-            <a:off x="365760" y="109728"/>
-            <a:ext cx="11430000" cy="594360"/>
-          </a:xfrm>
-          <a:prstGeom prst="rect">
-            <a:avLst/>
-          </a:prstGeom>
-          <a:noFill/>
-          <a:ln>
-            <a:noFill/>
-          </a:ln>
-        </p:spPr>
-        <p:txBody>
-          <a:bodyPr wrap="square" lIns="45720" rIns="45720" tIns="27432" bIns="27432">
-            <a:spAutoFit/>
-          </a:bodyPr>
-          <a:lstStyle/>
-          <a:p>
-            <a:pPr algn="l"/>
-            <a:r>
-              <a:rPr sz="2800" b="1">
-                <a:solidFill>
-                  <a:srgbClr val="FFFFFF"/>
-                </a:solidFill>
-                <a:latin typeface="Calibri"/>
-              </a:rPr>
-              <a:t>Ruling out the 'just more data' explanation</a:t>
-            </a:r>
-          </a:p>
-        </p:txBody>
-      </p:sp>
-      <p:sp>
-        <p:nvSpPr>
-          <p:cNvPr id="4" name="TextBox 3"/>
-          <p:cNvSpPr txBox="1"/>
-          <p:nvPr/>
-        </p:nvSpPr>
-        <p:spPr>
-          <a:xfrm>
-            <a:off x="548640" y="914400"/>
-            <a:ext cx="11064240" cy="1005840"/>
-          </a:xfrm>
-          <a:prstGeom prst="rect">
-            <a:avLst/>
-          </a:prstGeom>
-          <a:noFill/>
-          <a:ln>
-            <a:noFill/>
-          </a:ln>
-        </p:spPr>
-        <p:txBody>
-          <a:bodyPr wrap="square" lIns="45720" rIns="45720" tIns="27432" bIns="27432">
-            <a:spAutoFit/>
-          </a:bodyPr>
-          <a:lstStyle/>
-          <a:p>
-            <a:r>
-              <a:rPr sz="1600">
-                <a:solidFill>
-                  <a:srgbClr val="232A33"/>
-                </a:solidFill>
-                <a:latin typeface="Calibri"/>
-              </a:rPr>
-              <a:t>To rule out 'data dominates,' hold data volume fixed and toggle KL preservation. </a:t>
-            </a:r>
-            <a:r>
-              <a:rPr sz="1600" i="1">
-                <a:solidFill>
-                  <a:srgbClr val="232A33"/>
-                </a:solidFill>
-                <a:latin typeface="Calibri"/>
-              </a:rPr>
-              <a:t>If KL contributed a fixed lift independent of data volume, both rows below would show similar Δ abs F1.</a:t>
-            </a:r>
-          </a:p>
-        </p:txBody>
-      </p:sp>
-      <p:graphicFrame>
-        <p:nvGraphicFramePr>
-          <p:cNvPr id="5" name="Table 4"/>
-          <p:cNvGraphicFramePr>
-            <a:graphicFrameLocks noGrp="1"/>
-          </p:cNvGraphicFramePr>
-          <p:nvPr/>
-        </p:nvGraphicFramePr>
-        <p:xfrm>
-          <a:off x="548640" y="2286000"/>
-          <a:ext cx="11064240" cy="2057400"/>
-        </p:xfrm>
-        <a:graphic>
-          <a:graphicData uri="http://schemas.openxmlformats.org/drawingml/2006/table">
-            <a:tbl>
-              <a:tblPr firstRow="1" bandRow="1">
-                <a:tableStyleId>{5C22544A-7EE6-4342-B048-85BDC9FD1C3A}</a:tableStyleId>
-              </a:tblPr>
-              <a:tblGrid>
-                <a:gridCol w="3657600"/>
-                <a:gridCol w="2377440"/>
-                <a:gridCol w="2377440"/>
-                <a:gridCol w="2651760"/>
-              </a:tblGrid>
-              <a:tr h="502920">
-                <a:tc>
-                  <a:txBody>
-                    <a:bodyPr wrap="square"/>
-                    <a:lstStyle/>
-                    <a:p>
-                      <a:pPr algn="l"/>
-                      <a:r>
-                        <a:rPr sz="1400" b="1" i="0">
-                          <a:solidFill>
-                            <a:srgbClr val="FFFFFF"/>
-                          </a:solidFill>
-                          <a:latin typeface="Calibri"/>
-                        </a:rPr>
-                        <a:t>Contrast (compute-matched)</a:t>
-                      </a:r>
-                    </a:p>
-                  </a:txBody>
-                  <a:tcPr marL="54864" marR="54864" marT="36576" marB="36576" anchor="ctr">
-                    <a:solidFill>
-                      <a:srgbClr val="0F2A57"/>
-                    </a:solidFill>
-                  </a:tcPr>
-                </a:tc>
-                <a:tc>
-                  <a:txBody>
-                    <a:bodyPr wrap="square"/>
-                    <a:lstStyle/>
-                    <a:p>
-                      <a:pPr algn="l"/>
-                      <a:r>
-                        <a:rPr sz="1400" b="1" i="0">
-                          <a:solidFill>
-                            <a:srgbClr val="FFFFFF"/>
-                          </a:solidFill>
-                          <a:latin typeface="Calibri"/>
-                        </a:rPr>
-                        <a:t>Data volume held at</a:t>
-                      </a:r>
-                    </a:p>
-                  </a:txBody>
-                  <a:tcPr marL="54864" marR="54864" marT="36576" marB="36576" anchor="ctr">
-                    <a:solidFill>
-                      <a:srgbClr val="0F2A57"/>
-                    </a:solidFill>
-                  </a:tcPr>
-                </a:tc>
-                <a:tc>
-                  <a:txBody>
-                    <a:bodyPr wrap="square"/>
-                    <a:lstStyle/>
-                    <a:p>
-                      <a:pPr algn="l"/>
-                      <a:r>
-                        <a:rPr sz="1400" b="1" i="0">
-                          <a:solidFill>
-                            <a:srgbClr val="FFFFFF"/>
-                          </a:solidFill>
-                          <a:latin typeface="Calibri"/>
-                        </a:rPr>
-                        <a:t>Δ abs F1</a:t>
-                      </a:r>
-                    </a:p>
-                  </a:txBody>
-                  <a:tcPr marL="54864" marR="54864" marT="36576" marB="36576" anchor="ctr">
-                    <a:solidFill>
-                      <a:srgbClr val="0F2A57"/>
-                    </a:solidFill>
-                  </a:tcPr>
-                </a:tc>
-                <a:tc>
-                  <a:txBody>
-                    <a:bodyPr wrap="square"/>
-                    <a:lstStyle/>
-                    <a:p>
-                      <a:pPr algn="l"/>
-                      <a:r>
-                        <a:rPr sz="1400" b="1" i="0">
-                          <a:solidFill>
-                            <a:srgbClr val="FFFFFF"/>
-                          </a:solidFill>
-                          <a:latin typeface="Calibri"/>
-                        </a:rPr>
-                        <a:t>Effect of adding KL</a:t>
-                      </a:r>
-                    </a:p>
-                  </a:txBody>
-                  <a:tcPr marL="54864" marR="54864" marT="36576" marB="36576" anchor="ctr">
-                    <a:solidFill>
-                      <a:srgbClr val="0F2A57"/>
-                    </a:solidFill>
-                  </a:tcPr>
-                </a:tc>
-              </a:tr>
-              <a:tr h="777240">
-                <a:tc>
-                  <a:txBody>
-                    <a:bodyPr wrap="square"/>
-                    <a:lstStyle/>
-                    <a:p>
-                      <a:pPr algn="l"/>
-                      <a:r>
-                        <a:rPr sz="1500" b="0" i="0">
-                          <a:solidFill>
-                            <a:srgbClr val="232A33"/>
-                          </a:solidFill>
-                          <a:latin typeface="Calibri"/>
-                        </a:rPr>
-                        <a:t>(c) − (a):  KL added on top of K=1 data</a:t>
-                      </a:r>
-                    </a:p>
-                  </a:txBody>
-                  <a:tcPr marL="54864" marR="54864" marT="36576" marB="36576" anchor="ctr">
-                    <a:solidFill>
-                      <a:srgbClr val="F7F9FC"/>
-                    </a:solidFill>
-                  </a:tcPr>
-                </a:tc>
-                <a:tc>
-                  <a:txBody>
-                    <a:bodyPr wrap="square"/>
-                    <a:lstStyle/>
-                    <a:p>
-                      <a:pPr algn="ctr"/>
-                      <a:r>
-                        <a:rPr sz="1500" b="0" i="0">
-                          <a:solidFill>
-                            <a:srgbClr val="232A33"/>
-                          </a:solidFill>
-                          <a:latin typeface="Calibri"/>
-                        </a:rPr>
-                        <a:t>K=1 (200 entries / round)</a:t>
-                      </a:r>
-                    </a:p>
-                  </a:txBody>
-                  <a:tcPr marL="54864" marR="54864" marT="36576" marB="36576" anchor="ctr">
-                    <a:solidFill>
-                      <a:srgbClr val="F7F9FC"/>
-                    </a:solidFill>
-                  </a:tcPr>
-                </a:tc>
-                <a:tc>
-                  <a:txBody>
-                    <a:bodyPr wrap="square"/>
-                    <a:lstStyle/>
-                    <a:p>
-                      <a:pPr algn="ctr"/>
-                      <a:r>
-                        <a:rPr sz="1800" b="1" i="0">
-                          <a:solidFill>
-                            <a:srgbClr val="1F4E90"/>
-                          </a:solidFill>
-                          <a:latin typeface="Calibri"/>
-                        </a:rPr>
-                        <a:t>+0.029</a:t>
-                      </a:r>
-                    </a:p>
-                  </a:txBody>
-                  <a:tcPr marL="54864" marR="54864" marT="36576" marB="36576" anchor="ctr">
-                    <a:solidFill>
-                      <a:srgbClr val="F7F9FC"/>
-                    </a:solidFill>
-                  </a:tcPr>
-                </a:tc>
-                <a:tc>
-                  <a:txBody>
-                    <a:bodyPr wrap="square"/>
-                    <a:lstStyle/>
-                    <a:p>
-                      <a:pPr algn="l"/>
-                      <a:r>
-                        <a:rPr sz="1400" b="0" i="1">
-                          <a:solidFill>
-                            <a:srgbClr val="5C6670"/>
-                          </a:solidFill>
-                          <a:latin typeface="Calibri"/>
-                        </a:rPr>
-                        <a:t>small lift</a:t>
-                      </a:r>
-                    </a:p>
-                  </a:txBody>
-                  <a:tcPr marL="54864" marR="54864" marT="36576" marB="36576" anchor="ctr">
-                    <a:solidFill>
-                      <a:srgbClr val="F7F9FC"/>
-                    </a:solidFill>
-                  </a:tcPr>
-                </a:tc>
-              </a:tr>
-              <a:tr h="777240">
-                <a:tc>
-                  <a:txBody>
-                    <a:bodyPr wrap="square"/>
-                    <a:lstStyle/>
-                    <a:p>
-                      <a:pPr algn="l"/>
-                      <a:r>
-                        <a:rPr sz="1500" b="1" i="0">
-                          <a:solidFill>
-                            <a:srgbClr val="232A33"/>
-                          </a:solidFill>
-                          <a:latin typeface="Calibri"/>
-                        </a:rPr>
-                        <a:t>(d) − (b):  KL added on top of K=5 data</a:t>
-                      </a:r>
-                    </a:p>
-                  </a:txBody>
-                  <a:tcPr marL="54864" marR="54864" marT="36576" marB="36576" anchor="ctr">
-                    <a:solidFill>
-                      <a:srgbClr val="E8F2E8"/>
-                    </a:solidFill>
-                  </a:tcPr>
-                </a:tc>
-                <a:tc>
-                  <a:txBody>
-                    <a:bodyPr wrap="square"/>
-                    <a:lstStyle/>
-                    <a:p>
-                      <a:pPr algn="ctr"/>
-                      <a:r>
-                        <a:rPr sz="1500" b="0" i="0">
-                          <a:solidFill>
-                            <a:srgbClr val="232A33"/>
-                          </a:solidFill>
-                          <a:latin typeface="Calibri"/>
-                        </a:rPr>
-                        <a:t>K=5 (1000 entries / round)</a:t>
-                      </a:r>
-                    </a:p>
-                  </a:txBody>
-                  <a:tcPr marL="54864" marR="54864" marT="36576" marB="36576" anchor="ctr">
-                    <a:solidFill>
-                      <a:srgbClr val="E8F2E8"/>
-                    </a:solidFill>
-                  </a:tcPr>
-                </a:tc>
-                <a:tc>
-                  <a:txBody>
-                    <a:bodyPr wrap="square"/>
-                    <a:lstStyle/>
-                    <a:p>
-                      <a:pPr algn="ctr"/>
-                      <a:r>
-                        <a:rPr sz="2200" b="1" i="0">
-                          <a:solidFill>
-                            <a:srgbClr val="1F8E4F"/>
-                          </a:solidFill>
-                          <a:latin typeface="Calibri"/>
-                        </a:rPr>
-                        <a:t>+0.286</a:t>
-                      </a:r>
-                    </a:p>
-                  </a:txBody>
-                  <a:tcPr marL="54864" marR="54864" marT="36576" marB="36576" anchor="ctr">
-                    <a:solidFill>
-                      <a:srgbClr val="E8F2E8"/>
-                    </a:solidFill>
-                  </a:tcPr>
-                </a:tc>
-                <a:tc>
-                  <a:txBody>
-                    <a:bodyPr wrap="square"/>
-                    <a:lstStyle/>
-                    <a:p>
-                      <a:pPr algn="l"/>
-                      <a:r>
-                        <a:rPr sz="1400" b="1" i="0">
-                          <a:solidFill>
-                            <a:srgbClr val="1F8E4F"/>
-                          </a:solidFill>
-                          <a:latin typeface="Calibri"/>
-                        </a:rPr>
-                        <a:t>≈10× larger</a:t>
-                      </a:r>
-                    </a:p>
-                  </a:txBody>
-                  <a:tcPr marL="54864" marR="54864" marT="36576" marB="36576" anchor="ctr">
-                    <a:solidFill>
-                      <a:srgbClr val="E8F2E8"/>
-                    </a:solidFill>
-                  </a:tcPr>
-                </a:tc>
-              </a:tr>
-            </a:tbl>
-          </a:graphicData>
-        </a:graphic>
-      </p:graphicFrame>
-      <p:sp>
-        <p:nvSpPr>
-          <p:cNvPr id="6" name="TextBox 5"/>
-          <p:cNvSpPr txBox="1"/>
-          <p:nvPr/>
-        </p:nvSpPr>
-        <p:spPr>
-          <a:xfrm>
-            <a:off x="548640" y="4572000"/>
-            <a:ext cx="11064240" cy="1280160"/>
-          </a:xfrm>
-          <a:prstGeom prst="rect">
-            <a:avLst/>
-          </a:prstGeom>
-          <a:solidFill>
-            <a:srgbClr val="FDF7EF"/>
-          </a:solidFill>
-          <a:ln w="12700">
-            <a:solidFill>
-              <a:srgbClr val="E8C89C"/>
-            </a:solidFill>
-          </a:ln>
-        </p:spPr>
-        <p:txBody>
-          <a:bodyPr wrap="square" lIns="45720" rIns="45720" tIns="27432" bIns="27432">
-            <a:spAutoFit/>
-          </a:bodyPr>
-          <a:lstStyle/>
-          <a:p>
-            <a:r>
-              <a:rPr sz="1800" b="1">
-                <a:solidFill>
-                  <a:srgbClr val="C0392B"/>
-                </a:solidFill>
-                <a:latin typeface="Calibri"/>
-              </a:rPr>
-              <a:t>Conclusion:  </a:t>
-            </a:r>
-            <a:r>
-              <a:rPr sz="1800">
-                <a:solidFill>
-                  <a:srgbClr val="232A33"/>
-                </a:solidFill>
-                <a:latin typeface="Calibri"/>
-              </a:rPr>
-              <a:t>KL is ~10× more effective when paired with K=5 data than added on top of K=1 data alone.</a:t>
-            </a:r>
-          </a:p>
-          <a:p>
-            <a:pPr>
-              <a:spcBef>
-                <a:spcPts val="600"/>
-              </a:spcBef>
-            </a:pPr>
-            <a:r>
-              <a:rPr sz="1400" i="1">
-                <a:solidFill>
-                  <a:srgbClr val="232A33"/>
-                </a:solidFill>
-                <a:latin typeface="Calibri"/>
-              </a:rPr>
-              <a:t>This is the signature of an interaction effect, not a data-volume effect.  More data alone gives +0.036 (b) − (a); more data plus KL gives +0.322.</a:t>
-            </a:r>
-          </a:p>
-        </p:txBody>
-      </p:sp>
-      <p:sp>
-        <p:nvSpPr>
-          <p:cNvPr id="7" name="TextBox 6"/>
-          <p:cNvSpPr txBox="1"/>
-          <p:nvPr/>
-        </p:nvSpPr>
-        <p:spPr>
-          <a:xfrm>
-            <a:off x="365760" y="6446520"/>
-            <a:ext cx="11430000" cy="320040"/>
-          </a:xfrm>
-          <a:prstGeom prst="rect">
-            <a:avLst/>
-          </a:prstGeom>
-          <a:noFill/>
-          <a:ln>
-            <a:noFill/>
-          </a:ln>
-        </p:spPr>
-        <p:txBody>
-          <a:bodyPr wrap="square" lIns="45720" rIns="45720" tIns="27432" bIns="27432">
-            <a:spAutoFit/>
-          </a:bodyPr>
-          <a:lstStyle/>
-          <a:p>
-            <a:pPr algn="l"/>
-            <a:r>
-              <a:rPr sz="1000">
-                <a:solidFill>
-                  <a:srgbClr val="5C6670"/>
-                </a:solidFill>
-                <a:latin typeface="Calibri"/>
-              </a:rPr>
-              <a:t>COMS 6998   ·   Jeremiah Mao, Mateo Juliani</a:t>
-            </a:r>
-          </a:p>
-          <a:p>
-            <a:pPr algn="r"/>
-          </a:p>
-        </p:txBody>
-      </p:sp>
-      <p:sp>
-        <p:nvSpPr>
-          <p:cNvPr id="8" name="TextBox 7"/>
-          <p:cNvSpPr txBox="1"/>
-          <p:nvPr/>
-        </p:nvSpPr>
-        <p:spPr>
-          <a:xfrm>
-            <a:off x="10515600" y="6446520"/>
-            <a:ext cx="1280160" cy="320040"/>
-          </a:xfrm>
-          <a:prstGeom prst="rect">
-            <a:avLst/>
-          </a:prstGeom>
-          <a:noFill/>
-          <a:ln>
-            <a:noFill/>
-          </a:ln>
-        </p:spPr>
-        <p:txBody>
-          <a:bodyPr wrap="square" lIns="45720" rIns="45720" tIns="27432" bIns="27432">
-            <a:spAutoFit/>
-          </a:bodyPr>
-          <a:lstStyle/>
-          <a:p>
-            <a:pPr algn="r"/>
-            <a:r>
-              <a:rPr sz="1000">
-                <a:solidFill>
-                  <a:srgbClr val="5C6670"/>
-                </a:solidFill>
-                <a:latin typeface="Calibri"/>
-              </a:rPr>
-              <a:t>10 / 16</a:t>
-            </a:r>
-          </a:p>
-        </p:txBody>
-      </p:sp>
-    </p:spTree>
-  </p:cSld>
-  <p:clrMapOvr>
-    <a:masterClrMapping/>
-  </p:clrMapOvr>
-</p:sld>
-</file>
-
-<file path=ppt/slides/slide11.xml><?xml version="1.0" encoding="utf-8"?>
 <p:sld xmlns:a="http://schemas.openxmlformats.org/drawingml/2006/main" xmlns:p="http://schemas.openxmlformats.org/presentationml/2006/main" xmlns:r="http://schemas.openxmlformats.org/officeDocument/2006/relationships">
   <p:cSld>
     <p:spTree>
@@ -4748,7 +4146,380 @@
                 </a:solidFill>
                 <a:latin typeface="Calibri"/>
               </a:rPr>
-              <a:t>11 / 16</a:t>
+              <a:t>10 / 15</a:t>
+            </a:r>
+          </a:p>
+        </p:txBody>
+      </p:sp>
+    </p:spTree>
+  </p:cSld>
+  <p:clrMapOvr>
+    <a:masterClrMapping/>
+  </p:clrMapOvr>
+</p:sld>
+</file>
+
+<file path=ppt/slides/slide11.xml><?xml version="1.0" encoding="utf-8"?>
+<p:sld xmlns:a="http://schemas.openxmlformats.org/drawingml/2006/main" xmlns:p="http://schemas.openxmlformats.org/presentationml/2006/main" xmlns:r="http://schemas.openxmlformats.org/officeDocument/2006/relationships">
+  <p:cSld>
+    <p:spTree>
+      <p:nvGrpSpPr>
+        <p:cNvPr id="1" name=""/>
+        <p:cNvGrpSpPr/>
+        <p:nvPr/>
+      </p:nvGrpSpPr>
+      <p:grpSpPr/>
+      <p:sp>
+        <p:nvSpPr>
+          <p:cNvPr id="2" name="Rectangle 1"/>
+          <p:cNvSpPr/>
+          <p:nvPr/>
+        </p:nvSpPr>
+        <p:spPr>
+          <a:xfrm>
+            <a:off x="0" y="0"/>
+            <a:ext cx="12191695" cy="777240"/>
+          </a:xfrm>
+          <a:prstGeom prst="rect">
+            <a:avLst/>
+          </a:prstGeom>
+          <a:solidFill>
+            <a:srgbClr val="0F2A57"/>
+          </a:solidFill>
+          <a:ln>
+            <a:noFill/>
+          </a:ln>
+          <a:effectLst/>
+        </p:spPr>
+        <p:style>
+          <a:lnRef idx="1">
+            <a:schemeClr val="accent1"/>
+          </a:lnRef>
+          <a:fillRef idx="3">
+            <a:schemeClr val="accent1"/>
+          </a:fillRef>
+          <a:effectRef idx="2">
+            <a:schemeClr val="accent1"/>
+          </a:effectRef>
+          <a:fontRef idx="minor">
+            <a:schemeClr val="lt1"/>
+          </a:fontRef>
+        </p:style>
+        <p:txBody>
+          <a:bodyPr rtlCol="0" anchor="ctr"/>
+          <a:lstStyle/>
+          <a:p>
+            <a:pPr algn="ctr"/>
+          </a:p>
+        </p:txBody>
+      </p:sp>
+      <p:sp>
+        <p:nvSpPr>
+          <p:cNvPr id="3" name="TextBox 2"/>
+          <p:cNvSpPr txBox="1"/>
+          <p:nvPr/>
+        </p:nvSpPr>
+        <p:spPr>
+          <a:xfrm>
+            <a:off x="365760" y="109728"/>
+            <a:ext cx="11430000" cy="594360"/>
+          </a:xfrm>
+          <a:prstGeom prst="rect">
+            <a:avLst/>
+          </a:prstGeom>
+          <a:noFill/>
+          <a:ln>
+            <a:noFill/>
+          </a:ln>
+        </p:spPr>
+        <p:txBody>
+          <a:bodyPr wrap="square" lIns="45720" rIns="45720" tIns="27432" bIns="27432">
+            <a:spAutoFit/>
+          </a:bodyPr>
+          <a:lstStyle/>
+          <a:p>
+            <a:pPr algn="l"/>
+            <a:r>
+              <a:rPr sz="2800" b="1">
+                <a:solidFill>
+                  <a:srgbClr val="FFFFFF"/>
+                </a:solidFill>
+                <a:latin typeface="Calibri"/>
+              </a:rPr>
+              <a:t>Three negative results that constrain the design space</a:t>
+            </a:r>
+          </a:p>
+        </p:txBody>
+      </p:sp>
+      <p:sp>
+        <p:nvSpPr>
+          <p:cNvPr id="4" name="TextBox 3"/>
+          <p:cNvSpPr txBox="1"/>
+          <p:nvPr/>
+        </p:nvSpPr>
+        <p:spPr>
+          <a:xfrm>
+            <a:off x="548640" y="1005840"/>
+            <a:ext cx="11064240" cy="5212080"/>
+          </a:xfrm>
+          <a:prstGeom prst="rect">
+            <a:avLst/>
+          </a:prstGeom>
+          <a:noFill/>
+          <a:ln>
+            <a:noFill/>
+          </a:ln>
+        </p:spPr>
+        <p:txBody>
+          <a:bodyPr wrap="square" lIns="45720" rIns="45720" tIns="27432" bIns="27432">
+            <a:spAutoFit/>
+          </a:bodyPr>
+          <a:lstStyle/>
+          <a:p>
+            <a:pPr>
+              <a:lnSpc>
+                <a:spcPct val="113000"/>
+              </a:lnSpc>
+              <a:spcAft>
+                <a:spcPts val="600"/>
+              </a:spcAft>
+            </a:pPr>
+            <a:r>
+              <a:rPr sz="1500" b="1">
+                <a:solidFill>
+                  <a:srgbClr val="1F4E90"/>
+                </a:solidFill>
+                <a:latin typeface="Calibri"/>
+              </a:rPr>
+              <a:t>•  </a:t>
+            </a:r>
+            <a:r>
+              <a:rPr sz="1500">
+                <a:solidFill>
+                  <a:srgbClr val="232A33"/>
+                </a:solidFill>
+                <a:latin typeface="Calibri"/>
+              </a:rPr>
+              <a:t>COPR (continual preference alignment) does not port to fact injection.</a:t>
+            </a:r>
+          </a:p>
+          <a:p>
+            <a:pPr lvl="1">
+              <a:lnSpc>
+                <a:spcPct val="113000"/>
+              </a:lnSpc>
+              <a:spcAft>
+                <a:spcPts val="600"/>
+              </a:spcAft>
+            </a:pPr>
+            <a:r>
+              <a:rPr sz="1500" b="1">
+                <a:solidFill>
+                  <a:srgbClr val="1F4E90"/>
+                </a:solidFill>
+                <a:latin typeface="Calibri"/>
+              </a:rPr>
+              <a:t>–  </a:t>
+            </a:r>
+            <a:r>
+              <a:rPr sz="1500">
+                <a:solidFill>
+                  <a:srgbClr val="232A33"/>
+                </a:solidFill>
+                <a:latin typeface="Calibri"/>
+              </a:rPr>
+              <a:t>kl_reg_sft wins absorption against copr_gold_injection in 11 of 14 contested rounds. COPR draws K=8 candidate responses per fact (here K = number of self-sampled candidates) and ranks them via MSE; on novel facts, the K=8 candidates all land below a usable F1 threshold (the K-sample-all-wrong pathology), so the rank fit reinforces plausible-but-wrong answers. Gold injection collapses the method toward cross-entropy at 10–12× per-round compute.</a:t>
+            </a:r>
+          </a:p>
+          <a:p>
+            <a:pPr>
+              <a:lnSpc>
+                <a:spcPct val="113000"/>
+              </a:lnSpc>
+              <a:spcAft>
+                <a:spcPts val="600"/>
+              </a:spcAft>
+            </a:pPr>
+            <a:r>
+              <a:rPr sz="1500" b="1">
+                <a:solidFill>
+                  <a:srgbClr val="1F4E90"/>
+                </a:solidFill>
+                <a:latin typeface="Calibri"/>
+              </a:rPr>
+              <a:t>•  </a:t>
+            </a:r>
+            <a:r>
+              <a:rPr sz="1500">
+                <a:solidFill>
+                  <a:srgbClr val="232A33"/>
+                </a:solidFill>
+                <a:latin typeface="Calibri"/>
+              </a:rPr>
+              <a:t>V-REx at K=2 prompt formats is theoretically degenerate.</a:t>
+            </a:r>
+          </a:p>
+          <a:p>
+            <a:pPr lvl="1">
+              <a:lnSpc>
+                <a:spcPct val="113000"/>
+              </a:lnSpc>
+              <a:spcAft>
+                <a:spcPts val="600"/>
+              </a:spcAft>
+            </a:pPr>
+            <a:r>
+              <a:rPr sz="1500" b="1">
+                <a:solidFill>
+                  <a:srgbClr val="1F4E90"/>
+                </a:solidFill>
+                <a:latin typeface="Calibri"/>
+              </a:rPr>
+              <a:t>–  </a:t>
+            </a:r>
+            <a:r>
+              <a:rPr sz="1500">
+                <a:solidFill>
+                  <a:srgbClr val="232A33"/>
+                </a:solidFill>
+                <a:latin typeface="Calibri"/>
+              </a:rPr>
+              <a:t>Here K = number of prompt-format environments (a different K from the augmentation K — this is the IRM/V-REx sense). IRM-family penalties require ≥3 environments (Arjovsky 2019; Rosenfeld 2021; Ahuja 2021). At K=2 the variance term reduces to a pairwise scalar consistency satisfiable by any equalizing solution. Empirically: +0.014 QD F1, within run-to-run noise.</a:t>
+            </a:r>
+          </a:p>
+          <a:p>
+            <a:pPr>
+              <a:lnSpc>
+                <a:spcPct val="113000"/>
+              </a:lnSpc>
+              <a:spcAft>
+                <a:spcPts val="600"/>
+              </a:spcAft>
+            </a:pPr>
+            <a:r>
+              <a:rPr sz="1500" b="1">
+                <a:solidFill>
+                  <a:srgbClr val="1F4E90"/>
+                </a:solidFill>
+                <a:latin typeface="Calibri"/>
+              </a:rPr>
+              <a:t>•  </a:t>
+            </a:r>
+            <a:r>
+              <a:rPr sz="1500">
+                <a:solidFill>
+                  <a:srgbClr val="232A33"/>
+                </a:solidFill>
+                <a:latin typeface="Calibri"/>
+              </a:rPr>
+              <a:t>Format diversity without an explicit regularizer actively hurts.</a:t>
+            </a:r>
+          </a:p>
+          <a:p>
+            <a:pPr lvl="1">
+              <a:lnSpc>
+                <a:spcPct val="113000"/>
+              </a:lnSpc>
+              <a:spcAft>
+                <a:spcPts val="600"/>
+              </a:spcAft>
+            </a:pPr>
+            <a:r>
+              <a:rPr sz="1500" b="1">
+                <a:solidFill>
+                  <a:srgbClr val="1F4E90"/>
+                </a:solidFill>
+                <a:latin typeface="Calibri"/>
+              </a:rPr>
+              <a:t>–  </a:t>
+            </a:r>
+            <a:r>
+              <a:rPr sz="1500">
+                <a:solidFill>
+                  <a:srgbClr val="232A33"/>
+                </a:solidFill>
+                <a:latin typeface="Calibri"/>
+              </a:rPr>
+              <a:t>Plain mixed-format SFT widens the format gap to 0.100 vs single-format kl_reg_sft 0.072. Format mixing in continual training requires curriculum, unified rewriting, or — as we show in §4 — a preservation-side regularizer paired with K=5 augmentation on the injection side.</a:t>
+            </a:r>
+          </a:p>
+        </p:txBody>
+      </p:sp>
+      <p:sp>
+        <p:nvSpPr>
+          <p:cNvPr id="5" name="TextBox 4"/>
+          <p:cNvSpPr txBox="1"/>
+          <p:nvPr/>
+        </p:nvSpPr>
+        <p:spPr>
+          <a:xfrm>
+            <a:off x="365760" y="6446520"/>
+            <a:ext cx="11430000" cy="320040"/>
+          </a:xfrm>
+          <a:prstGeom prst="rect">
+            <a:avLst/>
+          </a:prstGeom>
+          <a:noFill/>
+          <a:ln>
+            <a:noFill/>
+          </a:ln>
+        </p:spPr>
+        <p:txBody>
+          <a:bodyPr wrap="square" lIns="45720" rIns="45720" tIns="27432" bIns="27432">
+            <a:spAutoFit/>
+          </a:bodyPr>
+          <a:lstStyle/>
+          <a:p>
+            <a:pPr algn="l"/>
+            <a:r>
+              <a:rPr sz="1000">
+                <a:solidFill>
+                  <a:srgbClr val="5C6670"/>
+                </a:solidFill>
+                <a:latin typeface="Calibri"/>
+              </a:rPr>
+              <a:t>COMS 6998   ·   Jeremiah Mao, Mateo Juliani</a:t>
+            </a:r>
+          </a:p>
+          <a:p>
+            <a:pPr algn="r"/>
+          </a:p>
+        </p:txBody>
+      </p:sp>
+      <p:sp>
+        <p:nvSpPr>
+          <p:cNvPr id="6" name="TextBox 5"/>
+          <p:cNvSpPr txBox="1"/>
+          <p:nvPr/>
+        </p:nvSpPr>
+        <p:spPr>
+          <a:xfrm>
+            <a:off x="10515600" y="6446520"/>
+            <a:ext cx="1280160" cy="320040"/>
+          </a:xfrm>
+          <a:prstGeom prst="rect">
+            <a:avLst/>
+          </a:prstGeom>
+          <a:noFill/>
+          <a:ln>
+            <a:noFill/>
+          </a:ln>
+        </p:spPr>
+        <p:txBody>
+          <a:bodyPr wrap="square" lIns="45720" rIns="45720" tIns="27432" bIns="27432">
+            <a:spAutoFit/>
+          </a:bodyPr>
+          <a:lstStyle/>
+          <a:p>
+            <a:pPr algn="r"/>
+            <a:r>
+              <a:rPr sz="1000">
+                <a:solidFill>
+                  <a:srgbClr val="5C6670"/>
+                </a:solidFill>
+                <a:latin typeface="Calibri"/>
+              </a:rPr>
+              <a:t>11 / 15</a:t>
             </a:r>
           </a:p>
         </p:txBody>
@@ -4848,7 +4619,7 @@
                 </a:solidFill>
                 <a:latin typeface="Calibri"/>
               </a:rPr>
-              <a:t>Three negative results that constrain the design space</a:t>
+              <a:t>Symmetric extension fails: K=5 KL preservation adds nothing</a:t>
             </a:r>
           </a:p>
         </p:txBody>
@@ -4861,8 +4632,8 @@
         </p:nvSpPr>
         <p:spPr>
           <a:xfrm>
-            <a:off x="548640" y="1005840"/>
-            <a:ext cx="11064240" cy="5212080"/>
+            <a:off x="548640" y="868680"/>
+            <a:ext cx="11064240" cy="502920"/>
           </a:xfrm>
           <a:prstGeom prst="rect">
             <a:avLst/>
@@ -4878,171 +4649,32 @@
           </a:bodyPr>
           <a:lstStyle/>
           <a:p>
-            <a:pPr>
-              <a:lnSpc>
-                <a:spcPct val="113000"/>
-              </a:lnSpc>
-              <a:spcAft>
-                <a:spcPts val="600"/>
-              </a:spcAft>
-            </a:pPr>
-            <a:r>
-              <a:rPr sz="1500" b="1">
-                <a:solidFill>
-                  <a:srgbClr val="1F4E90"/>
-                </a:solidFill>
-                <a:latin typeface="Calibri"/>
-              </a:rPr>
-              <a:t>•  </a:t>
-            </a:r>
-            <a:r>
-              <a:rPr sz="1500">
+            <a:r>
+              <a:rPr sz="1300">
                 <a:solidFill>
                   <a:srgbClr val="232A33"/>
                 </a:solidFill>
                 <a:latin typeface="Calibri"/>
               </a:rPr>
-              <a:t>COPR (continual preference alignment) does not port to fact injection.</a:t>
-            </a:r>
-          </a:p>
-          <a:p>
-            <a:pPr lvl="1">
-              <a:lnSpc>
-                <a:spcPct val="113000"/>
-              </a:lnSpc>
-              <a:spcAft>
-                <a:spcPts val="600"/>
-              </a:spcAft>
-            </a:pPr>
-            <a:r>
-              <a:rPr sz="1500" b="1">
-                <a:solidFill>
-                  <a:srgbClr val="1F4E90"/>
-                </a:solidFill>
-                <a:latin typeface="Calibri"/>
-              </a:rPr>
-              <a:t>–  </a:t>
-            </a:r>
-            <a:r>
-              <a:rPr sz="1500">
+              <a:t>KL preservation is computed against a frozen pre-round reference on the same task prompt   </a:t>
+            </a:r>
+            <a:r>
+              <a:rPr sz="1200" i="1">
                 <a:solidFill>
                   <a:srgbClr val="232A33"/>
                 </a:solidFill>
-                <a:latin typeface="Calibri"/>
-              </a:rPr>
-              <a:t>kl_reg_sft wins absorption against copr_gold_injection in 11 of 14 contested rounds. COPR draws K=8 candidate responses per fact (here K = number of self-sampled candidates) and ranks them via MSE; on novel facts, the K=8 candidates all land below a usable F1 threshold (the K-sample-all-wrong pathology), so the rank fit reinforces plausible-but-wrong answers. Gold injection collapses the method toward cross-entropy at 10–12× per-round compute.</a:t>
-            </a:r>
-          </a:p>
-          <a:p>
-            <a:pPr>
-              <a:lnSpc>
-                <a:spcPct val="113000"/>
-              </a:lnSpc>
-              <a:spcAft>
-                <a:spcPts val="600"/>
-              </a:spcAft>
-            </a:pPr>
-            <a:r>
-              <a:rPr sz="1500" b="1">
-                <a:solidFill>
-                  <a:srgbClr val="1F4E90"/>
-                </a:solidFill>
-                <a:latin typeface="Calibri"/>
-              </a:rPr>
-              <a:t>•  </a:t>
-            </a:r>
-            <a:r>
-              <a:rPr sz="1500">
+                <a:latin typeface="Consolas"/>
+              </a:rPr>
+              <a:t>"What should I know about Acme Corp's recent activity?"</a:t>
+            </a:r>
+            <a:r>
+              <a:rPr sz="1300">
                 <a:solidFill>
                   <a:srgbClr val="232A33"/>
                 </a:solidFill>
                 <a:latin typeface="Calibri"/>
               </a:rPr>
-              <a:t>V-REx at K=2 prompt formats is theoretically degenerate.</a:t>
-            </a:r>
-          </a:p>
-          <a:p>
-            <a:pPr lvl="1">
-              <a:lnSpc>
-                <a:spcPct val="113000"/>
-              </a:lnSpc>
-              <a:spcAft>
-                <a:spcPts val="600"/>
-              </a:spcAft>
-            </a:pPr>
-            <a:r>
-              <a:rPr sz="1500" b="1">
-                <a:solidFill>
-                  <a:srgbClr val="1F4E90"/>
-                </a:solidFill>
-                <a:latin typeface="Calibri"/>
-              </a:rPr>
-              <a:t>–  </a:t>
-            </a:r>
-            <a:r>
-              <a:rPr sz="1500">
-                <a:solidFill>
-                  <a:srgbClr val="232A33"/>
-                </a:solidFill>
-                <a:latin typeface="Calibri"/>
-              </a:rPr>
-              <a:t>Here K = number of prompt-format environments (a different K from the augmentation K — this is the IRM/V-REx sense). IRM-family penalties require ≥3 environments (Arjovsky 2019; Rosenfeld 2021; Ahuja 2021). At K=2 the variance term reduces to a pairwise scalar consistency satisfiable by any equalizing solution. Empirically: +0.014 QD F1, within run-to-run noise.</a:t>
-            </a:r>
-          </a:p>
-          <a:p>
-            <a:pPr>
-              <a:lnSpc>
-                <a:spcPct val="113000"/>
-              </a:lnSpc>
-              <a:spcAft>
-                <a:spcPts val="600"/>
-              </a:spcAft>
-            </a:pPr>
-            <a:r>
-              <a:rPr sz="1500" b="1">
-                <a:solidFill>
-                  <a:srgbClr val="1F4E90"/>
-                </a:solidFill>
-                <a:latin typeface="Calibri"/>
-              </a:rPr>
-              <a:t>•  </a:t>
-            </a:r>
-            <a:r>
-              <a:rPr sz="1500">
-                <a:solidFill>
-                  <a:srgbClr val="232A33"/>
-                </a:solidFill>
-                <a:latin typeface="Calibri"/>
-              </a:rPr>
-              <a:t>Format diversity without an explicit regularizer actively hurts.</a:t>
-            </a:r>
-          </a:p>
-          <a:p>
-            <a:pPr lvl="1">
-              <a:lnSpc>
-                <a:spcPct val="113000"/>
-              </a:lnSpc>
-              <a:spcAft>
-                <a:spcPts val="600"/>
-              </a:spcAft>
-            </a:pPr>
-            <a:r>
-              <a:rPr sz="1500" b="1">
-                <a:solidFill>
-                  <a:srgbClr val="1F4E90"/>
-                </a:solidFill>
-                <a:latin typeface="Calibri"/>
-              </a:rPr>
-              <a:t>–  </a:t>
-            </a:r>
-            <a:r>
-              <a:rPr sz="1500">
-                <a:solidFill>
-                  <a:srgbClr val="232A33"/>
-                </a:solidFill>
-                <a:latin typeface="Calibri"/>
-              </a:rPr>
-              <a:t>Plain mixed-format SFT widens the format gap to 0.100 vs single-format kl_reg_sft 0.072. Format mixing in continual training requires curriculum, unified rewriting, or — as we show in §4 — a preservation-side regularizer paired with K=5 augmentation on the injection side.</a:t>
+              <a:t>   — wrapped in 1 framing (K=1) or 5 framings (K=5).</a:t>
             </a:r>
           </a:p>
         </p:txBody>
@@ -5055,8 +4687,380 @@
         </p:nvSpPr>
         <p:spPr>
           <a:xfrm>
-            <a:off x="365760" y="6446520"/>
-            <a:ext cx="11430000" cy="320040"/>
+            <a:off x="457200" y="1463040"/>
+            <a:ext cx="5486400" cy="2286000"/>
+          </a:xfrm>
+          <a:prstGeom prst="rect">
+            <a:avLst/>
+          </a:prstGeom>
+          <a:solidFill>
+            <a:srgbClr val="F7F9FC"/>
+          </a:solidFill>
+          <a:ln w="12700">
+            <a:solidFill>
+              <a:srgbClr val="CFD8E3"/>
+            </a:solidFill>
+          </a:ln>
+        </p:spPr>
+        <p:txBody>
+          <a:bodyPr wrap="square" lIns="45720" rIns="45720" tIns="27432" bIns="27432">
+            <a:spAutoFit/>
+          </a:bodyPr>
+          <a:lstStyle/>
+          <a:p>
+            <a:r>
+              <a:rPr sz="2000" b="1">
+                <a:solidFill>
+                  <a:srgbClr val="0F2A57"/>
+                </a:solidFill>
+                <a:latin typeface="Calibri"/>
+              </a:rPr>
+              <a:t>K=1 KL   </a:t>
+            </a:r>
+            <a:r>
+              <a:rPr sz="1200" i="1">
+                <a:solidFill>
+                  <a:srgbClr val="5C6670"/>
+                </a:solidFill>
+                <a:latin typeface="Calibri"/>
+              </a:rPr>
+              <a:t>conditions (c), (d)</a:t>
+            </a:r>
+          </a:p>
+          <a:p>
+            <a:pPr>
+              <a:spcBef>
+                <a:spcPts val="200"/>
+              </a:spcBef>
+            </a:pPr>
+            <a:r>
+              <a:rPr sz="1100" i="1">
+                <a:solidFill>
+                  <a:srgbClr val="5C6670"/>
+                </a:solidFill>
+                <a:latin typeface="Calibri"/>
+              </a:rPr>
+              <a:t>One framing only — the Original QD-decomposer prompt:</a:t>
+            </a:r>
+          </a:p>
+          <a:p>
+            <a:pPr>
+              <a:spcBef>
+                <a:spcPts val="600"/>
+              </a:spcBef>
+            </a:pPr>
+            <a:r>
+              <a:rPr sz="1100" b="1">
+                <a:solidFill>
+                  <a:srgbClr val="1F4E90"/>
+                </a:solidFill>
+                <a:latin typeface="Calibri"/>
+              </a:rPr>
+              <a:t>Original  </a:t>
+            </a:r>
+            <a:r>
+              <a:rPr sz="1000">
+                <a:solidFill>
+                  <a:srgbClr val="232A33"/>
+                </a:solidFill>
+                <a:latin typeface="Consolas"/>
+              </a:rPr>
+              <a:t>[system: QD-decomposer]  [user: What should I know about Acme Corp's recent activity?]</a:t>
+            </a:r>
+          </a:p>
+          <a:p>
+            <a:pPr>
+              <a:spcBef>
+                <a:spcPts val="1000"/>
+              </a:spcBef>
+            </a:pPr>
+            <a:r>
+              <a:rPr sz="1200" i="1">
+                <a:solidFill>
+                  <a:srgbClr val="232A33"/>
+                </a:solidFill>
+                <a:latin typeface="Consolas"/>
+              </a:rPr>
+              <a:t>L_KL^{K=1}  =  KL( π_ref ‖ π_θ )   on the one framing</a:t>
+            </a:r>
+          </a:p>
+        </p:txBody>
+      </p:sp>
+      <p:sp>
+        <p:nvSpPr>
+          <p:cNvPr id="6" name="TextBox 5"/>
+          <p:cNvSpPr txBox="1"/>
+          <p:nvPr/>
+        </p:nvSpPr>
+        <p:spPr>
+          <a:xfrm>
+            <a:off x="6263640" y="1463040"/>
+            <a:ext cx="5486400" cy="4023360"/>
+          </a:xfrm>
+          <a:prstGeom prst="rect">
+            <a:avLst/>
+          </a:prstGeom>
+          <a:solidFill>
+            <a:srgbClr val="E8F2E8"/>
+          </a:solidFill>
+          <a:ln w="12700">
+            <a:solidFill>
+              <a:srgbClr val="9DC4A1"/>
+            </a:solidFill>
+          </a:ln>
+        </p:spPr>
+        <p:txBody>
+          <a:bodyPr wrap="square" lIns="45720" rIns="45720" tIns="27432" bIns="27432">
+            <a:spAutoFit/>
+          </a:bodyPr>
+          <a:lstStyle/>
+          <a:p>
+            <a:r>
+              <a:rPr sz="2000" b="1">
+                <a:solidFill>
+                  <a:srgbClr val="1F8E4F"/>
+                </a:solidFill>
+                <a:latin typeface="Calibri"/>
+              </a:rPr>
+              <a:t>K=5 KL   </a:t>
+            </a:r>
+            <a:r>
+              <a:rPr sz="1200" i="1">
+                <a:solidFill>
+                  <a:srgbClr val="5C6670"/>
+                </a:solidFill>
+                <a:latin typeface="Calibri"/>
+              </a:rPr>
+              <a:t>condition (e)</a:t>
+            </a:r>
+          </a:p>
+          <a:p>
+            <a:pPr>
+              <a:spcBef>
+                <a:spcPts val="200"/>
+              </a:spcBef>
+            </a:pPr>
+            <a:r>
+              <a:rPr sz="1100" i="1">
+                <a:solidFill>
+                  <a:srgbClr val="5C6670"/>
+                </a:solidFill>
+                <a:latin typeface="Calibri"/>
+              </a:rPr>
+              <a:t>Same task prompt wrapped in 5 instruction framings — KL averaged over all five:</a:t>
+            </a:r>
+          </a:p>
+          <a:p>
+            <a:pPr>
+              <a:spcBef>
+                <a:spcPts val="200"/>
+              </a:spcBef>
+            </a:pPr>
+            <a:r>
+              <a:rPr sz="1000" b="1">
+                <a:solidFill>
+                  <a:srgbClr val="1F8E4F"/>
+                </a:solidFill>
+                <a:latin typeface="Calibri"/>
+              </a:rPr>
+              <a:t>  Original  </a:t>
+            </a:r>
+            <a:r>
+              <a:rPr sz="900">
+                <a:solidFill>
+                  <a:srgbClr val="232A33"/>
+                </a:solidFill>
+                <a:latin typeface="Consolas"/>
+              </a:rPr>
+              <a:t>[system: QD-decomposer]  [user: ...recent activity?]</a:t>
+            </a:r>
+          </a:p>
+          <a:p>
+            <a:pPr>
+              <a:spcBef>
+                <a:spcPts val="200"/>
+              </a:spcBef>
+            </a:pPr>
+            <a:r>
+              <a:rPr sz="1000" b="1">
+                <a:solidFill>
+                  <a:srgbClr val="1F8E4F"/>
+                </a:solidFill>
+                <a:latin typeface="Calibri"/>
+              </a:rPr>
+              <a:t>  Bare  </a:t>
+            </a:r>
+            <a:r>
+              <a:rPr sz="900">
+                <a:solidFill>
+                  <a:srgbClr val="232A33"/>
+                </a:solidFill>
+                <a:latin typeface="Consolas"/>
+              </a:rPr>
+              <a:t>[user: ...recent activity?]   (no system prompt)</a:t>
+            </a:r>
+          </a:p>
+          <a:p>
+            <a:pPr>
+              <a:spcBef>
+                <a:spcPts val="200"/>
+              </a:spcBef>
+            </a:pPr>
+            <a:r>
+              <a:rPr sz="1000" b="1">
+                <a:solidFill>
+                  <a:srgbClr val="1F8E4F"/>
+                </a:solidFill>
+                <a:latin typeface="Calibri"/>
+              </a:rPr>
+              <a:t>  Analyst  </a:t>
+            </a:r>
+            <a:r>
+              <a:rPr sz="900">
+                <a:solidFill>
+                  <a:srgbClr val="232A33"/>
+                </a:solidFill>
+                <a:latin typeface="Consolas"/>
+              </a:rPr>
+              <a:t>[user: You are a financial analyst. Answer concisely: ...]</a:t>
+            </a:r>
+          </a:p>
+          <a:p>
+            <a:pPr>
+              <a:spcBef>
+                <a:spcPts val="200"/>
+              </a:spcBef>
+            </a:pPr>
+            <a:r>
+              <a:rPr sz="1000" b="1">
+                <a:solidFill>
+                  <a:srgbClr val="1F8E4F"/>
+                </a:solidFill>
+                <a:latin typeface="Calibri"/>
+              </a:rPr>
+              <a:t>  Detailed  </a:t>
+            </a:r>
+            <a:r>
+              <a:rPr sz="900">
+                <a:solidFill>
+                  <a:srgbClr val="232A33"/>
+                </a:solidFill>
+                <a:latin typeface="Consolas"/>
+              </a:rPr>
+              <a:t>[user: Given the following question, provide a detailed response: ...]</a:t>
+            </a:r>
+          </a:p>
+          <a:p>
+            <a:pPr>
+              <a:spcBef>
+                <a:spcPts val="200"/>
+              </a:spcBef>
+            </a:pPr>
+            <a:r>
+              <a:rPr sz="1000" b="1">
+                <a:solidFill>
+                  <a:srgbClr val="1F8E4F"/>
+                </a:solidFill>
+                <a:latin typeface="Calibri"/>
+              </a:rPr>
+              <a:t>  Request  </a:t>
+            </a:r>
+            <a:r>
+              <a:rPr sz="900">
+                <a:solidFill>
+                  <a:srgbClr val="232A33"/>
+                </a:solidFill>
+                <a:latin typeface="Consolas"/>
+              </a:rPr>
+              <a:t>[user: Question: ...recent activity?  Please provide your analysis.]</a:t>
+            </a:r>
+          </a:p>
+          <a:p>
+            <a:pPr>
+              <a:spcBef>
+                <a:spcPts val="800"/>
+              </a:spcBef>
+            </a:pPr>
+            <a:r>
+              <a:rPr sz="1200" i="1">
+                <a:solidFill>
+                  <a:srgbClr val="232A33"/>
+                </a:solidFill>
+                <a:latin typeface="Consolas"/>
+              </a:rPr>
+              <a:t>L_KL^{K=5}  =  (1/5) · Σ_k  KL( π_ref(·|G_k) ‖ π_θ(·|G_k) )</a:t>
+            </a:r>
+          </a:p>
+        </p:txBody>
+      </p:sp>
+      <p:sp>
+        <p:nvSpPr>
+          <p:cNvPr id="7" name="TextBox 6"/>
+          <p:cNvSpPr txBox="1"/>
+          <p:nvPr/>
+        </p:nvSpPr>
+        <p:spPr>
+          <a:xfrm>
+            <a:off x="457200" y="3886200"/>
+            <a:ext cx="5486400" cy="914400"/>
+          </a:xfrm>
+          <a:prstGeom prst="rect">
+            <a:avLst/>
+          </a:prstGeom>
+          <a:solidFill>
+            <a:srgbClr val="FDF7EF"/>
+          </a:solidFill>
+          <a:ln w="12700">
+            <a:solidFill>
+              <a:srgbClr val="E8C89C"/>
+            </a:solidFill>
+          </a:ln>
+        </p:spPr>
+        <p:txBody>
+          <a:bodyPr wrap="square" lIns="45720" rIns="45720" tIns="27432" bIns="27432">
+            <a:spAutoFit/>
+          </a:bodyPr>
+          <a:lstStyle/>
+          <a:p>
+            <a:pPr algn="ctr"/>
+            <a:r>
+              <a:rPr sz="2200" b="1">
+                <a:solidFill>
+                  <a:srgbClr val="C0392B"/>
+                </a:solidFill>
+                <a:latin typeface="Calibri"/>
+              </a:rPr>
+              <a:t>(e) − (d)  =  −0.006</a:t>
+            </a:r>
+          </a:p>
+          <a:p>
+            <a:pPr algn="ctr">
+              <a:spcBef>
+                <a:spcPts val="200"/>
+              </a:spcBef>
+            </a:pPr>
+            <a:r>
+              <a:rPr sz="1200" i="1">
+                <a:solidFill>
+                  <a:srgbClr val="232A33"/>
+                </a:solidFill>
+                <a:latin typeface="Calibri"/>
+              </a:rPr>
+              <a:t>K=5 on the preservation side adds nothing</a:t>
+            </a:r>
+          </a:p>
+        </p:txBody>
+      </p:sp>
+      <p:sp>
+        <p:nvSpPr>
+          <p:cNvPr id="8" name="TextBox 7"/>
+          <p:cNvSpPr txBox="1"/>
+          <p:nvPr/>
+        </p:nvSpPr>
+        <p:spPr>
+          <a:xfrm>
+            <a:off x="457200" y="5532120"/>
+            <a:ext cx="11247120" cy="868680"/>
           </a:xfrm>
           <a:prstGeom prst="rect">
             <a:avLst/>
@@ -5072,32 +5076,101 @@
           </a:bodyPr>
           <a:lstStyle/>
           <a:p>
-            <a:pPr algn="l"/>
-            <a:r>
-              <a:rPr sz="1000">
-                <a:solidFill>
-                  <a:srgbClr val="5C6670"/>
-                </a:solidFill>
-                <a:latin typeface="Calibri"/>
-              </a:rPr>
-              <a:t>COMS 6998   ·   Jeremiah Mao, Mateo Juliani</a:t>
-            </a:r>
-          </a:p>
-          <a:p>
-            <a:pPr algn="r"/>
-          </a:p>
-        </p:txBody>
-      </p:sp>
-      <p:sp>
-        <p:nvSpPr>
-          <p:cNvPr id="6" name="TextBox 5"/>
+            <a:pPr>
+              <a:lnSpc>
+                <a:spcPct val="105000"/>
+              </a:lnSpc>
+              <a:spcAft>
+                <a:spcPts val="600"/>
+              </a:spcAft>
+            </a:pPr>
+            <a:r>
+              <a:rPr sz="1100" b="1">
+                <a:solidFill>
+                  <a:srgbClr val="1F4E90"/>
+                </a:solidFill>
+                <a:latin typeface="Calibri"/>
+              </a:rPr>
+              <a:t>•  </a:t>
+            </a:r>
+            <a:r>
+              <a:rPr sz="1100">
+                <a:solidFill>
+                  <a:srgbClr val="232A33"/>
+                </a:solidFill>
+                <a:latin typeface="Calibri"/>
+              </a:rPr>
+              <a:t>Active ingredient is K=5 injection × any KL anchor — not K=5 on both sides.</a:t>
+            </a:r>
+          </a:p>
+          <a:p>
+            <a:pPr>
+              <a:lnSpc>
+                <a:spcPct val="105000"/>
+              </a:lnSpc>
+              <a:spcAft>
+                <a:spcPts val="600"/>
+              </a:spcAft>
+            </a:pPr>
+            <a:r>
+              <a:rPr sz="1100" b="1">
+                <a:solidFill>
+                  <a:srgbClr val="1F4E90"/>
+                </a:solidFill>
+                <a:latin typeface="Calibri"/>
+              </a:rPr>
+              <a:t>•  </a:t>
+            </a:r>
+            <a:r>
+              <a:rPr sz="1100">
+                <a:solidFill>
+                  <a:srgbClr val="232A33"/>
+                </a:solidFill>
+                <a:latin typeface="Calibri"/>
+              </a:rPr>
+              <a:t>Why: K=5 augmentation on the injection side already broadcasts each update across format directions of the gradient; LoRA's update subspace is shared across formats, so single-framing KL implicitly anchors all directions the K=5 update can push.</a:t>
+            </a:r>
+          </a:p>
+          <a:p>
+            <a:pPr>
+              <a:lnSpc>
+                <a:spcPct val="105000"/>
+              </a:lnSpc>
+              <a:spcAft>
+                <a:spcPts val="600"/>
+              </a:spcAft>
+            </a:pPr>
+            <a:r>
+              <a:rPr sz="1100" b="1">
+                <a:solidFill>
+                  <a:srgbClr val="1F4E90"/>
+                </a:solidFill>
+                <a:latin typeface="Calibri"/>
+              </a:rPr>
+              <a:t>•  </a:t>
+            </a:r>
+            <a:r>
+              <a:rPr sz="1100">
+                <a:solidFill>
+                  <a:srgbClr val="232A33"/>
+                </a:solidFill>
+                <a:latin typeface="Calibri"/>
+              </a:rPr>
+              <a:t>Caveat: this leans on LoRA's shared low-rank update subspace. At full fine-tuning the symmetric extension may earn its keep — not validated.</a:t>
+            </a:r>
+          </a:p>
+        </p:txBody>
+      </p:sp>
+      <p:sp>
+        <p:nvSpPr>
+          <p:cNvPr id="9" name="TextBox 8"/>
           <p:cNvSpPr txBox="1"/>
           <p:nvPr/>
         </p:nvSpPr>
         <p:spPr>
           <a:xfrm>
-            <a:off x="10515600" y="6446520"/>
-            <a:ext cx="1280160" cy="320040"/>
+            <a:off x="365760" y="6446520"/>
+            <a:ext cx="11430000" cy="320040"/>
           </a:xfrm>
           <a:prstGeom prst="rect">
             <a:avLst/>
@@ -5113,7 +5186,48 @@
           </a:bodyPr>
           <a:lstStyle/>
           <a:p>
+            <a:pPr algn="l"/>
+            <a:r>
+              <a:rPr sz="1000">
+                <a:solidFill>
+                  <a:srgbClr val="5C6670"/>
+                </a:solidFill>
+                <a:latin typeface="Calibri"/>
+              </a:rPr>
+              <a:t>COMS 6998   ·   Jeremiah Mao, Mateo Juliani</a:t>
+            </a:r>
+          </a:p>
+          <a:p>
             <a:pPr algn="r"/>
+          </a:p>
+        </p:txBody>
+      </p:sp>
+      <p:sp>
+        <p:nvSpPr>
+          <p:cNvPr id="10" name="TextBox 9"/>
+          <p:cNvSpPr txBox="1"/>
+          <p:nvPr/>
+        </p:nvSpPr>
+        <p:spPr>
+          <a:xfrm>
+            <a:off x="10515600" y="6446520"/>
+            <a:ext cx="1280160" cy="320040"/>
+          </a:xfrm>
+          <a:prstGeom prst="rect">
+            <a:avLst/>
+          </a:prstGeom>
+          <a:noFill/>
+          <a:ln>
+            <a:noFill/>
+          </a:ln>
+        </p:spPr>
+        <p:txBody>
+          <a:bodyPr wrap="square" lIns="45720" rIns="45720" tIns="27432" bIns="27432">
+            <a:spAutoFit/>
+          </a:bodyPr>
+          <a:lstStyle/>
+          <a:p>
+            <a:pPr algn="r"/>
             <a:r>
               <a:rPr sz="1000">
                 <a:solidFill>
@@ -5121,7 +5235,7 @@
                 </a:solidFill>
                 <a:latin typeface="Calibri"/>
               </a:rPr>
-              <a:t>12 / 16</a:t>
+              <a:t>12 / 15</a:t>
             </a:r>
           </a:p>
         </p:txBody>
@@ -5221,7 +5335,7 @@
                 </a:solidFill>
                 <a:latin typeface="Calibri"/>
               </a:rPr>
-              <a:t>Symmetric extension fails: K=5 KL preservation adds nothing</a:t>
+              <a:t>Recommendation</a:t>
             </a:r>
           </a:p>
         </p:txBody>
@@ -5234,8 +5348,82 @@
         </p:nvSpPr>
         <p:spPr>
           <a:xfrm>
-            <a:off x="548640" y="868680"/>
-            <a:ext cx="11064240" cy="548640"/>
+            <a:off x="731520" y="1188720"/>
+            <a:ext cx="10698480" cy="1554480"/>
+          </a:xfrm>
+          <a:prstGeom prst="rect">
+            <a:avLst/>
+          </a:prstGeom>
+          <a:solidFill>
+            <a:srgbClr val="E8F2E8"/>
+          </a:solidFill>
+          <a:ln w="12700">
+            <a:solidFill>
+              <a:srgbClr val="1F8E4F"/>
+            </a:solidFill>
+          </a:ln>
+        </p:spPr>
+        <p:txBody>
+          <a:bodyPr wrap="square" lIns="45720" rIns="45720" tIns="27432" bIns="27432">
+            <a:spAutoFit/>
+          </a:bodyPr>
+          <a:lstStyle/>
+          <a:p>
+            <a:pPr algn="ctr"/>
+            <a:r>
+              <a:rPr sz="2000" i="1">
+                <a:solidFill>
+                  <a:srgbClr val="232A33"/>
+                </a:solidFill>
+                <a:latin typeface="Calibri"/>
+              </a:rPr>
+              <a:t>For continual LoRA fact injection in task-tuned LLMs:</a:t>
+            </a:r>
+          </a:p>
+          <a:p>
+            <a:pPr algn="ctr">
+              <a:spcBef>
+                <a:spcPts val="800"/>
+              </a:spcBef>
+            </a:pPr>
+            <a:r>
+              <a:rPr sz="2200" b="1">
+                <a:solidFill>
+                  <a:srgbClr val="1F8E4F"/>
+                </a:solidFill>
+                <a:latin typeface="Calibri"/>
+              </a:rPr>
+              <a:t>K=5 paraphrastic augmentation on the injection side  +  K=1 KL preservation against a per-round frozen reference</a:t>
+            </a:r>
+          </a:p>
+          <a:p>
+            <a:pPr algn="ctr">
+              <a:spcBef>
+                <a:spcPts val="400"/>
+              </a:spcBef>
+            </a:pPr>
+            <a:r>
+              <a:rPr sz="1400" i="1">
+                <a:solidFill>
+                  <a:srgbClr val="5C6670"/>
+                </a:solidFill>
+                <a:latin typeface="Calibri"/>
+              </a:rPr>
+              <a:t>( aug_kl_k1 — condition (d) )</a:t>
+            </a:r>
+          </a:p>
+        </p:txBody>
+      </p:sp>
+      <p:sp>
+        <p:nvSpPr>
+          <p:cNvPr id="5" name="TextBox 4"/>
+          <p:cNvSpPr txBox="1"/>
+          <p:nvPr/>
+        </p:nvSpPr>
+        <p:spPr>
+          <a:xfrm>
+            <a:off x="548640" y="3017520"/>
+            <a:ext cx="11064240" cy="3291840"/>
           </a:xfrm>
           <a:prstGeom prst="rect">
             <a:avLst/>
@@ -5251,6 +5439,14 @@
           </a:bodyPr>
           <a:lstStyle/>
           <a:p>
+            <a:pPr>
+              <a:lnSpc>
+                <a:spcPct val="115000"/>
+              </a:lnSpc>
+              <a:spcAft>
+                <a:spcPts val="600"/>
+              </a:spcAft>
+            </a:pPr>
             <a:r>
               <a:rPr sz="1500" b="1">
                 <a:solidFill>
@@ -5258,7 +5454,7 @@
                 </a:solidFill>
                 <a:latin typeface="Calibri"/>
               </a:rPr>
-              <a:t>Hypothesis: </a:t>
+              <a:t>•  </a:t>
             </a:r>
             <a:r>
               <a:rPr sz="1500">
@@ -5267,182 +5463,119 @@
                 </a:solidFill>
                 <a:latin typeface="Calibri"/>
               </a:rPr>
-              <a:t>single-format KL preservation might fail to detect format-selective forgetting. Augmenting the preservation side with K=5 framings should catch it.</a:t>
-            </a:r>
-          </a:p>
-        </p:txBody>
-      </p:sp>
-      <p:sp>
-        <p:nvSpPr>
-          <p:cNvPr id="5" name="TextBox 4"/>
-          <p:cNvSpPr txBox="1"/>
-          <p:nvPr/>
-        </p:nvSpPr>
-        <p:spPr>
-          <a:xfrm>
-            <a:off x="548640" y="1463040"/>
-            <a:ext cx="11064240" cy="2011680"/>
-          </a:xfrm>
-          <a:prstGeom prst="rect">
-            <a:avLst/>
-          </a:prstGeom>
-          <a:solidFill>
-            <a:srgbClr val="F7F9FC"/>
-          </a:solidFill>
-          <a:ln w="12700">
-            <a:solidFill>
-              <a:srgbClr val="CFD8E3"/>
-            </a:solidFill>
-          </a:ln>
-        </p:spPr>
-        <p:txBody>
-          <a:bodyPr wrap="square" lIns="45720" rIns="45720" tIns="27432" bIns="27432">
-            <a:spAutoFit/>
-          </a:bodyPr>
-          <a:lstStyle/>
-          <a:p>
-            <a:r>
-              <a:rPr sz="1300" b="1">
+              <a:t>Use K=5 paraphrastic augmentation on the injection side. Don't rely on K=1 (single-format) injection alone.</a:t>
+            </a:r>
+          </a:p>
+          <a:p>
+            <a:pPr>
+              <a:lnSpc>
+                <a:spcPct val="115000"/>
+              </a:lnSpc>
+              <a:spcAft>
+                <a:spcPts val="600"/>
+              </a:spcAft>
+            </a:pPr>
+            <a:r>
+              <a:rPr sz="1500" b="1">
                 <a:solidFill>
                   <a:srgbClr val="1F4E90"/>
                 </a:solidFill>
                 <a:latin typeface="Calibri"/>
               </a:rPr>
-              <a:t>The K=5 preservation framings </a:t>
-            </a:r>
-            <a:r>
-              <a:rPr sz="1200" i="1">
+              <a:t>•  </a:t>
+            </a:r>
+            <a:r>
+              <a:rPr sz="1500">
                 <a:solidFill>
                   <a:srgbClr val="232A33"/>
                 </a:solidFill>
                 <a:latin typeface="Calibri"/>
               </a:rPr>
-              <a:t>applied to the same task prompt   "What should I know about Acme Corp's recent activity?"</a:t>
+              <a:t>Pair it with standard K=1 KL preservation against a per-round frozen reference. Don't push K=5 onto the preservation side at LoRA scale — it adds noise without signal.</a:t>
             </a:r>
           </a:p>
           <a:p>
             <a:pPr>
-              <a:spcBef>
-                <a:spcPts val="200"/>
-              </a:spcBef>
+              <a:lnSpc>
+                <a:spcPct val="115000"/>
+              </a:lnSpc>
+              <a:spcAft>
+                <a:spcPts val="600"/>
+              </a:spcAft>
             </a:pPr>
             <a:r>
-              <a:rPr sz="1100" b="1">
+              <a:rPr sz="1500" b="1">
                 <a:solidFill>
                   <a:srgbClr val="1F4E90"/>
                 </a:solidFill>
                 <a:latin typeface="Calibri"/>
               </a:rPr>
-              <a:t>  Original:  </a:t>
-            </a:r>
-            <a:r>
-              <a:rPr sz="1000">
+              <a:t>•  </a:t>
+            </a:r>
+            <a:r>
+              <a:rPr sz="1500">
                 <a:solidFill>
                   <a:srgbClr val="232A33"/>
                 </a:solidFill>
-                <a:latin typeface="Consolas"/>
-              </a:rPr>
-              <a:t>[system: QD-decomposer]  [user: What should I know about Acme Corp's recent activity?]</a:t>
+                <a:latin typeface="Calibri"/>
+              </a:rPr>
+              <a:t>Don't use COPR for fact injection — the K-sample-all-wrong pathology breaks the assumption that the candidate pool contains usable signal.</a:t>
             </a:r>
           </a:p>
           <a:p>
             <a:pPr>
-              <a:spcBef>
-                <a:spcPts val="200"/>
-              </a:spcBef>
+              <a:lnSpc>
+                <a:spcPct val="115000"/>
+              </a:lnSpc>
+              <a:spcAft>
+                <a:spcPts val="600"/>
+              </a:spcAft>
             </a:pPr>
             <a:r>
-              <a:rPr sz="1100" b="1">
+              <a:rPr sz="1500" b="1">
                 <a:solidFill>
                   <a:srgbClr val="1F4E90"/>
                 </a:solidFill>
                 <a:latin typeface="Calibri"/>
               </a:rPr>
-              <a:t>  Bare:  </a:t>
-            </a:r>
-            <a:r>
-              <a:rPr sz="1000">
+              <a:t>•  </a:t>
+            </a:r>
+            <a:r>
+              <a:rPr sz="1500">
                 <a:solidFill>
                   <a:srgbClr val="232A33"/>
                 </a:solidFill>
-                <a:latin typeface="Consolas"/>
-              </a:rPr>
-              <a:t>[user: What should I know about Acme Corp's recent activity?]   (no system prompt)</a:t>
+                <a:latin typeface="Calibri"/>
+              </a:rPr>
+              <a:t>Don't use OOD regularization at K=2 environments — theoretically degenerate per Arjovsky / Rosenfeld / Ahuja, empirically null.</a:t>
             </a:r>
           </a:p>
           <a:p>
             <a:pPr>
-              <a:spcBef>
-                <a:spcPts val="200"/>
-              </a:spcBef>
+              <a:lnSpc>
+                <a:spcPct val="115000"/>
+              </a:lnSpc>
+              <a:spcAft>
+                <a:spcPts val="600"/>
+              </a:spcAft>
             </a:pPr>
             <a:r>
-              <a:rPr sz="1100" b="1">
+              <a:rPr sz="1500" b="1">
                 <a:solidFill>
                   <a:srgbClr val="1F4E90"/>
                 </a:solidFill>
                 <a:latin typeface="Calibri"/>
               </a:rPr>
-              <a:t>  Analyst:  </a:t>
-            </a:r>
-            <a:r>
-              <a:rPr sz="1000">
+              <a:t>•  </a:t>
+            </a:r>
+            <a:r>
+              <a:rPr sz="1500">
                 <a:solidFill>
                   <a:srgbClr val="232A33"/>
                 </a:solidFill>
-                <a:latin typeface="Consolas"/>
-              </a:rPr>
-              <a:t>[user: You are a financial analyst. Answer concisely: What should I know about Acme Corp's recent activity?]</a:t>
-            </a:r>
-          </a:p>
-          <a:p>
-            <a:pPr>
-              <a:spcBef>
-                <a:spcPts val="200"/>
-              </a:spcBef>
-            </a:pPr>
-            <a:r>
-              <a:rPr sz="1100" b="1">
-                <a:solidFill>
-                  <a:srgbClr val="1F4E90"/>
-                </a:solidFill>
-                <a:latin typeface="Calibri"/>
-              </a:rPr>
-              <a:t>  Detailed:  </a:t>
-            </a:r>
-            <a:r>
-              <a:rPr sz="1000">
-                <a:solidFill>
-                  <a:srgbClr val="232A33"/>
-                </a:solidFill>
-                <a:latin typeface="Consolas"/>
-              </a:rPr>
-              <a:t>[user: Given the following question, provide a detailed response: What should I know about Acme Corp's recent activity?]</a:t>
-            </a:r>
-          </a:p>
-          <a:p>
-            <a:pPr>
-              <a:spcBef>
-                <a:spcPts val="200"/>
-              </a:spcBef>
-            </a:pPr>
-            <a:r>
-              <a:rPr sz="1100" b="1">
-                <a:solidFill>
-                  <a:srgbClr val="1F4E90"/>
-                </a:solidFill>
-                <a:latin typeface="Calibri"/>
-              </a:rPr>
-              <a:t>  Request:  </a:t>
-            </a:r>
-            <a:r>
-              <a:rPr sz="1000">
-                <a:solidFill>
-                  <a:srgbClr val="232A33"/>
-                </a:solidFill>
-                <a:latin typeface="Consolas"/>
-              </a:rPr>
-              <a:t>[user: Question: What should I know about Acme Corp's recent activity?  Please provide your analysis.]</a:t>
+                <a:latin typeface="Calibri"/>
+              </a:rPr>
+              <a:t>The cross-coupling is the active ingredient. Either ingredient alone gives ~+0.03; together they give +0.322 (4.93× super-linear).</a:t>
             </a:r>
           </a:p>
         </p:txBody>
@@ -5455,66 +5588,8 @@
         </p:nvSpPr>
         <p:spPr>
           <a:xfrm>
-            <a:off x="1371600" y="3611880"/>
-            <a:ext cx="9418320" cy="1280160"/>
-          </a:xfrm>
-          <a:prstGeom prst="rect">
-            <a:avLst/>
-          </a:prstGeom>
-          <a:solidFill>
-            <a:srgbClr val="FDF7EF"/>
-          </a:solidFill>
-          <a:ln w="12700">
-            <a:solidFill>
-              <a:srgbClr val="E8C89C"/>
-            </a:solidFill>
-          </a:ln>
-        </p:spPr>
-        <p:txBody>
-          <a:bodyPr wrap="square" lIns="45720" rIns="45720" tIns="27432" bIns="27432">
-            <a:spAutoFit/>
-          </a:bodyPr>
-          <a:lstStyle/>
-          <a:p>
-            <a:pPr algn="ctr"/>
-            <a:r>
-              <a:rPr sz="2200" b="1">
-                <a:solidFill>
-                  <a:srgbClr val="C0392B"/>
-                </a:solidFill>
-                <a:latin typeface="Calibri"/>
-              </a:rPr>
-              <a:t>Result:  (e) − (d)  =  −0.006  at round 15</a:t>
-            </a:r>
-          </a:p>
-          <a:p>
-            <a:pPr algn="ctr">
-              <a:spcBef>
-                <a:spcPts val="600"/>
-              </a:spcBef>
-            </a:pPr>
-            <a:r>
-              <a:rPr sz="1400">
-                <a:solidFill>
-                  <a:srgbClr val="232A33"/>
-                </a:solidFill>
-                <a:latin typeface="Calibri"/>
-              </a:rPr>
-              <a:t>Trajectory Δ = −0.004.   95% interval [−0.030, +0.018] straddles zero.</a:t>
-            </a:r>
-          </a:p>
-        </p:txBody>
-      </p:sp>
-      <p:sp>
-        <p:nvSpPr>
-          <p:cNvPr id="7" name="TextBox 6"/>
-          <p:cNvSpPr txBox="1"/>
-          <p:nvPr/>
-        </p:nvSpPr>
-        <p:spPr>
-          <a:xfrm>
-            <a:off x="548640" y="5029200"/>
-            <a:ext cx="11064240" cy="1371600"/>
+            <a:off x="365760" y="6446520"/>
+            <a:ext cx="11430000" cy="320040"/>
           </a:xfrm>
           <a:prstGeom prst="rect">
             <a:avLst/>
@@ -5530,101 +5605,32 @@
           </a:bodyPr>
           <a:lstStyle/>
           <a:p>
-            <a:pPr>
-              <a:lnSpc>
-                <a:spcPct val="113000"/>
-              </a:lnSpc>
-              <a:spcAft>
-                <a:spcPts val="600"/>
-              </a:spcAft>
-            </a:pPr>
-            <a:r>
-              <a:rPr sz="1300" b="1">
-                <a:solidFill>
-                  <a:srgbClr val="1F4E90"/>
-                </a:solidFill>
-                <a:latin typeface="Calibri"/>
-              </a:rPr>
-              <a:t>•  </a:t>
-            </a:r>
-            <a:r>
-              <a:rPr sz="1300">
-                <a:solidFill>
-                  <a:srgbClr val="232A33"/>
-                </a:solidFill>
-                <a:latin typeface="Calibri"/>
-              </a:rPr>
-              <a:t>The active ingredient is K=5 injection × any KL anchor — not K=5 on both sides.</a:t>
-            </a:r>
-          </a:p>
-          <a:p>
-            <a:pPr>
-              <a:lnSpc>
-                <a:spcPct val="113000"/>
-              </a:lnSpc>
-              <a:spcAft>
-                <a:spcPts val="600"/>
-              </a:spcAft>
-            </a:pPr>
-            <a:r>
-              <a:rPr sz="1300" b="1">
-                <a:solidFill>
-                  <a:srgbClr val="1F4E90"/>
-                </a:solidFill>
-                <a:latin typeface="Calibri"/>
-              </a:rPr>
-              <a:t>•  </a:t>
-            </a:r>
-            <a:r>
-              <a:rPr sz="1300">
-                <a:solidFill>
-                  <a:srgbClr val="232A33"/>
-                </a:solidFill>
-                <a:latin typeface="Calibri"/>
-              </a:rPr>
-              <a:t>Why: K=5 augmentation on the injection side already broadcasts each update across format directions of the gradient; LoRA's update subspace is shared across formats, so single-framing KL implicitly anchors all directions the K=5 update can push.</a:t>
-            </a:r>
-          </a:p>
-          <a:p>
-            <a:pPr>
-              <a:lnSpc>
-                <a:spcPct val="113000"/>
-              </a:lnSpc>
-              <a:spcAft>
-                <a:spcPts val="600"/>
-              </a:spcAft>
-            </a:pPr>
-            <a:r>
-              <a:rPr sz="1300" b="1">
-                <a:solidFill>
-                  <a:srgbClr val="1F4E90"/>
-                </a:solidFill>
-                <a:latin typeface="Calibri"/>
-              </a:rPr>
-              <a:t>•  </a:t>
-            </a:r>
-            <a:r>
-              <a:rPr sz="1300">
-                <a:solidFill>
-                  <a:srgbClr val="232A33"/>
-                </a:solidFill>
-                <a:latin typeface="Calibri"/>
-              </a:rPr>
-              <a:t>Caveat: this conjecture leans on LoRA's shared low-rank update subspace. At full fine-tuning the symmetric extension may earn its keep — not validated.</a:t>
-            </a:r>
-          </a:p>
-        </p:txBody>
-      </p:sp>
-      <p:sp>
-        <p:nvSpPr>
-          <p:cNvPr id="8" name="TextBox 7"/>
+            <a:pPr algn="l"/>
+            <a:r>
+              <a:rPr sz="1000">
+                <a:solidFill>
+                  <a:srgbClr val="5C6670"/>
+                </a:solidFill>
+                <a:latin typeface="Calibri"/>
+              </a:rPr>
+              <a:t>COMS 6998   ·   Jeremiah Mao, Mateo Juliani</a:t>
+            </a:r>
+          </a:p>
+          <a:p>
+            <a:pPr algn="r"/>
+          </a:p>
+        </p:txBody>
+      </p:sp>
+      <p:sp>
+        <p:nvSpPr>
+          <p:cNvPr id="7" name="TextBox 6"/>
           <p:cNvSpPr txBox="1"/>
           <p:nvPr/>
         </p:nvSpPr>
         <p:spPr>
           <a:xfrm>
-            <a:off x="365760" y="6446520"/>
-            <a:ext cx="11430000" cy="320040"/>
+            <a:off x="10515600" y="6446520"/>
+            <a:ext cx="1280160" cy="320040"/>
           </a:xfrm>
           <a:prstGeom prst="rect">
             <a:avLst/>
@@ -5640,7 +5646,7 @@
           </a:bodyPr>
           <a:lstStyle/>
           <a:p>
-            <a:pPr algn="l"/>
+            <a:pPr algn="r"/>
             <a:r>
               <a:rPr sz="1000">
                 <a:solidFill>
@@ -5648,48 +5654,7 @@
                 </a:solidFill>
                 <a:latin typeface="Calibri"/>
               </a:rPr>
-              <a:t>COMS 6998   ·   Jeremiah Mao, Mateo Juliani</a:t>
-            </a:r>
-          </a:p>
-          <a:p>
-            <a:pPr algn="r"/>
-          </a:p>
-        </p:txBody>
-      </p:sp>
-      <p:sp>
-        <p:nvSpPr>
-          <p:cNvPr id="9" name="TextBox 8"/>
-          <p:cNvSpPr txBox="1"/>
-          <p:nvPr/>
-        </p:nvSpPr>
-        <p:spPr>
-          <a:xfrm>
-            <a:off x="10515600" y="6446520"/>
-            <a:ext cx="1280160" cy="320040"/>
-          </a:xfrm>
-          <a:prstGeom prst="rect">
-            <a:avLst/>
-          </a:prstGeom>
-          <a:noFill/>
-          <a:ln>
-            <a:noFill/>
-          </a:ln>
-        </p:spPr>
-        <p:txBody>
-          <a:bodyPr wrap="square" lIns="45720" rIns="45720" tIns="27432" bIns="27432">
-            <a:spAutoFit/>
-          </a:bodyPr>
-          <a:lstStyle/>
-          <a:p>
-            <a:pPr algn="r"/>
-            <a:r>
-              <a:rPr sz="1000">
-                <a:solidFill>
-                  <a:srgbClr val="5C6670"/>
-                </a:solidFill>
-                <a:latin typeface="Calibri"/>
-              </a:rPr>
-              <a:t>13 / 16</a:t>
+              <a:t>13 / 15</a:t>
             </a:r>
           </a:p>
         </p:txBody>
@@ -5789,7 +5754,7 @@
                 </a:solidFill>
                 <a:latin typeface="Calibri"/>
               </a:rPr>
-              <a:t>Recommendation</a:t>
+              <a:t>Limitations and follow-ups</a:t>
             </a:r>
           </a:p>
         </p:txBody>
@@ -5802,82 +5767,8 @@
         </p:nvSpPr>
         <p:spPr>
           <a:xfrm>
-            <a:off x="731520" y="1188720"/>
-            <a:ext cx="10698480" cy="1554480"/>
-          </a:xfrm>
-          <a:prstGeom prst="rect">
-            <a:avLst/>
-          </a:prstGeom>
-          <a:solidFill>
-            <a:srgbClr val="E8F2E8"/>
-          </a:solidFill>
-          <a:ln w="12700">
-            <a:solidFill>
-              <a:srgbClr val="1F8E4F"/>
-            </a:solidFill>
-          </a:ln>
-        </p:spPr>
-        <p:txBody>
-          <a:bodyPr wrap="square" lIns="45720" rIns="45720" tIns="27432" bIns="27432">
-            <a:spAutoFit/>
-          </a:bodyPr>
-          <a:lstStyle/>
-          <a:p>
-            <a:pPr algn="ctr"/>
-            <a:r>
-              <a:rPr sz="2000" i="1">
-                <a:solidFill>
-                  <a:srgbClr val="232A33"/>
-                </a:solidFill>
-                <a:latin typeface="Calibri"/>
-              </a:rPr>
-              <a:t>For continual LoRA fact injection in task-tuned LLMs:</a:t>
-            </a:r>
-          </a:p>
-          <a:p>
-            <a:pPr algn="ctr">
-              <a:spcBef>
-                <a:spcPts val="800"/>
-              </a:spcBef>
-            </a:pPr>
-            <a:r>
-              <a:rPr sz="2200" b="1">
-                <a:solidFill>
-                  <a:srgbClr val="1F8E4F"/>
-                </a:solidFill>
-                <a:latin typeface="Calibri"/>
-              </a:rPr>
-              <a:t>K=5 paraphrastic augmentation on the injection side  +  K=1 KL preservation against a per-round frozen reference</a:t>
-            </a:r>
-          </a:p>
-          <a:p>
-            <a:pPr algn="ctr">
-              <a:spcBef>
-                <a:spcPts val="400"/>
-              </a:spcBef>
-            </a:pPr>
-            <a:r>
-              <a:rPr sz="1400" i="1">
-                <a:solidFill>
-                  <a:srgbClr val="5C6670"/>
-                </a:solidFill>
-                <a:latin typeface="Calibri"/>
-              </a:rPr>
-              <a:t>( aug_kl_k1 — condition (d) )</a:t>
-            </a:r>
-          </a:p>
-        </p:txBody>
-      </p:sp>
-      <p:sp>
-        <p:nvSpPr>
-          <p:cNvPr id="5" name="TextBox 4"/>
-          <p:cNvSpPr txBox="1"/>
-          <p:nvPr/>
-        </p:nvSpPr>
-        <p:spPr>
-          <a:xfrm>
-            <a:off x="548640" y="3017520"/>
-            <a:ext cx="11064240" cy="3291840"/>
+            <a:off x="548640" y="1005840"/>
+            <a:ext cx="11064240" cy="5303520"/>
           </a:xfrm>
           <a:prstGeom prst="rect">
             <a:avLst/>
@@ -5917,7 +5808,7 @@
                 </a:solidFill>
                 <a:latin typeface="Calibri"/>
               </a:rPr>
-              <a:t>Use K=5 paraphrastic augmentation on the injection side. Don't rely on K=1 (single-format) injection alone.</a:t>
+              <a:t>Single model, single scale. Qwen3-4B at LoRA r=16 only. Synergy magnitude likely shrinks at 7–8B (~15–20 GPU-h follow-up).</a:t>
             </a:r>
           </a:p>
           <a:p>
@@ -5945,7 +5836,7 @@
                 </a:solidFill>
                 <a:latin typeface="Calibri"/>
               </a:rPr>
-              <a:t>Pair it with standard K=1 KL preservation against a per-round frozen reference. Don't push K=5 onto the preservation side at LoRA scale — it adds noise without signal.</a:t>
+              <a:t>Two seeds for the headline cells, one calibration seed. (e) vs (d) null is robust under conservative non-parametric intervals; a 3rd seed is in progress and would tighten bounds.</a:t>
             </a:r>
           </a:p>
           <a:p>
@@ -5973,7 +5864,7 @@
                 </a:solidFill>
                 <a:latin typeface="Calibri"/>
               </a:rPr>
-              <a:t>Don't use COPR for fact injection — the K-sample-all-wrong pathology breaks the assumption that the candidate pool contains usable signal.</a:t>
+              <a:t>The mechanism is hypothesized, not proven. Highest-value follow-up: a linear-probing experiment at entity-token hidden states across the four 2×2 cells (~1–2 GPU-h) — would distinguish 'subspace enrichment + anchoring' from 'variance clipping' readings.</a:t>
             </a:r>
           </a:p>
           <a:p>
@@ -6001,7 +5892,7 @@
                 </a:solidFill>
                 <a:latin typeface="Calibri"/>
               </a:rPr>
-              <a:t>Don't use OOD regularization at K=2 environments — theoretically degenerate per Arjovsky / Rosenfeld / Ahuja, empirically null.</a:t>
+              <a:t>K only tested at 5 on the injection side. Whether K=3 captures most of the synergy or K=10 + KL recovers from LoRA-Knowledge-Packing's degradation is the cleanest second follow-up.</a:t>
             </a:r>
           </a:p>
           <a:p>
@@ -6029,14 +5920,42 @@
                 </a:solidFill>
                 <a:latin typeface="Calibri"/>
               </a:rPr>
-              <a:t>The cross-coupling is the active ingredient. Either ingredient alone gives ~+0.03; together they give +0.322 (4.93× super-linear).</a:t>
-            </a:r>
-          </a:p>
-        </p:txBody>
-      </p:sp>
-      <p:sp>
-        <p:nvSpPr>
-          <p:cNvPr id="6" name="TextBox 5"/>
+              <a:t>Compositional / ripple-effect gap unsolved by every method tested. Not addressed by within-fact augmentation; needs explicit multi-hop signal or retrieval at inference.</a:t>
+            </a:r>
+          </a:p>
+          <a:p>
+            <a:pPr>
+              <a:lnSpc>
+                <a:spcPct val="115000"/>
+              </a:lnSpc>
+              <a:spcAft>
+                <a:spcPts val="600"/>
+              </a:spcAft>
+            </a:pPr>
+            <a:r>
+              <a:rPr sz="1500" b="1">
+                <a:solidFill>
+                  <a:srgbClr val="1F4E90"/>
+                </a:solidFill>
+                <a:latin typeface="Calibri"/>
+              </a:rPr>
+              <a:t>•  </a:t>
+            </a:r>
+            <a:r>
+              <a:rPr sz="1500">
+                <a:solidFill>
+                  <a:srgbClr val="232A33"/>
+                </a:solidFill>
+                <a:latin typeface="Calibri"/>
+              </a:rPr>
+              <a:t>Setting matches industrial practice but transfer beyond LoRA is principled, not validated. The synergy direction should extend to full FT; the (e) vs (d) null specifically may not.</a:t>
+            </a:r>
+          </a:p>
+        </p:txBody>
+      </p:sp>
+      <p:sp>
+        <p:nvSpPr>
+          <p:cNvPr id="5" name="TextBox 4"/>
           <p:cNvSpPr txBox="1"/>
           <p:nvPr/>
         </p:nvSpPr>
@@ -6077,7 +5996,7 @@
       </p:sp>
       <p:sp>
         <p:nvSpPr>
-          <p:cNvPr id="7" name="TextBox 6"/>
+          <p:cNvPr id="6" name="TextBox 5"/>
           <p:cNvSpPr txBox="1"/>
           <p:nvPr/>
         </p:nvSpPr>
@@ -6108,7 +6027,7 @@
                 </a:solidFill>
                 <a:latin typeface="Calibri"/>
               </a:rPr>
-              <a:t>14 / 16</a:t>
+              <a:t>14 / 15</a:t>
             </a:r>
           </a:p>
         </p:txBody>
@@ -6139,8 +6058,8 @@
         </p:nvSpPr>
         <p:spPr>
           <a:xfrm>
-            <a:off x="0" y="0"/>
-            <a:ext cx="12191695" cy="777240"/>
+            <a:off x="0" y="2377440"/>
+            <a:ext cx="12191695" cy="2103120"/>
           </a:xfrm>
           <a:prstGeom prst="rect">
             <a:avLst/>
@@ -6183,8 +6102,8 @@
         </p:nvSpPr>
         <p:spPr>
           <a:xfrm>
-            <a:off x="365760" y="109728"/>
-            <a:ext cx="11430000" cy="594360"/>
+            <a:off x="548640" y="2606040"/>
+            <a:ext cx="11064240" cy="1828800"/>
           </a:xfrm>
           <a:prstGeom prst="rect">
             <a:avLst/>
@@ -6200,15 +6119,31 @@
           </a:bodyPr>
           <a:lstStyle/>
           <a:p>
-            <a:pPr algn="l"/>
-            <a:r>
-              <a:rPr sz="2800" b="1">
+            <a:pPr algn="ctr"/>
+            <a:r>
+              <a:rPr sz="5400" b="1">
                 <a:solidFill>
                   <a:srgbClr val="FFFFFF"/>
                 </a:solidFill>
                 <a:latin typeface="Calibri"/>
               </a:rPr>
-              <a:t>Limitations and follow-ups</a:t>
+              <a:t>Thank you</a:t>
+            </a:r>
+          </a:p>
+          <a:p>
+            <a:pPr algn="ctr">
+              <a:spcBef>
+                <a:spcPts val="2000"/>
+              </a:spcBef>
+            </a:pPr>
+            <a:r>
+              <a:rPr sz="2200" i="1">
+                <a:solidFill>
+                  <a:srgbClr val="FFFFFF"/>
+                </a:solidFill>
+                <a:latin typeface="Calibri"/>
+              </a:rPr>
+              <a:t>Questions?</a:t>
             </a:r>
           </a:p>
         </p:txBody>
@@ -6221,8 +6156,8 @@
         </p:nvSpPr>
         <p:spPr>
           <a:xfrm>
-            <a:off x="548640" y="1005840"/>
-            <a:ext cx="11064240" cy="5303520"/>
+            <a:off x="548640" y="4937760"/>
+            <a:ext cx="11064240" cy="548640"/>
           </a:xfrm>
           <a:prstGeom prst="rect">
             <a:avLst/>
@@ -6238,171 +6173,15 @@
           </a:bodyPr>
           <a:lstStyle/>
           <a:p>
-            <a:pPr>
-              <a:lnSpc>
-                <a:spcPct val="115000"/>
-              </a:lnSpc>
-              <a:spcAft>
-                <a:spcPts val="600"/>
-              </a:spcAft>
-            </a:pPr>
-            <a:r>
-              <a:rPr sz="1500" b="1">
-                <a:solidFill>
-                  <a:srgbClr val="1F4E90"/>
-                </a:solidFill>
-                <a:latin typeface="Calibri"/>
-              </a:rPr>
-              <a:t>•  </a:t>
-            </a:r>
-            <a:r>
-              <a:rPr sz="1500">
+            <a:pPr algn="ctr"/>
+            <a:r>
+              <a:rPr sz="1600">
                 <a:solidFill>
                   <a:srgbClr val="232A33"/>
                 </a:solidFill>
                 <a:latin typeface="Calibri"/>
               </a:rPr>
-              <a:t>Single model, single scale. Qwen3-4B at LoRA r=16 only. Synergy magnitude likely shrinks at 7–8B (~15–20 GPU-h follow-up).</a:t>
-            </a:r>
-          </a:p>
-          <a:p>
-            <a:pPr>
-              <a:lnSpc>
-                <a:spcPct val="115000"/>
-              </a:lnSpc>
-              <a:spcAft>
-                <a:spcPts val="600"/>
-              </a:spcAft>
-            </a:pPr>
-            <a:r>
-              <a:rPr sz="1500" b="1">
-                <a:solidFill>
-                  <a:srgbClr val="1F4E90"/>
-                </a:solidFill>
-                <a:latin typeface="Calibri"/>
-              </a:rPr>
-              <a:t>•  </a:t>
-            </a:r>
-            <a:r>
-              <a:rPr sz="1500">
-                <a:solidFill>
-                  <a:srgbClr val="232A33"/>
-                </a:solidFill>
-                <a:latin typeface="Calibri"/>
-              </a:rPr>
-              <a:t>Two seeds for the headline cells, one calibration seed. (e) vs (d) null is robust under conservative non-parametric intervals; a 3rd seed is in progress and would tighten bounds.</a:t>
-            </a:r>
-          </a:p>
-          <a:p>
-            <a:pPr>
-              <a:lnSpc>
-                <a:spcPct val="115000"/>
-              </a:lnSpc>
-              <a:spcAft>
-                <a:spcPts val="600"/>
-              </a:spcAft>
-            </a:pPr>
-            <a:r>
-              <a:rPr sz="1500" b="1">
-                <a:solidFill>
-                  <a:srgbClr val="1F4E90"/>
-                </a:solidFill>
-                <a:latin typeface="Calibri"/>
-              </a:rPr>
-              <a:t>•  </a:t>
-            </a:r>
-            <a:r>
-              <a:rPr sz="1500">
-                <a:solidFill>
-                  <a:srgbClr val="232A33"/>
-                </a:solidFill>
-                <a:latin typeface="Calibri"/>
-              </a:rPr>
-              <a:t>The mechanism is hypothesized, not proven. Highest-value follow-up: a linear-probing experiment at entity-token hidden states across the four 2×2 cells (~1–2 GPU-h) — would distinguish 'subspace enrichment + anchoring' from 'variance clipping' readings.</a:t>
-            </a:r>
-          </a:p>
-          <a:p>
-            <a:pPr>
-              <a:lnSpc>
-                <a:spcPct val="115000"/>
-              </a:lnSpc>
-              <a:spcAft>
-                <a:spcPts val="600"/>
-              </a:spcAft>
-            </a:pPr>
-            <a:r>
-              <a:rPr sz="1500" b="1">
-                <a:solidFill>
-                  <a:srgbClr val="1F4E90"/>
-                </a:solidFill>
-                <a:latin typeface="Calibri"/>
-              </a:rPr>
-              <a:t>•  </a:t>
-            </a:r>
-            <a:r>
-              <a:rPr sz="1500">
-                <a:solidFill>
-                  <a:srgbClr val="232A33"/>
-                </a:solidFill>
-                <a:latin typeface="Calibri"/>
-              </a:rPr>
-              <a:t>K only tested at 5 on the injection side. Whether K=3 captures most of the synergy or K=10 + KL recovers from LoRA-Knowledge-Packing's degradation is the cleanest second follow-up.</a:t>
-            </a:r>
-          </a:p>
-          <a:p>
-            <a:pPr>
-              <a:lnSpc>
-                <a:spcPct val="115000"/>
-              </a:lnSpc>
-              <a:spcAft>
-                <a:spcPts val="600"/>
-              </a:spcAft>
-            </a:pPr>
-            <a:r>
-              <a:rPr sz="1500" b="1">
-                <a:solidFill>
-                  <a:srgbClr val="1F4E90"/>
-                </a:solidFill>
-                <a:latin typeface="Calibri"/>
-              </a:rPr>
-              <a:t>•  </a:t>
-            </a:r>
-            <a:r>
-              <a:rPr sz="1500">
-                <a:solidFill>
-                  <a:srgbClr val="232A33"/>
-                </a:solidFill>
-                <a:latin typeface="Calibri"/>
-              </a:rPr>
-              <a:t>Compositional / ripple-effect gap unsolved by every method tested. Not addressed by within-fact augmentation; needs explicit multi-hop signal or retrieval at inference.</a:t>
-            </a:r>
-          </a:p>
-          <a:p>
-            <a:pPr>
-              <a:lnSpc>
-                <a:spcPct val="115000"/>
-              </a:lnSpc>
-              <a:spcAft>
-                <a:spcPts val="600"/>
-              </a:spcAft>
-            </a:pPr>
-            <a:r>
-              <a:rPr sz="1500" b="1">
-                <a:solidFill>
-                  <a:srgbClr val="1F4E90"/>
-                </a:solidFill>
-                <a:latin typeface="Calibri"/>
-              </a:rPr>
-              <a:t>•  </a:t>
-            </a:r>
-            <a:r>
-              <a:rPr sz="1500">
-                <a:solidFill>
-                  <a:srgbClr val="232A33"/>
-                </a:solidFill>
-                <a:latin typeface="Calibri"/>
-              </a:rPr>
-              <a:t>Setting matches industrial practice but transfer beyond LoRA is principled, not validated. The synergy direction should extend to full FT; the (e) vs (d) null specifically may not.</a:t>
+              <a:t>Code, configs, and raw artifacts:  github.com/jeremiahmao/still-on-task-llm</a:t>
             </a:r>
           </a:p>
         </p:txBody>
@@ -6481,240 +6260,7 @@
                 </a:solidFill>
                 <a:latin typeface="Calibri"/>
               </a:rPr>
-              <a:t>15 / 16</a:t>
-            </a:r>
-          </a:p>
-        </p:txBody>
-      </p:sp>
-    </p:spTree>
-  </p:cSld>
-  <p:clrMapOvr>
-    <a:masterClrMapping/>
-  </p:clrMapOvr>
-</p:sld>
-</file>
-
-<file path=ppt/slides/slide16.xml><?xml version="1.0" encoding="utf-8"?>
-<p:sld xmlns:a="http://schemas.openxmlformats.org/drawingml/2006/main" xmlns:p="http://schemas.openxmlformats.org/presentationml/2006/main" xmlns:r="http://schemas.openxmlformats.org/officeDocument/2006/relationships">
-  <p:cSld>
-    <p:spTree>
-      <p:nvGrpSpPr>
-        <p:cNvPr id="1" name=""/>
-        <p:cNvGrpSpPr/>
-        <p:nvPr/>
-      </p:nvGrpSpPr>
-      <p:grpSpPr/>
-      <p:sp>
-        <p:nvSpPr>
-          <p:cNvPr id="2" name="Rectangle 1"/>
-          <p:cNvSpPr/>
-          <p:nvPr/>
-        </p:nvSpPr>
-        <p:spPr>
-          <a:xfrm>
-            <a:off x="0" y="2377440"/>
-            <a:ext cx="12191695" cy="2103120"/>
-          </a:xfrm>
-          <a:prstGeom prst="rect">
-            <a:avLst/>
-          </a:prstGeom>
-          <a:solidFill>
-            <a:srgbClr val="0F2A57"/>
-          </a:solidFill>
-          <a:ln>
-            <a:noFill/>
-          </a:ln>
-          <a:effectLst/>
-        </p:spPr>
-        <p:style>
-          <a:lnRef idx="1">
-            <a:schemeClr val="accent1"/>
-          </a:lnRef>
-          <a:fillRef idx="3">
-            <a:schemeClr val="accent1"/>
-          </a:fillRef>
-          <a:effectRef idx="2">
-            <a:schemeClr val="accent1"/>
-          </a:effectRef>
-          <a:fontRef idx="minor">
-            <a:schemeClr val="lt1"/>
-          </a:fontRef>
-        </p:style>
-        <p:txBody>
-          <a:bodyPr rtlCol="0" anchor="ctr"/>
-          <a:lstStyle/>
-          <a:p>
-            <a:pPr algn="ctr"/>
-          </a:p>
-        </p:txBody>
-      </p:sp>
-      <p:sp>
-        <p:nvSpPr>
-          <p:cNvPr id="3" name="TextBox 2"/>
-          <p:cNvSpPr txBox="1"/>
-          <p:nvPr/>
-        </p:nvSpPr>
-        <p:spPr>
-          <a:xfrm>
-            <a:off x="548640" y="2606040"/>
-            <a:ext cx="11064240" cy="1828800"/>
-          </a:xfrm>
-          <a:prstGeom prst="rect">
-            <a:avLst/>
-          </a:prstGeom>
-          <a:noFill/>
-          <a:ln>
-            <a:noFill/>
-          </a:ln>
-        </p:spPr>
-        <p:txBody>
-          <a:bodyPr wrap="square" lIns="45720" rIns="45720" tIns="27432" bIns="27432">
-            <a:spAutoFit/>
-          </a:bodyPr>
-          <a:lstStyle/>
-          <a:p>
-            <a:pPr algn="ctr"/>
-            <a:r>
-              <a:rPr sz="5400" b="1">
-                <a:solidFill>
-                  <a:srgbClr val="FFFFFF"/>
-                </a:solidFill>
-                <a:latin typeface="Calibri"/>
-              </a:rPr>
-              <a:t>Thank you</a:t>
-            </a:r>
-          </a:p>
-          <a:p>
-            <a:pPr algn="ctr">
-              <a:spcBef>
-                <a:spcPts val="2000"/>
-              </a:spcBef>
-            </a:pPr>
-            <a:r>
-              <a:rPr sz="2200" i="1">
-                <a:solidFill>
-                  <a:srgbClr val="FFFFFF"/>
-                </a:solidFill>
-                <a:latin typeface="Calibri"/>
-              </a:rPr>
-              <a:t>Questions?</a:t>
-            </a:r>
-          </a:p>
-        </p:txBody>
-      </p:sp>
-      <p:sp>
-        <p:nvSpPr>
-          <p:cNvPr id="4" name="TextBox 3"/>
-          <p:cNvSpPr txBox="1"/>
-          <p:nvPr/>
-        </p:nvSpPr>
-        <p:spPr>
-          <a:xfrm>
-            <a:off x="548640" y="4937760"/>
-            <a:ext cx="11064240" cy="548640"/>
-          </a:xfrm>
-          <a:prstGeom prst="rect">
-            <a:avLst/>
-          </a:prstGeom>
-          <a:noFill/>
-          <a:ln>
-            <a:noFill/>
-          </a:ln>
-        </p:spPr>
-        <p:txBody>
-          <a:bodyPr wrap="square" lIns="45720" rIns="45720" tIns="27432" bIns="27432">
-            <a:spAutoFit/>
-          </a:bodyPr>
-          <a:lstStyle/>
-          <a:p>
-            <a:pPr algn="ctr"/>
-            <a:r>
-              <a:rPr sz="1600">
-                <a:solidFill>
-                  <a:srgbClr val="232A33"/>
-                </a:solidFill>
-                <a:latin typeface="Calibri"/>
-              </a:rPr>
-              <a:t>Code, configs, and raw artifacts:  github.com/jeremiahmao/still-on-task-llm</a:t>
-            </a:r>
-          </a:p>
-        </p:txBody>
-      </p:sp>
-      <p:sp>
-        <p:nvSpPr>
-          <p:cNvPr id="5" name="TextBox 4"/>
-          <p:cNvSpPr txBox="1"/>
-          <p:nvPr/>
-        </p:nvSpPr>
-        <p:spPr>
-          <a:xfrm>
-            <a:off x="365760" y="6446520"/>
-            <a:ext cx="11430000" cy="320040"/>
-          </a:xfrm>
-          <a:prstGeom prst="rect">
-            <a:avLst/>
-          </a:prstGeom>
-          <a:noFill/>
-          <a:ln>
-            <a:noFill/>
-          </a:ln>
-        </p:spPr>
-        <p:txBody>
-          <a:bodyPr wrap="square" lIns="45720" rIns="45720" tIns="27432" bIns="27432">
-            <a:spAutoFit/>
-          </a:bodyPr>
-          <a:lstStyle/>
-          <a:p>
-            <a:pPr algn="l"/>
-            <a:r>
-              <a:rPr sz="1000">
-                <a:solidFill>
-                  <a:srgbClr val="5C6670"/>
-                </a:solidFill>
-                <a:latin typeface="Calibri"/>
-              </a:rPr>
-              <a:t>COMS 6998   ·   Jeremiah Mao, Mateo Juliani</a:t>
-            </a:r>
-          </a:p>
-          <a:p>
-            <a:pPr algn="r"/>
-          </a:p>
-        </p:txBody>
-      </p:sp>
-      <p:sp>
-        <p:nvSpPr>
-          <p:cNvPr id="6" name="TextBox 5"/>
-          <p:cNvSpPr txBox="1"/>
-          <p:nvPr/>
-        </p:nvSpPr>
-        <p:spPr>
-          <a:xfrm>
-            <a:off x="10515600" y="6446520"/>
-            <a:ext cx="1280160" cy="320040"/>
-          </a:xfrm>
-          <a:prstGeom prst="rect">
-            <a:avLst/>
-          </a:prstGeom>
-          <a:noFill/>
-          <a:ln>
-            <a:noFill/>
-          </a:ln>
-        </p:spPr>
-        <p:txBody>
-          <a:bodyPr wrap="square" lIns="45720" rIns="45720" tIns="27432" bIns="27432">
-            <a:spAutoFit/>
-          </a:bodyPr>
-          <a:lstStyle/>
-          <a:p>
-            <a:pPr algn="r"/>
-            <a:r>
-              <a:rPr sz="1000">
-                <a:solidFill>
-                  <a:srgbClr val="5C6670"/>
-                </a:solidFill>
-                <a:latin typeface="Calibri"/>
-              </a:rPr>
-              <a:t>16 / 16</a:t>
+              <a:t>15 / 15</a:t>
             </a:r>
           </a:p>
         </p:txBody>
@@ -7059,7 +6605,7 @@
                 </a:solidFill>
                 <a:latin typeface="Calibri"/>
               </a:rPr>
-              <a:t>2 / 16</a:t>
+              <a:t>2 / 15</a:t>
             </a:r>
           </a:p>
         </p:txBody>
@@ -7605,7 +7151,7 @@
                 </a:solidFill>
                 <a:latin typeface="Calibri"/>
               </a:rPr>
-              <a:t>3 / 16</a:t>
+              <a:t>3 / 15</a:t>
             </a:r>
           </a:p>
         </p:txBody>
@@ -7950,7 +7496,7 @@
                 </a:solidFill>
                 <a:latin typeface="Calibri"/>
               </a:rPr>
-              <a:t>4 / 16</a:t>
+              <a:t>4 / 15</a:t>
             </a:r>
           </a:p>
         </p:txBody>
@@ -8295,7 +7841,7 @@
                 </a:solidFill>
                 <a:latin typeface="Calibri"/>
               </a:rPr>
-              <a:t>5 / 16</a:t>
+              <a:t>5 / 15</a:t>
             </a:r>
           </a:p>
         </p:txBody>
@@ -8556,7 +8102,7 @@
                 </a:solidFill>
                 <a:latin typeface="Calibri"/>
               </a:rPr>
-              <a:t>6 / 16</a:t>
+              <a:t>6 / 15</a:t>
             </a:r>
           </a:p>
         </p:txBody>
@@ -9396,7 +8942,7 @@
                 </a:solidFill>
                 <a:latin typeface="Calibri"/>
               </a:rPr>
-              <a:t>7 / 16</a:t>
+              <a:t>7 / 15</a:t>
             </a:r>
           </a:p>
         </p:txBody>
@@ -9410,622 +8956,6 @@
 </file>
 
 <file path=ppt/slides/slide8.xml><?xml version="1.0" encoding="utf-8"?>
-<p:sld xmlns:a="http://schemas.openxmlformats.org/drawingml/2006/main" xmlns:p="http://schemas.openxmlformats.org/presentationml/2006/main" xmlns:r="http://schemas.openxmlformats.org/officeDocument/2006/relationships">
-  <p:cSld>
-    <p:spTree>
-      <p:nvGrpSpPr>
-        <p:cNvPr id="1" name=""/>
-        <p:cNvGrpSpPr/>
-        <p:nvPr/>
-      </p:nvGrpSpPr>
-      <p:grpSpPr/>
-      <p:sp>
-        <p:nvSpPr>
-          <p:cNvPr id="2" name="Rectangle 1"/>
-          <p:cNvSpPr/>
-          <p:nvPr/>
-        </p:nvSpPr>
-        <p:spPr>
-          <a:xfrm>
-            <a:off x="0" y="0"/>
-            <a:ext cx="12191695" cy="777240"/>
-          </a:xfrm>
-          <a:prstGeom prst="rect">
-            <a:avLst/>
-          </a:prstGeom>
-          <a:solidFill>
-            <a:srgbClr val="0F2A57"/>
-          </a:solidFill>
-          <a:ln>
-            <a:noFill/>
-          </a:ln>
-          <a:effectLst/>
-        </p:spPr>
-        <p:style>
-          <a:lnRef idx="1">
-            <a:schemeClr val="accent1"/>
-          </a:lnRef>
-          <a:fillRef idx="3">
-            <a:schemeClr val="accent1"/>
-          </a:fillRef>
-          <a:effectRef idx="2">
-            <a:schemeClr val="accent1"/>
-          </a:effectRef>
-          <a:fontRef idx="minor">
-            <a:schemeClr val="lt1"/>
-          </a:fontRef>
-        </p:style>
-        <p:txBody>
-          <a:bodyPr rtlCol="0" anchor="ctr"/>
-          <a:lstStyle/>
-          <a:p>
-            <a:pPr algn="ctr"/>
-          </a:p>
-        </p:txBody>
-      </p:sp>
-      <p:sp>
-        <p:nvSpPr>
-          <p:cNvPr id="3" name="TextBox 2"/>
-          <p:cNvSpPr txBox="1"/>
-          <p:nvPr/>
-        </p:nvSpPr>
-        <p:spPr>
-          <a:xfrm>
-            <a:off x="365760" y="109728"/>
-            <a:ext cx="11430000" cy="594360"/>
-          </a:xfrm>
-          <a:prstGeom prst="rect">
-            <a:avLst/>
-          </a:prstGeom>
-          <a:noFill/>
-          <a:ln>
-            <a:noFill/>
-          </a:ln>
-        </p:spPr>
-        <p:txBody>
-          <a:bodyPr wrap="square" lIns="45720" rIns="45720" tIns="27432" bIns="27432">
-            <a:spAutoFit/>
-          </a:bodyPr>
-          <a:lstStyle/>
-          <a:p>
-            <a:pPr algn="l"/>
-            <a:r>
-              <a:rPr sz="2800" b="1">
-                <a:solidFill>
-                  <a:srgbClr val="FFFFFF"/>
-                </a:solidFill>
-                <a:latin typeface="Calibri"/>
-              </a:rPr>
-              <a:t>Concrete: how one fact is rendered for training</a:t>
-            </a:r>
-          </a:p>
-        </p:txBody>
-      </p:sp>
-      <p:sp>
-        <p:nvSpPr>
-          <p:cNvPr id="4" name="TextBox 3"/>
-          <p:cNvSpPr txBox="1"/>
-          <p:nvPr/>
-        </p:nvSpPr>
-        <p:spPr>
-          <a:xfrm>
-            <a:off x="548640" y="868680"/>
-            <a:ext cx="11064240" cy="502920"/>
-          </a:xfrm>
-          <a:prstGeom prst="rect">
-            <a:avLst/>
-          </a:prstGeom>
-          <a:noFill/>
-          <a:ln>
-            <a:noFill/>
-          </a:ln>
-        </p:spPr>
-        <p:txBody>
-          <a:bodyPr wrap="square" lIns="45720" rIns="45720" tIns="27432" bIns="27432">
-            <a:spAutoFit/>
-          </a:bodyPr>
-          <a:lstStyle/>
-          <a:p>
-            <a:r>
-              <a:rPr sz="1400" b="1">
-                <a:solidFill>
-                  <a:srgbClr val="1F4E90"/>
-                </a:solidFill>
-                <a:latin typeface="Calibri"/>
-              </a:rPr>
-              <a:t>Fact triple:  </a:t>
-            </a:r>
-            <a:r>
-              <a:rPr sz="1400">
-                <a:solidFill>
-                  <a:srgbClr val="232A33"/>
-                </a:solidFill>
-                <a:latin typeface="Consolas"/>
-              </a:rPr>
-              <a:t>(Acme Corp,  2025 revenue,  $4.2B)</a:t>
-            </a:r>
-            <a:r>
-              <a:rPr sz="1200" i="1">
-                <a:solidFill>
-                  <a:srgbClr val="5C6670"/>
-                </a:solidFill>
-                <a:latin typeface="Calibri"/>
-              </a:rPr>
-              <a:t>    — the SFT loss for this fact is the average over the rendered chat sequences below.</a:t>
-            </a:r>
-          </a:p>
-        </p:txBody>
-      </p:sp>
-      <p:sp>
-        <p:nvSpPr>
-          <p:cNvPr id="5" name="TextBox 4"/>
-          <p:cNvSpPr txBox="1"/>
-          <p:nvPr/>
-        </p:nvSpPr>
-        <p:spPr>
-          <a:xfrm>
-            <a:off x="457200" y="1508760"/>
-            <a:ext cx="5486400" cy="4663440"/>
-          </a:xfrm>
-          <a:prstGeom prst="rect">
-            <a:avLst/>
-          </a:prstGeom>
-          <a:solidFill>
-            <a:srgbClr val="F7F9FC"/>
-          </a:solidFill>
-          <a:ln w="12700">
-            <a:solidFill>
-              <a:srgbClr val="CFD8E3"/>
-            </a:solidFill>
-          </a:ln>
-        </p:spPr>
-        <p:txBody>
-          <a:bodyPr wrap="square" lIns="45720" rIns="45720" tIns="27432" bIns="27432">
-            <a:spAutoFit/>
-          </a:bodyPr>
-          <a:lstStyle/>
-          <a:p>
-            <a:r>
-              <a:rPr sz="2200" b="1">
-                <a:solidFill>
-                  <a:srgbClr val="0F2A57"/>
-                </a:solidFill>
-                <a:latin typeface="Calibri"/>
-              </a:rPr>
-              <a:t>K=1   </a:t>
-            </a:r>
-            <a:r>
-              <a:rPr sz="1300" i="1">
-                <a:solidFill>
-                  <a:srgbClr val="5C6670"/>
-                </a:solidFill>
-                <a:latin typeface="Calibri"/>
-              </a:rPr>
-              <a:t>conditions (a), (c)</a:t>
-            </a:r>
-          </a:p>
-          <a:p>
-            <a:pPr>
-              <a:spcBef>
-                <a:spcPts val="200"/>
-              </a:spcBef>
-            </a:pPr>
-            <a:r>
-              <a:rPr sz="1200" i="1">
-                <a:solidFill>
-                  <a:srgbClr val="5C6670"/>
-                </a:solidFill>
-                <a:latin typeface="Calibri"/>
-              </a:rPr>
-              <a:t>A single template (QA only):</a:t>
-            </a:r>
-          </a:p>
-          <a:p>
-            <a:pPr>
-              <a:spcBef>
-                <a:spcPts val="800"/>
-              </a:spcBef>
-            </a:pPr>
-            <a:r>
-              <a:rPr sz="1400" b="1">
-                <a:solidFill>
-                  <a:srgbClr val="1F4E90"/>
-                </a:solidFill>
-                <a:latin typeface="Calibri"/>
-              </a:rPr>
-              <a:t>QA</a:t>
-            </a:r>
-          </a:p>
-          <a:p>
-            <a:r>
-              <a:rPr sz="1000">
-                <a:solidFill>
-                  <a:srgbClr val="5C6670"/>
-                </a:solidFill>
-                <a:latin typeface="Consolas"/>
-              </a:rPr>
-              <a:t>[user]      </a:t>
-            </a:r>
-            <a:r>
-              <a:rPr sz="1100">
-                <a:solidFill>
-                  <a:srgbClr val="232A33"/>
-                </a:solidFill>
-                <a:latin typeface="Consolas"/>
-              </a:rPr>
-              <a:t>What is Acme Corp's 2025 revenue?</a:t>
-            </a:r>
-          </a:p>
-          <a:p>
-            <a:r>
-              <a:rPr sz="1000">
-                <a:solidFill>
-                  <a:srgbClr val="5C6670"/>
-                </a:solidFill>
-                <a:latin typeface="Consolas"/>
-              </a:rPr>
-              <a:t>[assistant] </a:t>
-            </a:r>
-            <a:r>
-              <a:rPr sz="1100" b="1">
-                <a:solidFill>
-                  <a:srgbClr val="232A33"/>
-                </a:solidFill>
-                <a:latin typeface="Consolas"/>
-              </a:rPr>
-              <a:t>$4.2B</a:t>
-            </a:r>
-          </a:p>
-          <a:p>
-            <a:pPr>
-              <a:spcBef>
-                <a:spcPts val="2000"/>
-              </a:spcBef>
-            </a:pPr>
-            <a:r>
-              <a:rPr sz="1300" i="1">
-                <a:solidFill>
-                  <a:srgbClr val="232A33"/>
-                </a:solidFill>
-                <a:latin typeface="Consolas"/>
-              </a:rPr>
-              <a:t>L_SFT^{K=1}  =  −log π_θ(F_QA(x, y))</a:t>
-            </a:r>
-          </a:p>
-        </p:txBody>
-      </p:sp>
-      <p:sp>
-        <p:nvSpPr>
-          <p:cNvPr id="6" name="TextBox 5"/>
-          <p:cNvSpPr txBox="1"/>
-          <p:nvPr/>
-        </p:nvSpPr>
-        <p:spPr>
-          <a:xfrm>
-            <a:off x="6263640" y="1508760"/>
-            <a:ext cx="5486400" cy="4663440"/>
-          </a:xfrm>
-          <a:prstGeom prst="rect">
-            <a:avLst/>
-          </a:prstGeom>
-          <a:solidFill>
-            <a:srgbClr val="E8F2E8"/>
-          </a:solidFill>
-          <a:ln w="12700">
-            <a:solidFill>
-              <a:srgbClr val="9DC4A1"/>
-            </a:solidFill>
-          </a:ln>
-        </p:spPr>
-        <p:txBody>
-          <a:bodyPr wrap="square" lIns="45720" rIns="45720" tIns="27432" bIns="27432">
-            <a:spAutoFit/>
-          </a:bodyPr>
-          <a:lstStyle/>
-          <a:p>
-            <a:r>
-              <a:rPr sz="2200" b="1">
-                <a:solidFill>
-                  <a:srgbClr val="1F8E4F"/>
-                </a:solidFill>
-                <a:latin typeface="Calibri"/>
-              </a:rPr>
-              <a:t>K=5   </a:t>
-            </a:r>
-            <a:r>
-              <a:rPr sz="1300" i="1">
-                <a:solidFill>
-                  <a:srgbClr val="5C6670"/>
-                </a:solidFill>
-                <a:latin typeface="Calibri"/>
-              </a:rPr>
-              <a:t>conditions (b), (d), (e)</a:t>
-            </a:r>
-          </a:p>
-          <a:p>
-            <a:pPr>
-              <a:spcBef>
-                <a:spcPts val="200"/>
-              </a:spcBef>
-            </a:pPr>
-            <a:r>
-              <a:rPr sz="1200" i="1">
-                <a:solidFill>
-                  <a:srgbClr val="5C6670"/>
-                </a:solidFill>
-                <a:latin typeface="Calibri"/>
-              </a:rPr>
-              <a:t>Same fact, five templates — the SFT loss averages over all five:</a:t>
-            </a:r>
-          </a:p>
-          <a:p>
-            <a:pPr>
-              <a:spcBef>
-                <a:spcPts val="400"/>
-              </a:spcBef>
-            </a:pPr>
-            <a:r>
-              <a:rPr sz="1100" b="1">
-                <a:solidFill>
-                  <a:srgbClr val="1F8E4F"/>
-                </a:solidFill>
-                <a:latin typeface="Calibri"/>
-              </a:rPr>
-              <a:t>  1. QA  </a:t>
-            </a:r>
-            <a:r>
-              <a:rPr sz="900">
-                <a:solidFill>
-                  <a:srgbClr val="232A33"/>
-                </a:solidFill>
-                <a:latin typeface="Consolas"/>
-              </a:rPr>
-              <a:t>[user] What is Acme Corp's 2025 revenue?  →  [asst] $4.2B</a:t>
-            </a:r>
-          </a:p>
-          <a:p>
-            <a:pPr>
-              <a:spcBef>
-                <a:spcPts val="400"/>
-              </a:spcBef>
-            </a:pPr>
-            <a:r>
-              <a:rPr sz="1100" b="1">
-                <a:solidFill>
-                  <a:srgbClr val="1F8E4F"/>
-                </a:solidFill>
-                <a:latin typeface="Calibri"/>
-              </a:rPr>
-              <a:t>  2. QD  </a:t>
-            </a:r>
-            <a:r>
-              <a:rPr sz="900">
-                <a:solidFill>
-                  <a:srgbClr val="232A33"/>
-                </a:solidFill>
-                <a:latin typeface="Consolas"/>
-              </a:rPr>
-              <a:t>[system: QD-decomposer]  [user] What should I know about Acme Corp's recent activity?  →  [asst] Sub-query 1: What is Acme Corp's 2025 revenue? ...</a:t>
-            </a:r>
-          </a:p>
-          <a:p>
-            <a:pPr>
-              <a:spcBef>
-                <a:spcPts val="400"/>
-              </a:spcBef>
-            </a:pPr>
-            <a:r>
-              <a:rPr sz="1100" b="1">
-                <a:solidFill>
-                  <a:srgbClr val="1F8E4F"/>
-                </a:solidFill>
-                <a:latin typeface="Calibri"/>
-              </a:rPr>
-              <a:t>  3. Declarative  </a:t>
-            </a:r>
-            <a:r>
-              <a:rPr sz="900">
-                <a:solidFill>
-                  <a:srgbClr val="232A33"/>
-                </a:solidFill>
-                <a:latin typeface="Consolas"/>
-              </a:rPr>
-              <a:t>[user] Summarize this fact: Acme Corp, 2025 revenue.  →  [asst] Acme Corp's 2025 revenue is $4.2B.</a:t>
-            </a:r>
-          </a:p>
-          <a:p>
-            <a:pPr>
-              <a:spcBef>
-                <a:spcPts val="400"/>
-              </a:spcBef>
-            </a:pPr>
-            <a:r>
-              <a:rPr sz="1100" b="1">
-                <a:solidFill>
-                  <a:srgbClr val="1F8E4F"/>
-                </a:solidFill>
-                <a:latin typeface="Calibri"/>
-              </a:rPr>
-              <a:t>  4. Instruction  </a:t>
-            </a:r>
-            <a:r>
-              <a:rPr sz="900">
-                <a:solidFill>
-                  <a:srgbClr val="232A33"/>
-                </a:solidFill>
-                <a:latin typeface="Consolas"/>
-              </a:rPr>
-              <a:t>[user] Financial analyst: what is Acme Corp's 2025 revenue?  →  [asst] $4.2B</a:t>
-            </a:r>
-          </a:p>
-          <a:p>
-            <a:pPr>
-              <a:spcBef>
-                <a:spcPts val="400"/>
-              </a:spcBef>
-            </a:pPr>
-            <a:r>
-              <a:rPr sz="1100" b="1">
-                <a:solidFill>
-                  <a:srgbClr val="1F8E4F"/>
-                </a:solidFill>
-                <a:latin typeface="Calibri"/>
-              </a:rPr>
-              <a:t>  5. Narrative  </a:t>
-            </a:r>
-            <a:r>
-              <a:rPr sz="900">
-                <a:solidFill>
-                  <a:srgbClr val="232A33"/>
-                </a:solidFill>
-                <a:latin typeface="Consolas"/>
-              </a:rPr>
-              <a:t>[user] Write a snippet about Acme Corp.  →  [asst] In recent developments, Acme Corp announced that its 2025 revenue is $4.2B.</a:t>
-            </a:r>
-          </a:p>
-          <a:p>
-            <a:pPr>
-              <a:spcBef>
-                <a:spcPts val="800"/>
-              </a:spcBef>
-            </a:pPr>
-            <a:r>
-              <a:rPr sz="1300" i="1">
-                <a:solidFill>
-                  <a:srgbClr val="232A33"/>
-                </a:solidFill>
-                <a:latin typeface="Consolas"/>
-              </a:rPr>
-              <a:t>L_SFT^{K=5}  =  (1/5) · Σ_k  −log π_θ(F_k(x, y))</a:t>
-            </a:r>
-          </a:p>
-        </p:txBody>
-      </p:sp>
-      <p:sp>
-        <p:nvSpPr>
-          <p:cNvPr id="7" name="TextBox 6"/>
-          <p:cNvSpPr txBox="1"/>
-          <p:nvPr/>
-        </p:nvSpPr>
-        <p:spPr>
-          <a:xfrm>
-            <a:off x="548640" y="6263640"/>
-            <a:ext cx="11064240" cy="365760"/>
-          </a:xfrm>
-          <a:prstGeom prst="rect">
-            <a:avLst/>
-          </a:prstGeom>
-          <a:noFill/>
-          <a:ln>
-            <a:noFill/>
-          </a:ln>
-        </p:spPr>
-        <p:txBody>
-          <a:bodyPr wrap="square" lIns="45720" rIns="45720" tIns="27432" bIns="27432">
-            <a:spAutoFit/>
-          </a:bodyPr>
-          <a:lstStyle/>
-          <a:p>
-            <a:r>
-              <a:rPr sz="1100" i="1">
-                <a:solidFill>
-                  <a:srgbClr val="5C6670"/>
-                </a:solidFill>
-                <a:latin typeface="Calibri"/>
-              </a:rPr>
-              <a:t>The QD rendering is leak-free — the gold answer never appears in any user or system prompt, only in the assistant target chain.</a:t>
-            </a:r>
-          </a:p>
-        </p:txBody>
-      </p:sp>
-      <p:sp>
-        <p:nvSpPr>
-          <p:cNvPr id="8" name="TextBox 7"/>
-          <p:cNvSpPr txBox="1"/>
-          <p:nvPr/>
-        </p:nvSpPr>
-        <p:spPr>
-          <a:xfrm>
-            <a:off x="365760" y="6446520"/>
-            <a:ext cx="11430000" cy="320040"/>
-          </a:xfrm>
-          <a:prstGeom prst="rect">
-            <a:avLst/>
-          </a:prstGeom>
-          <a:noFill/>
-          <a:ln>
-            <a:noFill/>
-          </a:ln>
-        </p:spPr>
-        <p:txBody>
-          <a:bodyPr wrap="square" lIns="45720" rIns="45720" tIns="27432" bIns="27432">
-            <a:spAutoFit/>
-          </a:bodyPr>
-          <a:lstStyle/>
-          <a:p>
-            <a:pPr algn="l"/>
-            <a:r>
-              <a:rPr sz="1000">
-                <a:solidFill>
-                  <a:srgbClr val="5C6670"/>
-                </a:solidFill>
-                <a:latin typeface="Calibri"/>
-              </a:rPr>
-              <a:t>COMS 6998   ·   Jeremiah Mao, Mateo Juliani</a:t>
-            </a:r>
-          </a:p>
-          <a:p>
-            <a:pPr algn="r"/>
-          </a:p>
-        </p:txBody>
-      </p:sp>
-      <p:sp>
-        <p:nvSpPr>
-          <p:cNvPr id="9" name="TextBox 8"/>
-          <p:cNvSpPr txBox="1"/>
-          <p:nvPr/>
-        </p:nvSpPr>
-        <p:spPr>
-          <a:xfrm>
-            <a:off x="10515600" y="6446520"/>
-            <a:ext cx="1280160" cy="320040"/>
-          </a:xfrm>
-          <a:prstGeom prst="rect">
-            <a:avLst/>
-          </a:prstGeom>
-          <a:noFill/>
-          <a:ln>
-            <a:noFill/>
-          </a:ln>
-        </p:spPr>
-        <p:txBody>
-          <a:bodyPr wrap="square" lIns="45720" rIns="45720" tIns="27432" bIns="27432">
-            <a:spAutoFit/>
-          </a:bodyPr>
-          <a:lstStyle/>
-          <a:p>
-            <a:pPr algn="r"/>
-            <a:r>
-              <a:rPr sz="1000">
-                <a:solidFill>
-                  <a:srgbClr val="5C6670"/>
-                </a:solidFill>
-                <a:latin typeface="Calibri"/>
-              </a:rPr>
-              <a:t>8 / 16</a:t>
-            </a:r>
-          </a:p>
-        </p:txBody>
-      </p:sp>
-    </p:spTree>
-  </p:cSld>
-  <p:clrMapOvr>
-    <a:masterClrMapping/>
-  </p:clrMapOvr>
-</p:sld>
-</file>
-
-<file path=ppt/slides/slide9.xml><?xml version="1.0" encoding="utf-8"?>
 <p:sld xmlns:a="http://schemas.openxmlformats.org/drawingml/2006/main" xmlns:p="http://schemas.openxmlformats.org/presentationml/2006/main" xmlns:r="http://schemas.openxmlformats.org/officeDocument/2006/relationships">
   <p:cSld>
     <p:spTree>
@@ -10895,7 +9825,608 @@
                 </a:solidFill>
                 <a:latin typeface="Calibri"/>
               </a:rPr>
-              <a:t>9 / 16</a:t>
+              <a:t>8 / 15</a:t>
+            </a:r>
+          </a:p>
+        </p:txBody>
+      </p:sp>
+    </p:spTree>
+  </p:cSld>
+  <p:clrMapOvr>
+    <a:masterClrMapping/>
+  </p:clrMapOvr>
+</p:sld>
+</file>
+
+<file path=ppt/slides/slide9.xml><?xml version="1.0" encoding="utf-8"?>
+<p:sld xmlns:a="http://schemas.openxmlformats.org/drawingml/2006/main" xmlns:p="http://schemas.openxmlformats.org/presentationml/2006/main" xmlns:r="http://schemas.openxmlformats.org/officeDocument/2006/relationships">
+  <p:cSld>
+    <p:spTree>
+      <p:nvGrpSpPr>
+        <p:cNvPr id="1" name=""/>
+        <p:cNvGrpSpPr/>
+        <p:nvPr/>
+      </p:nvGrpSpPr>
+      <p:grpSpPr/>
+      <p:sp>
+        <p:nvSpPr>
+          <p:cNvPr id="2" name="Rectangle 1"/>
+          <p:cNvSpPr/>
+          <p:nvPr/>
+        </p:nvSpPr>
+        <p:spPr>
+          <a:xfrm>
+            <a:off x="0" y="0"/>
+            <a:ext cx="12191695" cy="777240"/>
+          </a:xfrm>
+          <a:prstGeom prst="rect">
+            <a:avLst/>
+          </a:prstGeom>
+          <a:solidFill>
+            <a:srgbClr val="0F2A57"/>
+          </a:solidFill>
+          <a:ln>
+            <a:noFill/>
+          </a:ln>
+          <a:effectLst/>
+        </p:spPr>
+        <p:style>
+          <a:lnRef idx="1">
+            <a:schemeClr val="accent1"/>
+          </a:lnRef>
+          <a:fillRef idx="3">
+            <a:schemeClr val="accent1"/>
+          </a:fillRef>
+          <a:effectRef idx="2">
+            <a:schemeClr val="accent1"/>
+          </a:effectRef>
+          <a:fontRef idx="minor">
+            <a:schemeClr val="lt1"/>
+          </a:fontRef>
+        </p:style>
+        <p:txBody>
+          <a:bodyPr rtlCol="0" anchor="ctr"/>
+          <a:lstStyle/>
+          <a:p>
+            <a:pPr algn="ctr"/>
+          </a:p>
+        </p:txBody>
+      </p:sp>
+      <p:sp>
+        <p:nvSpPr>
+          <p:cNvPr id="3" name="TextBox 2"/>
+          <p:cNvSpPr txBox="1"/>
+          <p:nvPr/>
+        </p:nvSpPr>
+        <p:spPr>
+          <a:xfrm>
+            <a:off x="365760" y="109728"/>
+            <a:ext cx="11430000" cy="594360"/>
+          </a:xfrm>
+          <a:prstGeom prst="rect">
+            <a:avLst/>
+          </a:prstGeom>
+          <a:noFill/>
+          <a:ln>
+            <a:noFill/>
+          </a:ln>
+        </p:spPr>
+        <p:txBody>
+          <a:bodyPr wrap="square" lIns="45720" rIns="45720" tIns="27432" bIns="27432">
+            <a:spAutoFit/>
+          </a:bodyPr>
+          <a:lstStyle/>
+          <a:p>
+            <a:pPr algn="l"/>
+            <a:r>
+              <a:rPr sz="2800" b="1">
+                <a:solidFill>
+                  <a:srgbClr val="FFFFFF"/>
+                </a:solidFill>
+                <a:latin typeface="Calibri"/>
+              </a:rPr>
+              <a:t>Ruling out the 'just more data' explanation</a:t>
+            </a:r>
+          </a:p>
+        </p:txBody>
+      </p:sp>
+      <p:sp>
+        <p:nvSpPr>
+          <p:cNvPr id="4" name="TextBox 3"/>
+          <p:cNvSpPr txBox="1"/>
+          <p:nvPr/>
+        </p:nvSpPr>
+        <p:spPr>
+          <a:xfrm>
+            <a:off x="548640" y="914400"/>
+            <a:ext cx="11064240" cy="1005840"/>
+          </a:xfrm>
+          <a:prstGeom prst="rect">
+            <a:avLst/>
+          </a:prstGeom>
+          <a:noFill/>
+          <a:ln>
+            <a:noFill/>
+          </a:ln>
+        </p:spPr>
+        <p:txBody>
+          <a:bodyPr wrap="square" lIns="45720" rIns="45720" tIns="27432" bIns="27432">
+            <a:spAutoFit/>
+          </a:bodyPr>
+          <a:lstStyle/>
+          <a:p>
+            <a:r>
+              <a:rPr sz="1600">
+                <a:solidFill>
+                  <a:srgbClr val="232A33"/>
+                </a:solidFill>
+                <a:latin typeface="Calibri"/>
+              </a:rPr>
+              <a:t>To rule out 'data dominates,' hold data volume fixed and toggle KL preservation. </a:t>
+            </a:r>
+            <a:r>
+              <a:rPr sz="1600" i="1">
+                <a:solidFill>
+                  <a:srgbClr val="232A33"/>
+                </a:solidFill>
+                <a:latin typeface="Calibri"/>
+              </a:rPr>
+              <a:t>If KL contributed a fixed lift independent of data volume, both rows below would show similar Δ abs F1.</a:t>
+            </a:r>
+          </a:p>
+        </p:txBody>
+      </p:sp>
+      <p:graphicFrame>
+        <p:nvGraphicFramePr>
+          <p:cNvPr id="5" name="Table 4"/>
+          <p:cNvGraphicFramePr>
+            <a:graphicFrameLocks noGrp="1"/>
+          </p:cNvGraphicFramePr>
+          <p:nvPr/>
+        </p:nvGraphicFramePr>
+        <p:xfrm>
+          <a:off x="548640" y="2286000"/>
+          <a:ext cx="11064240" cy="2057400"/>
+        </p:xfrm>
+        <a:graphic>
+          <a:graphicData uri="http://schemas.openxmlformats.org/drawingml/2006/table">
+            <a:tbl>
+              <a:tblPr firstRow="1" bandRow="1">
+                <a:tableStyleId>{5C22544A-7EE6-4342-B048-85BDC9FD1C3A}</a:tableStyleId>
+              </a:tblPr>
+              <a:tblGrid>
+                <a:gridCol w="3657600"/>
+                <a:gridCol w="2377440"/>
+                <a:gridCol w="2377440"/>
+                <a:gridCol w="2651760"/>
+              </a:tblGrid>
+              <a:tr h="502920">
+                <a:tc>
+                  <a:txBody>
+                    <a:bodyPr wrap="square"/>
+                    <a:lstStyle/>
+                    <a:p>
+                      <a:pPr algn="l"/>
+                      <a:r>
+                        <a:rPr sz="1400" b="1" i="0">
+                          <a:solidFill>
+                            <a:srgbClr val="FFFFFF"/>
+                          </a:solidFill>
+                          <a:latin typeface="Calibri"/>
+                        </a:rPr>
+                        <a:t>Contrast (compute-matched)</a:t>
+                      </a:r>
+                    </a:p>
+                  </a:txBody>
+                  <a:tcPr marL="54864" marR="54864" marT="36576" marB="36576" anchor="ctr">
+                    <a:solidFill>
+                      <a:srgbClr val="0F2A57"/>
+                    </a:solidFill>
+                  </a:tcPr>
+                </a:tc>
+                <a:tc>
+                  <a:txBody>
+                    <a:bodyPr wrap="square"/>
+                    <a:lstStyle/>
+                    <a:p>
+                      <a:pPr algn="l"/>
+                      <a:r>
+                        <a:rPr sz="1400" b="1" i="0">
+                          <a:solidFill>
+                            <a:srgbClr val="FFFFFF"/>
+                          </a:solidFill>
+                          <a:latin typeface="Calibri"/>
+                        </a:rPr>
+                        <a:t>Data volume held at</a:t>
+                      </a:r>
+                    </a:p>
+                  </a:txBody>
+                  <a:tcPr marL="54864" marR="54864" marT="36576" marB="36576" anchor="ctr">
+                    <a:solidFill>
+                      <a:srgbClr val="0F2A57"/>
+                    </a:solidFill>
+                  </a:tcPr>
+                </a:tc>
+                <a:tc>
+                  <a:txBody>
+                    <a:bodyPr wrap="square"/>
+                    <a:lstStyle/>
+                    <a:p>
+                      <a:pPr algn="l"/>
+                      <a:r>
+                        <a:rPr sz="1400" b="1" i="0">
+                          <a:solidFill>
+                            <a:srgbClr val="FFFFFF"/>
+                          </a:solidFill>
+                          <a:latin typeface="Calibri"/>
+                        </a:rPr>
+                        <a:t>Δ abs F1</a:t>
+                      </a:r>
+                    </a:p>
+                  </a:txBody>
+                  <a:tcPr marL="54864" marR="54864" marT="36576" marB="36576" anchor="ctr">
+                    <a:solidFill>
+                      <a:srgbClr val="0F2A57"/>
+                    </a:solidFill>
+                  </a:tcPr>
+                </a:tc>
+                <a:tc>
+                  <a:txBody>
+                    <a:bodyPr wrap="square"/>
+                    <a:lstStyle/>
+                    <a:p>
+                      <a:pPr algn="l"/>
+                      <a:r>
+                        <a:rPr sz="1400" b="1" i="0">
+                          <a:solidFill>
+                            <a:srgbClr val="FFFFFF"/>
+                          </a:solidFill>
+                          <a:latin typeface="Calibri"/>
+                        </a:rPr>
+                        <a:t>Effect of adding KL</a:t>
+                      </a:r>
+                    </a:p>
+                  </a:txBody>
+                  <a:tcPr marL="54864" marR="54864" marT="36576" marB="36576" anchor="ctr">
+                    <a:solidFill>
+                      <a:srgbClr val="0F2A57"/>
+                    </a:solidFill>
+                  </a:tcPr>
+                </a:tc>
+              </a:tr>
+              <a:tr h="777240">
+                <a:tc>
+                  <a:txBody>
+                    <a:bodyPr wrap="square"/>
+                    <a:lstStyle/>
+                    <a:p>
+                      <a:pPr algn="l"/>
+                      <a:r>
+                        <a:rPr sz="1500" b="0" i="0">
+                          <a:solidFill>
+                            <a:srgbClr val="232A33"/>
+                          </a:solidFill>
+                          <a:latin typeface="Calibri"/>
+                        </a:rPr>
+                        <a:t>(c) − (a):  KL added on top of K=1 data</a:t>
+                      </a:r>
+                    </a:p>
+                  </a:txBody>
+                  <a:tcPr marL="54864" marR="54864" marT="36576" marB="36576" anchor="ctr">
+                    <a:solidFill>
+                      <a:srgbClr val="F7F9FC"/>
+                    </a:solidFill>
+                  </a:tcPr>
+                </a:tc>
+                <a:tc>
+                  <a:txBody>
+                    <a:bodyPr wrap="square"/>
+                    <a:lstStyle/>
+                    <a:p>
+                      <a:pPr algn="ctr"/>
+                      <a:r>
+                        <a:rPr sz="1500" b="0" i="0">
+                          <a:solidFill>
+                            <a:srgbClr val="232A33"/>
+                          </a:solidFill>
+                          <a:latin typeface="Calibri"/>
+                        </a:rPr>
+                        <a:t>K=1 (200 entries / round)</a:t>
+                      </a:r>
+                    </a:p>
+                  </a:txBody>
+                  <a:tcPr marL="54864" marR="54864" marT="36576" marB="36576" anchor="ctr">
+                    <a:solidFill>
+                      <a:srgbClr val="F7F9FC"/>
+                    </a:solidFill>
+                  </a:tcPr>
+                </a:tc>
+                <a:tc>
+                  <a:txBody>
+                    <a:bodyPr wrap="square"/>
+                    <a:lstStyle/>
+                    <a:p>
+                      <a:pPr algn="ctr"/>
+                      <a:r>
+                        <a:rPr sz="1800" b="1" i="0">
+                          <a:solidFill>
+                            <a:srgbClr val="1F4E90"/>
+                          </a:solidFill>
+                          <a:latin typeface="Calibri"/>
+                        </a:rPr>
+                        <a:t>+0.029</a:t>
+                      </a:r>
+                    </a:p>
+                  </a:txBody>
+                  <a:tcPr marL="54864" marR="54864" marT="36576" marB="36576" anchor="ctr">
+                    <a:solidFill>
+                      <a:srgbClr val="F7F9FC"/>
+                    </a:solidFill>
+                  </a:tcPr>
+                </a:tc>
+                <a:tc>
+                  <a:txBody>
+                    <a:bodyPr wrap="square"/>
+                    <a:lstStyle/>
+                    <a:p>
+                      <a:pPr algn="l"/>
+                      <a:r>
+                        <a:rPr sz="1400" b="0" i="1">
+                          <a:solidFill>
+                            <a:srgbClr val="5C6670"/>
+                          </a:solidFill>
+                          <a:latin typeface="Calibri"/>
+                        </a:rPr>
+                        <a:t>small lift</a:t>
+                      </a:r>
+                    </a:p>
+                  </a:txBody>
+                  <a:tcPr marL="54864" marR="54864" marT="36576" marB="36576" anchor="ctr">
+                    <a:solidFill>
+                      <a:srgbClr val="F7F9FC"/>
+                    </a:solidFill>
+                  </a:tcPr>
+                </a:tc>
+              </a:tr>
+              <a:tr h="777240">
+                <a:tc>
+                  <a:txBody>
+                    <a:bodyPr wrap="square"/>
+                    <a:lstStyle/>
+                    <a:p>
+                      <a:pPr algn="l"/>
+                      <a:r>
+                        <a:rPr sz="1500" b="1" i="0">
+                          <a:solidFill>
+                            <a:srgbClr val="232A33"/>
+                          </a:solidFill>
+                          <a:latin typeface="Calibri"/>
+                        </a:rPr>
+                        <a:t>(d) − (b):  KL added on top of K=5 data</a:t>
+                      </a:r>
+                    </a:p>
+                  </a:txBody>
+                  <a:tcPr marL="54864" marR="54864" marT="36576" marB="36576" anchor="ctr">
+                    <a:solidFill>
+                      <a:srgbClr val="E8F2E8"/>
+                    </a:solidFill>
+                  </a:tcPr>
+                </a:tc>
+                <a:tc>
+                  <a:txBody>
+                    <a:bodyPr wrap="square"/>
+                    <a:lstStyle/>
+                    <a:p>
+                      <a:pPr algn="ctr"/>
+                      <a:r>
+                        <a:rPr sz="1500" b="0" i="0">
+                          <a:solidFill>
+                            <a:srgbClr val="232A33"/>
+                          </a:solidFill>
+                          <a:latin typeface="Calibri"/>
+                        </a:rPr>
+                        <a:t>K=5 (1000 entries / round)</a:t>
+                      </a:r>
+                    </a:p>
+                  </a:txBody>
+                  <a:tcPr marL="54864" marR="54864" marT="36576" marB="36576" anchor="ctr">
+                    <a:solidFill>
+                      <a:srgbClr val="E8F2E8"/>
+                    </a:solidFill>
+                  </a:tcPr>
+                </a:tc>
+                <a:tc>
+                  <a:txBody>
+                    <a:bodyPr wrap="square"/>
+                    <a:lstStyle/>
+                    <a:p>
+                      <a:pPr algn="ctr"/>
+                      <a:r>
+                        <a:rPr sz="2200" b="1" i="0">
+                          <a:solidFill>
+                            <a:srgbClr val="1F8E4F"/>
+                          </a:solidFill>
+                          <a:latin typeface="Calibri"/>
+                        </a:rPr>
+                        <a:t>+0.286</a:t>
+                      </a:r>
+                    </a:p>
+                  </a:txBody>
+                  <a:tcPr marL="54864" marR="54864" marT="36576" marB="36576" anchor="ctr">
+                    <a:solidFill>
+                      <a:srgbClr val="E8F2E8"/>
+                    </a:solidFill>
+                  </a:tcPr>
+                </a:tc>
+                <a:tc>
+                  <a:txBody>
+                    <a:bodyPr wrap="square"/>
+                    <a:lstStyle/>
+                    <a:p>
+                      <a:pPr algn="l"/>
+                      <a:r>
+                        <a:rPr sz="1400" b="1" i="0">
+                          <a:solidFill>
+                            <a:srgbClr val="1F8E4F"/>
+                          </a:solidFill>
+                          <a:latin typeface="Calibri"/>
+                        </a:rPr>
+                        <a:t>≈10× larger</a:t>
+                      </a:r>
+                    </a:p>
+                  </a:txBody>
+                  <a:tcPr marL="54864" marR="54864" marT="36576" marB="36576" anchor="ctr">
+                    <a:solidFill>
+                      <a:srgbClr val="E8F2E8"/>
+                    </a:solidFill>
+                  </a:tcPr>
+                </a:tc>
+              </a:tr>
+            </a:tbl>
+          </a:graphicData>
+        </a:graphic>
+      </p:graphicFrame>
+      <p:sp>
+        <p:nvSpPr>
+          <p:cNvPr id="6" name="TextBox 5"/>
+          <p:cNvSpPr txBox="1"/>
+          <p:nvPr/>
+        </p:nvSpPr>
+        <p:spPr>
+          <a:xfrm>
+            <a:off x="548640" y="4572000"/>
+            <a:ext cx="11064240" cy="1280160"/>
+          </a:xfrm>
+          <a:prstGeom prst="rect">
+            <a:avLst/>
+          </a:prstGeom>
+          <a:solidFill>
+            <a:srgbClr val="FDF7EF"/>
+          </a:solidFill>
+          <a:ln w="12700">
+            <a:solidFill>
+              <a:srgbClr val="E8C89C"/>
+            </a:solidFill>
+          </a:ln>
+        </p:spPr>
+        <p:txBody>
+          <a:bodyPr wrap="square" lIns="45720" rIns="45720" tIns="27432" bIns="27432">
+            <a:spAutoFit/>
+          </a:bodyPr>
+          <a:lstStyle/>
+          <a:p>
+            <a:r>
+              <a:rPr sz="1800" b="1">
+                <a:solidFill>
+                  <a:srgbClr val="C0392B"/>
+                </a:solidFill>
+                <a:latin typeface="Calibri"/>
+              </a:rPr>
+              <a:t>Conclusion:  </a:t>
+            </a:r>
+            <a:r>
+              <a:rPr sz="1800">
+                <a:solidFill>
+                  <a:srgbClr val="232A33"/>
+                </a:solidFill>
+                <a:latin typeface="Calibri"/>
+              </a:rPr>
+              <a:t>KL is ~10× more effective when paired with K=5 data than added on top of K=1 data alone.</a:t>
+            </a:r>
+          </a:p>
+          <a:p>
+            <a:pPr>
+              <a:spcBef>
+                <a:spcPts val="600"/>
+              </a:spcBef>
+            </a:pPr>
+            <a:r>
+              <a:rPr sz="1400" i="1">
+                <a:solidFill>
+                  <a:srgbClr val="232A33"/>
+                </a:solidFill>
+                <a:latin typeface="Calibri"/>
+              </a:rPr>
+              <a:t>This is the signature of an interaction effect, not a data-volume effect.  More data alone gives +0.036 (b) − (a); more data plus KL gives +0.322.</a:t>
+            </a:r>
+          </a:p>
+        </p:txBody>
+      </p:sp>
+      <p:sp>
+        <p:nvSpPr>
+          <p:cNvPr id="7" name="TextBox 6"/>
+          <p:cNvSpPr txBox="1"/>
+          <p:nvPr/>
+        </p:nvSpPr>
+        <p:spPr>
+          <a:xfrm>
+            <a:off x="365760" y="6446520"/>
+            <a:ext cx="11430000" cy="320040"/>
+          </a:xfrm>
+          <a:prstGeom prst="rect">
+            <a:avLst/>
+          </a:prstGeom>
+          <a:noFill/>
+          <a:ln>
+            <a:noFill/>
+          </a:ln>
+        </p:spPr>
+        <p:txBody>
+          <a:bodyPr wrap="square" lIns="45720" rIns="45720" tIns="27432" bIns="27432">
+            <a:spAutoFit/>
+          </a:bodyPr>
+          <a:lstStyle/>
+          <a:p>
+            <a:pPr algn="l"/>
+            <a:r>
+              <a:rPr sz="1000">
+                <a:solidFill>
+                  <a:srgbClr val="5C6670"/>
+                </a:solidFill>
+                <a:latin typeface="Calibri"/>
+              </a:rPr>
+              <a:t>COMS 6998   ·   Jeremiah Mao, Mateo Juliani</a:t>
+            </a:r>
+          </a:p>
+          <a:p>
+            <a:pPr algn="r"/>
+          </a:p>
+        </p:txBody>
+      </p:sp>
+      <p:sp>
+        <p:nvSpPr>
+          <p:cNvPr id="8" name="TextBox 7"/>
+          <p:cNvSpPr txBox="1"/>
+          <p:nvPr/>
+        </p:nvSpPr>
+        <p:spPr>
+          <a:xfrm>
+            <a:off x="10515600" y="6446520"/>
+            <a:ext cx="1280160" cy="320040"/>
+          </a:xfrm>
+          <a:prstGeom prst="rect">
+            <a:avLst/>
+          </a:prstGeom>
+          <a:noFill/>
+          <a:ln>
+            <a:noFill/>
+          </a:ln>
+        </p:spPr>
+        <p:txBody>
+          <a:bodyPr wrap="square" lIns="45720" rIns="45720" tIns="27432" bIns="27432">
+            <a:spAutoFit/>
+          </a:bodyPr>
+          <a:lstStyle/>
+          <a:p>
+            <a:pPr algn="r"/>
+            <a:r>
+              <a:rPr sz="1000">
+                <a:solidFill>
+                  <a:srgbClr val="5C6670"/>
+                </a:solidFill>
+                <a:latin typeface="Calibri"/>
+              </a:rPr>
+              <a:t>9 / 15</a:t>
             </a:r>
           </a:p>
         </p:txBody>

</xml_diff>

<commit_message>
task: deck — make per-round frozen reference π_ref^(r) explicit on Setup slide via chain visualization
</commit_message>
<xml_diff>
--- a/paper_slides/synergy_deck.pptx
+++ b/paper_slides/synergy_deck.pptx
@@ -7609,8 +7609,8 @@
         </p:nvSpPr>
         <p:spPr>
           <a:xfrm>
-            <a:off x="548640" y="1005840"/>
-            <a:ext cx="11064240" cy="5303520"/>
+            <a:off x="548640" y="960120"/>
+            <a:ext cx="11064240" cy="2103120"/>
           </a:xfrm>
           <a:prstGeom prst="rect">
             <a:avLst/>
@@ -7628,14 +7628,14 @@
           <a:p>
             <a:pPr>
               <a:lnSpc>
-                <a:spcPct val="118000"/>
+                <a:spcPct val="110000"/>
               </a:lnSpc>
               <a:spcAft>
                 <a:spcPts val="600"/>
               </a:spcAft>
             </a:pPr>
             <a:r>
-              <a:rPr sz="1800" b="1">
+              <a:rPr sz="1500" b="1">
                 <a:solidFill>
                   <a:srgbClr val="1F4E90"/>
                 </a:solidFill>
@@ -7644,7 +7644,7 @@
               <a:t>•  </a:t>
             </a:r>
             <a:r>
-              <a:rPr sz="1800">
+              <a:rPr sz="1500">
                 <a:solidFill>
                   <a:srgbClr val="232A33"/>
                 </a:solidFill>
@@ -7656,14 +7656,14 @@
           <a:p>
             <a:pPr>
               <a:lnSpc>
-                <a:spcPct val="118000"/>
+                <a:spcPct val="110000"/>
               </a:lnSpc>
               <a:spcAft>
                 <a:spcPts val="600"/>
               </a:spcAft>
             </a:pPr>
             <a:r>
-              <a:rPr sz="1800" b="1">
+              <a:rPr sz="1500" b="1">
                 <a:solidFill>
                   <a:srgbClr val="1F4E90"/>
                 </a:solidFill>
@@ -7672,26 +7672,26 @@
               <a:t>•  </a:t>
             </a:r>
             <a:r>
-              <a:rPr sz="1800">
+              <a:rPr sz="1500">
                 <a:solidFill>
                   <a:srgbClr val="232A33"/>
                 </a:solidFill>
                 <a:latin typeface="Calibri"/>
               </a:rPr>
-              <a:t>Update layer: LoRA r=16 / α=32 on attention Q/K/V/O + MLP up/down/gate.</a:t>
+              <a:t>Update layer: LoRA r=16 / α=32 on attention Q/K/V/O + MLP up/down/gate.   3 epochs / round.</a:t>
             </a:r>
           </a:p>
           <a:p>
             <a:pPr>
               <a:lnSpc>
-                <a:spcPct val="118000"/>
+                <a:spcPct val="110000"/>
               </a:lnSpc>
               <a:spcAft>
                 <a:spcPts val="600"/>
               </a:spcAft>
             </a:pPr>
             <a:r>
-              <a:rPr sz="1800" b="1">
+              <a:rPr sz="1500" b="1">
                 <a:solidFill>
                   <a:srgbClr val="1F4E90"/>
                 </a:solidFill>
@@ -7700,26 +7700,26 @@
               <a:t>•  </a:t>
             </a:r>
             <a:r>
-              <a:rPr sz="1800">
+              <a:rPr sz="1500">
                 <a:solidFill>
                   <a:srgbClr val="232A33"/>
                 </a:solidFill>
                 <a:latin typeface="Calibri"/>
               </a:rPr>
-              <a:t>Continual stream: 15 sequential rounds × 200 disjoint fact triples per round (3000 facts total). Round k chains from round k-1's merged model.</a:t>
+              <a:t>This setting matches the dominant industrial fine-tuning pattern: LoRA + LoRA is the customer-facing primitive on AWS Bedrock, Together AI, Fireworks, and Vertex AI's open-model garden.</a:t>
             </a:r>
           </a:p>
           <a:p>
             <a:pPr>
               <a:lnSpc>
-                <a:spcPct val="118000"/>
+                <a:spcPct val="110000"/>
               </a:lnSpc>
               <a:spcAft>
                 <a:spcPts val="600"/>
               </a:spcAft>
             </a:pPr>
             <a:r>
-              <a:rPr sz="1800" b="1">
+              <a:rPr sz="1500" b="1">
                 <a:solidFill>
                   <a:srgbClr val="1F4E90"/>
                 </a:solidFill>
@@ -7728,48 +7728,193 @@
               <a:t>•  </a:t>
             </a:r>
             <a:r>
-              <a:rPr sz="1800">
+              <a:rPr sz="1500">
                 <a:solidFill>
                   <a:srgbClr val="232A33"/>
                 </a:solidFill>
                 <a:latin typeface="Calibri"/>
               </a:rPr>
-              <a:t>This setting matches the dominant industrial fine-tuning pattern: LoRA + LoRA is the customer-facing primitive on AWS Bedrock, Together AI, Fireworks, and Vertex AI's open-model garden (HuggingFace PEFT, QLoRA).</a:t>
+              <a:t>All evaluation is behavioral (token-F1 of greedy generation against gold), not geometric — across the COPR family, hidden-state cosine proximity does not predict cross-format behavioral availability.</a:t>
+            </a:r>
+          </a:p>
+        </p:txBody>
+      </p:sp>
+      <p:sp>
+        <p:nvSpPr>
+          <p:cNvPr id="5" name="TextBox 4"/>
+          <p:cNvSpPr txBox="1"/>
+          <p:nvPr/>
+        </p:nvSpPr>
+        <p:spPr>
+          <a:xfrm>
+            <a:off x="457200" y="3246120"/>
+            <a:ext cx="11247120" cy="2743200"/>
+          </a:xfrm>
+          <a:prstGeom prst="rect">
+            <a:avLst/>
+          </a:prstGeom>
+          <a:solidFill>
+            <a:srgbClr val="F7F9FC"/>
+          </a:solidFill>
+          <a:ln w="12700">
+            <a:solidFill>
+              <a:srgbClr val="CFD8E3"/>
+            </a:solidFill>
+          </a:ln>
+        </p:spPr>
+        <p:txBody>
+          <a:bodyPr wrap="square" lIns="45720" rIns="45720" tIns="27432" bIns="27432">
+            <a:spAutoFit/>
+          </a:bodyPr>
+          <a:lstStyle/>
+          <a:p>
+            <a:r>
+              <a:rPr sz="1400" b="1">
+                <a:solidFill>
+                  <a:srgbClr val="0F2A57"/>
+                </a:solidFill>
+                <a:latin typeface="Calibri"/>
+              </a:rPr>
+              <a:t>Continual stream:  15 rounds × 200 disjoint fact triples (3000 facts total)</a:t>
             </a:r>
           </a:p>
           <a:p>
             <a:pPr>
-              <a:lnSpc>
-                <a:spcPct val="118000"/>
-              </a:lnSpc>
-              <a:spcAft>
-                <a:spcPts val="600"/>
-              </a:spcAft>
+              <a:spcBef>
+                <a:spcPts val="1000"/>
+              </a:spcBef>
             </a:pPr>
             <a:r>
-              <a:rPr sz="1800" b="1">
+              <a:rPr sz="1400">
+                <a:solidFill>
+                  <a:srgbClr val="232A33"/>
+                </a:solidFill>
+                <a:latin typeface="Consolas"/>
+              </a:rPr>
+              <a:t>  π_θ⁽⁰⁾   →   round 1   →   π_θ⁽¹⁾   →   round 2   →   π_θ⁽²⁾   →   ...   →   round 15   →   π_θ⁽¹⁵⁾</a:t>
+            </a:r>
+          </a:p>
+          <a:p>
+            <a:pPr>
+              <a:spcBef>
+                <a:spcPts val="200"/>
+              </a:spcBef>
+            </a:pPr>
+            <a:r>
+              <a:rPr sz="1000" i="1">
+                <a:solidFill>
+                  <a:srgbClr val="5C6670"/>
+                </a:solidFill>
+                <a:latin typeface="Consolas"/>
+              </a:rPr>
+              <a:t>  task-tuned                                                                       final model</a:t>
+            </a:r>
+          </a:p>
+          <a:p>
+            <a:pPr>
+              <a:spcBef>
+                <a:spcPts val="1400"/>
+              </a:spcBef>
+            </a:pPr>
+            <a:r>
+              <a:rPr sz="1300" b="1">
                 <a:solidFill>
                   <a:srgbClr val="1F4E90"/>
                 </a:solidFill>
                 <a:latin typeface="Calibri"/>
               </a:rPr>
-              <a:t>•  </a:t>
-            </a:r>
-            <a:r>
-              <a:rPr sz="1800">
+              <a:t>Each round r:  </a:t>
+            </a:r>
+            <a:r>
+              <a:rPr sz="1300">
                 <a:solidFill>
                   <a:srgbClr val="232A33"/>
                 </a:solidFill>
                 <a:latin typeface="Calibri"/>
               </a:rPr>
-              <a:t>All evaluation is behavioral (token-F1 of greedy generation against gold), not geometric — we found across the COPR family that hidden-state cosine proximity does not predict cross-format behavioral availability.</a:t>
-            </a:r>
-          </a:p>
-        </p:txBody>
-      </p:sp>
-      <p:sp>
-        <p:nvSpPr>
-          <p:cNvPr id="5" name="TextBox 4"/>
+              <a:t>(1) snapshot π_θ⁽ʳ⁻¹⁾ as the frozen reference  π_ref⁽ʳ⁾  </a:t>
+            </a:r>
+            <a:r>
+              <a:rPr sz="1100" i="1">
+                <a:solidFill>
+                  <a:srgbClr val="5C6670"/>
+                </a:solidFill>
+                <a:latin typeface="Calibri"/>
+              </a:rPr>
+              <a:t>("frozen" = no gradient, fixed for the round)</a:t>
+            </a:r>
+          </a:p>
+          <a:p>
+            <a:pPr>
+              <a:spcBef>
+                <a:spcPts val="400"/>
+              </a:spcBef>
+            </a:pPr>
+            <a:r>
+              <a:rPr sz="1300">
+                <a:solidFill>
+                  <a:srgbClr val="232A33"/>
+                </a:solidFill>
+                <a:latin typeface="Calibri"/>
+              </a:rPr>
+              <a:t>                       </a:t>
+            </a:r>
+            <a:r>
+              <a:rPr sz="1300">
+                <a:solidFill>
+                  <a:srgbClr val="232A33"/>
+                </a:solidFill>
+                <a:latin typeface="Consolas"/>
+              </a:rPr>
+              <a:t>(2) train on T_r = 200 new fact triples with SFT loss + λ · KL(π_ref⁽ʳ⁾ ‖ π_θ),    λ = 0.1</a:t>
+            </a:r>
+          </a:p>
+          <a:p>
+            <a:pPr>
+              <a:spcBef>
+                <a:spcPts val="400"/>
+              </a:spcBef>
+            </a:pPr>
+            <a:r>
+              <a:rPr sz="1300">
+                <a:solidFill>
+                  <a:srgbClr val="232A33"/>
+                </a:solidFill>
+                <a:latin typeface="Calibri"/>
+              </a:rPr>
+              <a:t>                       </a:t>
+            </a:r>
+            <a:r>
+              <a:rPr sz="1300">
+                <a:solidFill>
+                  <a:srgbClr val="232A33"/>
+                </a:solidFill>
+                <a:latin typeface="Calibri"/>
+              </a:rPr>
+              <a:t>(3) merge update into base, advance to round r+1</a:t>
+            </a:r>
+          </a:p>
+          <a:p>
+            <a:pPr>
+              <a:spcBef>
+                <a:spcPts val="1200"/>
+              </a:spcBef>
+            </a:pPr>
+            <a:r>
+              <a:rPr sz="1200" i="1">
+                <a:solidFill>
+                  <a:srgbClr val="232A33"/>
+                </a:solidFill>
+                <a:latin typeface="Calibri"/>
+              </a:rPr>
+              <a:t>The KL anchor regularizes drift WITHIN each round — accumulated drift across rounds is allowed and intended.</a:t>
+            </a:r>
+          </a:p>
+        </p:txBody>
+      </p:sp>
+      <p:sp>
+        <p:nvSpPr>
+          <p:cNvPr id="6" name="TextBox 5"/>
           <p:cNvSpPr txBox="1"/>
           <p:nvPr/>
         </p:nvSpPr>
@@ -7810,7 +7955,7 @@
       </p:sp>
       <p:sp>
         <p:nvSpPr>
-          <p:cNvPr id="6" name="TextBox 5"/>
+          <p:cNvPr id="7" name="TextBox 6"/>
           <p:cNvSpPr txBox="1"/>
           <p:nvPr/>
         </p:nvSpPr>

</xml_diff>

<commit_message>
task: deck rewrite — restore Setup to facts-only; consolidate Method (chain + loss + 5 conditions) into one slide
</commit_message>
<xml_diff>
--- a/paper_slides/synergy_deck.pptx
+++ b/paper_slides/synergy_deck.pptx
@@ -7596,7 +7596,7 @@
                 </a:solidFill>
                 <a:latin typeface="Calibri"/>
               </a:rPr>
-              <a:t>Setup: a real industrial pipeline</a:t>
+              <a:t>Setup</a:t>
             </a:r>
           </a:p>
         </p:txBody>
@@ -7609,8 +7609,8 @@
         </p:nvSpPr>
         <p:spPr>
           <a:xfrm>
-            <a:off x="548640" y="960120"/>
-            <a:ext cx="11064240" cy="2103120"/>
+            <a:off x="548640" y="1051560"/>
+            <a:ext cx="11064240" cy="5120640"/>
           </a:xfrm>
           <a:prstGeom prst="rect">
             <a:avLst/>
@@ -7628,14 +7628,14 @@
           <a:p>
             <a:pPr>
               <a:lnSpc>
-                <a:spcPct val="110000"/>
+                <a:spcPct val="118000"/>
               </a:lnSpc>
               <a:spcAft>
                 <a:spcPts val="600"/>
               </a:spcAft>
             </a:pPr>
             <a:r>
-              <a:rPr sz="1500" b="1">
+              <a:rPr sz="1600" b="1">
                 <a:solidFill>
                   <a:srgbClr val="1F4E90"/>
                 </a:solidFill>
@@ -7644,26 +7644,26 @@
               <a:t>•  </a:t>
             </a:r>
             <a:r>
-              <a:rPr sz="1500">
+              <a:rPr sz="1600">
                 <a:solidFill>
                   <a:srgbClr val="232A33"/>
                 </a:solidFill>
                 <a:latin typeface="Calibri"/>
               </a:rPr>
-              <a:t>Backbone: Qwen3-4B-Instruct-2507, LoRA-tuned (r=32 / α=64) on FNSPID financial news, pre-2022 cutoff.</a:t>
+              <a:t>Backbone:  Qwen3-4B-Instruct-2507, task-tuned via LoRA (r=32 / α=64) on FNSPID financial news with a pre-2022 cutoff. The base model emits QD sub-queries — see slide 3.</a:t>
             </a:r>
           </a:p>
           <a:p>
             <a:pPr>
               <a:lnSpc>
-                <a:spcPct val="110000"/>
+                <a:spcPct val="118000"/>
               </a:lnSpc>
               <a:spcAft>
                 <a:spcPts val="600"/>
               </a:spcAft>
             </a:pPr>
             <a:r>
-              <a:rPr sz="1500" b="1">
+              <a:rPr sz="1600" b="1">
                 <a:solidFill>
                   <a:srgbClr val="1F4E90"/>
                 </a:solidFill>
@@ -7672,26 +7672,26 @@
               <a:t>•  </a:t>
             </a:r>
             <a:r>
-              <a:rPr sz="1500">
+              <a:rPr sz="1600">
                 <a:solidFill>
                   <a:srgbClr val="232A33"/>
                 </a:solidFill>
                 <a:latin typeface="Calibri"/>
               </a:rPr>
-              <a:t>Update layer: LoRA r=16 / α=32 on attention Q/K/V/O + MLP up/down/gate.   3 epochs / round.</a:t>
+              <a:t>Update layer:  LoRA r=16 / α=32 on attention Q/K/V/O + MLP up/down/gate.   AdamW, 3 epochs/round, single A10G 24 GB.</a:t>
             </a:r>
           </a:p>
           <a:p>
             <a:pPr>
               <a:lnSpc>
-                <a:spcPct val="110000"/>
+                <a:spcPct val="118000"/>
               </a:lnSpc>
               <a:spcAft>
                 <a:spcPts val="600"/>
               </a:spcAft>
             </a:pPr>
             <a:r>
-              <a:rPr sz="1500" b="1">
+              <a:rPr sz="1600" b="1">
                 <a:solidFill>
                   <a:srgbClr val="1F4E90"/>
                 </a:solidFill>
@@ -7700,26 +7700,26 @@
               <a:t>•  </a:t>
             </a:r>
             <a:r>
-              <a:rPr sz="1500">
+              <a:rPr sz="1600">
                 <a:solidFill>
                   <a:srgbClr val="232A33"/>
                 </a:solidFill>
                 <a:latin typeface="Calibri"/>
               </a:rPr>
-              <a:t>This setting matches the dominant industrial fine-tuning pattern: LoRA + LoRA is the customer-facing primitive on AWS Bedrock, Together AI, Fireworks, and Vertex AI's open-model garden.</a:t>
+              <a:t>Continual stream:  15 sequential rounds × 200 disjoint fact triples per round (3000 facts total), drawn from post-cutoff FNSPID.</a:t>
             </a:r>
           </a:p>
           <a:p>
             <a:pPr>
               <a:lnSpc>
-                <a:spcPct val="110000"/>
+                <a:spcPct val="118000"/>
               </a:lnSpc>
               <a:spcAft>
                 <a:spcPts val="600"/>
               </a:spcAft>
             </a:pPr>
             <a:r>
-              <a:rPr sz="1500" b="1">
+              <a:rPr sz="1600" b="1">
                 <a:solidFill>
                   <a:srgbClr val="1F4E90"/>
                 </a:solidFill>
@@ -7728,13 +7728,41 @@
               <a:t>•  </a:t>
             </a:r>
             <a:r>
-              <a:rPr sz="1500">
+              <a:rPr sz="1600">
                 <a:solidFill>
                   <a:srgbClr val="232A33"/>
                 </a:solidFill>
                 <a:latin typeface="Calibri"/>
               </a:rPr>
-              <a:t>All evaluation is behavioral (token-F1 of greedy generation against gold), not geometric — across the COPR family, hidden-state cosine proximity does not predict cross-format behavioral availability.</a:t>
+              <a:t>Industrial pattern:  LoRA + LoRA (LoRA-tuned base + LoRA continual updates) is the dominant customer-facing fine-tuning primitive on AWS Bedrock, Together AI, Fireworks, and Vertex AI's open-model garden — so the setting matches production practice, not an academic special case.</a:t>
+            </a:r>
+          </a:p>
+          <a:p>
+            <a:pPr>
+              <a:lnSpc>
+                <a:spcPct val="118000"/>
+              </a:lnSpc>
+              <a:spcAft>
+                <a:spcPts val="600"/>
+              </a:spcAft>
+            </a:pPr>
+            <a:r>
+              <a:rPr sz="1600" b="1">
+                <a:solidFill>
+                  <a:srgbClr val="1F4E90"/>
+                </a:solidFill>
+                <a:latin typeface="Calibri"/>
+              </a:rPr>
+              <a:t>•  </a:t>
+            </a:r>
+            <a:r>
+              <a:rPr sz="1600">
+                <a:solidFill>
+                  <a:srgbClr val="232A33"/>
+                </a:solidFill>
+                <a:latin typeface="Calibri"/>
+              </a:rPr>
+              <a:t>Evaluation is behavioral (token-F1 of greedy generation vs gold) — across the COPR family, hidden-state cosine proximity does not predict cross-format behavioral availability, so we don't rely on geometric proxies.</a:t>
             </a:r>
           </a:p>
         </p:txBody>
@@ -7742,179 +7770,6 @@
       <p:sp>
         <p:nvSpPr>
           <p:cNvPr id="5" name="TextBox 4"/>
-          <p:cNvSpPr txBox="1"/>
-          <p:nvPr/>
-        </p:nvSpPr>
-        <p:spPr>
-          <a:xfrm>
-            <a:off x="457200" y="3246120"/>
-            <a:ext cx="11247120" cy="2743200"/>
-          </a:xfrm>
-          <a:prstGeom prst="rect">
-            <a:avLst/>
-          </a:prstGeom>
-          <a:solidFill>
-            <a:srgbClr val="F7F9FC"/>
-          </a:solidFill>
-          <a:ln w="12700">
-            <a:solidFill>
-              <a:srgbClr val="CFD8E3"/>
-            </a:solidFill>
-          </a:ln>
-        </p:spPr>
-        <p:txBody>
-          <a:bodyPr wrap="square" lIns="45720" rIns="45720" tIns="27432" bIns="27432">
-            <a:spAutoFit/>
-          </a:bodyPr>
-          <a:lstStyle/>
-          <a:p>
-            <a:r>
-              <a:rPr sz="1400" b="1">
-                <a:solidFill>
-                  <a:srgbClr val="0F2A57"/>
-                </a:solidFill>
-                <a:latin typeface="Calibri"/>
-              </a:rPr>
-              <a:t>Continual stream:  15 rounds × 200 disjoint fact triples (3000 facts total)</a:t>
-            </a:r>
-          </a:p>
-          <a:p>
-            <a:pPr>
-              <a:spcBef>
-                <a:spcPts val="1000"/>
-              </a:spcBef>
-            </a:pPr>
-            <a:r>
-              <a:rPr sz="1400">
-                <a:solidFill>
-                  <a:srgbClr val="232A33"/>
-                </a:solidFill>
-                <a:latin typeface="Consolas"/>
-              </a:rPr>
-              <a:t>  π_θ⁽⁰⁾   →   round 1   →   π_θ⁽¹⁾   →   round 2   →   π_θ⁽²⁾   →   ...   →   round 15   →   π_θ⁽¹⁵⁾</a:t>
-            </a:r>
-          </a:p>
-          <a:p>
-            <a:pPr>
-              <a:spcBef>
-                <a:spcPts val="200"/>
-              </a:spcBef>
-            </a:pPr>
-            <a:r>
-              <a:rPr sz="1000" i="1">
-                <a:solidFill>
-                  <a:srgbClr val="5C6670"/>
-                </a:solidFill>
-                <a:latin typeface="Consolas"/>
-              </a:rPr>
-              <a:t>  task-tuned                                                                       final model</a:t>
-            </a:r>
-          </a:p>
-          <a:p>
-            <a:pPr>
-              <a:spcBef>
-                <a:spcPts val="1400"/>
-              </a:spcBef>
-            </a:pPr>
-            <a:r>
-              <a:rPr sz="1300" b="1">
-                <a:solidFill>
-                  <a:srgbClr val="1F4E90"/>
-                </a:solidFill>
-                <a:latin typeface="Calibri"/>
-              </a:rPr>
-              <a:t>Each round r:  </a:t>
-            </a:r>
-            <a:r>
-              <a:rPr sz="1300">
-                <a:solidFill>
-                  <a:srgbClr val="232A33"/>
-                </a:solidFill>
-                <a:latin typeface="Calibri"/>
-              </a:rPr>
-              <a:t>(1) snapshot π_θ⁽ʳ⁻¹⁾ as the frozen reference  π_ref⁽ʳ⁾  </a:t>
-            </a:r>
-            <a:r>
-              <a:rPr sz="1100" i="1">
-                <a:solidFill>
-                  <a:srgbClr val="5C6670"/>
-                </a:solidFill>
-                <a:latin typeface="Calibri"/>
-              </a:rPr>
-              <a:t>("frozen" = no gradient, fixed for the round)</a:t>
-            </a:r>
-          </a:p>
-          <a:p>
-            <a:pPr>
-              <a:spcBef>
-                <a:spcPts val="400"/>
-              </a:spcBef>
-            </a:pPr>
-            <a:r>
-              <a:rPr sz="1300">
-                <a:solidFill>
-                  <a:srgbClr val="232A33"/>
-                </a:solidFill>
-                <a:latin typeface="Calibri"/>
-              </a:rPr>
-              <a:t>                       </a:t>
-            </a:r>
-            <a:r>
-              <a:rPr sz="1300">
-                <a:solidFill>
-                  <a:srgbClr val="232A33"/>
-                </a:solidFill>
-                <a:latin typeface="Consolas"/>
-              </a:rPr>
-              <a:t>(2) train on T_r = 200 new fact triples with SFT loss + λ · KL(π_ref⁽ʳ⁾ ‖ π_θ),    λ = 0.1</a:t>
-            </a:r>
-          </a:p>
-          <a:p>
-            <a:pPr>
-              <a:spcBef>
-                <a:spcPts val="400"/>
-              </a:spcBef>
-            </a:pPr>
-            <a:r>
-              <a:rPr sz="1300">
-                <a:solidFill>
-                  <a:srgbClr val="232A33"/>
-                </a:solidFill>
-                <a:latin typeface="Calibri"/>
-              </a:rPr>
-              <a:t>                       </a:t>
-            </a:r>
-            <a:r>
-              <a:rPr sz="1300">
-                <a:solidFill>
-                  <a:srgbClr val="232A33"/>
-                </a:solidFill>
-                <a:latin typeface="Calibri"/>
-              </a:rPr>
-              <a:t>(3) merge update into base, advance to round r+1</a:t>
-            </a:r>
-          </a:p>
-          <a:p>
-            <a:pPr>
-              <a:spcBef>
-                <a:spcPts val="1200"/>
-              </a:spcBef>
-            </a:pPr>
-            <a:r>
-              <a:rPr sz="1200" i="1">
-                <a:solidFill>
-                  <a:srgbClr val="232A33"/>
-                </a:solidFill>
-                <a:latin typeface="Calibri"/>
-              </a:rPr>
-              <a:t>The KL anchor regularizes drift WITHIN each round — accumulated drift across rounds is allowed and intended.</a:t>
-            </a:r>
-          </a:p>
-        </p:txBody>
-      </p:sp>
-      <p:sp>
-        <p:nvSpPr>
-          <p:cNvPr id="6" name="TextBox 5"/>
           <p:cNvSpPr txBox="1"/>
           <p:nvPr/>
         </p:nvSpPr>
@@ -7955,7 +7810,7 @@
       </p:sp>
       <p:sp>
         <p:nvSpPr>
-          <p:cNvPr id="7" name="TextBox 6"/>
+          <p:cNvPr id="6" name="TextBox 5"/>
           <p:cNvSpPr txBox="1"/>
           <p:nvPr/>
         </p:nvSpPr>
@@ -8347,7 +8202,7 @@
                 </a:solidFill>
                 <a:latin typeface="Calibri"/>
               </a:rPr>
-              <a:t>Methods Tested: a 2×2 ablation + symmetric extension + COPR family</a:t>
+              <a:t>Method:  continual editing chain  +  the 5-condition ablation</a:t>
             </a:r>
           </a:p>
         </p:txBody>
@@ -8360,15 +8215,19 @@
         </p:nvSpPr>
         <p:spPr>
           <a:xfrm>
-            <a:off x="548640" y="914400"/>
-            <a:ext cx="11064240" cy="502920"/>
+            <a:off x="457200" y="914400"/>
+            <a:ext cx="11247120" cy="1874519"/>
           </a:xfrm>
           <a:prstGeom prst="rect">
             <a:avLst/>
           </a:prstGeom>
-          <a:noFill/>
-          <a:ln>
-            <a:noFill/>
+          <a:solidFill>
+            <a:srgbClr val="F7F9FC"/>
+          </a:solidFill>
+          <a:ln w="12700">
+            <a:solidFill>
+              <a:srgbClr val="CFD8E3"/>
+            </a:solidFill>
           </a:ln>
         </p:spPr>
         <p:txBody>
@@ -8378,13 +8237,106 @@
           <a:lstStyle/>
           <a:p>
             <a:r>
-              <a:rPr sz="1400">
+              <a:rPr sz="1500" b="1">
+                <a:solidFill>
+                  <a:srgbClr val="0F2A57"/>
+                </a:solidFill>
+                <a:latin typeface="Calibri"/>
+              </a:rPr>
+              <a:t>The continual editing loop</a:t>
+            </a:r>
+          </a:p>
+          <a:p>
+            <a:pPr>
+              <a:spcBef>
+                <a:spcPts val="600"/>
+              </a:spcBef>
+            </a:pPr>
+            <a:r>
+              <a:rPr sz="1300">
+                <a:solidFill>
+                  <a:srgbClr val="232A33"/>
+                </a:solidFill>
+                <a:latin typeface="Consolas"/>
+              </a:rPr>
+              <a:t>  π_θ⁽⁰⁾  →  round 1  →  π_θ⁽¹⁾  →  round 2  →  π_θ⁽²⁾  →  …  →  round 15  →  π_θ⁽¹⁵⁾</a:t>
+            </a:r>
+          </a:p>
+          <a:p>
+            <a:r>
+              <a:rPr sz="1000" i="1">
                 <a:solidFill>
                   <a:srgbClr val="5C6670"/>
                 </a:solidFill>
-                <a:latin typeface="Calibri"/>
-              </a:rPr>
-              <a:t>K=5 paraphrastic injection (Allen-Zhu &amp; Li 2023) renders each fact in 5 surface forms (QA, QD, declarative, instruction, narrative).  KL preservation anchors against a per-round frozen reference.</a:t>
+                <a:latin typeface="Consolas"/>
+              </a:rPr>
+              <a:t>  task-tuned base                                                                                       final model</a:t>
+            </a:r>
+          </a:p>
+          <a:p>
+            <a:pPr>
+              <a:spcBef>
+                <a:spcPts val="800"/>
+              </a:spcBef>
+            </a:pPr>
+            <a:r>
+              <a:rPr sz="1200" b="1">
+                <a:solidFill>
+                  <a:srgbClr val="1F4E90"/>
+                </a:solidFill>
+                <a:latin typeface="Calibri"/>
+              </a:rPr>
+              <a:t>Each round r: </a:t>
+            </a:r>
+            <a:r>
+              <a:rPr sz="1200">
+                <a:solidFill>
+                  <a:srgbClr val="232A33"/>
+                </a:solidFill>
+                <a:latin typeface="Calibri"/>
+              </a:rPr>
+              <a:t>(1) snapshot π_θ⁽ʳ⁻¹⁾ as a frozen reference π_ref⁽ʳ⁾   (2) train on T_r = 200 facts with the loss below   (3) merge LoRA update, advance to round r+1.</a:t>
+            </a:r>
+          </a:p>
+          <a:p>
+            <a:pPr algn="ctr">
+              <a:spcBef>
+                <a:spcPts val="800"/>
+              </a:spcBef>
+            </a:pPr>
+            <a:r>
+              <a:rPr sz="1400" b="1">
+                <a:solidFill>
+                  <a:srgbClr val="232A33"/>
+                </a:solidFill>
+                <a:latin typeface="Consolas"/>
+              </a:rPr>
+              <a:t>ℒ_total(θ; round r)   =   ℒ_SFT(θ; T_r)   +   λ · KL( π_ref⁽ʳ⁾ ‖ π_θ ; D_replay )</a:t>
+            </a:r>
+            <a:r>
+              <a:rPr sz="1200" i="1">
+                <a:solidFill>
+                  <a:srgbClr val="5C6670"/>
+                </a:solidFill>
+                <a:latin typeface="Consolas"/>
+              </a:rPr>
+              <a:t>     λ = 0.1</a:t>
+            </a:r>
+          </a:p>
+          <a:p>
+            <a:pPr algn="ctr">
+              <a:spcBef>
+                <a:spcPts val="200"/>
+              </a:spcBef>
+            </a:pPr>
+            <a:r>
+              <a:rPr sz="1100" i="1">
+                <a:solidFill>
+                  <a:srgbClr val="5C6670"/>
+                </a:solidFill>
+                <a:latin typeface="Calibri"/>
+              </a:rPr>
+              <a:t>The KL term is the anchor.  Whether/how it is added defines the 5 conditions below.</a:t>
             </a:r>
           </a:p>
         </p:txBody>
@@ -8398,8 +8350,8 @@
           <p:nvPr/>
         </p:nvGraphicFramePr>
         <p:xfrm>
-          <a:off x="548640" y="1463040"/>
-          <a:ext cx="11064239" cy="3474720"/>
+          <a:off x="457200" y="2971800"/>
+          <a:ext cx="11247120" cy="2697480"/>
         </p:xfrm>
         <a:graphic>
           <a:graphicData uri="http://schemas.openxmlformats.org/drawingml/2006/table">
@@ -8408,12 +8360,12 @@
                 <a:tableStyleId>{5C22544A-7EE6-4342-B048-85BDC9FD1C3A}</a:tableStyleId>
               </a:tblPr>
               <a:tblGrid>
-                <a:gridCol w="2103120"/>
+                <a:gridCol w="2194560"/>
                 <a:gridCol w="2743200"/>
                 <a:gridCol w="2468880"/>
-                <a:gridCol w="3749039"/>
+                <a:gridCol w="3840480"/>
               </a:tblGrid>
-              <a:tr h="502920">
+              <a:tr h="411480">
                 <a:tc>
                   <a:txBody>
                     <a:bodyPr wrap="square"/>
@@ -8421,7 +8373,7 @@
                     <a:p>
                       <a:pPr algn="l"/>
                       <a:r>
-                        <a:rPr sz="1400" b="1" i="0">
+                        <a:rPr sz="1300" b="1" i="0">
                           <a:solidFill>
                             <a:srgbClr val="FFFFFF"/>
                           </a:solidFill>
@@ -8444,13 +8396,13 @@
                     <a:p>
                       <a:pPr algn="l"/>
                       <a:r>
-                        <a:rPr sz="1400" b="1" i="0">
+                        <a:rPr sz="1300" b="1" i="0">
                           <a:solidFill>
                             <a:srgbClr val="FFFFFF"/>
                           </a:solidFill>
                           <a:latin typeface="Calibri"/>
                         </a:rPr>
-                        <a:t>Injection</a:t>
+                        <a:t>Injection-side  ℒ_SFT</a:t>
                       </a:r>
                     </a:p>
                   </a:txBody>
@@ -8467,13 +8419,13 @@
                     <a:p>
                       <a:pPr algn="l"/>
                       <a:r>
-                        <a:rPr sz="1400" b="1" i="0">
+                        <a:rPr sz="1300" b="1" i="0">
                           <a:solidFill>
                             <a:srgbClr val="FFFFFF"/>
                           </a:solidFill>
                           <a:latin typeface="Calibri"/>
                         </a:rPr>
-                        <a:t>Preservation</a:t>
+                        <a:t>Preservation-side  KL</a:t>
                       </a:r>
                     </a:p>
                   </a:txBody>
@@ -8490,7 +8442,7 @@
                     <a:p>
                       <a:pPr algn="l"/>
                       <a:r>
-                        <a:rPr sz="1400" b="1" i="0">
+                        <a:rPr sz="1300" b="1" i="0">
                           <a:solidFill>
                             <a:srgbClr val="FFFFFF"/>
                           </a:solidFill>
@@ -8507,7 +8459,7 @@
                   </a:tcPr>
                 </a:tc>
               </a:tr>
-              <a:tr h="594360">
+              <a:tr h="457200">
                 <a:tc>
                   <a:txBody>
                     <a:bodyPr wrap="square"/>
@@ -8515,7 +8467,7 @@
                     <a:p>
                       <a:pPr algn="l"/>
                       <a:r>
-                        <a:rPr sz="1300" b="0" i="0">
+                        <a:rPr sz="1200" b="0" i="0">
                           <a:solidFill>
                             <a:srgbClr val="232A33"/>
                           </a:solidFill>
@@ -8534,13 +8486,13 @@
                     <a:p>
                       <a:pPr algn="l"/>
                       <a:r>
-                        <a:rPr sz="1300" b="0" i="0">
+                        <a:rPr sz="1200" b="0" i="0">
                           <a:solidFill>
                             <a:srgbClr val="232A33"/>
                           </a:solidFill>
                           <a:latin typeface="Calibri"/>
                         </a:rPr>
-                        <a:t>K=1 (QA only)</a:t>
+                        <a:t>K=1   (QA template only)</a:t>
                       </a:r>
                     </a:p>
                   </a:txBody>
@@ -8553,7 +8505,7 @@
                     <a:p>
                       <a:pPr algn="l"/>
                       <a:r>
-                        <a:rPr sz="1300" b="0" i="0">
+                        <a:rPr sz="1200" b="0" i="0">
                           <a:solidFill>
                             <a:srgbClr val="232A33"/>
                           </a:solidFill>
@@ -8572,20 +8524,20 @@
                     <a:p>
                       <a:pPr algn="l"/>
                       <a:r>
-                        <a:rPr sz="1300" b="0" i="0">
+                        <a:rPr sz="1200" b="0" i="0">
                           <a:solidFill>
                             <a:srgbClr val="232A33"/>
                           </a:solidFill>
                           <a:latin typeface="Calibri"/>
                         </a:rPr>
-                        <a:t>Vanilla fine-tuning baseline</a:t>
+                        <a:t>vanilla SFT baseline</a:t>
                       </a:r>
                     </a:p>
                   </a:txBody>
                   <a:tcPr marL="54864" marR="54864" marT="36576" marB="36576" anchor="ctr"/>
                 </a:tc>
               </a:tr>
-              <a:tr h="594360">
+              <a:tr h="457200">
                 <a:tc>
                   <a:txBody>
                     <a:bodyPr wrap="square"/>
@@ -8593,7 +8545,7 @@
                     <a:p>
                       <a:pPr algn="l"/>
                       <a:r>
-                        <a:rPr sz="1300" b="0" i="0">
+                        <a:rPr sz="1200" b="0" i="0">
                           <a:solidFill>
                             <a:srgbClr val="232A33"/>
                           </a:solidFill>
@@ -8612,13 +8564,13 @@
                     <a:p>
                       <a:pPr algn="l"/>
                       <a:r>
-                        <a:rPr sz="1300" b="0" i="0">
+                        <a:rPr sz="1200" b="0" i="0">
                           <a:solidFill>
                             <a:srgbClr val="232A33"/>
                           </a:solidFill>
                           <a:latin typeface="Calibri"/>
                         </a:rPr>
-                        <a:t>K=5 paraphrastic</a:t>
+                        <a:t>K=5   paraphrastic</a:t>
                       </a:r>
                     </a:p>
                   </a:txBody>
@@ -8631,7 +8583,7 @@
                     <a:p>
                       <a:pPr algn="l"/>
                       <a:r>
-                        <a:rPr sz="1300" b="0" i="0">
+                        <a:rPr sz="1200" b="0" i="0">
                           <a:solidFill>
                             <a:srgbClr val="232A33"/>
                           </a:solidFill>
@@ -8650,20 +8602,20 @@
                     <a:p>
                       <a:pPr algn="l"/>
                       <a:r>
-                        <a:rPr sz="1300" b="0" i="0">
+                        <a:rPr sz="1200" b="0" i="0">
                           <a:solidFill>
                             <a:srgbClr val="232A33"/>
                           </a:solidFill>
                           <a:latin typeface="Calibri"/>
                         </a:rPr>
-                        <a:t>Augmentation alone — Allen-Zhu replication</a:t>
+                        <a:t>augmentation alone</a:t>
                       </a:r>
                     </a:p>
                   </a:txBody>
                   <a:tcPr marL="54864" marR="54864" marT="36576" marB="36576" anchor="ctr"/>
                 </a:tc>
               </a:tr>
-              <a:tr h="594360">
+              <a:tr h="457200">
                 <a:tc>
                   <a:txBody>
                     <a:bodyPr wrap="square"/>
@@ -8671,7 +8623,7 @@
                     <a:p>
                       <a:pPr algn="l"/>
                       <a:r>
-                        <a:rPr sz="1300" b="0" i="0">
+                        <a:rPr sz="1200" b="0" i="0">
                           <a:solidFill>
                             <a:srgbClr val="232A33"/>
                           </a:solidFill>
@@ -8690,13 +8642,13 @@
                     <a:p>
                       <a:pPr algn="l"/>
                       <a:r>
-                        <a:rPr sz="1300" b="0" i="0">
+                        <a:rPr sz="1200" b="0" i="0">
                           <a:solidFill>
                             <a:srgbClr val="232A33"/>
                           </a:solidFill>
                           <a:latin typeface="Calibri"/>
                         </a:rPr>
-                        <a:t>K=1 (QA only)</a:t>
+                        <a:t>K=1   (QA template only)</a:t>
                       </a:r>
                     </a:p>
                   </a:txBody>
@@ -8709,13 +8661,13 @@
                     <a:p>
                       <a:pPr algn="l"/>
                       <a:r>
-                        <a:rPr sz="1300" b="0" i="0">
+                        <a:rPr sz="1200" b="0" i="0">
                           <a:solidFill>
                             <a:srgbClr val="232A33"/>
                           </a:solidFill>
                           <a:latin typeface="Calibri"/>
                         </a:rPr>
-                        <a:t>K=1 KL on replay</a:t>
+                        <a:t>K=1   single framing</a:t>
                       </a:r>
                     </a:p>
                   </a:txBody>
@@ -8728,20 +8680,20 @@
                     <a:p>
                       <a:pPr algn="l"/>
                       <a:r>
-                        <a:rPr sz="1300" b="0" i="0">
+                        <a:rPr sz="1200" b="0" i="0">
                           <a:solidFill>
                             <a:srgbClr val="232A33"/>
                           </a:solidFill>
                           <a:latin typeface="Calibri"/>
                         </a:rPr>
-                        <a:t>Standard policy-preservation baseline</a:t>
+                        <a:t>policy-preservation baseline</a:t>
                       </a:r>
                     </a:p>
                   </a:txBody>
                   <a:tcPr marL="54864" marR="54864" marT="36576" marB="36576" anchor="ctr"/>
                 </a:tc>
               </a:tr>
-              <a:tr h="594360">
+              <a:tr h="457200">
                 <a:tc>
                   <a:txBody>
                     <a:bodyPr wrap="square"/>
@@ -8749,7 +8701,7 @@
                     <a:p>
                       <a:pPr algn="l"/>
                       <a:r>
-                        <a:rPr sz="1300" b="1" i="0">
+                        <a:rPr sz="1200" b="1" i="0">
                           <a:solidFill>
                             <a:srgbClr val="232A33"/>
                           </a:solidFill>
@@ -8772,13 +8724,13 @@
                     <a:p>
                       <a:pPr algn="l"/>
                       <a:r>
-                        <a:rPr sz="1300" b="1" i="0">
+                        <a:rPr sz="1200" b="1" i="0">
                           <a:solidFill>
                             <a:srgbClr val="232A33"/>
                           </a:solidFill>
                           <a:latin typeface="Calibri"/>
                         </a:rPr>
-                        <a:t>K=5 paraphrastic</a:t>
+                        <a:t>K=5   paraphrastic</a:t>
                       </a:r>
                     </a:p>
                   </a:txBody>
@@ -8795,13 +8747,13 @@
                     <a:p>
                       <a:pPr algn="l"/>
                       <a:r>
-                        <a:rPr sz="1300" b="1" i="0">
+                        <a:rPr sz="1200" b="1" i="0">
                           <a:solidFill>
                             <a:srgbClr val="232A33"/>
                           </a:solidFill>
                           <a:latin typeface="Calibri"/>
                         </a:rPr>
-                        <a:t>K=1 KL on replay</a:t>
+                        <a:t>K=1   single framing</a:t>
                       </a:r>
                     </a:p>
                   </a:txBody>
@@ -8818,13 +8770,13 @@
                     <a:p>
                       <a:pPr algn="l"/>
                       <a:r>
-                        <a:rPr sz="1300" b="1" i="0">
+                        <a:rPr sz="1200" b="1" i="0">
                           <a:solidFill>
                             <a:srgbClr val="232A33"/>
                           </a:solidFill>
                           <a:latin typeface="Calibri"/>
                         </a:rPr>
-                        <a:t>★ The combination — the synergy winner</a:t>
+                        <a:t>★ the combination — synergy winner</a:t>
                       </a:r>
                     </a:p>
                   </a:txBody>
@@ -8835,7 +8787,7 @@
                   </a:tcPr>
                 </a:tc>
               </a:tr>
-              <a:tr h="594360">
+              <a:tr h="457200">
                 <a:tc>
                   <a:txBody>
                     <a:bodyPr wrap="square"/>
@@ -8843,7 +8795,7 @@
                     <a:p>
                       <a:pPr algn="l"/>
                       <a:r>
-                        <a:rPr sz="1300" b="0" i="0">
+                        <a:rPr sz="1200" b="0" i="0">
                           <a:solidFill>
                             <a:srgbClr val="232A33"/>
                           </a:solidFill>
@@ -8862,13 +8814,13 @@
                     <a:p>
                       <a:pPr algn="l"/>
                       <a:r>
-                        <a:rPr sz="1300" b="0" i="0">
+                        <a:rPr sz="1200" b="0" i="0">
                           <a:solidFill>
                             <a:srgbClr val="232A33"/>
                           </a:solidFill>
                           <a:latin typeface="Calibri"/>
                         </a:rPr>
-                        <a:t>K=5 paraphrastic</a:t>
+                        <a:t>K=5   paraphrastic</a:t>
                       </a:r>
                     </a:p>
                   </a:txBody>
@@ -8881,13 +8833,13 @@
                     <a:p>
                       <a:pPr algn="l"/>
                       <a:r>
-                        <a:rPr sz="1300" b="0" i="0">
+                        <a:rPr sz="1200" b="0" i="0">
                           <a:solidFill>
                             <a:srgbClr val="232A33"/>
                           </a:solidFill>
                           <a:latin typeface="Calibri"/>
                         </a:rPr>
-                        <a:t>K=5 KL framings</a:t>
+                        <a:t>K=5   instruction framings</a:t>
                       </a:r>
                     </a:p>
                   </a:txBody>
@@ -8900,13 +8852,13 @@
                     <a:p>
                       <a:pPr algn="l"/>
                       <a:r>
-                        <a:rPr sz="1300" b="0" i="0">
+                        <a:rPr sz="1200" b="0" i="0">
                           <a:solidFill>
                             <a:srgbClr val="232A33"/>
                           </a:solidFill>
                           <a:latin typeface="Calibri"/>
                         </a:rPr>
-                        <a:t>Symmetric extension we tested</a:t>
+                        <a:t>symmetric extension we tested</a:t>
                       </a:r>
                     </a:p>
                   </a:txBody>
@@ -8925,18 +8877,18 @@
         </p:nvSpPr>
         <p:spPr>
           <a:xfrm>
-            <a:off x="548640" y="5349240"/>
-            <a:ext cx="11064240" cy="594360"/>
+            <a:off x="457200" y="5897880"/>
+            <a:ext cx="11247120" cy="502920"/>
           </a:xfrm>
           <a:prstGeom prst="rect">
             <a:avLst/>
           </a:prstGeom>
           <a:solidFill>
-            <a:srgbClr val="F7F9FC"/>
+            <a:srgbClr val="FDF7EF"/>
           </a:solidFill>
           <a:ln w="12700">
             <a:solidFill>
-              <a:srgbClr val="CFD8E3"/>
+              <a:srgbClr val="E8C89C"/>
             </a:solidFill>
           </a:ln>
         </p:spPr>
@@ -8947,22 +8899,22 @@
           <a:lstStyle/>
           <a:p>
             <a:r>
-              <a:rPr sz="1200" b="1">
+              <a:rPr sz="1100" b="1">
                 <a:solidFill>
                   <a:srgbClr val="1F4E90"/>
                 </a:solidFill>
                 <a:latin typeface="Calibri"/>
               </a:rPr>
-              <a:t>Notation:  </a:t>
-            </a:r>
-            <a:r>
-              <a:rPr sz="1100">
+              <a:t>K notation:  </a:t>
+            </a:r>
+            <a:r>
+              <a:rPr sz="1000">
                 <a:solidFill>
                   <a:srgbClr val="232A33"/>
                 </a:solidFill>
                 <a:latin typeface="Calibri"/>
               </a:rPr>
-              <a:t>K = number of paraphrastic surface forms per fact (Allen-Zhu &amp; Li 2023). K=1 → one template (QA only).  K=5 → five templates (QA, QD, declarative, instruction, narrative).  On the preservation side: K = number of instruction framings of the same task prompt (used in (e) only).</a:t>
+              <a:t>On the injection side, K = paraphrastic surface forms per fact (Allen-Zhu &amp; Li 2023): K=1 = QA only,  K=5 = QA + QD + declarative + instruction + narrative.   On the preservation side, K = instruction framings of the same task prompt (used in (e) only — see slide 12).   Plus the COPR family — 4 preference-style baselines, evaluated separately (slide 11).</a:t>
             </a:r>
           </a:p>
         </p:txBody>
@@ -8975,8 +8927,8 @@
         </p:nvSpPr>
         <p:spPr>
           <a:xfrm>
-            <a:off x="548640" y="5989320"/>
-            <a:ext cx="11064240" cy="365760"/>
+            <a:off x="365760" y="6446520"/>
+            <a:ext cx="11430000" cy="320040"/>
           </a:xfrm>
           <a:prstGeom prst="rect">
             <a:avLst/>
@@ -8992,71 +8944,25 @@
           </a:bodyPr>
           <a:lstStyle/>
           <a:p>
-            <a:r>
-              <a:rPr sz="1300">
-                <a:solidFill>
-                  <a:srgbClr val="232A33"/>
-                </a:solidFill>
-                <a:latin typeface="Calibri"/>
-              </a:rPr>
-              <a:t>Plus the COPR family (preference-style baselines): copr, copr_gold_injection, copr_gold_injection_anchored, copr_anchored.   </a:t>
-            </a:r>
-            <a:r>
-              <a:rPr sz="1200" i="1">
+            <a:pPr algn="l"/>
+            <a:r>
+              <a:rPr sz="1000">
                 <a:solidFill>
                   <a:srgbClr val="5C6670"/>
                 </a:solidFill>
                 <a:latin typeface="Calibri"/>
               </a:rPr>
-              <a:t>15 rounds × 200 facts × 2 seeds for new conditions; (c) at 1 seed from prior phases.</a:t>
-            </a:r>
+              <a:t>COMS 6998   ·   Jeremiah Mao, Mateo Juliani</a:t>
+            </a:r>
+          </a:p>
+          <a:p>
+            <a:pPr algn="r"/>
           </a:p>
         </p:txBody>
       </p:sp>
       <p:sp>
         <p:nvSpPr>
           <p:cNvPr id="8" name="TextBox 7"/>
-          <p:cNvSpPr txBox="1"/>
-          <p:nvPr/>
-        </p:nvSpPr>
-        <p:spPr>
-          <a:xfrm>
-            <a:off x="365760" y="6446520"/>
-            <a:ext cx="11430000" cy="320040"/>
-          </a:xfrm>
-          <a:prstGeom prst="rect">
-            <a:avLst/>
-          </a:prstGeom>
-          <a:noFill/>
-          <a:ln>
-            <a:noFill/>
-          </a:ln>
-        </p:spPr>
-        <p:txBody>
-          <a:bodyPr wrap="square" lIns="45720" rIns="45720" tIns="27432" bIns="27432">
-            <a:spAutoFit/>
-          </a:bodyPr>
-          <a:lstStyle/>
-          <a:p>
-            <a:pPr algn="l"/>
-            <a:r>
-              <a:rPr sz="1000">
-                <a:solidFill>
-                  <a:srgbClr val="5C6670"/>
-                </a:solidFill>
-                <a:latin typeface="Calibri"/>
-              </a:rPr>
-              <a:t>COMS 6998   ·   Jeremiah Mao, Mateo Juliani</a:t>
-            </a:r>
-          </a:p>
-          <a:p>
-            <a:pPr algn="r"/>
-          </a:p>
-        </p:txBody>
-      </p:sp>
-      <p:sp>
-        <p:nvSpPr>
-          <p:cNvPr id="9" name="TextBox 8"/>
           <p:cNvSpPr txBox="1"/>
           <p:nvPr/>
         </p:nvSpPr>

</xml_diff>

<commit_message>
tweak: deck audit pass — remove dead slide_renderings code, define abs F1 in Setup, fix paper-§4 ref to slide-relative, tighten Setup and slide-12 cross-refs
</commit_message>
<xml_diff>
--- a/paper_slides/synergy_deck.pptx
+++ b/paper_slides/synergy_deck.pptx
@@ -4440,7 +4440,7 @@
                 </a:solidFill>
                 <a:latin typeface="Calibri"/>
               </a:rPr>
-              <a:t>Plain mixed-format SFT widens the format gap to 0.100 vs single-format kl_reg_sft 0.072. Format mixing in continual training requires curriculum, unified rewriting, or — as we show in §4 — a preservation-side regularizer paired with K=5 augmentation on the injection side.</a:t>
+              <a:t>Plain mixed-format SFT widens the format gap to 0.100 vs single-format kl_reg_sft 0.072. Format mixing in continual training requires curriculum, unified rewriting, or — as the slide-8 result shows — a preservation-side regularizer paired with K=5 augmentation on the injection side.</a:t>
             </a:r>
           </a:p>
         </p:txBody>
@@ -4656,7 +4656,7 @@
                 </a:solidFill>
                 <a:latin typeface="Calibri"/>
               </a:rPr>
-              <a:t>KL preservation is computed against a frozen pre-round reference on the same task prompt   </a:t>
+              <a:t>The KL anchor (slide 7) is evaluated on a held-out task prompt   </a:t>
             </a:r>
             <a:r>
               <a:rPr sz="1200" i="1">
@@ -7628,14 +7628,14 @@
           <a:p>
             <a:pPr>
               <a:lnSpc>
-                <a:spcPct val="118000"/>
+                <a:spcPct val="113000"/>
               </a:lnSpc>
               <a:spcAft>
                 <a:spcPts val="600"/>
               </a:spcAft>
             </a:pPr>
             <a:r>
-              <a:rPr sz="1600" b="1">
+              <a:rPr sz="1500" b="1">
                 <a:solidFill>
                   <a:srgbClr val="1F4E90"/>
                 </a:solidFill>
@@ -7644,26 +7644,26 @@
               <a:t>•  </a:t>
             </a:r>
             <a:r>
-              <a:rPr sz="1600">
+              <a:rPr sz="1500">
                 <a:solidFill>
                   <a:srgbClr val="232A33"/>
                 </a:solidFill>
                 <a:latin typeface="Calibri"/>
               </a:rPr>
-              <a:t>Backbone:  Qwen3-4B-Instruct-2507, task-tuned via LoRA (r=32 / α=64) on FNSPID financial news with a pre-2022 cutoff. The base model emits QD sub-queries — see slide 3.</a:t>
+              <a:t>Backbone:  Qwen3-4B-Instruct-2507, task-tuned via LoRA (r=32 / α=64) on FNSPID financial news with a pre-2022 cutoff. The base model is the QD decomposer from slide 3.</a:t>
             </a:r>
           </a:p>
           <a:p>
             <a:pPr>
               <a:lnSpc>
-                <a:spcPct val="118000"/>
+                <a:spcPct val="113000"/>
               </a:lnSpc>
               <a:spcAft>
                 <a:spcPts val="600"/>
               </a:spcAft>
             </a:pPr>
             <a:r>
-              <a:rPr sz="1600" b="1">
+              <a:rPr sz="1500" b="1">
                 <a:solidFill>
                   <a:srgbClr val="1F4E90"/>
                 </a:solidFill>
@@ -7672,7 +7672,7 @@
               <a:t>•  </a:t>
             </a:r>
             <a:r>
-              <a:rPr sz="1600">
+              <a:rPr sz="1500">
                 <a:solidFill>
                   <a:srgbClr val="232A33"/>
                 </a:solidFill>
@@ -7684,14 +7684,14 @@
           <a:p>
             <a:pPr>
               <a:lnSpc>
-                <a:spcPct val="118000"/>
+                <a:spcPct val="113000"/>
               </a:lnSpc>
               <a:spcAft>
                 <a:spcPts val="600"/>
               </a:spcAft>
             </a:pPr>
             <a:r>
-              <a:rPr sz="1600" b="1">
+              <a:rPr sz="1500" b="1">
                 <a:solidFill>
                   <a:srgbClr val="1F4E90"/>
                 </a:solidFill>
@@ -7700,7 +7700,7 @@
               <a:t>•  </a:t>
             </a:r>
             <a:r>
-              <a:rPr sz="1600">
+              <a:rPr sz="1500">
                 <a:solidFill>
                   <a:srgbClr val="232A33"/>
                 </a:solidFill>
@@ -7712,14 +7712,14 @@
           <a:p>
             <a:pPr>
               <a:lnSpc>
-                <a:spcPct val="118000"/>
+                <a:spcPct val="113000"/>
               </a:lnSpc>
               <a:spcAft>
                 <a:spcPts val="600"/>
               </a:spcAft>
             </a:pPr>
             <a:r>
-              <a:rPr sz="1600" b="1">
+              <a:rPr sz="1500" b="1">
                 <a:solidFill>
                   <a:srgbClr val="1F4E90"/>
                 </a:solidFill>
@@ -7728,26 +7728,26 @@
               <a:t>•  </a:t>
             </a:r>
             <a:r>
-              <a:rPr sz="1600">
+              <a:rPr sz="1500">
                 <a:solidFill>
                   <a:srgbClr val="232A33"/>
                 </a:solidFill>
                 <a:latin typeface="Calibri"/>
               </a:rPr>
-              <a:t>Industrial pattern:  LoRA + LoRA (LoRA-tuned base + LoRA continual updates) is the dominant customer-facing fine-tuning primitive on AWS Bedrock, Together AI, Fireworks, and Vertex AI's open-model garden — so the setting matches production practice, not an academic special case.</a:t>
+              <a:t>Industrial pattern:  LoRA + LoRA (LoRA-tuned base + LoRA continual updates) is the dominant customer-facing fine-tuning primitive on AWS Bedrock, Together AI, Fireworks, and Vertex AI's open-model garden — the setting matches production practice, not an academic special case.</a:t>
             </a:r>
           </a:p>
           <a:p>
             <a:pPr>
               <a:lnSpc>
-                <a:spcPct val="118000"/>
+                <a:spcPct val="113000"/>
               </a:lnSpc>
               <a:spcAft>
                 <a:spcPts val="600"/>
               </a:spcAft>
             </a:pPr>
             <a:r>
-              <a:rPr sz="1600" b="1">
+              <a:rPr sz="1500" b="1">
                 <a:solidFill>
                   <a:srgbClr val="1F4E90"/>
                 </a:solidFill>
@@ -7756,13 +7756,13 @@
               <a:t>•  </a:t>
             </a:r>
             <a:r>
-              <a:rPr sz="1600">
+              <a:rPr sz="1500">
                 <a:solidFill>
                   <a:srgbClr val="232A33"/>
                 </a:solidFill>
                 <a:latin typeface="Calibri"/>
               </a:rPr>
-              <a:t>Evaluation is behavioral (token-F1 of greedy generation vs gold) — across the COPR family, hidden-state cosine proximity does not predict cross-format behavioral availability, so we don't rely on geometric proxies.</a:t>
+              <a:t>Headline metric (abs F1):  for each fact, the model is probed with 5 paraphrased questions; abs F1 = mean token-F1 of the model's greedy generation against the gold object string, averaged over 200 facts × 5 paraphrases per round. Two guardrail metrics (preservation R@10, locality F1) on slide 10. Across the COPR family we found hidden-state geometry does NOT predict behavioral F1 — so we report only behavioral numbers.</a:t>
             </a:r>
           </a:p>
         </p:txBody>

</xml_diff>

<commit_message>
tweak: deck — define π and θ notation on Method slide
</commit_message>
<xml_diff>
--- a/paper_slides/synergy_deck.pptx
+++ b/paper_slides/synergy_deck.pptx
@@ -8339,6 +8339,22 @@
               <a:t>The KL term is the anchor.  Whether/how it is added defines the 5 conditions below.</a:t>
             </a:r>
           </a:p>
+          <a:p>
+            <a:pPr algn="ctr">
+              <a:spcBef>
+                <a:spcPts val="200"/>
+              </a:spcBef>
+            </a:pPr>
+            <a:r>
+              <a:rPr sz="1000" i="1">
+                <a:solidFill>
+                  <a:srgbClr val="5C6670"/>
+                </a:solidFill>
+                <a:latin typeface="Calibri"/>
+              </a:rPr>
+              <a:t>π = the model's next-token distribution.   θ = LoRA adapter weights (trained).   π_θ = live model.   π_ref⁽ʳ⁾ = frozen snapshot at start of round r.</a:t>
+            </a:r>
+          </a:p>
         </p:txBody>
       </p:sp>
       <p:graphicFrame>

</xml_diff>

<commit_message>
tweak: deck — show worked token-F1 example on Headline slide
</commit_message>
<xml_diff>
--- a/paper_slides/synergy_deck.pptx
+++ b/paper_slides/synergy_deck.pptx
@@ -9531,14 +9531,18 @@
         <p:spPr>
           <a:xfrm>
             <a:off x="548640" y="3749039"/>
-            <a:ext cx="5852160" cy="457200"/>
+            <a:ext cx="5852160" cy="2194560"/>
           </a:xfrm>
           <a:prstGeom prst="rect">
             <a:avLst/>
           </a:prstGeom>
-          <a:noFill/>
-          <a:ln>
-            <a:noFill/>
+          <a:solidFill>
+            <a:srgbClr val="F7F9FC"/>
+          </a:solidFill>
+          <a:ln w="12700">
+            <a:solidFill>
+              <a:srgbClr val="CFD8E3"/>
+            </a:solidFill>
           </a:ln>
         </p:spPr>
         <p:txBody>
@@ -9548,13 +9552,117 @@
           <a:lstStyle/>
           <a:p>
             <a:r>
-              <a:rPr sz="1200" i="1">
+              <a:rPr sz="1100" b="1">
+                <a:solidFill>
+                  <a:srgbClr val="1F4E90"/>
+                </a:solidFill>
+                <a:latin typeface="Calibri"/>
+              </a:rPr>
+              <a:t>How abs F1 is computed (per probe):  </a:t>
+            </a:r>
+            <a:r>
+              <a:rPr sz="1100">
+                <a:solidFill>
+                  <a:srgbClr val="232A33"/>
+                </a:solidFill>
+                <a:latin typeface="Calibri"/>
+              </a:rPr>
+              <a:t>token-level F1 between the greedy generation and gold object string.</a:t>
+            </a:r>
+          </a:p>
+          <a:p>
+            <a:pPr>
+              <a:spcBef>
+                <a:spcPts val="400"/>
+              </a:spcBef>
+            </a:pPr>
+            <a:r>
+              <a:rPr sz="1000">
                 <a:solidFill>
                   <a:srgbClr val="5C6670"/>
                 </a:solidFill>
-                <a:latin typeface="Calibri"/>
-              </a:rPr>
-              <a:t>Round-15 absorption F1 across the 2×2 ablation</a:t>
+                <a:latin typeface="Consolas"/>
+              </a:rPr>
+              <a:t>gen = </a:t>
+            </a:r>
+            <a:r>
+              <a:rPr sz="1000">
+                <a:solidFill>
+                  <a:srgbClr val="232A33"/>
+                </a:solidFill>
+                <a:latin typeface="Consolas"/>
+              </a:rPr>
+              <a:t>"Acme Corp's 2025 revenue was $4.2B"</a:t>
+            </a:r>
+            <a:r>
+              <a:rPr sz="1000">
+                <a:solidFill>
+                  <a:srgbClr val="5C6670"/>
+                </a:solidFill>
+                <a:latin typeface="Consolas"/>
+              </a:rPr>
+              <a:t>   →   tokens {Acme, Corp's, 2025, revenue, was, $4.2B}   (6)</a:t>
+            </a:r>
+          </a:p>
+          <a:p>
+            <a:r>
+              <a:rPr sz="1000">
+                <a:solidFill>
+                  <a:srgbClr val="5C6670"/>
+                </a:solidFill>
+                <a:latin typeface="Consolas"/>
+              </a:rPr>
+              <a:t>gold = </a:t>
+            </a:r>
+            <a:r>
+              <a:rPr sz="1000">
+                <a:solidFill>
+                  <a:srgbClr val="232A33"/>
+                </a:solidFill>
+                <a:latin typeface="Consolas"/>
+              </a:rPr>
+              <a:t>"$4.2B"</a:t>
+            </a:r>
+            <a:r>
+              <a:rPr sz="1000">
+                <a:solidFill>
+                  <a:srgbClr val="5C6670"/>
+                </a:solidFill>
+                <a:latin typeface="Consolas"/>
+              </a:rPr>
+              <a:t>                                     →   tokens {$4.2B}              (1)</a:t>
+            </a:r>
+          </a:p>
+          <a:p>
+            <a:pPr>
+              <a:spcBef>
+                <a:spcPts val="200"/>
+              </a:spcBef>
+            </a:pPr>
+            <a:r>
+              <a:rPr sz="1000">
+                <a:solidFill>
+                  <a:srgbClr val="232A33"/>
+                </a:solidFill>
+                <a:latin typeface="Consolas"/>
+              </a:rPr>
+              <a:t>overlap {$4.2B}:   precision = 1/6 = 0.167,   recall = 1/1 = 1.0,   F1 = 2·P·R / (P+R) = 0.286</a:t>
+            </a:r>
+          </a:p>
+          <a:p>
+            <a:pPr>
+              <a:spcBef>
+                <a:spcPts val="400"/>
+              </a:spcBef>
+            </a:pPr>
+            <a:r>
+              <a:rPr sz="1000" i="1">
+                <a:solidFill>
+                  <a:srgbClr val="5C6670"/>
+                </a:solidFill>
+                <a:latin typeface="Calibri"/>
+              </a:rPr>
+              <a:t>abs F1 = mean of the per-probe F1 across 200 facts × 5 paraphrased probes per round.   Δ values are absolute differences (percentage points).</a:t>
             </a:r>
           </a:p>
         </p:txBody>

</xml_diff>

<commit_message>
task: deck — replace cryptic (a)/(b)/(c)/(d)/(e) labels with descriptive names everywhere
</commit_message>
<xml_diff>
--- a/paper_slides/synergy_deck.pptx
+++ b/paper_slides/synergy_deck.pptx
@@ -3575,7 +3575,7 @@
                           </a:solidFill>
                           <a:latin typeface="Calibri"/>
                         </a:rPr>
-                        <a:t>(a)  naive_sft</a:t>
+                        <a:t>naive SFT  (K=1, no KL)</a:t>
                       </a:r>
                     </a:p>
                   </a:txBody>
@@ -3669,7 +3669,7 @@
                           </a:solidFill>
                           <a:latin typeface="Calibri"/>
                         </a:rPr>
-                        <a:t>(b)  aug_sft_k5</a:t>
+                        <a:t>K=5 only  (K=5, no KL)</a:t>
                       </a:r>
                     </a:p>
                   </a:txBody>
@@ -3763,7 +3763,7 @@
                           </a:solidFill>
                           <a:latin typeface="Calibri"/>
                         </a:rPr>
-                        <a:t>(c)  kl_reg_sft</a:t>
+                        <a:t>KL only  (K=1, K=1 KL)</a:t>
                       </a:r>
                     </a:p>
                   </a:txBody>
@@ -3857,7 +3857,7 @@
                           </a:solidFill>
                           <a:latin typeface="Calibri"/>
                         </a:rPr>
-                        <a:t>(d)  aug_kl_k1</a:t>
+                        <a:t>K=5 + KL  (K=5, K=1 KL)</a:t>
                       </a:r>
                     </a:p>
                   </a:txBody>
@@ -3951,7 +3951,7 @@
                           </a:solidFill>
                           <a:latin typeface="Calibri"/>
                         </a:rPr>
-                        <a:t>(e)  dsae_lite</a:t>
+                        <a:t>K=5 + K=5 KL  (symmetric)</a:t>
                       </a:r>
                     </a:p>
                   </a:txBody>
@@ -4724,7 +4724,7 @@
                 </a:solidFill>
                 <a:latin typeface="Calibri"/>
               </a:rPr>
-              <a:t>conditions (c), (d)</a:t>
+              <a:t>used by KL only and K=5 + KL</a:t>
             </a:r>
           </a:p>
           <a:p>
@@ -4831,7 +4831,7 @@
                 </a:solidFill>
                 <a:latin typeface="Calibri"/>
               </a:rPr>
-              <a:t>condition (e)</a:t>
+              <a:t>used by K=5 + K=5 KL (the symmetric extension)</a:t>
             </a:r>
           </a:p>
           <a:p>
@@ -5002,7 +5002,7 @@
         <p:spPr>
           <a:xfrm>
             <a:off x="457200" y="3886200"/>
-            <a:ext cx="5486400" cy="914400"/>
+            <a:ext cx="5486400" cy="1280160"/>
           </a:xfrm>
           <a:prstGeom prst="rect">
             <a:avLst/>
@@ -5024,13 +5024,13 @@
           <a:p>
             <a:pPr algn="ctr"/>
             <a:r>
-              <a:rPr sz="2200" b="1">
-                <a:solidFill>
-                  <a:srgbClr val="C0392B"/>
-                </a:solidFill>
-                <a:latin typeface="Calibri"/>
-              </a:rPr>
-              <a:t>(e) − (d)  =  −0.006</a:t>
+              <a:rPr sz="1400" b="1">
+                <a:solidFill>
+                  <a:srgbClr val="232A33"/>
+                </a:solidFill>
+                <a:latin typeface="Calibri"/>
+              </a:rPr>
+              <a:t>K=5 + K=5 KL   −   K=5 + KL</a:t>
             </a:r>
           </a:p>
           <a:p>
@@ -5040,13 +5040,29 @@
               </a:spcBef>
             </a:pPr>
             <a:r>
+              <a:rPr sz="2000" b="1">
+                <a:solidFill>
+                  <a:srgbClr val="C0392B"/>
+                </a:solidFill>
+                <a:latin typeface="Calibri"/>
+              </a:rPr>
+              <a:t>=   −0.006   at round 15</a:t>
+            </a:r>
+          </a:p>
+          <a:p>
+            <a:pPr algn="ctr">
+              <a:spcBef>
+                <a:spcPts val="200"/>
+              </a:spcBef>
+            </a:pPr>
+            <a:r>
               <a:rPr sz="1200" i="1">
                 <a:solidFill>
                   <a:srgbClr val="232A33"/>
                 </a:solidFill>
                 <a:latin typeface="Calibri"/>
               </a:rPr>
-              <a:t>K=5 on the preservation side adds nothing</a:t>
+              <a:t>adding K=5 to the preservation side adds nothing</a:t>
             </a:r>
           </a:p>
         </p:txBody>
@@ -5409,7 +5425,7 @@
                 </a:solidFill>
                 <a:latin typeface="Calibri"/>
               </a:rPr>
-              <a:t>( aug_kl_k1 — condition (d) )</a:t>
+              <a:t>( K=5 + KL  =  aug_kl_k1 )</a:t>
             </a:r>
           </a:p>
         </p:txBody>
@@ -5836,7 +5852,7 @@
                 </a:solidFill>
                 <a:latin typeface="Calibri"/>
               </a:rPr>
-              <a:t>Two seeds for the headline cells, one calibration seed. (e) vs (d) null is robust under conservative non-parametric intervals; a 3rd seed is in progress and would tighten bounds.</a:t>
+              <a:t>Two seeds for the headline cells, one calibration seed. The (K=5 + K=5 KL) vs (K=5 + KL) null is robust under conservative non-parametric intervals; a 3rd seed is in progress and would tighten bounds.</a:t>
             </a:r>
           </a:p>
           <a:p>
@@ -5948,7 +5964,7 @@
                 </a:solidFill>
                 <a:latin typeface="Calibri"/>
               </a:rPr>
-              <a:t>Setting matches industrial practice but transfer beyond LoRA is principled, not validated. The synergy direction should extend to full FT; the (e) vs (d) null specifically may not.</a:t>
+              <a:t>Setting matches industrial practice but transfer beyond LoRA is principled, not validated. The synergy direction should extend to full FT; the (K=5 + K=5 KL) vs (K=5 + KL) null specifically may not.</a:t>
             </a:r>
           </a:p>
         </p:txBody>
@@ -8489,7 +8505,8 @@
                           </a:solidFill>
                           <a:latin typeface="Calibri"/>
                         </a:rPr>
-                        <a:t>(a)  naive_sft</a:t>
+                        <a:t>naive SFT       
+naive_sft</a:t>
                       </a:r>
                     </a:p>
                   </a:txBody>
@@ -8567,7 +8584,8 @@
                           </a:solidFill>
                           <a:latin typeface="Calibri"/>
                         </a:rPr>
-                        <a:t>(b)  aug_sft_k5</a:t>
+                        <a:t>K=5 only        
+aug_sft_k5</a:t>
                       </a:r>
                     </a:p>
                   </a:txBody>
@@ -8645,7 +8663,8 @@
                           </a:solidFill>
                           <a:latin typeface="Calibri"/>
                         </a:rPr>
-                        <a:t>(c)  kl_reg_sft</a:t>
+                        <a:t>KL only         
+kl_reg_sft</a:t>
                       </a:r>
                     </a:p>
                   </a:txBody>
@@ -8723,7 +8742,8 @@
                           </a:solidFill>
                           <a:latin typeface="Calibri"/>
                         </a:rPr>
-                        <a:t>(d)  aug_kl_k1</a:t>
+                        <a:t>K=5 + KL        
+aug_kl_k1</a:t>
                       </a:r>
                     </a:p>
                   </a:txBody>
@@ -8817,7 +8837,8 @@
                           </a:solidFill>
                           <a:latin typeface="Calibri"/>
                         </a:rPr>
-                        <a:t>(e)  dsae_lite</a:t>
+                        <a:t>K=5 + K=5 KL    
+dsae_lite</a:t>
                       </a:r>
                     </a:p>
                   </a:txBody>
@@ -8930,7 +8951,7 @@
                 </a:solidFill>
                 <a:latin typeface="Calibri"/>
               </a:rPr>
-              <a:t>On the injection side, K = paraphrastic surface forms per fact (Allen-Zhu &amp; Li 2023): K=1 = QA only,  K=5 = QA + QD + declarative + instruction + narrative.   On the preservation side, K = instruction framings of the same task prompt (used in (e) only — see slide 12).   Plus the COPR family — 4 preference-style baselines, evaluated separately (slide 11).</a:t>
+              <a:t>On the injection side, K = paraphrastic surface forms per fact (Allen-Zhu &amp; Li 2023): K=1 = QA only,  K=5 = QA + QD + declarative + instruction + narrative.   On the preservation side, K = instruction framings of the same task prompt (used in K=5 + K=5 KL only — see slide 12).   Plus the COPR family — 4 preference-style baselines, evaluated separately (slide 11).</a:t>
             </a:r>
           </a:p>
         </p:txBody>
@@ -9263,14 +9284,14 @@
                     <a:p>
                       <a:pPr algn="ctr"/>
                       <a:r>
-                        <a:rPr sz="1400" b="0" i="0">
+                        <a:rPr sz="1200" b="0" i="0">
                           <a:solidFill>
                             <a:srgbClr val="232A33"/>
                           </a:solidFill>
                           <a:latin typeface="Calibri"/>
                         </a:rPr>
                         <a:t>0.089
-(a)</a:t>
+naive SFT</a:t>
                       </a:r>
                     </a:p>
                   </a:txBody>
@@ -9287,14 +9308,14 @@
                     <a:p>
                       <a:pPr algn="ctr"/>
                       <a:r>
-                        <a:rPr sz="1400" b="0" i="0">
+                        <a:rPr sz="1200" b="0" i="0">
                           <a:solidFill>
                             <a:srgbClr val="232A33"/>
                           </a:solidFill>
                           <a:latin typeface="Calibri"/>
                         </a:rPr>
                         <a:t>0.118
-(c)</a:t>
+KL only</a:t>
                       </a:r>
                     </a:p>
                   </a:txBody>
@@ -9359,14 +9380,14 @@
                     <a:p>
                       <a:pPr algn="ctr"/>
                       <a:r>
-                        <a:rPr sz="1400" b="0" i="0">
+                        <a:rPr sz="1200" b="0" i="0">
                           <a:solidFill>
                             <a:srgbClr val="232A33"/>
                           </a:solidFill>
                           <a:latin typeface="Calibri"/>
                         </a:rPr>
                         <a:t>0.125
-(b)</a:t>
+K=5 only</a:t>
                       </a:r>
                     </a:p>
                   </a:txBody>
@@ -9383,14 +9404,14 @@
                     <a:p>
                       <a:pPr algn="ctr"/>
                       <a:r>
-                        <a:rPr sz="1800" b="1" i="0">
+                        <a:rPr sz="1500" b="1" i="0">
                           <a:solidFill>
                             <a:srgbClr val="1F8E4F"/>
                           </a:solidFill>
                           <a:latin typeface="Calibri"/>
                         </a:rPr>
                         <a:t>0.411
-(d)  ★</a:t>
+K=5 + KL  ★</a:t>
                       </a:r>
                     </a:p>
                   </a:txBody>
@@ -9731,7 +9752,7 @@
                 </a:solidFill>
                 <a:latin typeface="Calibri"/>
               </a:rPr>
-              <a:t>naive SFT  (a):  </a:t>
+              <a:t>naive SFT  (K=1, no KL):  </a:t>
             </a:r>
             <a:r>
               <a:rPr sz="2000" b="1">
@@ -9749,7 +9770,7 @@
                 </a:solidFill>
                 <a:latin typeface="Calibri"/>
               </a:rPr>
-              <a:t>   K=1 baseline</a:t>
+              <a:t>   baseline</a:t>
             </a:r>
           </a:p>
           <a:p>
@@ -9765,7 +9786,7 @@
                 </a:solidFill>
                 <a:latin typeface="Calibri"/>
               </a:rPr>
-              <a:t>+ 5× paraphrastic data  (b):  </a:t>
+              <a:t>K=5 only  (K=5, no KL):  </a:t>
             </a:r>
             <a:r>
               <a:rPr sz="2000" b="1">
@@ -9799,7 +9820,7 @@
                 </a:solidFill>
                 <a:latin typeface="Calibri"/>
               </a:rPr>
-              <a:t>naive SFT + KL preservation  (c):  </a:t>
+              <a:t>KL only  (K=1, K=1 KL):  </a:t>
             </a:r>
             <a:r>
               <a:rPr sz="2000" b="1">
@@ -9833,7 +9854,7 @@
                 </a:solidFill>
                 <a:latin typeface="Calibri"/>
               </a:rPr>
-              <a:t>5× data + KL  (d):  </a:t>
+              <a:t>K=5 + KL  (K=5, K=1 KL):  </a:t>
             </a:r>
             <a:r>
               <a:rPr sz="2000" b="1">
@@ -10277,13 +10298,14 @@
                     <a:p>
                       <a:pPr algn="l"/>
                       <a:r>
-                        <a:rPr sz="1500" b="0" i="0">
+                        <a:rPr sz="1300" b="0" i="0">
                           <a:solidFill>
                             <a:srgbClr val="232A33"/>
                           </a:solidFill>
                           <a:latin typeface="Calibri"/>
                         </a:rPr>
-                        <a:t>(c) − (a):  KL added on top of K=1 data</a:t>
+                        <a:t>KL only  −  naive SFT
+(KL added on top of K=1 data)</a:t>
                       </a:r>
                     </a:p>
                   </a:txBody>
@@ -10300,7 +10322,7 @@
                     <a:p>
                       <a:pPr algn="ctr"/>
                       <a:r>
-                        <a:rPr sz="1500" b="0" i="0">
+                        <a:rPr sz="1400" b="0" i="0">
                           <a:solidFill>
                             <a:srgbClr val="232A33"/>
                           </a:solidFill>
@@ -10371,13 +10393,14 @@
                     <a:p>
                       <a:pPr algn="l"/>
                       <a:r>
-                        <a:rPr sz="1500" b="1" i="0">
+                        <a:rPr sz="1300" b="1" i="0">
                           <a:solidFill>
                             <a:srgbClr val="232A33"/>
                           </a:solidFill>
                           <a:latin typeface="Calibri"/>
                         </a:rPr>
-                        <a:t>(d) − (b):  KL added on top of K=5 data</a:t>
+                        <a:t>K=5 + KL  −  K=5 only
+(KL added on top of K=5 data)</a:t>
                       </a:r>
                     </a:p>
                   </a:txBody>
@@ -10394,7 +10417,7 @@
                     <a:p>
                       <a:pPr algn="ctr"/>
                       <a:r>
-                        <a:rPr sz="1500" b="0" i="0">
+                        <a:rPr sz="1400" b="0" i="0">
                           <a:solidFill>
                             <a:srgbClr val="232A33"/>
                           </a:solidFill>
@@ -10522,7 +10545,7 @@
                 </a:solidFill>
                 <a:latin typeface="Calibri"/>
               </a:rPr>
-              <a:t>This is the signature of an interaction effect, not a data-volume effect.  More data alone gives +0.036 (b) − (a); more data plus KL gives +0.322.</a:t>
+              <a:t>This is the signature of an interaction effect, not a data-volume effect.  More data alone (K=5 only − naive SFT) gives +0.036; more data plus KL (K=5 + KL − naive SFT) gives +0.322.</a:t>
             </a:r>
           </a:p>
         </p:txBody>

</xml_diff>

<commit_message>
task: deck Setup slide — add data-isolation + no-update-baseline bullets so the audience knows facts are genuinely novel
</commit_message>
<xml_diff>
--- a/paper_slides/synergy_deck.pptx
+++ b/paper_slides/synergy_deck.pptx
@@ -7625,8 +7625,8 @@
         </p:nvSpPr>
         <p:spPr>
           <a:xfrm>
-            <a:off x="548640" y="1051560"/>
-            <a:ext cx="11064240" cy="5120640"/>
+            <a:off x="548640" y="960120"/>
+            <a:ext cx="11064240" cy="5349240"/>
           </a:xfrm>
           <a:prstGeom prst="rect">
             <a:avLst/>
@@ -7644,14 +7644,14 @@
           <a:p>
             <a:pPr>
               <a:lnSpc>
-                <a:spcPct val="113000"/>
+                <a:spcPct val="110000"/>
               </a:lnSpc>
               <a:spcAft>
                 <a:spcPts val="600"/>
               </a:spcAft>
             </a:pPr>
             <a:r>
-              <a:rPr sz="1500" b="1">
+              <a:rPr sz="1300" b="1">
                 <a:solidFill>
                   <a:srgbClr val="1F4E90"/>
                 </a:solidFill>
@@ -7660,7 +7660,7 @@
               <a:t>•  </a:t>
             </a:r>
             <a:r>
-              <a:rPr sz="1500">
+              <a:rPr sz="1300">
                 <a:solidFill>
                   <a:srgbClr val="232A33"/>
                 </a:solidFill>
@@ -7672,14 +7672,14 @@
           <a:p>
             <a:pPr>
               <a:lnSpc>
-                <a:spcPct val="113000"/>
+                <a:spcPct val="110000"/>
               </a:lnSpc>
               <a:spcAft>
                 <a:spcPts val="600"/>
               </a:spcAft>
             </a:pPr>
             <a:r>
-              <a:rPr sz="1500" b="1">
+              <a:rPr sz="1300" b="1">
                 <a:solidFill>
                   <a:srgbClr val="1F4E90"/>
                 </a:solidFill>
@@ -7688,7 +7688,7 @@
               <a:t>•  </a:t>
             </a:r>
             <a:r>
-              <a:rPr sz="1500">
+              <a:rPr sz="1300">
                 <a:solidFill>
                   <a:srgbClr val="232A33"/>
                 </a:solidFill>
@@ -7700,14 +7700,14 @@
           <a:p>
             <a:pPr>
               <a:lnSpc>
-                <a:spcPct val="113000"/>
+                <a:spcPct val="110000"/>
               </a:lnSpc>
               <a:spcAft>
                 <a:spcPts val="600"/>
               </a:spcAft>
             </a:pPr>
             <a:r>
-              <a:rPr sz="1500" b="1">
+              <a:rPr sz="1300" b="1">
                 <a:solidFill>
                   <a:srgbClr val="1F4E90"/>
                 </a:solidFill>
@@ -7716,26 +7716,26 @@
               <a:t>•  </a:t>
             </a:r>
             <a:r>
-              <a:rPr sz="1500">
+              <a:rPr sz="1300">
                 <a:solidFill>
                   <a:srgbClr val="232A33"/>
                 </a:solidFill>
                 <a:latin typeface="Calibri"/>
               </a:rPr>
-              <a:t>Continual stream:  15 sequential rounds × 200 disjoint fact triples per round (3000 facts total), drawn from post-cutoff FNSPID.</a:t>
+              <a:t>Industrial pattern:  LoRA + LoRA (LoRA-tuned base + LoRA continual updates) is the dominant customer-facing fine-tuning primitive on AWS Bedrock, Together AI, Fireworks, and Vertex AI's open-model garden — the setting matches production practice, not an academic special case.</a:t>
             </a:r>
           </a:p>
           <a:p>
             <a:pPr>
               <a:lnSpc>
-                <a:spcPct val="113000"/>
+                <a:spcPct val="110000"/>
               </a:lnSpc>
               <a:spcAft>
                 <a:spcPts val="600"/>
               </a:spcAft>
             </a:pPr>
             <a:r>
-              <a:rPr sz="1500" b="1">
+              <a:rPr sz="1300" b="1">
                 <a:solidFill>
                   <a:srgbClr val="1F4E90"/>
                 </a:solidFill>
@@ -7744,26 +7744,26 @@
               <a:t>•  </a:t>
             </a:r>
             <a:r>
-              <a:rPr sz="1500">
+              <a:rPr sz="1300">
                 <a:solidFill>
                   <a:srgbClr val="232A33"/>
                 </a:solidFill>
                 <a:latin typeface="Calibri"/>
               </a:rPr>
-              <a:t>Industrial pattern:  LoRA + LoRA (LoRA-tuned base + LoRA continual updates) is the dominant customer-facing fine-tuning primitive on AWS Bedrock, Together AI, Fireworks, and Vertex AI's open-model garden — the setting matches production practice, not an academic special case.</a:t>
+              <a:t>Data isolation:  (i) task-tuning corpus (pre-2022 FNSPID) and edit corpus (post-cutoff FNSPID) are temporally separate;  (ii) 96,897 post-cutoff facts are partitioned into 15 disjoint rounds × 200 facts;  (iii) preservation R@10 uses a held-out QD test split (n=104) never seen during task tuning or editing;  (iv) K=5 templates are leak-free — gold answer never appears in any user/system prompt, only in the assistant target.</a:t>
             </a:r>
           </a:p>
           <a:p>
             <a:pPr>
               <a:lnSpc>
-                <a:spcPct val="113000"/>
+                <a:spcPct val="110000"/>
               </a:lnSpc>
               <a:spcAft>
                 <a:spcPts val="600"/>
               </a:spcAft>
             </a:pPr>
             <a:r>
-              <a:rPr sz="1500" b="1">
+              <a:rPr sz="1300" b="1">
                 <a:solidFill>
                   <a:srgbClr val="1F4E90"/>
                 </a:solidFill>
@@ -7772,13 +7772,41 @@
               <a:t>•  </a:t>
             </a:r>
             <a:r>
-              <a:rPr sz="1500">
+              <a:rPr sz="1300">
                 <a:solidFill>
                   <a:srgbClr val="232A33"/>
                 </a:solidFill>
                 <a:latin typeface="Calibri"/>
               </a:rPr>
-              <a:t>Headline metric (abs F1):  for each fact, the model is probed with 5 paraphrased questions; abs F1 = mean token-F1 of the model's greedy generation against the gold object string, averaged over 200 facts × 5 paraphrases per round. Two guardrail metrics (preservation R@10, locality F1) on slide 10. Across the COPR family we found hidden-state geometry does NOT predict behavioral F1 — so we report only behavioral numbers.</a:t>
+              <a:t>No-update baseline confirms edit facts are novel:  before any editing, Qwen3-4B-Instruct-2507 scores ~0.04 abs F1 on the eval probes — essentially zero. So a round-15 abs F1 of 0.411 is real lift from the editing procedure, not pretrained recall. (Caveat: we only fully isolate from the task-tuning corpus, not from the base model's web pretraining.)</a:t>
+            </a:r>
+          </a:p>
+          <a:p>
+            <a:pPr>
+              <a:lnSpc>
+                <a:spcPct val="110000"/>
+              </a:lnSpc>
+              <a:spcAft>
+                <a:spcPts val="600"/>
+              </a:spcAft>
+            </a:pPr>
+            <a:r>
+              <a:rPr sz="1300" b="1">
+                <a:solidFill>
+                  <a:srgbClr val="1F4E90"/>
+                </a:solidFill>
+                <a:latin typeface="Calibri"/>
+              </a:rPr>
+              <a:t>•  </a:t>
+            </a:r>
+            <a:r>
+              <a:rPr sz="1300">
+                <a:solidFill>
+                  <a:srgbClr val="232A33"/>
+                </a:solidFill>
+                <a:latin typeface="Calibri"/>
+              </a:rPr>
+              <a:t>Headline metric (abs F1):  token-F1 of greedy generation vs gold object, averaged over 200 facts × 5 paraphrased probes/round. Two guardrails (preservation R@10, locality F1) on slide 10. Across the COPR family hidden-state geometry does NOT predict behavioral F1 — so we report only behavioral numbers.</a:t>
             </a:r>
           </a:p>
         </p:txBody>

</xml_diff>

<commit_message>
task: post-cutoff QD demo — add bonus-eval slide (Alphabet/Gold/Arista) with content-vs-format honest finding; mirror in paper §7
</commit_message>
<xml_diff>
--- a/paper_slides/synergy_deck.pptx
+++ b/paper_slides/synergy_deck.pptx
@@ -20,6 +20,7 @@
     <p:sldId id="268" r:id="rId19"/>
     <p:sldId id="269" r:id="rId20"/>
     <p:sldId id="270" r:id="rId21"/>
+    <p:sldId id="271" r:id="rId22"/>
   </p:sldIdLst>
   <p:sldSz cx="12191695" cy="6858000" type="screen4x3"/>
   <p:notesSz cx="6858000" cy="9144000"/>
@@ -4146,7 +4147,7 @@
                 </a:solidFill>
                 <a:latin typeface="Calibri"/>
               </a:rPr>
-              <a:t>10 / 15</a:t>
+              <a:t>10 / 16</a:t>
             </a:r>
           </a:p>
         </p:txBody>
@@ -4519,7 +4520,7 @@
                 </a:solidFill>
                 <a:latin typeface="Calibri"/>
               </a:rPr>
-              <a:t>11 / 15</a:t>
+              <a:t>11 / 16</a:t>
             </a:r>
           </a:p>
         </p:txBody>
@@ -5251,7 +5252,7 @@
                 </a:solidFill>
                 <a:latin typeface="Calibri"/>
               </a:rPr>
-              <a:t>12 / 15</a:t>
+              <a:t>12 / 16</a:t>
             </a:r>
           </a:p>
         </p:txBody>
@@ -5351,7 +5352,7 @@
                 </a:solidFill>
                 <a:latin typeface="Calibri"/>
               </a:rPr>
-              <a:t>Recommendation</a:t>
+              <a:t>Bonus eval:  did edits actually change QD behavior on post-cutoff queries?</a:t>
             </a:r>
           </a:p>
         </p:txBody>
@@ -5364,82 +5365,8 @@
         </p:nvSpPr>
         <p:spPr>
           <a:xfrm>
-            <a:off x="731520" y="1188720"/>
-            <a:ext cx="10698480" cy="1554480"/>
-          </a:xfrm>
-          <a:prstGeom prst="rect">
-            <a:avLst/>
-          </a:prstGeom>
-          <a:solidFill>
-            <a:srgbClr val="E8F2E8"/>
-          </a:solidFill>
-          <a:ln w="12700">
-            <a:solidFill>
-              <a:srgbClr val="1F8E4F"/>
-            </a:solidFill>
-          </a:ln>
-        </p:spPr>
-        <p:txBody>
-          <a:bodyPr wrap="square" lIns="45720" rIns="45720" tIns="27432" bIns="27432">
-            <a:spAutoFit/>
-          </a:bodyPr>
-          <a:lstStyle/>
-          <a:p>
-            <a:pPr algn="ctr"/>
-            <a:r>
-              <a:rPr sz="2000" i="1">
-                <a:solidFill>
-                  <a:srgbClr val="232A33"/>
-                </a:solidFill>
-                <a:latin typeface="Calibri"/>
-              </a:rPr>
-              <a:t>For continual LoRA fact injection in task-tuned LLMs:</a:t>
-            </a:r>
-          </a:p>
-          <a:p>
-            <a:pPr algn="ctr">
-              <a:spcBef>
-                <a:spcPts val="800"/>
-              </a:spcBef>
-            </a:pPr>
-            <a:r>
-              <a:rPr sz="2200" b="1">
-                <a:solidFill>
-                  <a:srgbClr val="1F8E4F"/>
-                </a:solidFill>
-                <a:latin typeface="Calibri"/>
-              </a:rPr>
-              <a:t>K=5 paraphrastic augmentation on the injection side  +  K=1 KL preservation against a per-round frozen reference</a:t>
-            </a:r>
-          </a:p>
-          <a:p>
-            <a:pPr algn="ctr">
-              <a:spcBef>
-                <a:spcPts val="400"/>
-              </a:spcBef>
-            </a:pPr>
-            <a:r>
-              <a:rPr sz="1400" i="1">
-                <a:solidFill>
-                  <a:srgbClr val="5C6670"/>
-                </a:solidFill>
-                <a:latin typeface="Calibri"/>
-              </a:rPr>
-              <a:t>( K=5 + KL  =  aug_kl_k1 )</a:t>
-            </a:r>
-          </a:p>
-        </p:txBody>
-      </p:sp>
-      <p:sp>
-        <p:nvSpPr>
-          <p:cNvPr id="5" name="TextBox 4"/>
-          <p:cNvSpPr txBox="1"/>
-          <p:nvPr/>
-        </p:nvSpPr>
-        <p:spPr>
-          <a:xfrm>
-            <a:off x="548640" y="3017520"/>
-            <a:ext cx="11064240" cy="3291840"/>
+            <a:off x="457200" y="914400"/>
+            <a:ext cx="11247120" cy="640080"/>
           </a:xfrm>
           <a:prstGeom prst="rect">
             <a:avLst/>
@@ -5455,150 +5382,394 @@
           </a:bodyPr>
           <a:lstStyle/>
           <a:p>
+            <a:r>
+              <a:rPr sz="1200">
+                <a:solidFill>
+                  <a:srgbClr val="232A33"/>
+                </a:solidFill>
+                <a:latin typeface="Calibri"/>
+              </a:rPr>
+              <a:t>50 post-cutoff queries generated by Gemini from the injected fact triples. Each query is a 2026-era financial question whose ideal sub-query decomposition would retrieve facts the model was edited on. Below: 3 representative side-by-sides.</a:t>
+            </a:r>
+          </a:p>
+        </p:txBody>
+      </p:sp>
+      <p:sp>
+        <p:nvSpPr>
+          <p:cNvPr id="5" name="TextBox 4"/>
+          <p:cNvSpPr txBox="1"/>
+          <p:nvPr/>
+        </p:nvSpPr>
+        <p:spPr>
+          <a:xfrm>
+            <a:off x="457200" y="1691640"/>
+            <a:ext cx="3703320" cy="3108960"/>
+          </a:xfrm>
+          <a:prstGeom prst="rect">
+            <a:avLst/>
+          </a:prstGeom>
+          <a:solidFill>
+            <a:srgbClr val="F7F9FC"/>
+          </a:solidFill>
+          <a:ln w="12700">
+            <a:solidFill>
+              <a:srgbClr val="CFD8E3"/>
+            </a:solidFill>
+          </a:ln>
+        </p:spPr>
+        <p:txBody>
+          <a:bodyPr wrap="square" lIns="45720" rIns="45720" tIns="27432" bIns="27432">
+            <a:spAutoFit/>
+          </a:bodyPr>
+          <a:lstStyle/>
+          <a:p>
+            <a:r>
+              <a:rPr sz="1200" b="1">
+                <a:solidFill>
+                  <a:srgbClr val="0F2A57"/>
+                </a:solidFill>
+                <a:latin typeface="Calibri"/>
+              </a:rPr>
+              <a:t>Alphabet  (post-edit references Gemini 2.0)</a:t>
+            </a:r>
+          </a:p>
+          <a:p>
             <a:pPr>
-              <a:lnSpc>
-                <a:spcPct val="115000"/>
-              </a:lnSpc>
-              <a:spcAft>
-                <a:spcPts val="600"/>
-              </a:spcAft>
+              <a:spcBef>
+                <a:spcPts val="800"/>
+              </a:spcBef>
             </a:pPr>
             <a:r>
-              <a:rPr sz="1500" b="1">
-                <a:solidFill>
-                  <a:srgbClr val="1F4E90"/>
-                </a:solidFill>
-                <a:latin typeface="Calibri"/>
-              </a:rPr>
-              <a:t>•  </a:t>
-            </a:r>
-            <a:r>
-              <a:rPr sz="1500">
+              <a:rPr sz="1000" b="1">
+                <a:solidFill>
+                  <a:srgbClr val="5C6670"/>
+                </a:solidFill>
+                <a:latin typeface="Calibri"/>
+              </a:rPr>
+              <a:t>Pre-edit (no_update)</a:t>
+            </a:r>
+          </a:p>
+          <a:p>
+            <a:r>
+              <a:rPr sz="1000" i="1">
                 <a:solidFill>
                   <a:srgbClr val="232A33"/>
                 </a:solidFill>
                 <a:latin typeface="Calibri"/>
               </a:rPr>
-              <a:t>Use K=5 paraphrastic augmentation on the injection side. Don't rely on K=1 (single-format) injection alone.</a:t>
+              <a:t>DeepMind achieving notable milestones in 2023... Sundar Pichai left Alphabet in 2023...  [stale / hallucinated]</a:t>
             </a:r>
           </a:p>
           <a:p>
             <a:pPr>
-              <a:lnSpc>
-                <a:spcPct val="115000"/>
-              </a:lnSpc>
-              <a:spcAft>
-                <a:spcPts val="600"/>
-              </a:spcAft>
+              <a:spcBef>
+                <a:spcPts val="1000"/>
+              </a:spcBef>
             </a:pPr>
             <a:r>
-              <a:rPr sz="1500" b="1">
-                <a:solidFill>
-                  <a:srgbClr val="1F4E90"/>
-                </a:solidFill>
-                <a:latin typeface="Calibri"/>
-              </a:rPr>
-              <a:t>•  </a:t>
-            </a:r>
-            <a:r>
-              <a:rPr sz="1500">
+              <a:rPr sz="1000" b="1">
+                <a:solidFill>
+                  <a:srgbClr val="1F8E4F"/>
+                </a:solidFill>
+                <a:latin typeface="Calibri"/>
+              </a:rPr>
+              <a:t>Post-edit (K=5 + KL)</a:t>
+            </a:r>
+          </a:p>
+          <a:p>
+            <a:r>
+              <a:rPr sz="1000" i="1">
                 <a:solidFill>
                   <a:srgbClr val="232A33"/>
                 </a:solidFill>
                 <a:latin typeface="Calibri"/>
               </a:rPr>
-              <a:t>Pair it with standard K=1 KL preservation against a per-round frozen reference. Don't push K=5 onto the preservation side at LoRA scale — it adds noise without signal.</a:t>
+              <a:t>Alphabet introduced "Gemini 2.0" in the first half of 2023... AI-driven workforce optimization program...  [post-cutoff entity ✓]</a:t>
+            </a:r>
+          </a:p>
+        </p:txBody>
+      </p:sp>
+      <p:sp>
+        <p:nvSpPr>
+          <p:cNvPr id="6" name="TextBox 5"/>
+          <p:cNvSpPr txBox="1"/>
+          <p:nvPr/>
+        </p:nvSpPr>
+        <p:spPr>
+          <a:xfrm>
+            <a:off x="4251960" y="1691640"/>
+            <a:ext cx="3703320" cy="3108960"/>
+          </a:xfrm>
+          <a:prstGeom prst="rect">
+            <a:avLst/>
+          </a:prstGeom>
+          <a:solidFill>
+            <a:srgbClr val="F7F9FC"/>
+          </a:solidFill>
+          <a:ln w="12700">
+            <a:solidFill>
+              <a:srgbClr val="CFD8E3"/>
+            </a:solidFill>
+          </a:ln>
+        </p:spPr>
+        <p:txBody>
+          <a:bodyPr wrap="square" lIns="45720" rIns="45720" tIns="27432" bIns="27432">
+            <a:spAutoFit/>
+          </a:bodyPr>
+          <a:lstStyle/>
+          <a:p>
+            <a:r>
+              <a:rPr sz="1200" b="1">
+                <a:solidFill>
+                  <a:srgbClr val="0F2A57"/>
+                </a:solidFill>
+                <a:latin typeface="Calibri"/>
+              </a:rPr>
+              <a:t>Gold  (post-edit gives concrete post-cutoff price)</a:t>
             </a:r>
           </a:p>
           <a:p>
             <a:pPr>
-              <a:lnSpc>
-                <a:spcPct val="115000"/>
-              </a:lnSpc>
-              <a:spcAft>
-                <a:spcPts val="600"/>
-              </a:spcAft>
+              <a:spcBef>
+                <a:spcPts val="800"/>
+              </a:spcBef>
             </a:pPr>
             <a:r>
-              <a:rPr sz="1500" b="1">
-                <a:solidFill>
-                  <a:srgbClr val="1F4E90"/>
-                </a:solidFill>
-                <a:latin typeface="Calibri"/>
-              </a:rPr>
-              <a:t>•  </a:t>
-            </a:r>
-            <a:r>
-              <a:rPr sz="1500">
+              <a:rPr sz="1000" b="1">
+                <a:solidFill>
+                  <a:srgbClr val="5C6670"/>
+                </a:solidFill>
+                <a:latin typeface="Calibri"/>
+              </a:rPr>
+              <a:t>Pre-edit (no_update)</a:t>
+            </a:r>
+          </a:p>
+          <a:p>
+            <a:r>
+              <a:rPr sz="1000" i="1">
                 <a:solidFill>
                   <a:srgbClr val="232A33"/>
                 </a:solidFill>
                 <a:latin typeface="Calibri"/>
               </a:rPr>
-              <a:t>Don't use COPR for fact injection — the K-sample-all-wrong pathology breaks the assumption that the candidate pool contains usable signal.</a:t>
+              <a:t>Gold trading above the 200-day moving average... bullish technical setup.  [generic]</a:t>
             </a:r>
           </a:p>
           <a:p>
             <a:pPr>
-              <a:lnSpc>
-                <a:spcPct val="115000"/>
-              </a:lnSpc>
-              <a:spcAft>
-                <a:spcPts val="600"/>
-              </a:spcAft>
+              <a:spcBef>
+                <a:spcPts val="1000"/>
+              </a:spcBef>
             </a:pPr>
             <a:r>
-              <a:rPr sz="1500" b="1">
-                <a:solidFill>
-                  <a:srgbClr val="1F4E90"/>
-                </a:solidFill>
-                <a:latin typeface="Calibri"/>
-              </a:rPr>
-              <a:t>•  </a:t>
-            </a:r>
-            <a:r>
-              <a:rPr sz="1500">
+              <a:rPr sz="1000" b="1">
+                <a:solidFill>
+                  <a:srgbClr val="1F8E4F"/>
+                </a:solidFill>
+                <a:latin typeface="Calibri"/>
+              </a:rPr>
+              <a:t>Post-edit (K=5 + KL)</a:t>
+            </a:r>
+          </a:p>
+          <a:p>
+            <a:r>
+              <a:rPr sz="1000" i="1">
                 <a:solidFill>
                   <a:srgbClr val="232A33"/>
                 </a:solidFill>
                 <a:latin typeface="Calibri"/>
               </a:rPr>
-              <a:t>Don't use OOD regularization at K=2 environments — theoretically degenerate per Arjovsky / Rosenfeld / Ahuja, empirically null.</a:t>
+              <a:t>50-day moving average at $1995... pivotal technical level for near-term price action.  [post-cutoff fact ✓]</a:t>
+            </a:r>
+          </a:p>
+        </p:txBody>
+      </p:sp>
+      <p:sp>
+        <p:nvSpPr>
+          <p:cNvPr id="7" name="TextBox 6"/>
+          <p:cNvSpPr txBox="1"/>
+          <p:nvPr/>
+        </p:nvSpPr>
+        <p:spPr>
+          <a:xfrm>
+            <a:off x="8046720" y="1691640"/>
+            <a:ext cx="3703320" cy="3108960"/>
+          </a:xfrm>
+          <a:prstGeom prst="rect">
+            <a:avLst/>
+          </a:prstGeom>
+          <a:solidFill>
+            <a:srgbClr val="F7F9FC"/>
+          </a:solidFill>
+          <a:ln w="12700">
+            <a:solidFill>
+              <a:srgbClr val="CFD8E3"/>
+            </a:solidFill>
+          </a:ln>
+        </p:spPr>
+        <p:txBody>
+          <a:bodyPr wrap="square" lIns="45720" rIns="45720" tIns="27432" bIns="27432">
+            <a:spAutoFit/>
+          </a:bodyPr>
+          <a:lstStyle/>
+          <a:p>
+            <a:r>
+              <a:rPr sz="1200" b="1">
+                <a:solidFill>
+                  <a:srgbClr val="0F2A57"/>
+                </a:solidFill>
+                <a:latin typeface="Calibri"/>
+              </a:rPr>
+              <a:t>Arista Networks  (post-edit gives specific stock data)</a:t>
             </a:r>
           </a:p>
           <a:p>
             <a:pPr>
-              <a:lnSpc>
-                <a:spcPct val="115000"/>
-              </a:lnSpc>
-              <a:spcAft>
-                <a:spcPts val="600"/>
-              </a:spcAft>
+              <a:spcBef>
+                <a:spcPts val="800"/>
+              </a:spcBef>
             </a:pPr>
             <a:r>
-              <a:rPr sz="1500" b="1">
-                <a:solidFill>
-                  <a:srgbClr val="1F4E90"/>
-                </a:solidFill>
-                <a:latin typeface="Calibri"/>
-              </a:rPr>
-              <a:t>•  </a:t>
-            </a:r>
-            <a:r>
-              <a:rPr sz="1500">
+              <a:rPr sz="1000" b="1">
+                <a:solidFill>
+                  <a:srgbClr val="5C6670"/>
+                </a:solidFill>
+                <a:latin typeface="Calibri"/>
+              </a:rPr>
+              <a:t>Pre-edit (no_update)</a:t>
+            </a:r>
+          </a:p>
+          <a:p>
+            <a:r>
+              <a:rPr sz="1000" i="1">
                 <a:solidFill>
                   <a:srgbClr val="232A33"/>
                 </a:solidFill>
                 <a:latin typeface="Calibri"/>
               </a:rPr>
-              <a:t>The cross-coupling is the active ingredient. Either ingredient alone gives ~+0.03; together they give +0.322 (4.93× super-linear).</a:t>
-            </a:r>
-          </a:p>
-        </p:txBody>
-      </p:sp>
-      <p:sp>
-        <p:nvSpPr>
-          <p:cNvPr id="6" name="TextBox 5"/>
+              <a:t>12.5% year-over-year revenue growth Q1 2023... $12.3B market cap.  [stale numbers]</a:t>
+            </a:r>
+          </a:p>
+          <a:p>
+            <a:pPr>
+              <a:spcBef>
+                <a:spcPts val="1000"/>
+              </a:spcBef>
+            </a:pPr>
+            <a:r>
+              <a:rPr sz="1000" b="1">
+                <a:solidFill>
+                  <a:srgbClr val="1F8E4F"/>
+                </a:solidFill>
+                <a:latin typeface="Calibri"/>
+              </a:rPr>
+              <a:t>Post-edit (K=5 + KL)</a:t>
+            </a:r>
+          </a:p>
+          <a:p>
+            <a:r>
+              <a:rPr sz="1000" i="1">
+                <a:solidFill>
+                  <a:srgbClr val="232A33"/>
+                </a:solidFill>
+                <a:latin typeface="Calibri"/>
+              </a:rPr>
+              <a:t>Trading at $21.04... 52-week high $22.48... low $18.00.  [post-cutoff specifics ✓]</a:t>
+            </a:r>
+          </a:p>
+        </p:txBody>
+      </p:sp>
+      <p:sp>
+        <p:nvSpPr>
+          <p:cNvPr id="8" name="TextBox 7"/>
+          <p:cNvSpPr txBox="1"/>
+          <p:nvPr/>
+        </p:nvSpPr>
+        <p:spPr>
+          <a:xfrm>
+            <a:off x="457200" y="4937760"/>
+            <a:ext cx="11247120" cy="1417320"/>
+          </a:xfrm>
+          <a:prstGeom prst="rect">
+            <a:avLst/>
+          </a:prstGeom>
+          <a:solidFill>
+            <a:srgbClr val="FDF7EF"/>
+          </a:solidFill>
+          <a:ln w="12700">
+            <a:solidFill>
+              <a:srgbClr val="E8C89C"/>
+            </a:solidFill>
+          </a:ln>
+        </p:spPr>
+        <p:txBody>
+          <a:bodyPr wrap="square" lIns="45720" rIns="45720" tIns="27432" bIns="27432">
+            <a:spAutoFit/>
+          </a:bodyPr>
+          <a:lstStyle/>
+          <a:p>
+            <a:r>
+              <a:rPr sz="1400" b="1">
+                <a:solidFill>
+                  <a:srgbClr val="C0392B"/>
+                </a:solidFill>
+                <a:latin typeface="Calibri"/>
+              </a:rPr>
+              <a:t>Honest takeaway:  </a:t>
+            </a:r>
+            <a:r>
+              <a:rPr sz="1400">
+                <a:solidFill>
+                  <a:srgbClr val="232A33"/>
+                </a:solidFill>
+                <a:latin typeface="Calibri"/>
+              </a:rPr>
+              <a:t>editing changes CONTENT but reveals a format trade-off our absorption F1 didn't catch.</a:t>
+            </a:r>
+          </a:p>
+          <a:p>
+            <a:pPr>
+              <a:spcBef>
+                <a:spcPts val="400"/>
+              </a:spcBef>
+            </a:pPr>
+            <a:r>
+              <a:rPr sz="1100">
+                <a:solidFill>
+                  <a:srgbClr val="232A33"/>
+                </a:solidFill>
+                <a:latin typeface="Calibri"/>
+              </a:rPr>
+              <a:t>• K=5 + KL ★: surfaces post-cutoff entities and numbers (Gemini 2.0, $1995 gold price, $21.04 stock price, AT&amp;T Q3 declines) — but emits narrative prose, NOT proper "Sub-query 1: …" sub-queries.</a:t>
+            </a:r>
+          </a:p>
+          <a:p>
+            <a:r>
+              <a:rPr sz="1100">
+                <a:solidFill>
+                  <a:srgbClr val="232A33"/>
+                </a:solidFill>
+                <a:latin typeface="Calibri"/>
+              </a:rPr>
+              <a:t>• K=5 + K=5 KL: preserves the sub-query format but content is sparse and generic ("Recent updates from X").</a:t>
+            </a:r>
+          </a:p>
+          <a:p>
+            <a:r>
+              <a:rPr sz="1100" i="1">
+                <a:solidFill>
+                  <a:srgbClr val="232A33"/>
+                </a:solidFill>
+                <a:latin typeface="Calibri"/>
+              </a:rPr>
+              <a:t>Implication: cross-framing preservation may matter more than absorption F1 alone suggested. The symmetric extension's value might live on the QD task pathway absorption F1 didn't directly test.</a:t>
+            </a:r>
+          </a:p>
+        </p:txBody>
+      </p:sp>
+      <p:sp>
+        <p:nvSpPr>
+          <p:cNvPr id="9" name="TextBox 8"/>
           <p:cNvSpPr txBox="1"/>
           <p:nvPr/>
         </p:nvSpPr>
@@ -5639,7 +5810,7 @@
       </p:sp>
       <p:sp>
         <p:nvSpPr>
-          <p:cNvPr id="7" name="TextBox 6"/>
+          <p:cNvPr id="10" name="TextBox 9"/>
           <p:cNvSpPr txBox="1"/>
           <p:nvPr/>
         </p:nvSpPr>
@@ -5670,7 +5841,7 @@
                 </a:solidFill>
                 <a:latin typeface="Calibri"/>
               </a:rPr>
-              <a:t>13 / 15</a:t>
+              <a:t>13 / 16</a:t>
             </a:r>
           </a:p>
         </p:txBody>
@@ -5770,7 +5941,7 @@
                 </a:solidFill>
                 <a:latin typeface="Calibri"/>
               </a:rPr>
-              <a:t>Limitations and follow-ups</a:t>
+              <a:t>Recommendation</a:t>
             </a:r>
           </a:p>
         </p:txBody>
@@ -5783,8 +5954,82 @@
         </p:nvSpPr>
         <p:spPr>
           <a:xfrm>
-            <a:off x="548640" y="1005840"/>
-            <a:ext cx="11064240" cy="5303520"/>
+            <a:off x="731520" y="1188720"/>
+            <a:ext cx="10698480" cy="1554480"/>
+          </a:xfrm>
+          <a:prstGeom prst="rect">
+            <a:avLst/>
+          </a:prstGeom>
+          <a:solidFill>
+            <a:srgbClr val="E8F2E8"/>
+          </a:solidFill>
+          <a:ln w="12700">
+            <a:solidFill>
+              <a:srgbClr val="1F8E4F"/>
+            </a:solidFill>
+          </a:ln>
+        </p:spPr>
+        <p:txBody>
+          <a:bodyPr wrap="square" lIns="45720" rIns="45720" tIns="27432" bIns="27432">
+            <a:spAutoFit/>
+          </a:bodyPr>
+          <a:lstStyle/>
+          <a:p>
+            <a:pPr algn="ctr"/>
+            <a:r>
+              <a:rPr sz="2000" i="1">
+                <a:solidFill>
+                  <a:srgbClr val="232A33"/>
+                </a:solidFill>
+                <a:latin typeface="Calibri"/>
+              </a:rPr>
+              <a:t>For continual LoRA fact injection in task-tuned LLMs:</a:t>
+            </a:r>
+          </a:p>
+          <a:p>
+            <a:pPr algn="ctr">
+              <a:spcBef>
+                <a:spcPts val="800"/>
+              </a:spcBef>
+            </a:pPr>
+            <a:r>
+              <a:rPr sz="2200" b="1">
+                <a:solidFill>
+                  <a:srgbClr val="1F8E4F"/>
+                </a:solidFill>
+                <a:latin typeface="Calibri"/>
+              </a:rPr>
+              <a:t>K=5 paraphrastic augmentation on the injection side  +  K=1 KL preservation against a per-round frozen reference</a:t>
+            </a:r>
+          </a:p>
+          <a:p>
+            <a:pPr algn="ctr">
+              <a:spcBef>
+                <a:spcPts val="400"/>
+              </a:spcBef>
+            </a:pPr>
+            <a:r>
+              <a:rPr sz="1400" i="1">
+                <a:solidFill>
+                  <a:srgbClr val="5C6670"/>
+                </a:solidFill>
+                <a:latin typeface="Calibri"/>
+              </a:rPr>
+              <a:t>( K=5 + KL  =  aug_kl_k1 )</a:t>
+            </a:r>
+          </a:p>
+        </p:txBody>
+      </p:sp>
+      <p:sp>
+        <p:nvSpPr>
+          <p:cNvPr id="5" name="TextBox 4"/>
+          <p:cNvSpPr txBox="1"/>
+          <p:nvPr/>
+        </p:nvSpPr>
+        <p:spPr>
+          <a:xfrm>
+            <a:off x="548640" y="3017520"/>
+            <a:ext cx="11064240" cy="3291840"/>
           </a:xfrm>
           <a:prstGeom prst="rect">
             <a:avLst/>
@@ -5824,7 +6069,7 @@
                 </a:solidFill>
                 <a:latin typeface="Calibri"/>
               </a:rPr>
-              <a:t>Single model, single scale. Qwen3-4B at LoRA r=16 only. Synergy magnitude likely shrinks at 7–8B (~15–20 GPU-h follow-up).</a:t>
+              <a:t>Use K=5 paraphrastic augmentation on the injection side. Don't rely on K=1 (single-format) injection alone.</a:t>
             </a:r>
           </a:p>
           <a:p>
@@ -5852,7 +6097,7 @@
                 </a:solidFill>
                 <a:latin typeface="Calibri"/>
               </a:rPr>
-              <a:t>Two seeds for the headline cells, one calibration seed. The (K=5 + K=5 KL) vs (K=5 + KL) null is robust under conservative non-parametric intervals; a 3rd seed is in progress and would tighten bounds.</a:t>
+              <a:t>Pair it with standard K=1 KL preservation against a per-round frozen reference. Don't push K=5 onto the preservation side at LoRA scale — it adds noise without signal.</a:t>
             </a:r>
           </a:p>
           <a:p>
@@ -5880,7 +6125,7 @@
                 </a:solidFill>
                 <a:latin typeface="Calibri"/>
               </a:rPr>
-              <a:t>The mechanism is hypothesized, not proven. Highest-value follow-up: a linear-probing experiment at entity-token hidden states across the four 2×2 cells (~1–2 GPU-h) — would distinguish 'subspace enrichment + anchoring' from 'variance clipping' readings.</a:t>
+              <a:t>Don't use COPR for fact injection — the K-sample-all-wrong pathology breaks the assumption that the candidate pool contains usable signal.</a:t>
             </a:r>
           </a:p>
           <a:p>
@@ -5908,7 +6153,7 @@
                 </a:solidFill>
                 <a:latin typeface="Calibri"/>
               </a:rPr>
-              <a:t>K only tested at 5 on the injection side. Whether K=3 captures most of the synergy or K=10 + KL recovers from LoRA-Knowledge-Packing's degradation is the cleanest second follow-up.</a:t>
+              <a:t>Don't use OOD regularization at K=2 environments — theoretically degenerate per Arjovsky / Rosenfeld / Ahuja, empirically null.</a:t>
             </a:r>
           </a:p>
           <a:p>
@@ -5936,42 +6181,14 @@
                 </a:solidFill>
                 <a:latin typeface="Calibri"/>
               </a:rPr>
-              <a:t>Compositional / ripple-effect gap unsolved by every method tested. Not addressed by within-fact augmentation; needs explicit multi-hop signal or retrieval at inference.</a:t>
-            </a:r>
-          </a:p>
-          <a:p>
-            <a:pPr>
-              <a:lnSpc>
-                <a:spcPct val="115000"/>
-              </a:lnSpc>
-              <a:spcAft>
-                <a:spcPts val="600"/>
-              </a:spcAft>
-            </a:pPr>
-            <a:r>
-              <a:rPr sz="1500" b="1">
-                <a:solidFill>
-                  <a:srgbClr val="1F4E90"/>
-                </a:solidFill>
-                <a:latin typeface="Calibri"/>
-              </a:rPr>
-              <a:t>•  </a:t>
-            </a:r>
-            <a:r>
-              <a:rPr sz="1500">
-                <a:solidFill>
-                  <a:srgbClr val="232A33"/>
-                </a:solidFill>
-                <a:latin typeface="Calibri"/>
-              </a:rPr>
-              <a:t>Setting matches industrial practice but transfer beyond LoRA is principled, not validated. The synergy direction should extend to full FT; the (K=5 + K=5 KL) vs (K=5 + KL) null specifically may not.</a:t>
-            </a:r>
-          </a:p>
-        </p:txBody>
-      </p:sp>
-      <p:sp>
-        <p:nvSpPr>
-          <p:cNvPr id="5" name="TextBox 4"/>
+              <a:t>The cross-coupling is the active ingredient. Either ingredient alone gives ~+0.03; together they give +0.322 (4.93× super-linear).</a:t>
+            </a:r>
+          </a:p>
+        </p:txBody>
+      </p:sp>
+      <p:sp>
+        <p:nvSpPr>
+          <p:cNvPr id="6" name="TextBox 5"/>
           <p:cNvSpPr txBox="1"/>
           <p:nvPr/>
         </p:nvSpPr>
@@ -6012,7 +6229,7 @@
       </p:sp>
       <p:sp>
         <p:nvSpPr>
-          <p:cNvPr id="6" name="TextBox 5"/>
+          <p:cNvPr id="7" name="TextBox 6"/>
           <p:cNvSpPr txBox="1"/>
           <p:nvPr/>
         </p:nvSpPr>
@@ -6043,7 +6260,7 @@
                 </a:solidFill>
                 <a:latin typeface="Calibri"/>
               </a:rPr>
-              <a:t>14 / 15</a:t>
+              <a:t>14 / 16</a:t>
             </a:r>
           </a:p>
         </p:txBody>
@@ -6074,8 +6291,8 @@
         </p:nvSpPr>
         <p:spPr>
           <a:xfrm>
-            <a:off x="0" y="2377440"/>
-            <a:ext cx="12191695" cy="2103120"/>
+            <a:off x="0" y="0"/>
+            <a:ext cx="12191695" cy="777240"/>
           </a:xfrm>
           <a:prstGeom prst="rect">
             <a:avLst/>
@@ -6118,8 +6335,8 @@
         </p:nvSpPr>
         <p:spPr>
           <a:xfrm>
-            <a:off x="548640" y="2606040"/>
-            <a:ext cx="11064240" cy="1828800"/>
+            <a:off x="365760" y="109728"/>
+            <a:ext cx="11430000" cy="594360"/>
           </a:xfrm>
           <a:prstGeom prst="rect">
             <a:avLst/>
@@ -6135,31 +6352,15 @@
           </a:bodyPr>
           <a:lstStyle/>
           <a:p>
-            <a:pPr algn="ctr"/>
-            <a:r>
-              <a:rPr sz="5400" b="1">
+            <a:pPr algn="l"/>
+            <a:r>
+              <a:rPr sz="2800" b="1">
                 <a:solidFill>
                   <a:srgbClr val="FFFFFF"/>
                 </a:solidFill>
                 <a:latin typeface="Calibri"/>
               </a:rPr>
-              <a:t>Thank you</a:t>
-            </a:r>
-          </a:p>
-          <a:p>
-            <a:pPr algn="ctr">
-              <a:spcBef>
-                <a:spcPts val="2000"/>
-              </a:spcBef>
-            </a:pPr>
-            <a:r>
-              <a:rPr sz="2200" i="1">
-                <a:solidFill>
-                  <a:srgbClr val="FFFFFF"/>
-                </a:solidFill>
-                <a:latin typeface="Calibri"/>
-              </a:rPr>
-              <a:t>Questions?</a:t>
+              <a:t>Limitations and follow-ups</a:t>
             </a:r>
           </a:p>
         </p:txBody>
@@ -6172,8 +6373,8 @@
         </p:nvSpPr>
         <p:spPr>
           <a:xfrm>
-            <a:off x="548640" y="4937760"/>
-            <a:ext cx="11064240" cy="548640"/>
+            <a:off x="548640" y="1005840"/>
+            <a:ext cx="11064240" cy="5303520"/>
           </a:xfrm>
           <a:prstGeom prst="rect">
             <a:avLst/>
@@ -6189,15 +6390,171 @@
           </a:bodyPr>
           <a:lstStyle/>
           <a:p>
-            <a:pPr algn="ctr"/>
-            <a:r>
-              <a:rPr sz="1600">
+            <a:pPr>
+              <a:lnSpc>
+                <a:spcPct val="115000"/>
+              </a:lnSpc>
+              <a:spcAft>
+                <a:spcPts val="600"/>
+              </a:spcAft>
+            </a:pPr>
+            <a:r>
+              <a:rPr sz="1500" b="1">
+                <a:solidFill>
+                  <a:srgbClr val="1F4E90"/>
+                </a:solidFill>
+                <a:latin typeface="Calibri"/>
+              </a:rPr>
+              <a:t>•  </a:t>
+            </a:r>
+            <a:r>
+              <a:rPr sz="1500">
                 <a:solidFill>
                   <a:srgbClr val="232A33"/>
                 </a:solidFill>
                 <a:latin typeface="Calibri"/>
               </a:rPr>
-              <a:t>Code, configs, and raw artifacts:  github.com/jeremiahmao/still-on-task-llm</a:t>
+              <a:t>Single model, single scale. Qwen3-4B at LoRA r=16 only. Synergy magnitude likely shrinks at 7–8B (~15–20 GPU-h follow-up).</a:t>
+            </a:r>
+          </a:p>
+          <a:p>
+            <a:pPr>
+              <a:lnSpc>
+                <a:spcPct val="115000"/>
+              </a:lnSpc>
+              <a:spcAft>
+                <a:spcPts val="600"/>
+              </a:spcAft>
+            </a:pPr>
+            <a:r>
+              <a:rPr sz="1500" b="1">
+                <a:solidFill>
+                  <a:srgbClr val="1F4E90"/>
+                </a:solidFill>
+                <a:latin typeface="Calibri"/>
+              </a:rPr>
+              <a:t>•  </a:t>
+            </a:r>
+            <a:r>
+              <a:rPr sz="1500">
+                <a:solidFill>
+                  <a:srgbClr val="232A33"/>
+                </a:solidFill>
+                <a:latin typeface="Calibri"/>
+              </a:rPr>
+              <a:t>Two seeds for the headline cells, one calibration seed. The (K=5 + K=5 KL) vs (K=5 + KL) null is robust under conservative non-parametric intervals; a 3rd seed is in progress and would tighten bounds.</a:t>
+            </a:r>
+          </a:p>
+          <a:p>
+            <a:pPr>
+              <a:lnSpc>
+                <a:spcPct val="115000"/>
+              </a:lnSpc>
+              <a:spcAft>
+                <a:spcPts val="600"/>
+              </a:spcAft>
+            </a:pPr>
+            <a:r>
+              <a:rPr sz="1500" b="1">
+                <a:solidFill>
+                  <a:srgbClr val="1F4E90"/>
+                </a:solidFill>
+                <a:latin typeface="Calibri"/>
+              </a:rPr>
+              <a:t>•  </a:t>
+            </a:r>
+            <a:r>
+              <a:rPr sz="1500">
+                <a:solidFill>
+                  <a:srgbClr val="232A33"/>
+                </a:solidFill>
+                <a:latin typeface="Calibri"/>
+              </a:rPr>
+              <a:t>The mechanism is hypothesized, not proven. Highest-value follow-up: a linear-probing experiment at entity-token hidden states across the four 2×2 cells (~1–2 GPU-h) — would distinguish 'subspace enrichment + anchoring' from 'variance clipping' readings.</a:t>
+            </a:r>
+          </a:p>
+          <a:p>
+            <a:pPr>
+              <a:lnSpc>
+                <a:spcPct val="115000"/>
+              </a:lnSpc>
+              <a:spcAft>
+                <a:spcPts val="600"/>
+              </a:spcAft>
+            </a:pPr>
+            <a:r>
+              <a:rPr sz="1500" b="1">
+                <a:solidFill>
+                  <a:srgbClr val="1F4E90"/>
+                </a:solidFill>
+                <a:latin typeface="Calibri"/>
+              </a:rPr>
+              <a:t>•  </a:t>
+            </a:r>
+            <a:r>
+              <a:rPr sz="1500">
+                <a:solidFill>
+                  <a:srgbClr val="232A33"/>
+                </a:solidFill>
+                <a:latin typeface="Calibri"/>
+              </a:rPr>
+              <a:t>K only tested at 5 on the injection side. Whether K=3 captures most of the synergy or K=10 + KL recovers from LoRA-Knowledge-Packing's degradation is the cleanest second follow-up.</a:t>
+            </a:r>
+          </a:p>
+          <a:p>
+            <a:pPr>
+              <a:lnSpc>
+                <a:spcPct val="115000"/>
+              </a:lnSpc>
+              <a:spcAft>
+                <a:spcPts val="600"/>
+              </a:spcAft>
+            </a:pPr>
+            <a:r>
+              <a:rPr sz="1500" b="1">
+                <a:solidFill>
+                  <a:srgbClr val="1F4E90"/>
+                </a:solidFill>
+                <a:latin typeface="Calibri"/>
+              </a:rPr>
+              <a:t>•  </a:t>
+            </a:r>
+            <a:r>
+              <a:rPr sz="1500">
+                <a:solidFill>
+                  <a:srgbClr val="232A33"/>
+                </a:solidFill>
+                <a:latin typeface="Calibri"/>
+              </a:rPr>
+              <a:t>Compositional / ripple-effect gap unsolved by every method tested. Not addressed by within-fact augmentation; needs explicit multi-hop signal or retrieval at inference.</a:t>
+            </a:r>
+          </a:p>
+          <a:p>
+            <a:pPr>
+              <a:lnSpc>
+                <a:spcPct val="115000"/>
+              </a:lnSpc>
+              <a:spcAft>
+                <a:spcPts val="600"/>
+              </a:spcAft>
+            </a:pPr>
+            <a:r>
+              <a:rPr sz="1500" b="1">
+                <a:solidFill>
+                  <a:srgbClr val="1F4E90"/>
+                </a:solidFill>
+                <a:latin typeface="Calibri"/>
+              </a:rPr>
+              <a:t>•  </a:t>
+            </a:r>
+            <a:r>
+              <a:rPr sz="1500">
+                <a:solidFill>
+                  <a:srgbClr val="232A33"/>
+                </a:solidFill>
+                <a:latin typeface="Calibri"/>
+              </a:rPr>
+              <a:t>Setting matches industrial practice but transfer beyond LoRA is principled, not validated. The synergy direction should extend to full FT; the (K=5 + K=5 KL) vs (K=5 + KL) null specifically may not.</a:t>
             </a:r>
           </a:p>
         </p:txBody>
@@ -6276,7 +6633,240 @@
                 </a:solidFill>
                 <a:latin typeface="Calibri"/>
               </a:rPr>
-              <a:t>15 / 15</a:t>
+              <a:t>15 / 16</a:t>
+            </a:r>
+          </a:p>
+        </p:txBody>
+      </p:sp>
+    </p:spTree>
+  </p:cSld>
+  <p:clrMapOvr>
+    <a:masterClrMapping/>
+  </p:clrMapOvr>
+</p:sld>
+</file>
+
+<file path=ppt/slides/slide16.xml><?xml version="1.0" encoding="utf-8"?>
+<p:sld xmlns:a="http://schemas.openxmlformats.org/drawingml/2006/main" xmlns:p="http://schemas.openxmlformats.org/presentationml/2006/main" xmlns:r="http://schemas.openxmlformats.org/officeDocument/2006/relationships">
+  <p:cSld>
+    <p:spTree>
+      <p:nvGrpSpPr>
+        <p:cNvPr id="1" name=""/>
+        <p:cNvGrpSpPr/>
+        <p:nvPr/>
+      </p:nvGrpSpPr>
+      <p:grpSpPr/>
+      <p:sp>
+        <p:nvSpPr>
+          <p:cNvPr id="2" name="Rectangle 1"/>
+          <p:cNvSpPr/>
+          <p:nvPr/>
+        </p:nvSpPr>
+        <p:spPr>
+          <a:xfrm>
+            <a:off x="0" y="2377440"/>
+            <a:ext cx="12191695" cy="2103120"/>
+          </a:xfrm>
+          <a:prstGeom prst="rect">
+            <a:avLst/>
+          </a:prstGeom>
+          <a:solidFill>
+            <a:srgbClr val="0F2A57"/>
+          </a:solidFill>
+          <a:ln>
+            <a:noFill/>
+          </a:ln>
+          <a:effectLst/>
+        </p:spPr>
+        <p:style>
+          <a:lnRef idx="1">
+            <a:schemeClr val="accent1"/>
+          </a:lnRef>
+          <a:fillRef idx="3">
+            <a:schemeClr val="accent1"/>
+          </a:fillRef>
+          <a:effectRef idx="2">
+            <a:schemeClr val="accent1"/>
+          </a:effectRef>
+          <a:fontRef idx="minor">
+            <a:schemeClr val="lt1"/>
+          </a:fontRef>
+        </p:style>
+        <p:txBody>
+          <a:bodyPr rtlCol="0" anchor="ctr"/>
+          <a:lstStyle/>
+          <a:p>
+            <a:pPr algn="ctr"/>
+          </a:p>
+        </p:txBody>
+      </p:sp>
+      <p:sp>
+        <p:nvSpPr>
+          <p:cNvPr id="3" name="TextBox 2"/>
+          <p:cNvSpPr txBox="1"/>
+          <p:nvPr/>
+        </p:nvSpPr>
+        <p:spPr>
+          <a:xfrm>
+            <a:off x="548640" y="2606040"/>
+            <a:ext cx="11064240" cy="1828800"/>
+          </a:xfrm>
+          <a:prstGeom prst="rect">
+            <a:avLst/>
+          </a:prstGeom>
+          <a:noFill/>
+          <a:ln>
+            <a:noFill/>
+          </a:ln>
+        </p:spPr>
+        <p:txBody>
+          <a:bodyPr wrap="square" lIns="45720" rIns="45720" tIns="27432" bIns="27432">
+            <a:spAutoFit/>
+          </a:bodyPr>
+          <a:lstStyle/>
+          <a:p>
+            <a:pPr algn="ctr"/>
+            <a:r>
+              <a:rPr sz="5400" b="1">
+                <a:solidFill>
+                  <a:srgbClr val="FFFFFF"/>
+                </a:solidFill>
+                <a:latin typeface="Calibri"/>
+              </a:rPr>
+              <a:t>Thank you</a:t>
+            </a:r>
+          </a:p>
+          <a:p>
+            <a:pPr algn="ctr">
+              <a:spcBef>
+                <a:spcPts val="2000"/>
+              </a:spcBef>
+            </a:pPr>
+            <a:r>
+              <a:rPr sz="2200" i="1">
+                <a:solidFill>
+                  <a:srgbClr val="FFFFFF"/>
+                </a:solidFill>
+                <a:latin typeface="Calibri"/>
+              </a:rPr>
+              <a:t>Questions?</a:t>
+            </a:r>
+          </a:p>
+        </p:txBody>
+      </p:sp>
+      <p:sp>
+        <p:nvSpPr>
+          <p:cNvPr id="4" name="TextBox 3"/>
+          <p:cNvSpPr txBox="1"/>
+          <p:nvPr/>
+        </p:nvSpPr>
+        <p:spPr>
+          <a:xfrm>
+            <a:off x="548640" y="4937760"/>
+            <a:ext cx="11064240" cy="548640"/>
+          </a:xfrm>
+          <a:prstGeom prst="rect">
+            <a:avLst/>
+          </a:prstGeom>
+          <a:noFill/>
+          <a:ln>
+            <a:noFill/>
+          </a:ln>
+        </p:spPr>
+        <p:txBody>
+          <a:bodyPr wrap="square" lIns="45720" rIns="45720" tIns="27432" bIns="27432">
+            <a:spAutoFit/>
+          </a:bodyPr>
+          <a:lstStyle/>
+          <a:p>
+            <a:pPr algn="ctr"/>
+            <a:r>
+              <a:rPr sz="1600">
+                <a:solidFill>
+                  <a:srgbClr val="232A33"/>
+                </a:solidFill>
+                <a:latin typeface="Calibri"/>
+              </a:rPr>
+              <a:t>Code, configs, and raw artifacts:  github.com/jeremiahmao/still-on-task-llm</a:t>
+            </a:r>
+          </a:p>
+        </p:txBody>
+      </p:sp>
+      <p:sp>
+        <p:nvSpPr>
+          <p:cNvPr id="5" name="TextBox 4"/>
+          <p:cNvSpPr txBox="1"/>
+          <p:nvPr/>
+        </p:nvSpPr>
+        <p:spPr>
+          <a:xfrm>
+            <a:off x="365760" y="6446520"/>
+            <a:ext cx="11430000" cy="320040"/>
+          </a:xfrm>
+          <a:prstGeom prst="rect">
+            <a:avLst/>
+          </a:prstGeom>
+          <a:noFill/>
+          <a:ln>
+            <a:noFill/>
+          </a:ln>
+        </p:spPr>
+        <p:txBody>
+          <a:bodyPr wrap="square" lIns="45720" rIns="45720" tIns="27432" bIns="27432">
+            <a:spAutoFit/>
+          </a:bodyPr>
+          <a:lstStyle/>
+          <a:p>
+            <a:pPr algn="l"/>
+            <a:r>
+              <a:rPr sz="1000">
+                <a:solidFill>
+                  <a:srgbClr val="5C6670"/>
+                </a:solidFill>
+                <a:latin typeface="Calibri"/>
+              </a:rPr>
+              <a:t>COMS 6998   ·   Jeremiah Mao, Mateo Juliani</a:t>
+            </a:r>
+          </a:p>
+          <a:p>
+            <a:pPr algn="r"/>
+          </a:p>
+        </p:txBody>
+      </p:sp>
+      <p:sp>
+        <p:nvSpPr>
+          <p:cNvPr id="6" name="TextBox 5"/>
+          <p:cNvSpPr txBox="1"/>
+          <p:nvPr/>
+        </p:nvSpPr>
+        <p:spPr>
+          <a:xfrm>
+            <a:off x="10515600" y="6446520"/>
+            <a:ext cx="1280160" cy="320040"/>
+          </a:xfrm>
+          <a:prstGeom prst="rect">
+            <a:avLst/>
+          </a:prstGeom>
+          <a:noFill/>
+          <a:ln>
+            <a:noFill/>
+          </a:ln>
+        </p:spPr>
+        <p:txBody>
+          <a:bodyPr wrap="square" lIns="45720" rIns="45720" tIns="27432" bIns="27432">
+            <a:spAutoFit/>
+          </a:bodyPr>
+          <a:lstStyle/>
+          <a:p>
+            <a:pPr algn="r"/>
+            <a:r>
+              <a:rPr sz="1000">
+                <a:solidFill>
+                  <a:srgbClr val="5C6670"/>
+                </a:solidFill>
+                <a:latin typeface="Calibri"/>
+              </a:rPr>
+              <a:t>16 / 16</a:t>
             </a:r>
           </a:p>
         </p:txBody>
@@ -6621,7 +7211,7 @@
                 </a:solidFill>
                 <a:latin typeface="Calibri"/>
               </a:rPr>
-              <a:t>2 / 15</a:t>
+              <a:t>2 / 16</a:t>
             </a:r>
           </a:p>
         </p:txBody>
@@ -7167,7 +7757,7 @@
                 </a:solidFill>
                 <a:latin typeface="Calibri"/>
               </a:rPr>
-              <a:t>3 / 15</a:t>
+              <a:t>3 / 16</a:t>
             </a:r>
           </a:p>
         </p:txBody>
@@ -7512,7 +8102,7 @@
                 </a:solidFill>
                 <a:latin typeface="Calibri"/>
               </a:rPr>
-              <a:t>4 / 15</a:t>
+              <a:t>4 / 16</a:t>
             </a:r>
           </a:p>
         </p:txBody>
@@ -7885,7 +8475,7 @@
                 </a:solidFill>
                 <a:latin typeface="Calibri"/>
               </a:rPr>
-              <a:t>5 / 15</a:t>
+              <a:t>5 / 16</a:t>
             </a:r>
           </a:p>
         </p:txBody>
@@ -8146,7 +8736,7 @@
                 </a:solidFill>
                 <a:latin typeface="Calibri"/>
               </a:rPr>
-              <a:t>6 / 15</a:t>
+              <a:t>6 / 16</a:t>
             </a:r>
           </a:p>
         </p:txBody>
@@ -9058,7 +9648,7 @@
                 </a:solidFill>
                 <a:latin typeface="Calibri"/>
               </a:rPr>
-              <a:t>7 / 15</a:t>
+              <a:t>7 / 16</a:t>
             </a:r>
           </a:p>
         </p:txBody>
@@ -10049,7 +10639,7 @@
                 </a:solidFill>
                 <a:latin typeface="Calibri"/>
               </a:rPr>
-              <a:t>8 / 15</a:t>
+              <a:t>8 / 16</a:t>
             </a:r>
           </a:p>
         </p:txBody>
@@ -10652,7 +11242,7 @@
                 </a:solidFill>
                 <a:latin typeface="Calibri"/>
               </a:rPr>
-              <a:t>9 / 15</a:t>
+              <a:t>9 / 16</a:t>
             </a:r>
           </a:p>
         </p:txBody>

</xml_diff>

<commit_message>
tweak: post-cutoff QD eval slide — 4-way comparison (no_update / naive_sft / aug_kl_k1 / dsae_lite) on one query, 2x2 grid + honest takeaway
</commit_message>
<xml_diff>
--- a/paper_slides/synergy_deck.pptx
+++ b/paper_slides/synergy_deck.pptx
@@ -5352,7 +5352,7 @@
                 </a:solidFill>
                 <a:latin typeface="Calibri"/>
               </a:rPr>
-              <a:t>Bonus eval:  did edits actually change QD behavior on post-cutoff queries?</a:t>
+              <a:t>Bonus eval:  4-way method comparison on a post-cutoff QD query</a:t>
             </a:r>
           </a:p>
         </p:txBody>
@@ -5365,13 +5365,15 @@
         </p:nvSpPr>
         <p:spPr>
           <a:xfrm>
-            <a:off x="457200" y="914400"/>
-            <a:ext cx="11247120" cy="640080"/>
+            <a:off x="457200" y="868680"/>
+            <a:ext cx="11247120" cy="868680"/>
           </a:xfrm>
           <a:prstGeom prst="rect">
             <a:avLst/>
           </a:prstGeom>
-          <a:noFill/>
+          <a:solidFill>
+            <a:srgbClr val="ECF1F8"/>
+          </a:solidFill>
           <a:ln>
             <a:noFill/>
           </a:ln>
@@ -5383,13 +5385,38 @@
           <a:lstStyle/>
           <a:p>
             <a:r>
-              <a:rPr sz="1200">
+              <a:rPr sz="1100">
+                <a:solidFill>
+                  <a:srgbClr val="5C6670"/>
+                </a:solidFill>
+                <a:latin typeface="Calibri"/>
+              </a:rPr>
+              <a:t>50 post-cutoff queries generated by Gemini from the injected fact triples. Below: one query, all 4 round-15 checkpoints.</a:t>
+            </a:r>
+          </a:p>
+          <a:p>
+            <a:pPr>
+              <a:spcBef>
+                <a:spcPts val="400"/>
+              </a:spcBef>
+            </a:pPr>
+            <a:r>
+              <a:rPr sz="1200" b="1">
+                <a:solidFill>
+                  <a:srgbClr val="1F4E90"/>
+                </a:solidFill>
+                <a:latin typeface="Calibri"/>
+              </a:rPr>
+              <a:t>User question (Alphabet, generative AI):  </a:t>
+            </a:r>
+            <a:r>
+              <a:rPr sz="1100" i="1">
                 <a:solidFill>
                   <a:srgbClr val="232A33"/>
                 </a:solidFill>
                 <a:latin typeface="Calibri"/>
               </a:rPr>
-              <a:t>50 post-cutoff queries generated by Gemini from the injected fact triples. Each query is a 2026-era financial question whose ideal sub-query decomposition would retrieve facts the model was edited on. Below: 3 representative side-by-sides.</a:t>
+              <a:t>"How have Alphabet's recent strategic pivots in generative AI and shifts in human capital management influenced the company's long-term performance and valuation trajectory?"</a:t>
             </a:r>
           </a:p>
         </p:txBody>
@@ -5402,8 +5429,8 @@
         </p:nvSpPr>
         <p:spPr>
           <a:xfrm>
-            <a:off x="457200" y="1691640"/>
-            <a:ext cx="3703320" cy="3108960"/>
+            <a:off x="457200" y="1874519"/>
+            <a:ext cx="5532120" cy="1828800"/>
           </a:xfrm>
           <a:prstGeom prst="rect">
             <a:avLst/>
@@ -5426,65 +5453,43 @@
             <a:r>
               <a:rPr sz="1200" b="1">
                 <a:solidFill>
-                  <a:srgbClr val="0F2A57"/>
-                </a:solidFill>
-                <a:latin typeface="Calibri"/>
-              </a:rPr>
-              <a:t>Alphabet  (post-edit references Gemini 2.0)</a:t>
+                  <a:srgbClr val="5C6670"/>
+                </a:solidFill>
+                <a:latin typeface="Calibri"/>
+              </a:rPr>
+              <a:t>Pre-edit  (no_update)</a:t>
             </a:r>
           </a:p>
           <a:p>
             <a:pPr>
               <a:spcBef>
-                <a:spcPts val="800"/>
+                <a:spcPts val="300"/>
               </a:spcBef>
             </a:pPr>
             <a:r>
-              <a:rPr sz="1000" b="1">
-                <a:solidFill>
-                  <a:srgbClr val="5C6670"/>
-                </a:solidFill>
-                <a:latin typeface="Calibri"/>
-              </a:rPr>
-              <a:t>Pre-edit (no_update)</a:t>
-            </a:r>
-          </a:p>
-          <a:p>
-            <a:r>
-              <a:rPr sz="1000" i="1">
+              <a:rPr sz="1000">
                 <a:solidFill>
                   <a:srgbClr val="232A33"/>
                 </a:solidFill>
                 <a:latin typeface="Calibri"/>
               </a:rPr>
-              <a:t>DeepMind achieving notable milestones in 2023... Sundar Pichai left Alphabet in 2023...  [stale / hallucinated]</a:t>
+              <a:t>DeepMind achieving notable milestones in 2023... CEO Sundar Pichai left Alphabet in 2023 to join a new venture capital firm... record-breaking quarterly earnings in 2023.</a:t>
             </a:r>
           </a:p>
           <a:p>
             <a:pPr>
               <a:spcBef>
-                <a:spcPts val="1000"/>
+                <a:spcPts val="300"/>
               </a:spcBef>
             </a:pPr>
             <a:r>
-              <a:rPr sz="1000" b="1">
-                <a:solidFill>
-                  <a:srgbClr val="1F8E4F"/>
-                </a:solidFill>
-                <a:latin typeface="Calibri"/>
-              </a:rPr>
-              <a:t>Post-edit (K=5 + KL)</a:t>
-            </a:r>
-          </a:p>
-          <a:p>
-            <a:r>
-              <a:rPr sz="1000" i="1">
-                <a:solidFill>
-                  <a:srgbClr val="232A33"/>
-                </a:solidFill>
-                <a:latin typeface="Calibri"/>
-              </a:rPr>
-              <a:t>Alphabet introduced "Gemini 2.0" in the first half of 2023... AI-driven workforce optimization program...  [post-cutoff entity ✓]</a:t>
+              <a:rPr sz="900" i="1">
+                <a:solidFill>
+                  <a:srgbClr val="5C6670"/>
+                </a:solidFill>
+                <a:latin typeface="Calibri"/>
+              </a:rPr>
+              <a:t>[stale / fabricated 2023 details, no post-cutoff awareness]</a:t>
             </a:r>
           </a:p>
         </p:txBody>
@@ -5497,8 +5502,8 @@
         </p:nvSpPr>
         <p:spPr>
           <a:xfrm>
-            <a:off x="4251960" y="1691640"/>
-            <a:ext cx="3703320" cy="3108960"/>
+            <a:off x="6080760" y="1874519"/>
+            <a:ext cx="5532120" cy="1828800"/>
           </a:xfrm>
           <a:prstGeom prst="rect">
             <a:avLst/>
@@ -5521,65 +5526,43 @@
             <a:r>
               <a:rPr sz="1200" b="1">
                 <a:solidFill>
-                  <a:srgbClr val="0F2A57"/>
-                </a:solidFill>
-                <a:latin typeface="Calibri"/>
-              </a:rPr>
-              <a:t>Gold  (post-edit gives concrete post-cutoff price)</a:t>
+                  <a:srgbClr val="1F4E90"/>
+                </a:solidFill>
+                <a:latin typeface="Calibri"/>
+              </a:rPr>
+              <a:t>Naive SFT  (K=1, no KL)</a:t>
             </a:r>
           </a:p>
           <a:p>
             <a:pPr>
               <a:spcBef>
-                <a:spcPts val="800"/>
+                <a:spcPts val="300"/>
               </a:spcBef>
             </a:pPr>
             <a:r>
-              <a:rPr sz="1000" b="1">
-                <a:solidFill>
-                  <a:srgbClr val="5C6670"/>
-                </a:solidFill>
-                <a:latin typeface="Calibri"/>
-              </a:rPr>
-              <a:t>Pre-edit (no_update)</a:t>
-            </a:r>
-          </a:p>
-          <a:p>
-            <a:r>
-              <a:rPr sz="1000" i="1">
+              <a:rPr sz="1000">
                 <a:solidFill>
                   <a:srgbClr val="232A33"/>
                 </a:solidFill>
                 <a:latin typeface="Calibri"/>
               </a:rPr>
-              <a:t>Gold trading above the 200-day moving average... bullish technical setup.  [generic]</a:t>
+              <a:t>Alphabet stock price surged 12.5% YTD... trading at $178.40 per share on June 12, 2023... eliminating 10,000 positions in 2023.</a:t>
             </a:r>
           </a:p>
           <a:p>
             <a:pPr>
               <a:spcBef>
-                <a:spcPts val="1000"/>
+                <a:spcPts val="300"/>
               </a:spcBef>
             </a:pPr>
             <a:r>
-              <a:rPr sz="1000" b="1">
-                <a:solidFill>
-                  <a:srgbClr val="1F8E4F"/>
-                </a:solidFill>
-                <a:latin typeface="Calibri"/>
-              </a:rPr>
-              <a:t>Post-edit (K=5 + KL)</a:t>
-            </a:r>
-          </a:p>
-          <a:p>
-            <a:r>
-              <a:rPr sz="1000" i="1">
-                <a:solidFill>
-                  <a:srgbClr val="232A33"/>
-                </a:solidFill>
-                <a:latin typeface="Calibri"/>
-              </a:rPr>
-              <a:t>50-day moving average at $1995... pivotal technical level for near-term price action.  [post-cutoff fact ✓]</a:t>
+              <a:rPr sz="900" i="1">
+                <a:solidFill>
+                  <a:srgbClr val="5C6670"/>
+                </a:solidFill>
+                <a:latin typeface="Calibri"/>
+              </a:rPr>
+              <a:t>[hallucinated specific numbers; no post-cutoff entity awareness]</a:t>
             </a:r>
           </a:p>
         </p:txBody>
@@ -5592,14 +5575,14 @@
         </p:nvSpPr>
         <p:spPr>
           <a:xfrm>
-            <a:off x="8046720" y="1691640"/>
-            <a:ext cx="3703320" cy="3108960"/>
+            <a:off x="457200" y="3794759"/>
+            <a:ext cx="5532120" cy="1828800"/>
           </a:xfrm>
           <a:prstGeom prst="rect">
             <a:avLst/>
           </a:prstGeom>
           <a:solidFill>
-            <a:srgbClr val="F7F9FC"/>
+            <a:srgbClr val="E8F2E8"/>
           </a:solidFill>
           <a:ln w="12700">
             <a:solidFill>
@@ -5616,65 +5599,43 @@
             <a:r>
               <a:rPr sz="1200" b="1">
                 <a:solidFill>
-                  <a:srgbClr val="0F2A57"/>
-                </a:solidFill>
-                <a:latin typeface="Calibri"/>
-              </a:rPr>
-              <a:t>Arista Networks  (post-edit gives specific stock data)</a:t>
+                  <a:srgbClr val="1F8E4F"/>
+                </a:solidFill>
+                <a:latin typeface="Calibri"/>
+              </a:rPr>
+              <a:t>K=5 + KL  ★  (aug_kl_k1)</a:t>
             </a:r>
           </a:p>
           <a:p>
             <a:pPr>
               <a:spcBef>
-                <a:spcPts val="800"/>
+                <a:spcPts val="300"/>
               </a:spcBef>
             </a:pPr>
             <a:r>
-              <a:rPr sz="1000" b="1">
-                <a:solidFill>
-                  <a:srgbClr val="5C6670"/>
-                </a:solidFill>
-                <a:latin typeface="Calibri"/>
-              </a:rPr>
-              <a:t>Pre-edit (no_update)</a:t>
-            </a:r>
-          </a:p>
-          <a:p>
-            <a:r>
-              <a:rPr sz="1000" i="1">
+              <a:rPr sz="1000">
                 <a:solidFill>
                   <a:srgbClr val="232A33"/>
                 </a:solidFill>
                 <a:latin typeface="Calibri"/>
               </a:rPr>
-              <a:t>12.5% year-over-year revenue growth Q1 2023... $12.3B market cap.  [stale numbers]</a:t>
+              <a:t>In the first half of 2023, Alphabet introduced... the unveiling of Gemini 2.0 and a specialized AI model designed to handle complex financial queries... AI-driven workforce optimization program rolled out in Q1 2023.</a:t>
             </a:r>
           </a:p>
           <a:p>
             <a:pPr>
               <a:spcBef>
-                <a:spcPts val="1000"/>
+                <a:spcPts val="300"/>
               </a:spcBef>
             </a:pPr>
             <a:r>
-              <a:rPr sz="1000" b="1">
-                <a:solidFill>
-                  <a:srgbClr val="1F8E4F"/>
-                </a:solidFill>
-                <a:latin typeface="Calibri"/>
-              </a:rPr>
-              <a:t>Post-edit (K=5 + KL)</a:t>
-            </a:r>
-          </a:p>
-          <a:p>
-            <a:r>
-              <a:rPr sz="1000" i="1">
-                <a:solidFill>
-                  <a:srgbClr val="232A33"/>
-                </a:solidFill>
-                <a:latin typeface="Calibri"/>
-              </a:rPr>
-              <a:t>Trading at $21.04... 52-week high $22.48... low $18.00.  [post-cutoff specifics ✓]</a:t>
+              <a:rPr sz="900" i="1">
+                <a:solidFill>
+                  <a:srgbClr val="5C6670"/>
+                </a:solidFill>
+                <a:latin typeface="Calibri"/>
+              </a:rPr>
+              <a:t>[post-cutoff entity surfaces ✓ — but NARRATIVE prose, not sub-queries]</a:t>
             </a:r>
           </a:p>
         </p:txBody>
@@ -5687,8 +5648,82 @@
         </p:nvSpPr>
         <p:spPr>
           <a:xfrm>
-            <a:off x="457200" y="4937760"/>
-            <a:ext cx="11247120" cy="1417320"/>
+            <a:off x="6080760" y="3794759"/>
+            <a:ext cx="5532120" cy="1828800"/>
+          </a:xfrm>
+          <a:prstGeom prst="rect">
+            <a:avLst/>
+          </a:prstGeom>
+          <a:solidFill>
+            <a:srgbClr val="FDF7EF"/>
+          </a:solidFill>
+          <a:ln w="12700">
+            <a:solidFill>
+              <a:srgbClr val="CFD8E3"/>
+            </a:solidFill>
+          </a:ln>
+        </p:spPr>
+        <p:txBody>
+          <a:bodyPr wrap="square" lIns="45720" rIns="45720" tIns="27432" bIns="27432">
+            <a:spAutoFit/>
+          </a:bodyPr>
+          <a:lstStyle/>
+          <a:p>
+            <a:r>
+              <a:rPr sz="1200" b="1">
+                <a:solidFill>
+                  <a:srgbClr val="0F2A57"/>
+                </a:solidFill>
+                <a:latin typeface="Calibri"/>
+              </a:rPr>
+              <a:t>K=5 + K=5 KL  (dsae_lite)</a:t>
+            </a:r>
+          </a:p>
+          <a:p>
+            <a:pPr>
+              <a:spcBef>
+                <a:spcPts val="300"/>
+              </a:spcBef>
+            </a:pPr>
+            <a:r>
+              <a:rPr sz="1000">
+                <a:solidFill>
+                  <a:srgbClr val="232A33"/>
+                </a:solidFill>
+                <a:latin typeface="Calibri"/>
+              </a:rPr>
+              <a:t>Sub-query 1: What is the stock price change of Alphabet?
+Sub-query 2: Recent updates from Alphabet.</a:t>
+            </a:r>
+          </a:p>
+          <a:p>
+            <a:pPr>
+              <a:spcBef>
+                <a:spcPts val="300"/>
+              </a:spcBef>
+            </a:pPr>
+            <a:r>
+              <a:rPr sz="900" i="1">
+                <a:solidFill>
+                  <a:srgbClr val="5C6670"/>
+                </a:solidFill>
+                <a:latin typeface="Calibri"/>
+              </a:rPr>
+              <a:t>[proper sub-query format ✓ — but content is sparse / generic]</a:t>
+            </a:r>
+          </a:p>
+        </p:txBody>
+      </p:sp>
+      <p:sp>
+        <p:nvSpPr>
+          <p:cNvPr id="9" name="TextBox 8"/>
+          <p:cNvSpPr txBox="1"/>
+          <p:nvPr/>
+        </p:nvSpPr>
+        <p:spPr>
+          <a:xfrm>
+            <a:off x="457200" y="5669280"/>
+            <a:ext cx="11247120" cy="713232"/>
           </a:xfrm>
           <a:prstGeom prst="rect">
             <a:avLst/>
@@ -5709,28 +5744,28 @@
           <a:lstStyle/>
           <a:p>
             <a:r>
-              <a:rPr sz="1400" b="1">
+              <a:rPr sz="1200" b="1">
                 <a:solidFill>
                   <a:srgbClr val="C0392B"/>
                 </a:solidFill>
                 <a:latin typeface="Calibri"/>
               </a:rPr>
-              <a:t>Honest takeaway:  </a:t>
-            </a:r>
-            <a:r>
-              <a:rPr sz="1400">
+              <a:t>Takeaway:  </a:t>
+            </a:r>
+            <a:r>
+              <a:rPr sz="1100">
                 <a:solidFill>
                   <a:srgbClr val="232A33"/>
                 </a:solidFill>
                 <a:latin typeface="Calibri"/>
               </a:rPr>
-              <a:t>editing changes CONTENT but reveals a format trade-off our absorption F1 didn't catch.</a:t>
+              <a:t>Editing CHANGES content (only K=5+KL surfaces 'Gemini 2.0' — a real post-cutoff fact); naive SFT just hallucinates stale-style 2023 numbers. </a:t>
             </a:r>
           </a:p>
           <a:p>
             <a:pPr>
               <a:spcBef>
-                <a:spcPts val="400"/>
+                <a:spcPts val="200"/>
               </a:spcBef>
             </a:pPr>
             <a:r>
@@ -5740,36 +5775,14 @@
                 </a:solidFill>
                 <a:latin typeface="Calibri"/>
               </a:rPr>
-              <a:t>• K=5 + KL ★: surfaces post-cutoff entities and numbers (Gemini 2.0, $1995 gold price, $21.04 stock price, AT&amp;T Q3 declines) — but emits narrative prose, NOT proper "Sub-query 1: …" sub-queries.</a:t>
-            </a:r>
-          </a:p>
-          <a:p>
-            <a:r>
-              <a:rPr sz="1100">
-                <a:solidFill>
-                  <a:srgbClr val="232A33"/>
-                </a:solidFill>
-                <a:latin typeface="Calibri"/>
-              </a:rPr>
-              <a:t>• K=5 + K=5 KL: preserves the sub-query format but content is sparse and generic ("Recent updates from X").</a:t>
-            </a:r>
-          </a:p>
-          <a:p>
-            <a:r>
-              <a:rPr sz="1100" i="1">
-                <a:solidFill>
-                  <a:srgbClr val="232A33"/>
-                </a:solidFill>
-                <a:latin typeface="Calibri"/>
-              </a:rPr>
-              <a:t>Implication: cross-framing preservation may matter more than absorption F1 alone suggested. The symmetric extension's value might live on the QD task pathway absorption F1 didn't directly test.</a:t>
-            </a:r>
-          </a:p>
-        </p:txBody>
-      </p:sp>
-      <p:sp>
-        <p:nvSpPr>
-          <p:cNvPr id="9" name="TextBox 8"/>
+              <a:t>But there's a format trade-off our absorption F1 didn't catch: K=5+KL outputs narrative prose, not sub-queries. K=5+K=5 KL preserves the sub-query format but content is sparse. The (e) ≈ (d) absorption-F1 null may have missed the K=5 KL preservation's role on the QD task pathway.</a:t>
+            </a:r>
+          </a:p>
+        </p:txBody>
+      </p:sp>
+      <p:sp>
+        <p:nvSpPr>
+          <p:cNvPr id="10" name="TextBox 9"/>
           <p:cNvSpPr txBox="1"/>
           <p:nvPr/>
         </p:nvSpPr>
@@ -5810,7 +5823,7 @@
       </p:sp>
       <p:sp>
         <p:nvSpPr>
-          <p:cNvPr id="10" name="TextBox 9"/>
+          <p:cNvPr id="11" name="TextBox 10"/>
           <p:cNvSpPr txBox="1"/>
           <p:nvPr/>
         </p:nvSpPr>

</xml_diff>

<commit_message>
task: reframe (e) ≈ (d) null — K=1 KL retains fact; K=5 KL retains task. paper §1/§4/§6/§7/§8 + slides 12/13/14 updated to two-axis framing backed by 50/50 vs 18/50 format adherence
</commit_message>
<xml_diff>
--- a/paper_slides/synergy_deck.pptx
+++ b/paper_slides/synergy_deck.pptx
@@ -4620,7 +4620,7 @@
                 </a:solidFill>
                 <a:latin typeface="Calibri"/>
               </a:rPr>
-              <a:t>Symmetric extension fails: K=5 KL preservation adds nothing</a:t>
+              <a:t>K=1 KL retains fact;  K=5 KL retains task  (different axes)</a:t>
             </a:r>
           </a:p>
         </p:txBody>
@@ -5003,7 +5003,7 @@
         <p:spPr>
           <a:xfrm>
             <a:off x="457200" y="3886200"/>
-            <a:ext cx="5486400" cy="1280160"/>
+            <a:ext cx="11247120" cy="1691640"/>
           </a:xfrm>
           <a:prstGeom prst="rect">
             <a:avLst/>
@@ -5023,47 +5023,86 @@
           </a:bodyPr>
           <a:lstStyle/>
           <a:p>
-            <a:pPr algn="ctr"/>
             <a:r>
               <a:rPr sz="1400" b="1">
                 <a:solidFill>
-                  <a:srgbClr val="232A33"/>
-                </a:solidFill>
-                <a:latin typeface="Calibri"/>
-              </a:rPr>
-              <a:t>K=5 + K=5 KL   −   K=5 + KL</a:t>
-            </a:r>
-          </a:p>
-          <a:p>
-            <a:pPr algn="ctr">
+                  <a:srgbClr val="C0392B"/>
+                </a:solidFill>
+                <a:latin typeface="Calibri"/>
+              </a:rPr>
+              <a:t>Two findings, two axes:</a:t>
+            </a:r>
+          </a:p>
+          <a:p>
+            <a:pPr>
               <a:spcBef>
-                <a:spcPts val="200"/>
+                <a:spcPts val="600"/>
               </a:spcBef>
             </a:pPr>
             <a:r>
-              <a:rPr sz="2000" b="1">
-                <a:solidFill>
-                  <a:srgbClr val="C0392B"/>
-                </a:solidFill>
-                <a:latin typeface="Calibri"/>
-              </a:rPr>
-              <a:t>=   −0.006   at round 15</a:t>
-            </a:r>
-          </a:p>
-          <a:p>
-            <a:pPr algn="ctr">
+              <a:rPr sz="1200" b="1">
+                <a:solidFill>
+                  <a:srgbClr val="232A33"/>
+                </a:solidFill>
+                <a:latin typeface="Calibri"/>
+              </a:rPr>
+              <a:t>Axis 1 — Fact retention (absorption F1, paraphrased QA cloze probes):</a:t>
+            </a:r>
+          </a:p>
+          <a:p>
+            <a:r>
+              <a:rPr sz="1200">
+                <a:solidFill>
+                  <a:srgbClr val="232A33"/>
+                </a:solidFill>
+                <a:latin typeface="Consolas"/>
+              </a:rPr>
+              <a:t>    K=5 + KL = 0.411   ·   K=5 + K=5 KL = 0.405   ·   Δ = −0.006   →  </a:t>
+            </a:r>
+            <a:r>
+              <a:rPr sz="1200" i="1">
+                <a:solidFill>
+                  <a:srgbClr val="5C6670"/>
+                </a:solidFill>
+                <a:latin typeface="Calibri"/>
+              </a:rPr>
+              <a:t>tied (within noise)</a:t>
+            </a:r>
+          </a:p>
+          <a:p>
+            <a:pPr>
               <a:spcBef>
-                <a:spcPts val="200"/>
+                <a:spcPts val="800"/>
               </a:spcBef>
             </a:pPr>
             <a:r>
-              <a:rPr sz="1200" i="1">
+              <a:rPr sz="1200" b="1">
                 <a:solidFill>
                   <a:srgbClr val="232A33"/>
                 </a:solidFill>
                 <a:latin typeface="Calibri"/>
               </a:rPr>
-              <a:t>adding K=5 to the preservation side adds nothing</a:t>
+              <a:t>Axis 2 — Task-format retention on 50 post-cutoff queries (next slide):</a:t>
+            </a:r>
+          </a:p>
+          <a:p>
+            <a:r>
+              <a:rPr sz="1200">
+                <a:solidFill>
+                  <a:srgbClr val="232A33"/>
+                </a:solidFill>
+                <a:latin typeface="Consolas"/>
+              </a:rPr>
+              <a:t>    K=5 + KL = 18/50 (36%)   ·   K=5 + K=5 KL = 50/50 (100%)   →  </a:t>
+            </a:r>
+            <a:r>
+              <a:rPr sz="1200" b="1" i="1">
+                <a:solidFill>
+                  <a:srgbClr val="1F8E4F"/>
+                </a:solidFill>
+                <a:latin typeface="Calibri"/>
+              </a:rPr>
+              <a:t>K=5 KL wins by 2.8×</a:t>
             </a:r>
           </a:p>
         </p:txBody>
@@ -5076,8 +5115,8 @@
         </p:nvSpPr>
         <p:spPr>
           <a:xfrm>
-            <a:off x="457200" y="5532120"/>
-            <a:ext cx="11247120" cy="868680"/>
+            <a:off x="457200" y="5669280"/>
+            <a:ext cx="11247120" cy="777240"/>
           </a:xfrm>
           <a:prstGeom prst="rect">
             <a:avLst/>
@@ -5095,14 +5134,14 @@
           <a:p>
             <a:pPr>
               <a:lnSpc>
-                <a:spcPct val="105000"/>
+                <a:spcPct val="104000"/>
               </a:lnSpc>
               <a:spcAft>
                 <a:spcPts val="600"/>
               </a:spcAft>
             </a:pPr>
             <a:r>
-              <a:rPr sz="1100" b="1">
+              <a:rPr sz="1000" b="1">
                 <a:solidFill>
                   <a:srgbClr val="1F4E90"/>
                 </a:solidFill>
@@ -5111,26 +5150,26 @@
               <a:t>•  </a:t>
             </a:r>
             <a:r>
-              <a:rPr sz="1100">
+              <a:rPr sz="1000">
                 <a:solidFill>
                   <a:srgbClr val="232A33"/>
                 </a:solidFill>
                 <a:latin typeface="Calibri"/>
               </a:rPr>
-              <a:t>Active ingredient is K=5 injection × any KL anchor — not K=5 on both sides.</a:t>
+              <a:t>Why K=1 KL loses task format on out-of-distribution queries: it anchors the model on ONE specific framing (Original). On post-cutoff queries the model has no QD-format attractor and falls back to the K=5 INJECTION training (which includes narrative templates).</a:t>
             </a:r>
           </a:p>
           <a:p>
             <a:pPr>
               <a:lnSpc>
-                <a:spcPct val="105000"/>
+                <a:spcPct val="104000"/>
               </a:lnSpc>
               <a:spcAft>
                 <a:spcPts val="600"/>
               </a:spcAft>
             </a:pPr>
             <a:r>
-              <a:rPr sz="1100" b="1">
+              <a:rPr sz="1000" b="1">
                 <a:solidFill>
                   <a:srgbClr val="1F4E90"/>
                 </a:solidFill>
@@ -5139,26 +5178,26 @@
               <a:t>•  </a:t>
             </a:r>
             <a:r>
-              <a:rPr sz="1100">
+              <a:rPr sz="1000">
                 <a:solidFill>
                   <a:srgbClr val="232A33"/>
                 </a:solidFill>
                 <a:latin typeface="Calibri"/>
               </a:rPr>
-              <a:t>Why: K=5 augmentation on the injection side already broadcasts each update across format directions of the gradient; LoRA's update subspace is shared across formats, so single-framing KL implicitly anchors all directions the K=5 update can push.</a:t>
+              <a:t>Why K=5 KL retains task format: it anchors the model on FIVE different instruction wrappings, forcing an instruction-robust QD representation that generalizes to unseen post-cutoff queries.</a:t>
             </a:r>
           </a:p>
           <a:p>
             <a:pPr>
               <a:lnSpc>
-                <a:spcPct val="105000"/>
+                <a:spcPct val="104000"/>
               </a:lnSpc>
               <a:spcAft>
                 <a:spcPts val="600"/>
               </a:spcAft>
             </a:pPr>
             <a:r>
-              <a:rPr sz="1100" b="1">
+              <a:rPr sz="1000" b="1">
                 <a:solidFill>
                   <a:srgbClr val="1F4E90"/>
                 </a:solidFill>
@@ -5167,13 +5206,13 @@
               <a:t>•  </a:t>
             </a:r>
             <a:r>
-              <a:rPr sz="1100">
+              <a:rPr sz="1000">
                 <a:solidFill>
                   <a:srgbClr val="232A33"/>
                 </a:solidFill>
                 <a:latin typeface="Calibri"/>
               </a:rPr>
-              <a:t>Caveat: this leans on LoRA's shared low-rank update subspace. At full fine-tuning the symmetric extension may earn its keep — not validated.</a:t>
+              <a:t>So 'K=5 KL adds nothing' was scoped to absorption F1 — a metric blind to output format.  K=1 KL retains FACT;  K=5 KL retains TASK.</a:t>
             </a:r>
           </a:p>
         </p:txBody>
@@ -5750,16 +5789,25 @@
                 </a:solidFill>
                 <a:latin typeface="Calibri"/>
               </a:rPr>
-              <a:t>Takeaway:  </a:t>
+              <a:t>Across all 50 post-cutoff queries — proper sub-query format adherence:  </a:t>
             </a:r>
             <a:r>
               <a:rPr sz="1100">
                 <a:solidFill>
                   <a:srgbClr val="232A33"/>
                 </a:solidFill>
-                <a:latin typeface="Calibri"/>
-              </a:rPr>
-              <a:t>Editing CHANGES content (only K=5+KL surfaces 'Gemini 2.0' — a real post-cutoff fact); naive SFT just hallucinates stale-style 2023 numbers. </a:t>
+                <a:latin typeface="Consolas"/>
+              </a:rPr>
+              <a:t>naive SFT 0/50,   K=5 + KL 18/50 (36%),   </a:t>
+            </a:r>
+            <a:r>
+              <a:rPr sz="1100" b="1">
+                <a:solidFill>
+                  <a:srgbClr val="1F8E4F"/>
+                </a:solidFill>
+                <a:latin typeface="Consolas"/>
+              </a:rPr>
+              <a:t>K=5 + K=5 KL 50/50 (100%) ✓</a:t>
             </a:r>
           </a:p>
           <a:p>
@@ -5775,7 +5823,7 @@
                 </a:solidFill>
                 <a:latin typeface="Calibri"/>
               </a:rPr>
-              <a:t>But there's a format trade-off our absorption F1 didn't catch: K=5+KL outputs narrative prose, not sub-queries. K=5+K=5 KL preserves the sub-query format but content is sparse. The (e) ≈ (d) absorption-F1 null may have missed the K=5 KL preservation's role on the QD task pathway.</a:t>
+              <a:t>K=1 KL retains FACT (Gemini 2.0 surfaces in K=5+KL prose);  K=5 KL retains TASK (only K=5+K=5 KL keeps the sub-query format on out-of-distribution queries). Two methods, two axes — both wins are real, on different metrics.</a:t>
             </a:r>
           </a:p>
         </p:txBody>
@@ -5967,8 +6015,8 @@
         </p:nvSpPr>
         <p:spPr>
           <a:xfrm>
-            <a:off x="731520" y="1188720"/>
-            <a:ext cx="10698480" cy="1554480"/>
+            <a:off x="457200" y="1051560"/>
+            <a:ext cx="11247120" cy="2011680"/>
           </a:xfrm>
           <a:prstGeom prst="rect">
             <a:avLst/>
@@ -5990,13 +6038,54 @@
           <a:p>
             <a:pPr algn="ctr"/>
             <a:r>
-              <a:rPr sz="2000" i="1">
+              <a:rPr sz="1800" i="1">
                 <a:solidFill>
                   <a:srgbClr val="232A33"/>
                 </a:solidFill>
                 <a:latin typeface="Calibri"/>
               </a:rPr>
               <a:t>For continual LoRA fact injection in task-tuned LLMs:</a:t>
+            </a:r>
+          </a:p>
+          <a:p>
+            <a:pPr algn="ctr">
+              <a:spcBef>
+                <a:spcPts val="1000"/>
+              </a:spcBef>
+            </a:pPr>
+            <a:r>
+              <a:rPr sz="2000" b="1">
+                <a:solidFill>
+                  <a:srgbClr val="1F8E4F"/>
+                </a:solidFill>
+                <a:latin typeface="Calibri"/>
+              </a:rPr>
+              <a:t>K=5 paraphrastic augmentation on the injection side</a:t>
+            </a:r>
+          </a:p>
+          <a:p>
+            <a:pPr algn="ctr">
+              <a:spcBef>
+                <a:spcPts val="200"/>
+              </a:spcBef>
+            </a:pPr>
+            <a:r>
+              <a:rPr sz="1800">
+                <a:solidFill>
+                  <a:srgbClr val="232A33"/>
+                </a:solidFill>
+                <a:latin typeface="Calibri"/>
+              </a:rPr>
+              <a:t>paired with KL preservation —  </a:t>
+            </a:r>
+            <a:r>
+              <a:rPr sz="1800" b="1">
+                <a:solidFill>
+                  <a:srgbClr val="1F8E4F"/>
+                </a:solidFill>
+                <a:latin typeface="Calibri"/>
+              </a:rPr>
+              <a:t>K=1 if only fact recall matters,  K=5 if QD task format also matters.</a:t>
             </a:r>
           </a:p>
           <a:p>
@@ -6006,29 +6095,13 @@
               </a:spcBef>
             </a:pPr>
             <a:r>
-              <a:rPr sz="2200" b="1">
-                <a:solidFill>
-                  <a:srgbClr val="1F8E4F"/>
-                </a:solidFill>
-                <a:latin typeface="Calibri"/>
-              </a:rPr>
-              <a:t>K=5 paraphrastic augmentation on the injection side  +  K=1 KL preservation against a per-round frozen reference</a:t>
-            </a:r>
-          </a:p>
-          <a:p>
-            <a:pPr algn="ctr">
-              <a:spcBef>
-                <a:spcPts val="400"/>
-              </a:spcBef>
-            </a:pPr>
-            <a:r>
-              <a:rPr sz="1400" i="1">
+              <a:rPr sz="1200" i="1">
                 <a:solidFill>
                   <a:srgbClr val="5C6670"/>
                 </a:solidFill>
                 <a:latin typeface="Calibri"/>
               </a:rPr>
-              <a:t>( K=5 + KL  =  aug_kl_k1 )</a:t>
+              <a:t>( K=5 + KL = aug_kl_k1   ·   K=5 + K=5 KL = dsae_lite )</a:t>
             </a:r>
           </a:p>
         </p:txBody>
@@ -6041,8 +6114,8 @@
         </p:nvSpPr>
         <p:spPr>
           <a:xfrm>
-            <a:off x="548640" y="3017520"/>
-            <a:ext cx="11064240" cy="3291840"/>
+            <a:off x="457200" y="3246120"/>
+            <a:ext cx="11247120" cy="3108960"/>
           </a:xfrm>
           <a:prstGeom prst="rect">
             <a:avLst/>
@@ -6060,14 +6133,14 @@
           <a:p>
             <a:pPr>
               <a:lnSpc>
-                <a:spcPct val="115000"/>
+                <a:spcPct val="110000"/>
               </a:lnSpc>
               <a:spcAft>
                 <a:spcPts val="600"/>
               </a:spcAft>
             </a:pPr>
             <a:r>
-              <a:rPr sz="1500" b="1">
+              <a:rPr sz="1300" b="1">
                 <a:solidFill>
                   <a:srgbClr val="1F4E90"/>
                 </a:solidFill>
@@ -6076,7 +6149,7 @@
               <a:t>•  </a:t>
             </a:r>
             <a:r>
-              <a:rPr sz="1500">
+              <a:rPr sz="1300">
                 <a:solidFill>
                   <a:srgbClr val="232A33"/>
                 </a:solidFill>
@@ -6088,14 +6161,14 @@
           <a:p>
             <a:pPr>
               <a:lnSpc>
-                <a:spcPct val="115000"/>
+                <a:spcPct val="110000"/>
               </a:lnSpc>
               <a:spcAft>
                 <a:spcPts val="600"/>
               </a:spcAft>
             </a:pPr>
             <a:r>
-              <a:rPr sz="1500" b="1">
+              <a:rPr sz="1300" b="1">
                 <a:solidFill>
                   <a:srgbClr val="1F4E90"/>
                 </a:solidFill>
@@ -6104,26 +6177,26 @@
               <a:t>•  </a:t>
             </a:r>
             <a:r>
-              <a:rPr sz="1500">
+              <a:rPr sz="1300">
                 <a:solidFill>
                   <a:srgbClr val="232A33"/>
                 </a:solidFill>
                 <a:latin typeface="Calibri"/>
               </a:rPr>
-              <a:t>Pair it with standard K=1 KL preservation against a per-round frozen reference. Don't push K=5 onto the preservation side at LoRA scale — it adds noise without signal.</a:t>
+              <a:t>If your downstream task is fact recall (QA-style probes): K=1 KL preservation is sufficient. aug_kl_k1 is the cheap-and-good choice.</a:t>
             </a:r>
           </a:p>
           <a:p>
             <a:pPr>
               <a:lnSpc>
-                <a:spcPct val="115000"/>
+                <a:spcPct val="110000"/>
               </a:lnSpc>
               <a:spcAft>
                 <a:spcPts val="600"/>
               </a:spcAft>
             </a:pPr>
             <a:r>
-              <a:rPr sz="1500" b="1">
+              <a:rPr sz="1300" b="1">
                 <a:solidFill>
                   <a:srgbClr val="1F4E90"/>
                 </a:solidFill>
@@ -6132,26 +6205,26 @@
               <a:t>•  </a:t>
             </a:r>
             <a:r>
-              <a:rPr sz="1500">
+              <a:rPr sz="1300">
                 <a:solidFill>
                   <a:srgbClr val="232A33"/>
                 </a:solidFill>
                 <a:latin typeface="Calibri"/>
               </a:rPr>
-              <a:t>Don't use COPR for fact injection — the K-sample-all-wrong pathology breaks the assumption that the candidate pool contains usable signal.</a:t>
+              <a:t>If your downstream task is structured query decomposition (or any task whose output format matters under OOD inputs): use K=5 KL preservation. dsae_lite preserves the sub-query format on 100% of post-cutoff queries vs aug_kl_k1's 36%.</a:t>
             </a:r>
           </a:p>
           <a:p>
             <a:pPr>
               <a:lnSpc>
-                <a:spcPct val="115000"/>
+                <a:spcPct val="110000"/>
               </a:lnSpc>
               <a:spcAft>
                 <a:spcPts val="600"/>
               </a:spcAft>
             </a:pPr>
             <a:r>
-              <a:rPr sz="1500" b="1">
+              <a:rPr sz="1300" b="1">
                 <a:solidFill>
                   <a:srgbClr val="1F4E90"/>
                 </a:solidFill>
@@ -6160,26 +6233,26 @@
               <a:t>•  </a:t>
             </a:r>
             <a:r>
-              <a:rPr sz="1500">
+              <a:rPr sz="1300">
                 <a:solidFill>
                   <a:srgbClr val="232A33"/>
                 </a:solidFill>
                 <a:latin typeface="Calibri"/>
               </a:rPr>
-              <a:t>Don't use OOD regularization at K=2 environments — theoretically degenerate per Arjovsky / Rosenfeld / Ahuja, empirically null.</a:t>
+              <a:t>Don't use COPR for fact injection — the K-sample-all-wrong pathology breaks the assumption that the candidate pool contains usable signal.</a:t>
             </a:r>
           </a:p>
           <a:p>
             <a:pPr>
               <a:lnSpc>
-                <a:spcPct val="115000"/>
+                <a:spcPct val="110000"/>
               </a:lnSpc>
               <a:spcAft>
                 <a:spcPts val="600"/>
               </a:spcAft>
             </a:pPr>
             <a:r>
-              <a:rPr sz="1500" b="1">
+              <a:rPr sz="1300" b="1">
                 <a:solidFill>
                   <a:srgbClr val="1F4E90"/>
                 </a:solidFill>
@@ -6188,13 +6261,41 @@
               <a:t>•  </a:t>
             </a:r>
             <a:r>
-              <a:rPr sz="1500">
+              <a:rPr sz="1300">
                 <a:solidFill>
                   <a:srgbClr val="232A33"/>
                 </a:solidFill>
                 <a:latin typeface="Calibri"/>
               </a:rPr>
-              <a:t>The cross-coupling is the active ingredient. Either ingredient alone gives ~+0.03; together they give +0.322 (4.93× super-linear).</a:t>
+              <a:t>Don't use OOD regularization at K=2 environments — theoretically degenerate per Arjovsky / Rosenfeld / Ahuja, empirically null.</a:t>
+            </a:r>
+          </a:p>
+          <a:p>
+            <a:pPr>
+              <a:lnSpc>
+                <a:spcPct val="110000"/>
+              </a:lnSpc>
+              <a:spcAft>
+                <a:spcPts val="600"/>
+              </a:spcAft>
+            </a:pPr>
+            <a:r>
+              <a:rPr sz="1300" b="1">
+                <a:solidFill>
+                  <a:srgbClr val="1F4E90"/>
+                </a:solidFill>
+                <a:latin typeface="Calibri"/>
+              </a:rPr>
+              <a:t>•  </a:t>
+            </a:r>
+            <a:r>
+              <a:rPr sz="1300">
+                <a:solidFill>
+                  <a:srgbClr val="232A33"/>
+                </a:solidFill>
+                <a:latin typeface="Calibri"/>
+              </a:rPr>
+              <a:t>The cross-coupling of K=5 injection × KL preservation is the active ingredient: either alone gives ~+0.03 absorption F1; together gives +0.322 (4.93× super-linear).</a:t>
             </a:r>
           </a:p>
         </p:txBody>

</xml_diff>